<commit_message>
Add Wesley as engineering co-presenter
</commit_message>
<xml_diff>
--- a/docs/presentation/Engineering_at_The_Kinetic_Group.pptx
+++ b/docs/presentation/Engineering_at_The_Kinetic_Group.pptx
@@ -2,22 +2,22 @@
 <file path=ppt/presentation.xml><?xml version="1.0" encoding="utf-8"?>
 <p:presentation xmlns:p="http://schemas.openxmlformats.org/presentationml/2006/main">
   <p:sldMasterIdLst>
-    <p:sldMasterId xmlns:r="http://schemas.openxmlformats.org/officeDocument/2006/relationships" id="2147483648" r:id="R1a1f229b833c42a6"/>
+    <p:sldMasterId xmlns:r="http://schemas.openxmlformats.org/officeDocument/2006/relationships" id="2147483648" r:id="Rede46759d1c74068"/>
   </p:sldMasterIdLst>
   <p:notesMasterIdLst>
-    <p:notesMasterId xmlns:r="http://schemas.openxmlformats.org/officeDocument/2006/relationships" r:id="R5a85bd5d27594aad"/>
+    <p:notesMasterId xmlns:r="http://schemas.openxmlformats.org/officeDocument/2006/relationships" r:id="Ref95a56e606341cf"/>
   </p:notesMasterIdLst>
   <p:sldIdLst>
-    <p:sldId xmlns:r="http://schemas.openxmlformats.org/officeDocument/2006/relationships" id="256" r:id="Rb2cb0350821a48d2"/>
-    <p:sldId xmlns:r="http://schemas.openxmlformats.org/officeDocument/2006/relationships" id="257" r:id="Rd6744cb2a4aa4a4d"/>
-    <p:sldId xmlns:r="http://schemas.openxmlformats.org/officeDocument/2006/relationships" id="258" r:id="R776d32cad20140e0"/>
-    <p:sldId xmlns:r="http://schemas.openxmlformats.org/officeDocument/2006/relationships" id="259" r:id="R373d5b97770340e4"/>
-    <p:sldId xmlns:r="http://schemas.openxmlformats.org/officeDocument/2006/relationships" id="260" r:id="R257bb674b42d4ad5"/>
-    <p:sldId xmlns:r="http://schemas.openxmlformats.org/officeDocument/2006/relationships" id="261" r:id="Rf300c4af668a450e"/>
-    <p:sldId xmlns:r="http://schemas.openxmlformats.org/officeDocument/2006/relationships" id="262" r:id="Rda54f88881234672"/>
-    <p:sldId xmlns:r="http://schemas.openxmlformats.org/officeDocument/2006/relationships" id="263" r:id="Rb8eef1017f674679"/>
-    <p:sldId xmlns:r="http://schemas.openxmlformats.org/officeDocument/2006/relationships" id="264" r:id="Reb5cb6a2d48e487b"/>
-    <p:sldId xmlns:r="http://schemas.openxmlformats.org/officeDocument/2006/relationships" id="265" r:id="Rf54405d5b08647ab"/>
+    <p:sldId xmlns:r="http://schemas.openxmlformats.org/officeDocument/2006/relationships" id="256" r:id="R40d72490408047b6"/>
+    <p:sldId xmlns:r="http://schemas.openxmlformats.org/officeDocument/2006/relationships" id="257" r:id="R045b43ace8e14d46"/>
+    <p:sldId xmlns:r="http://schemas.openxmlformats.org/officeDocument/2006/relationships" id="258" r:id="R03163fdee49648be"/>
+    <p:sldId xmlns:r="http://schemas.openxmlformats.org/officeDocument/2006/relationships" id="259" r:id="Rcdf20f27e27345c9"/>
+    <p:sldId xmlns:r="http://schemas.openxmlformats.org/officeDocument/2006/relationships" id="260" r:id="Rd10fc1fbb063430c"/>
+    <p:sldId xmlns:r="http://schemas.openxmlformats.org/officeDocument/2006/relationships" id="261" r:id="Rd7a80537863a46b4"/>
+    <p:sldId xmlns:r="http://schemas.openxmlformats.org/officeDocument/2006/relationships" id="262" r:id="Rb78027dc02f44fa8"/>
+    <p:sldId xmlns:r="http://schemas.openxmlformats.org/officeDocument/2006/relationships" id="263" r:id="R2f5368904e35420c"/>
+    <p:sldId xmlns:r="http://schemas.openxmlformats.org/officeDocument/2006/relationships" id="264" r:id="R8d44cebb45074d4c"/>
+    <p:sldId xmlns:r="http://schemas.openxmlformats.org/officeDocument/2006/relationships" id="265" r:id="R3c90913c65ec4bff"/>
   </p:sldIdLst>
   <p:sldSz cx="12192000" cy="6858000"/>
   <p:notesSz cx="6858000" cy="9144000"/>
@@ -451,7 +451,7 @@
           <a:lstStyle xmlns:a="http://schemas.openxmlformats.org/drawingml/2006/main"/>
           <a:p xmlns:a="http://schemas.openxmlformats.org/drawingml/2006/main">
             <a:r>
-              <a:t>Introduce yourself as Brad Daugherty. You lead small engineering teams across The Kinetic Group and work primarily at Remington in Lonoke. Set the expectation that you will show real engineering work, then invite questions and connections.</a:t>
+              <a:t>Brad opens. Introduce Wesley Siharth as an engineer who helped start Remington Vision. Wesley was first tasked with the project as an intern and carried it into his engineering role. Both Brad and Wesley will speak.</a:t>
             </a:r>
           </a:p>
         </p:txBody>
@@ -521,7 +521,7 @@
           <a:lstStyle xmlns:a="http://schemas.openxmlformats.org/drawingml/2006/main"/>
           <a:p xmlns:a="http://schemas.openxmlformats.org/drawingml/2006/main">
             <a:r>
-              <a:t>Close with three paths: email Brad for a conversation, use the official The Kinetic Group careers page for jobs, and connect through the independent 4Founders platform for project follow-up. Invite questions and conversations after the presentation.</a:t>
+              <a:t>Brad closes. Invite follow-up with both Brad and Wesley. Brad’s email is on screen; company jobs use the official careers page, while 4Founders is an independent project platform.</a:t>
             </a:r>
           </a:p>
         </p:txBody>
@@ -731,7 +731,7 @@
           <a:lstStyle xmlns:a="http://schemas.openxmlformats.org/drawingml/2006/main"/>
           <a:p xmlns:a="http://schemas.openxmlformats.org/drawingml/2006/main">
             <a:r>
-              <a:t>Speak personally about the variety of problems, the satisfaction of seeing a result in real operations, learning across disciplines, and taking responsibility for what the team builds. Keep the tone grounded in your experience.</a:t>
+              <a:t>Wesley speaks. Remington Vision was first assigned to him as an intern, and he carried the work into his role as an engineer. Explain why both presenters love the variety, visible results, learning, and ownership in this work.</a:t>
             </a:r>
           </a:p>
         </p:txBody>
@@ -801,7 +801,7 @@
           <a:lstStyle xmlns:a="http://schemas.openxmlformats.org/drawingml/2006/main"/>
           <a:p xmlns:a="http://schemas.openxmlformats.org/drawingml/2006/main">
             <a:r>
-              <a:t>Transition into the live demonstration. Show the camera image, Gatorade bottle detection, and on-screen sorting result. Let the audience see the result before explaining details. The slide is the only walkthrough cue; the demonstration program carries the explanation.</a:t>
+              <a:t>Wesley leads the live demonstration. Show the camera image, Gatorade bottle detection, and on-screen sorting result. The demonstration program carries the explanation. This is a demonstration setup, not a production sorting line.</a:t>
             </a:r>
           </a:p>
         </p:txBody>
@@ -871,7 +871,7 @@
           <a:lstStyle xmlns:a="http://schemas.openxmlformats.org/drawingml/2006/main"/>
           <a:p xmlns:a="http://schemas.openxmlformats.org/drawingml/2006/main">
             <a:r>
-              <a:t>After the demonstration, explain the engineering difficulty in plain language: real conditions vary, decisions must happen at the right pace, and a system needs repeatable results people can trust. The bottle example shows an on-screen sorting decision; it does not actuate production sorting hardware.</a:t>
+              <a:t>Wesley explains the engineering difficulty after the demo: conditions vary, decisions have to happen at the right pace, and results need to be reliable enough for people to trust. The on-screen sorting decision does not actuate production hardware.</a:t>
             </a:r>
           </a:p>
         </p:txBody>
@@ -941,7 +941,7 @@
           <a:lstStyle xmlns:a="http://schemas.openxmlformats.org/drawingml/2006/main"/>
           <a:p xmlns:a="http://schemas.openxmlformats.org/drawingml/2006/main">
             <a:r>
-              <a:t>Invite people who want to tackle these challenges. Opportunities span Remington and The Kinetic Group, including mechanical work, controls, software, and testing. Describe the actual roles or projects you can publicly discuss, and direct employment interest to the official careers page.</a:t>
+              <a:t>Brad resumes. Invite people who want to take on these challenges. Opportunities span Remington and The Kinetic Group. Point employment interest to the official careers page.</a:t>
             </a:r>
           </a:p>
         </p:txBody>
@@ -3524,12 +3524,12 @@
   </p:cSld>
   <p:clrMap bg1="lt1" tx1="dk1" bg2="lt2" tx2="dk2" accent1="accent1" accent2="accent2" accent3="accent3" accent4="accent4" accent5="accent5" accent6="accent6" hlink="hlink" folHlink="folHlink"/>
   <p:sldLayoutIdLst>
-    <p:sldLayoutId xmlns:r="http://schemas.openxmlformats.org/officeDocument/2006/relationships" id="2147483649" r:id="R358d10893f944cf7"/>
-    <p:sldLayoutId xmlns:r="http://schemas.openxmlformats.org/officeDocument/2006/relationships" id="2147483650" r:id="Rd97496dd4f76416f"/>
-    <p:sldLayoutId xmlns:r="http://schemas.openxmlformats.org/officeDocument/2006/relationships" id="2147483651" r:id="Rcebffb55e8b8422c"/>
-    <p:sldLayoutId xmlns:r="http://schemas.openxmlformats.org/officeDocument/2006/relationships" id="2147483652" r:id="R942fb571133e4b0f"/>
-    <p:sldLayoutId xmlns:r="http://schemas.openxmlformats.org/officeDocument/2006/relationships" id="2147483653" r:id="Re3205d3f09c145c7"/>
-    <p:sldLayoutId xmlns:r="http://schemas.openxmlformats.org/officeDocument/2006/relationships" id="2147483654" r:id="R35d687921f6c4ca7"/>
+    <p:sldLayoutId xmlns:r="http://schemas.openxmlformats.org/officeDocument/2006/relationships" id="2147483649" r:id="R5c32e10bd4454f07"/>
+    <p:sldLayoutId xmlns:r="http://schemas.openxmlformats.org/officeDocument/2006/relationships" id="2147483650" r:id="R4201aff697014e8a"/>
+    <p:sldLayoutId xmlns:r="http://schemas.openxmlformats.org/officeDocument/2006/relationships" id="2147483651" r:id="Rc3a9cefd27b9443c"/>
+    <p:sldLayoutId xmlns:r="http://schemas.openxmlformats.org/officeDocument/2006/relationships" id="2147483652" r:id="Rd08d1d051eb64f45"/>
+    <p:sldLayoutId xmlns:r="http://schemas.openxmlformats.org/officeDocument/2006/relationships" id="2147483653" r:id="R64cf28eb2029474f"/>
+    <p:sldLayoutId xmlns:r="http://schemas.openxmlformats.org/officeDocument/2006/relationships" id="2147483654" r:id="R1dce60d7d559426e"/>
   </p:sldLayoutIdLst>
   <p:txStyles>
     <p:titleStyle>
@@ -4080,7 +4080,7 @@
           <p:cNvPr id="6" name="">
             <a:extLst xmlns:a="http://schemas.openxmlformats.org/drawingml/2006/main">
               <a:ext uri="{FF2B5EF4-FFF2-40B4-BE49-F238E27FC236}">
-                <a16:creationId xmlns:a16="http://schemas.microsoft.com/office/drawing/2014/main" id="{9E832E52-003D-49B1-B6F4-D05E3D1942E8}"/>
+                <a16:creationId xmlns:a16="http://schemas.microsoft.com/office/drawing/2014/main" id="{C281F9BE-729D-4EEA-A056-B10B043D5765}"/>
               </a:ext>
             </a:extLst>
           </p:cNvPr>
@@ -4090,7 +4090,7 @@
           <p:nvPr/>
         </p:nvPicPr>
         <p:blipFill>
-          <a:blip xmlns:r="http://schemas.openxmlformats.org/officeDocument/2006/relationships" xmlns:a="http://schemas.openxmlformats.org/drawingml/2006/main" r:embed="R22c1a2af0ace4f8f"/>
+          <a:blip xmlns:r="http://schemas.openxmlformats.org/officeDocument/2006/relationships" xmlns:a="http://schemas.openxmlformats.org/drawingml/2006/main" r:embed="R1176cbb55a1d489d"/>
           <a:stretch xmlns:a="http://schemas.openxmlformats.org/drawingml/2006/main"/>
         </p:blipFill>
         <p:spPr>
@@ -4596,31 +4596,7 @@
                 <a:ea typeface="Arial"/>
                 <a:cs typeface="Arial"/>
               </a:rPr>
-              <a:t>Brad Daugherty</a:t>
-            </a:r>
-          </a:p>
-          <a:p xmlns:a="http://schemas.openxmlformats.org/drawingml/2006/main">
-            <a:pPr>
-              <a:buNone/>
-              <a:defRPr sz="2175" b="0">
-                <a:solidFill>
-                  <a:srgbClr val="D7D3CC"/>
-                </a:solidFill>
-                <a:latin typeface="Arial"/>
-                <a:ea typeface="Arial"/>
-                <a:cs typeface="Arial"/>
-              </a:defRPr>
-            </a:pPr>
-            <a:r>
-              <a:rPr sz="2175" b="0">
-                <a:solidFill>
-                  <a:srgbClr val="D7D3CC"/>
-                </a:solidFill>
-                <a:latin typeface="Arial"/>
-                <a:ea typeface="Arial"/>
-                <a:cs typeface="Arial"/>
-              </a:rPr>
-              <a:t>Engineering Team Lead, Remington</a:t>
+              <a:t/>
             </a:r>
           </a:p>
         </p:txBody>
@@ -4811,6 +4787,490 @@
                 <a:cs typeface="Arial"/>
               </a:rPr>
               <a:t>October 23, 2026</a:t>
+            </a:r>
+          </a:p>
+        </p:txBody>
+      </p:sp>
+      <p:sp>
+        <p:nvSpPr>
+          <p:cNvPr id="7" name="">
+            <a:extLst xmlns:a="http://schemas.openxmlformats.org/drawingml/2006/main">
+              <a:ext uri="{FF2B5EF4-FFF2-40B4-BE49-F238E27FC236}">
+                <a16:creationId xmlns:a16="http://schemas.microsoft.com/office/drawing/2014/main" id="{864E43FC-C41B-4D2B-AB44-496AEEAC7033}"/>
+              </a:ext>
+            </a:extLst>
+          </p:cNvPr>
+          <p:cNvSpPr>
+            <a:spLocks xmlns:a="http://schemas.openxmlformats.org/drawingml/2006/main" noGrp="1"/>
+          </p:cNvSpPr>
+          <p:nvPr/>
+        </p:nvSpPr>
+        <p:spPr>
+          <a:xfrm xmlns:a="http://schemas.openxmlformats.org/drawingml/2006/main">
+            <a:off x="762000" y="4933950"/>
+            <a:ext cx="3667125" cy="428625"/>
+          </a:xfrm>
+          <a:prstGeom xmlns:a="http://schemas.openxmlformats.org/drawingml/2006/main" prst="rect">
+            <a:avLst/>
+          </a:prstGeom>
+          <a:noFill xmlns:a="http://schemas.openxmlformats.org/drawingml/2006/main"/>
+          <a:ln xmlns:a="http://schemas.openxmlformats.org/drawingml/2006/main" w="0">
+            <a:noFill/>
+            <a:prstDash val="solid"/>
+          </a:ln>
+        </p:spPr>
+        <p:txBody>
+          <a:bodyPr xmlns:a="http://schemas.openxmlformats.org/drawingml/2006/main" lIns="0" tIns="0" rIns="0" bIns="0"/>
+          <a:lstStyle xmlns:a="http://schemas.openxmlformats.org/drawingml/2006/main">
+            <a:defPPr algn="l">
+              <a:defRPr sz="2100" b="1">
+                <a:solidFill>
+                  <a:srgbClr val="FFFFFF"/>
+                </a:solidFill>
+              </a:defRPr>
+            </a:defPPr>
+            <a:lvl1pPr algn="l">
+              <a:defRPr sz="2100" b="1">
+                <a:solidFill>
+                  <a:srgbClr val="FFFFFF"/>
+                </a:solidFill>
+              </a:defRPr>
+            </a:lvl1pPr>
+            <a:lvl2pPr algn="l">
+              <a:defRPr sz="2100" b="1">
+                <a:solidFill>
+                  <a:srgbClr val="FFFFFF"/>
+                </a:solidFill>
+              </a:defRPr>
+            </a:lvl2pPr>
+            <a:lvl3pPr algn="l">
+              <a:defRPr sz="2100" b="1">
+                <a:solidFill>
+                  <a:srgbClr val="FFFFFF"/>
+                </a:solidFill>
+              </a:defRPr>
+            </a:lvl3pPr>
+            <a:lvl4pPr algn="l">
+              <a:defRPr sz="2100" b="1">
+                <a:solidFill>
+                  <a:srgbClr val="FFFFFF"/>
+                </a:solidFill>
+              </a:defRPr>
+            </a:lvl4pPr>
+            <a:lvl5pPr algn="l">
+              <a:defRPr sz="2100" b="1">
+                <a:solidFill>
+                  <a:srgbClr val="FFFFFF"/>
+                </a:solidFill>
+              </a:defRPr>
+            </a:lvl5pPr>
+            <a:lvl6pPr algn="l">
+              <a:defRPr sz="2100" b="1">
+                <a:solidFill>
+                  <a:srgbClr val="FFFFFF"/>
+                </a:solidFill>
+              </a:defRPr>
+            </a:lvl6pPr>
+            <a:lvl7pPr algn="l">
+              <a:defRPr sz="2100" b="1">
+                <a:solidFill>
+                  <a:srgbClr val="FFFFFF"/>
+                </a:solidFill>
+              </a:defRPr>
+            </a:lvl7pPr>
+            <a:lvl8pPr algn="l">
+              <a:defRPr sz="2100" b="1">
+                <a:solidFill>
+                  <a:srgbClr val="FFFFFF"/>
+                </a:solidFill>
+              </a:defRPr>
+            </a:lvl8pPr>
+            <a:lvl9pPr algn="l">
+              <a:defRPr sz="2100" b="1">
+                <a:solidFill>
+                  <a:srgbClr val="FFFFFF"/>
+                </a:solidFill>
+              </a:defRPr>
+            </a:lvl9pPr>
+          </a:lstStyle>
+          <a:p xmlns:a="http://schemas.openxmlformats.org/drawingml/2006/main">
+            <a:pPr algn="l">
+              <a:defRPr sz="2100" b="1">
+                <a:solidFill>
+                  <a:srgbClr val="FFFFFF"/>
+                </a:solidFill>
+              </a:defRPr>
+            </a:pPr>
+            <a:r>
+              <a:rPr sz="2100" b="1">
+                <a:solidFill>
+                  <a:srgbClr val="FFFFFF"/>
+                </a:solidFill>
+              </a:rPr>
+              <a:t>Brad Daugherty</a:t>
+            </a:r>
+          </a:p>
+        </p:txBody>
+      </p:sp>
+      <p:sp>
+        <p:nvSpPr>
+          <p:cNvPr id="8" name="">
+            <a:extLst xmlns:a="http://schemas.openxmlformats.org/drawingml/2006/main">
+              <a:ext uri="{FF2B5EF4-FFF2-40B4-BE49-F238E27FC236}">
+                <a16:creationId xmlns:a16="http://schemas.microsoft.com/office/drawing/2014/main" id="{4A3469CE-0AB9-4DCF-80F8-A3791C0565F8}"/>
+              </a:ext>
+            </a:extLst>
+          </p:cNvPr>
+          <p:cNvSpPr>
+            <a:spLocks xmlns:a="http://schemas.openxmlformats.org/drawingml/2006/main" noGrp="1"/>
+          </p:cNvSpPr>
+          <p:nvPr/>
+        </p:nvSpPr>
+        <p:spPr>
+          <a:xfrm xmlns:a="http://schemas.openxmlformats.org/drawingml/2006/main">
+            <a:off x="762000" y="5362575"/>
+            <a:ext cx="3667125" cy="495300"/>
+          </a:xfrm>
+          <a:prstGeom xmlns:a="http://schemas.openxmlformats.org/drawingml/2006/main" prst="rect">
+            <a:avLst/>
+          </a:prstGeom>
+          <a:noFill xmlns:a="http://schemas.openxmlformats.org/drawingml/2006/main"/>
+          <a:ln xmlns:a="http://schemas.openxmlformats.org/drawingml/2006/main" w="0">
+            <a:noFill/>
+            <a:prstDash val="solid"/>
+          </a:ln>
+        </p:spPr>
+        <p:txBody>
+          <a:bodyPr xmlns:a="http://schemas.openxmlformats.org/drawingml/2006/main" lIns="0" tIns="0" rIns="0" bIns="0"/>
+          <a:lstStyle xmlns:a="http://schemas.openxmlformats.org/drawingml/2006/main">
+            <a:defPPr algn="l">
+              <a:defRPr sz="1500" b="0">
+                <a:solidFill>
+                  <a:srgbClr val="D7D3CC"/>
+                </a:solidFill>
+              </a:defRPr>
+            </a:defPPr>
+            <a:lvl1pPr algn="l">
+              <a:defRPr sz="1500" b="0">
+                <a:solidFill>
+                  <a:srgbClr val="D7D3CC"/>
+                </a:solidFill>
+              </a:defRPr>
+            </a:lvl1pPr>
+            <a:lvl2pPr algn="l">
+              <a:defRPr sz="1500" b="0">
+                <a:solidFill>
+                  <a:srgbClr val="D7D3CC"/>
+                </a:solidFill>
+              </a:defRPr>
+            </a:lvl2pPr>
+            <a:lvl3pPr algn="l">
+              <a:defRPr sz="1500" b="0">
+                <a:solidFill>
+                  <a:srgbClr val="D7D3CC"/>
+                </a:solidFill>
+              </a:defRPr>
+            </a:lvl3pPr>
+            <a:lvl4pPr algn="l">
+              <a:defRPr sz="1500" b="0">
+                <a:solidFill>
+                  <a:srgbClr val="D7D3CC"/>
+                </a:solidFill>
+              </a:defRPr>
+            </a:lvl4pPr>
+            <a:lvl5pPr algn="l">
+              <a:defRPr sz="1500" b="0">
+                <a:solidFill>
+                  <a:srgbClr val="D7D3CC"/>
+                </a:solidFill>
+              </a:defRPr>
+            </a:lvl5pPr>
+            <a:lvl6pPr algn="l">
+              <a:defRPr sz="1500" b="0">
+                <a:solidFill>
+                  <a:srgbClr val="D7D3CC"/>
+                </a:solidFill>
+              </a:defRPr>
+            </a:lvl6pPr>
+            <a:lvl7pPr algn="l">
+              <a:defRPr sz="1500" b="0">
+                <a:solidFill>
+                  <a:srgbClr val="D7D3CC"/>
+                </a:solidFill>
+              </a:defRPr>
+            </a:lvl7pPr>
+            <a:lvl8pPr algn="l">
+              <a:defRPr sz="1500" b="0">
+                <a:solidFill>
+                  <a:srgbClr val="D7D3CC"/>
+                </a:solidFill>
+              </a:defRPr>
+            </a:lvl8pPr>
+            <a:lvl9pPr algn="l">
+              <a:defRPr sz="1500" b="0">
+                <a:solidFill>
+                  <a:srgbClr val="D7D3CC"/>
+                </a:solidFill>
+              </a:defRPr>
+            </a:lvl9pPr>
+          </a:lstStyle>
+          <a:p xmlns:a="http://schemas.openxmlformats.org/drawingml/2006/main">
+            <a:pPr algn="l">
+              <a:defRPr sz="1500" b="0">
+                <a:solidFill>
+                  <a:srgbClr val="D7D3CC"/>
+                </a:solidFill>
+              </a:defRPr>
+            </a:pPr>
+            <a:r>
+              <a:rPr sz="1500" b="0">
+                <a:solidFill>
+                  <a:srgbClr val="D7D3CC"/>
+                </a:solidFill>
+              </a:rPr>
+              <a:t>Engineering Team Lead, Remington</a:t>
+            </a:r>
+          </a:p>
+        </p:txBody>
+      </p:sp>
+      <p:sp>
+        <p:nvSpPr>
+          <p:cNvPr id="9" name="">
+            <a:extLst xmlns:a="http://schemas.openxmlformats.org/drawingml/2006/main">
+              <a:ext uri="{FF2B5EF4-FFF2-40B4-BE49-F238E27FC236}">
+                <a16:creationId xmlns:a16="http://schemas.microsoft.com/office/drawing/2014/main" id="{1AD6AB4A-A049-4EFB-975F-067ABEC1CB78}"/>
+              </a:ext>
+            </a:extLst>
+          </p:cNvPr>
+          <p:cNvSpPr>
+            <a:spLocks xmlns:a="http://schemas.openxmlformats.org/drawingml/2006/main" noGrp="1"/>
+          </p:cNvSpPr>
+          <p:nvPr/>
+        </p:nvSpPr>
+        <p:spPr>
+          <a:xfrm xmlns:a="http://schemas.openxmlformats.org/drawingml/2006/main">
+            <a:off x="4552950" y="4933950"/>
+            <a:ext cx="3667125" cy="428625"/>
+          </a:xfrm>
+          <a:prstGeom xmlns:a="http://schemas.openxmlformats.org/drawingml/2006/main" prst="rect">
+            <a:avLst/>
+          </a:prstGeom>
+          <a:noFill xmlns:a="http://schemas.openxmlformats.org/drawingml/2006/main"/>
+          <a:ln xmlns:a="http://schemas.openxmlformats.org/drawingml/2006/main" w="0">
+            <a:noFill/>
+            <a:prstDash val="solid"/>
+          </a:ln>
+        </p:spPr>
+        <p:txBody>
+          <a:bodyPr xmlns:a="http://schemas.openxmlformats.org/drawingml/2006/main" lIns="0" tIns="0" rIns="0" bIns="0"/>
+          <a:lstStyle xmlns:a="http://schemas.openxmlformats.org/drawingml/2006/main">
+            <a:defPPr algn="l">
+              <a:defRPr sz="2100" b="1">
+                <a:solidFill>
+                  <a:srgbClr val="FFFFFF"/>
+                </a:solidFill>
+              </a:defRPr>
+            </a:defPPr>
+            <a:lvl1pPr algn="l">
+              <a:defRPr sz="2100" b="1">
+                <a:solidFill>
+                  <a:srgbClr val="FFFFFF"/>
+                </a:solidFill>
+              </a:defRPr>
+            </a:lvl1pPr>
+            <a:lvl2pPr algn="l">
+              <a:defRPr sz="2100" b="1">
+                <a:solidFill>
+                  <a:srgbClr val="FFFFFF"/>
+                </a:solidFill>
+              </a:defRPr>
+            </a:lvl2pPr>
+            <a:lvl3pPr algn="l">
+              <a:defRPr sz="2100" b="1">
+                <a:solidFill>
+                  <a:srgbClr val="FFFFFF"/>
+                </a:solidFill>
+              </a:defRPr>
+            </a:lvl3pPr>
+            <a:lvl4pPr algn="l">
+              <a:defRPr sz="2100" b="1">
+                <a:solidFill>
+                  <a:srgbClr val="FFFFFF"/>
+                </a:solidFill>
+              </a:defRPr>
+            </a:lvl4pPr>
+            <a:lvl5pPr algn="l">
+              <a:defRPr sz="2100" b="1">
+                <a:solidFill>
+                  <a:srgbClr val="FFFFFF"/>
+                </a:solidFill>
+              </a:defRPr>
+            </a:lvl5pPr>
+            <a:lvl6pPr algn="l">
+              <a:defRPr sz="2100" b="1">
+                <a:solidFill>
+                  <a:srgbClr val="FFFFFF"/>
+                </a:solidFill>
+              </a:defRPr>
+            </a:lvl6pPr>
+            <a:lvl7pPr algn="l">
+              <a:defRPr sz="2100" b="1">
+                <a:solidFill>
+                  <a:srgbClr val="FFFFFF"/>
+                </a:solidFill>
+              </a:defRPr>
+            </a:lvl7pPr>
+            <a:lvl8pPr algn="l">
+              <a:defRPr sz="2100" b="1">
+                <a:solidFill>
+                  <a:srgbClr val="FFFFFF"/>
+                </a:solidFill>
+              </a:defRPr>
+            </a:lvl8pPr>
+            <a:lvl9pPr algn="l">
+              <a:defRPr sz="2100" b="1">
+                <a:solidFill>
+                  <a:srgbClr val="FFFFFF"/>
+                </a:solidFill>
+              </a:defRPr>
+            </a:lvl9pPr>
+          </a:lstStyle>
+          <a:p xmlns:a="http://schemas.openxmlformats.org/drawingml/2006/main">
+            <a:pPr algn="l">
+              <a:defRPr sz="2100" b="1">
+                <a:solidFill>
+                  <a:srgbClr val="FFFFFF"/>
+                </a:solidFill>
+              </a:defRPr>
+            </a:pPr>
+            <a:r>
+              <a:rPr sz="2100" b="1">
+                <a:solidFill>
+                  <a:srgbClr val="FFFFFF"/>
+                </a:solidFill>
+              </a:rPr>
+              <a:t>Wesley Siharth</a:t>
+            </a:r>
+          </a:p>
+        </p:txBody>
+      </p:sp>
+      <p:sp>
+        <p:nvSpPr>
+          <p:cNvPr id="10" name="">
+            <a:extLst xmlns:a="http://schemas.openxmlformats.org/drawingml/2006/main">
+              <a:ext uri="{FF2B5EF4-FFF2-40B4-BE49-F238E27FC236}">
+                <a16:creationId xmlns:a16="http://schemas.microsoft.com/office/drawing/2014/main" id="{07902AB8-797A-45D3-8DAA-BF75684B2885}"/>
+              </a:ext>
+            </a:extLst>
+          </p:cNvPr>
+          <p:cNvSpPr>
+            <a:spLocks xmlns:a="http://schemas.openxmlformats.org/drawingml/2006/main" noGrp="1"/>
+          </p:cNvSpPr>
+          <p:nvPr/>
+        </p:nvSpPr>
+        <p:spPr>
+          <a:xfrm xmlns:a="http://schemas.openxmlformats.org/drawingml/2006/main">
+            <a:off x="4552950" y="5362575"/>
+            <a:ext cx="3667125" cy="495300"/>
+          </a:xfrm>
+          <a:prstGeom xmlns:a="http://schemas.openxmlformats.org/drawingml/2006/main" prst="rect">
+            <a:avLst/>
+          </a:prstGeom>
+          <a:noFill xmlns:a="http://schemas.openxmlformats.org/drawingml/2006/main"/>
+          <a:ln xmlns:a="http://schemas.openxmlformats.org/drawingml/2006/main" w="0">
+            <a:noFill/>
+            <a:prstDash val="solid"/>
+          </a:ln>
+        </p:spPr>
+        <p:txBody>
+          <a:bodyPr xmlns:a="http://schemas.openxmlformats.org/drawingml/2006/main" lIns="0" tIns="0" rIns="0" bIns="0"/>
+          <a:lstStyle xmlns:a="http://schemas.openxmlformats.org/drawingml/2006/main">
+            <a:defPPr algn="l">
+              <a:defRPr sz="1500" b="0">
+                <a:solidFill>
+                  <a:srgbClr val="D7D3CC"/>
+                </a:solidFill>
+              </a:defRPr>
+            </a:defPPr>
+            <a:lvl1pPr algn="l">
+              <a:defRPr sz="1500" b="0">
+                <a:solidFill>
+                  <a:srgbClr val="D7D3CC"/>
+                </a:solidFill>
+              </a:defRPr>
+            </a:lvl1pPr>
+            <a:lvl2pPr algn="l">
+              <a:defRPr sz="1500" b="0">
+                <a:solidFill>
+                  <a:srgbClr val="D7D3CC"/>
+                </a:solidFill>
+              </a:defRPr>
+            </a:lvl2pPr>
+            <a:lvl3pPr algn="l">
+              <a:defRPr sz="1500" b="0">
+                <a:solidFill>
+                  <a:srgbClr val="D7D3CC"/>
+                </a:solidFill>
+              </a:defRPr>
+            </a:lvl3pPr>
+            <a:lvl4pPr algn="l">
+              <a:defRPr sz="1500" b="0">
+                <a:solidFill>
+                  <a:srgbClr val="D7D3CC"/>
+                </a:solidFill>
+              </a:defRPr>
+            </a:lvl4pPr>
+            <a:lvl5pPr algn="l">
+              <a:defRPr sz="1500" b="0">
+                <a:solidFill>
+                  <a:srgbClr val="D7D3CC"/>
+                </a:solidFill>
+              </a:defRPr>
+            </a:lvl5pPr>
+            <a:lvl6pPr algn="l">
+              <a:defRPr sz="1500" b="0">
+                <a:solidFill>
+                  <a:srgbClr val="D7D3CC"/>
+                </a:solidFill>
+              </a:defRPr>
+            </a:lvl6pPr>
+            <a:lvl7pPr algn="l">
+              <a:defRPr sz="1500" b="0">
+                <a:solidFill>
+                  <a:srgbClr val="D7D3CC"/>
+                </a:solidFill>
+              </a:defRPr>
+            </a:lvl7pPr>
+            <a:lvl8pPr algn="l">
+              <a:defRPr sz="1500" b="0">
+                <a:solidFill>
+                  <a:srgbClr val="D7D3CC"/>
+                </a:solidFill>
+              </a:defRPr>
+            </a:lvl8pPr>
+            <a:lvl9pPr algn="l">
+              <a:defRPr sz="1500" b="0">
+                <a:solidFill>
+                  <a:srgbClr val="D7D3CC"/>
+                </a:solidFill>
+              </a:defRPr>
+            </a:lvl9pPr>
+          </a:lstStyle>
+          <a:p xmlns:a="http://schemas.openxmlformats.org/drawingml/2006/main">
+            <a:pPr algn="l">
+              <a:defRPr sz="1500" b="0">
+                <a:solidFill>
+                  <a:srgbClr val="D7D3CC"/>
+                </a:solidFill>
+              </a:defRPr>
+            </a:pPr>
+            <a:r>
+              <a:rPr sz="1500" b="0">
+                <a:solidFill>
+                  <a:srgbClr val="D7D3CC"/>
+                </a:solidFill>
+              </a:rPr>
+              <a:t>Engineer</a:t>
             </a:r>
           </a:p>
         </p:txBody>
@@ -4849,7 +5309,7 @@
           <p:cNvPr id="3" name="">
             <a:extLst xmlns:a="http://schemas.openxmlformats.org/drawingml/2006/main">
               <a:ext uri="{FF2B5EF4-FFF2-40B4-BE49-F238E27FC236}">
-                <a16:creationId xmlns:a16="http://schemas.microsoft.com/office/drawing/2014/main" id="{4D380033-1BAE-456D-A879-44A0468BA9D0}"/>
+                <a16:creationId xmlns:a16="http://schemas.microsoft.com/office/drawing/2014/main" id="{2AFEB78C-684E-44C8-A2CE-9348D9B7F914}"/>
               </a:ext>
             </a:extLst>
           </p:cNvPr>
@@ -4859,7 +5319,7 @@
           <p:nvPr/>
         </p:nvPicPr>
         <p:blipFill>
-          <a:blip xmlns:r="http://schemas.openxmlformats.org/officeDocument/2006/relationships" xmlns:a="http://schemas.openxmlformats.org/drawingml/2006/main" r:embed="R912b08b497154063"/>
+          <a:blip xmlns:r="http://schemas.openxmlformats.org/officeDocument/2006/relationships" xmlns:a="http://schemas.openxmlformats.org/drawingml/2006/main" r:embed="R03682504381e4ac3"/>
           <a:stretch xmlns:a="http://schemas.openxmlformats.org/drawingml/2006/main"/>
         </p:blipFill>
         <p:spPr>
@@ -4877,7 +5337,7 @@
           <p:cNvPr id="16" name="">
             <a:extLst xmlns:a="http://schemas.openxmlformats.org/drawingml/2006/main">
               <a:ext uri="{FF2B5EF4-FFF2-40B4-BE49-F238E27FC236}">
-                <a16:creationId xmlns:a16="http://schemas.microsoft.com/office/drawing/2014/main" id="{12F707A1-0C27-4470-970D-D1A6DA0DA48F}"/>
+                <a16:creationId xmlns:a16="http://schemas.microsoft.com/office/drawing/2014/main" id="{1C51C999-99FE-447B-A4EA-B4CD3A30702B}"/>
               </a:ext>
             </a:extLst>
           </p:cNvPr>
@@ -4887,7 +5347,7 @@
           <p:nvPr/>
         </p:nvPicPr>
         <p:blipFill>
-          <a:blip xmlns:r="http://schemas.openxmlformats.org/officeDocument/2006/relationships" xmlns:a="http://schemas.openxmlformats.org/drawingml/2006/main" r:embed="Ra4b9800f3efd4b20"/>
+          <a:blip xmlns:r="http://schemas.openxmlformats.org/officeDocument/2006/relationships" xmlns:a="http://schemas.openxmlformats.org/drawingml/2006/main" r:embed="R8622f21e6ec64500"/>
           <a:stretch xmlns:a="http://schemas.openxmlformats.org/drawingml/2006/main"/>
         </p:blipFill>
         <p:spPr>
@@ -6277,7 +6737,7 @@
           <p:cNvPr id="29" name="">
             <a:extLst xmlns:a="http://schemas.openxmlformats.org/drawingml/2006/main">
               <a:ext uri="{FF2B5EF4-FFF2-40B4-BE49-F238E27FC236}">
-                <a16:creationId xmlns:a16="http://schemas.microsoft.com/office/drawing/2014/main" id="{BA38886D-E71E-4630-9ABF-2E68A7EB85E3}"/>
+                <a16:creationId xmlns:a16="http://schemas.microsoft.com/office/drawing/2014/main" id="{5E1C3825-BF41-49C3-B660-391D74D22269}"/>
               </a:ext>
             </a:extLst>
           </p:cNvPr>
@@ -6287,7 +6747,7 @@
           <p:nvPr/>
         </p:nvPicPr>
         <p:blipFill>
-          <a:blip xmlns:r="http://schemas.openxmlformats.org/officeDocument/2006/relationships" xmlns:a="http://schemas.openxmlformats.org/drawingml/2006/main" r:embed="R57f8b50d42f84eeb"/>
+          <a:blip xmlns:r="http://schemas.openxmlformats.org/officeDocument/2006/relationships" xmlns:a="http://schemas.openxmlformats.org/drawingml/2006/main" r:embed="R7bf7fc33c7d2452f"/>
           <a:stretch xmlns:a="http://schemas.openxmlformats.org/drawingml/2006/main"/>
         </p:blipFill>
         <p:spPr>
@@ -6334,7 +6794,7 @@
           <p:cNvPr id="3" name="">
             <a:extLst xmlns:a="http://schemas.openxmlformats.org/drawingml/2006/main">
               <a:ext uri="{FF2B5EF4-FFF2-40B4-BE49-F238E27FC236}">
-                <a16:creationId xmlns:a16="http://schemas.microsoft.com/office/drawing/2014/main" id="{F6B49CB4-0366-4C44-832F-0949C1935F26}"/>
+                <a16:creationId xmlns:a16="http://schemas.microsoft.com/office/drawing/2014/main" id="{7CD3DAD3-5385-4886-A0E5-40CBF3254DEA}"/>
               </a:ext>
             </a:extLst>
           </p:cNvPr>
@@ -6344,7 +6804,7 @@
           <p:nvPr/>
         </p:nvPicPr>
         <p:blipFill>
-          <a:blip xmlns:r="http://schemas.openxmlformats.org/officeDocument/2006/relationships" xmlns:a="http://schemas.openxmlformats.org/drawingml/2006/main" r:embed="R6e2585848e1e48f9"/>
+          <a:blip xmlns:r="http://schemas.openxmlformats.org/officeDocument/2006/relationships" xmlns:a="http://schemas.openxmlformats.org/drawingml/2006/main" r:embed="Rc6fd4b6133014af4"/>
           <a:stretch xmlns:a="http://schemas.openxmlformats.org/drawingml/2006/main"/>
         </p:blipFill>
         <p:spPr>
@@ -7603,7 +8063,7 @@
           <p:cNvPr id="15" name="">
             <a:extLst xmlns:a="http://schemas.openxmlformats.org/drawingml/2006/main">
               <a:ext uri="{FF2B5EF4-FFF2-40B4-BE49-F238E27FC236}">
-                <a16:creationId xmlns:a16="http://schemas.microsoft.com/office/drawing/2014/main" id="{6C77292F-7FAC-4660-B8C5-717FF8B86D45}"/>
+                <a16:creationId xmlns:a16="http://schemas.microsoft.com/office/drawing/2014/main" id="{F14D0DA4-1DE1-4002-8149-4DDA1991BA3F}"/>
               </a:ext>
             </a:extLst>
           </p:cNvPr>
@@ -7613,7 +8073,7 @@
           <p:nvPr/>
         </p:nvPicPr>
         <p:blipFill>
-          <a:blip xmlns:r="http://schemas.openxmlformats.org/officeDocument/2006/relationships" xmlns:a="http://schemas.openxmlformats.org/drawingml/2006/main" r:embed="R8fed1b3333a949c6"/>
+          <a:blip xmlns:r="http://schemas.openxmlformats.org/officeDocument/2006/relationships" xmlns:a="http://schemas.openxmlformats.org/drawingml/2006/main" r:embed="R02736cfe8b554a6a"/>
           <a:stretch xmlns:a="http://schemas.openxmlformats.org/drawingml/2006/main"/>
         </p:blipFill>
         <p:spPr>
@@ -7660,7 +8120,7 @@
           <p:cNvPr id="3" name="">
             <a:extLst xmlns:a="http://schemas.openxmlformats.org/drawingml/2006/main">
               <a:ext uri="{FF2B5EF4-FFF2-40B4-BE49-F238E27FC236}">
-                <a16:creationId xmlns:a16="http://schemas.microsoft.com/office/drawing/2014/main" id="{EB1D19EA-D85B-4427-8D52-037B86B5DDBC}"/>
+                <a16:creationId xmlns:a16="http://schemas.microsoft.com/office/drawing/2014/main" id="{D058BE97-DB7D-4318-90DA-C898E5BB104B}"/>
               </a:ext>
             </a:extLst>
           </p:cNvPr>
@@ -7670,7 +8130,7 @@
           <p:nvPr/>
         </p:nvPicPr>
         <p:blipFill>
-          <a:blip xmlns:r="http://schemas.openxmlformats.org/officeDocument/2006/relationships" xmlns:a="http://schemas.openxmlformats.org/drawingml/2006/main" r:embed="Rbdd7126c773c4a48"/>
+          <a:blip xmlns:r="http://schemas.openxmlformats.org/officeDocument/2006/relationships" xmlns:a="http://schemas.openxmlformats.org/drawingml/2006/main" r:embed="Racacc491cb814f3b"/>
           <a:stretch xmlns:a="http://schemas.openxmlformats.org/drawingml/2006/main"/>
         </p:blipFill>
         <p:spPr>
@@ -8598,7 +9058,7 @@
           <p:cNvPr id="14" name="">
             <a:extLst xmlns:a="http://schemas.openxmlformats.org/drawingml/2006/main">
               <a:ext uri="{FF2B5EF4-FFF2-40B4-BE49-F238E27FC236}">
-                <a16:creationId xmlns:a16="http://schemas.microsoft.com/office/drawing/2014/main" id="{6F535E07-26F0-49C8-A357-DEDD7431E403}"/>
+                <a16:creationId xmlns:a16="http://schemas.microsoft.com/office/drawing/2014/main" id="{270AE770-4FE8-483A-BDFD-3F57616B1A79}"/>
               </a:ext>
             </a:extLst>
           </p:cNvPr>
@@ -8608,7 +9068,7 @@
           <p:nvPr/>
         </p:nvPicPr>
         <p:blipFill>
-          <a:blip xmlns:r="http://schemas.openxmlformats.org/officeDocument/2006/relationships" xmlns:a="http://schemas.openxmlformats.org/drawingml/2006/main" r:embed="R575d9f9332654c99"/>
+          <a:blip xmlns:r="http://schemas.openxmlformats.org/officeDocument/2006/relationships" xmlns:a="http://schemas.openxmlformats.org/drawingml/2006/main" r:embed="R22bd137d53a0477f"/>
           <a:stretch xmlns:a="http://schemas.openxmlformats.org/drawingml/2006/main"/>
         </p:blipFill>
         <p:spPr>
@@ -8791,6 +9251,7 @@
               </a:defRPr>
             </a:defPPr>
             <a:lvl1pPr algn="l">
+              <a:buNone/>
               <a:defRPr sz="1725" b="0">
                 <a:solidFill>
                   <a:srgbClr val="D7D3CC"/>
@@ -8798,6 +9259,7 @@
               </a:defRPr>
             </a:lvl1pPr>
             <a:lvl2pPr algn="l">
+              <a:buNone/>
               <a:defRPr sz="1725" b="0">
                 <a:solidFill>
                   <a:srgbClr val="D7D3CC"/>
@@ -8805,6 +9267,7 @@
               </a:defRPr>
             </a:lvl2pPr>
             <a:lvl3pPr algn="l">
+              <a:buNone/>
               <a:defRPr sz="1725" b="0">
                 <a:solidFill>
                   <a:srgbClr val="D7D3CC"/>
@@ -8812,6 +9275,7 @@
               </a:defRPr>
             </a:lvl3pPr>
             <a:lvl4pPr algn="l">
+              <a:buNone/>
               <a:defRPr sz="1725" b="0">
                 <a:solidFill>
                   <a:srgbClr val="D7D3CC"/>
@@ -8819,6 +9283,7 @@
               </a:defRPr>
             </a:lvl4pPr>
             <a:lvl5pPr algn="l">
+              <a:buNone/>
               <a:defRPr sz="1725" b="0">
                 <a:solidFill>
                   <a:srgbClr val="D7D3CC"/>
@@ -8826,6 +9291,7 @@
               </a:defRPr>
             </a:lvl5pPr>
             <a:lvl6pPr algn="l">
+              <a:buNone/>
               <a:defRPr sz="1725" b="0">
                 <a:solidFill>
                   <a:srgbClr val="D7D3CC"/>
@@ -8833,6 +9299,7 @@
               </a:defRPr>
             </a:lvl6pPr>
             <a:lvl7pPr algn="l">
+              <a:buNone/>
               <a:defRPr sz="1725" b="0">
                 <a:solidFill>
                   <a:srgbClr val="D7D3CC"/>
@@ -8840,6 +9307,7 @@
               </a:defRPr>
             </a:lvl7pPr>
             <a:lvl8pPr algn="l">
+              <a:buNone/>
               <a:defRPr sz="1725" b="0">
                 <a:solidFill>
                   <a:srgbClr val="D7D3CC"/>
@@ -8847,6 +9315,7 @@
               </a:defRPr>
             </a:lvl8pPr>
             <a:lvl9pPr algn="l">
+              <a:buNone/>
               <a:defRPr sz="1725" b="0">
                 <a:solidFill>
                   <a:srgbClr val="D7D3CC"/>
@@ -8856,6 +9325,7 @@
           </a:lstStyle>
           <a:p xmlns:a="http://schemas.openxmlformats.org/drawingml/2006/main">
             <a:pPr algn="l">
+              <a:buNone/>
               <a:defRPr sz="1725" b="0">
                 <a:solidFill>
                   <a:srgbClr val="D7D3CC"/>
@@ -8912,6 +9382,7 @@
               </a:defRPr>
             </a:defPPr>
             <a:lvl1pPr algn="l">
+              <a:buNone/>
               <a:defRPr sz="1725" b="0">
                 <a:solidFill>
                   <a:srgbClr val="D7D3CC"/>
@@ -8919,6 +9390,7 @@
               </a:defRPr>
             </a:lvl1pPr>
             <a:lvl2pPr algn="l">
+              <a:buNone/>
               <a:defRPr sz="1725" b="0">
                 <a:solidFill>
                   <a:srgbClr val="D7D3CC"/>
@@ -8926,6 +9398,7 @@
               </a:defRPr>
             </a:lvl2pPr>
             <a:lvl3pPr algn="l">
+              <a:buNone/>
               <a:defRPr sz="1725" b="0">
                 <a:solidFill>
                   <a:srgbClr val="D7D3CC"/>
@@ -8933,6 +9406,7 @@
               </a:defRPr>
             </a:lvl3pPr>
             <a:lvl4pPr algn="l">
+              <a:buNone/>
               <a:defRPr sz="1725" b="0">
                 <a:solidFill>
                   <a:srgbClr val="D7D3CC"/>
@@ -8940,6 +9414,7 @@
               </a:defRPr>
             </a:lvl4pPr>
             <a:lvl5pPr algn="l">
+              <a:buNone/>
               <a:defRPr sz="1725" b="0">
                 <a:solidFill>
                   <a:srgbClr val="D7D3CC"/>
@@ -8947,6 +9422,7 @@
               </a:defRPr>
             </a:lvl5pPr>
             <a:lvl6pPr algn="l">
+              <a:buNone/>
               <a:defRPr sz="1725" b="0">
                 <a:solidFill>
                   <a:srgbClr val="D7D3CC"/>
@@ -8954,6 +9430,7 @@
               </a:defRPr>
             </a:lvl6pPr>
             <a:lvl7pPr algn="l">
+              <a:buNone/>
               <a:defRPr sz="1725" b="0">
                 <a:solidFill>
                   <a:srgbClr val="D7D3CC"/>
@@ -8961,6 +9438,7 @@
               </a:defRPr>
             </a:lvl7pPr>
             <a:lvl8pPr algn="l">
+              <a:buNone/>
               <a:defRPr sz="1725" b="0">
                 <a:solidFill>
                   <a:srgbClr val="D7D3CC"/>
@@ -8968,6 +9446,7 @@
               </a:defRPr>
             </a:lvl8pPr>
             <a:lvl9pPr algn="l">
+              <a:buNone/>
               <a:defRPr sz="1725" b="0">
                 <a:solidFill>
                   <a:srgbClr val="D7D3CC"/>
@@ -8977,6 +9456,7 @@
           </a:lstStyle>
           <a:p xmlns:a="http://schemas.openxmlformats.org/drawingml/2006/main">
             <a:pPr algn="l">
+              <a:buNone/>
               <a:defRPr sz="1725" b="0">
                 <a:solidFill>
                   <a:srgbClr val="D7D3CC"/>
@@ -9033,6 +9513,7 @@
               </a:defRPr>
             </a:defPPr>
             <a:lvl1pPr algn="l">
+              <a:buNone/>
               <a:defRPr sz="1725" b="0">
                 <a:solidFill>
                   <a:srgbClr val="D7D3CC"/>
@@ -9040,6 +9521,7 @@
               </a:defRPr>
             </a:lvl1pPr>
             <a:lvl2pPr algn="l">
+              <a:buNone/>
               <a:defRPr sz="1725" b="0">
                 <a:solidFill>
                   <a:srgbClr val="D7D3CC"/>
@@ -9047,6 +9529,7 @@
               </a:defRPr>
             </a:lvl2pPr>
             <a:lvl3pPr algn="l">
+              <a:buNone/>
               <a:defRPr sz="1725" b="0">
                 <a:solidFill>
                   <a:srgbClr val="D7D3CC"/>
@@ -9054,6 +9537,7 @@
               </a:defRPr>
             </a:lvl3pPr>
             <a:lvl4pPr algn="l">
+              <a:buNone/>
               <a:defRPr sz="1725" b="0">
                 <a:solidFill>
                   <a:srgbClr val="D7D3CC"/>
@@ -9061,6 +9545,7 @@
               </a:defRPr>
             </a:lvl4pPr>
             <a:lvl5pPr algn="l">
+              <a:buNone/>
               <a:defRPr sz="1725" b="0">
                 <a:solidFill>
                   <a:srgbClr val="D7D3CC"/>
@@ -9068,6 +9553,7 @@
               </a:defRPr>
             </a:lvl5pPr>
             <a:lvl6pPr algn="l">
+              <a:buNone/>
               <a:defRPr sz="1725" b="0">
                 <a:solidFill>
                   <a:srgbClr val="D7D3CC"/>
@@ -9075,6 +9561,7 @@
               </a:defRPr>
             </a:lvl6pPr>
             <a:lvl7pPr algn="l">
+              <a:buNone/>
               <a:defRPr sz="1725" b="0">
                 <a:solidFill>
                   <a:srgbClr val="D7D3CC"/>
@@ -9082,6 +9569,7 @@
               </a:defRPr>
             </a:lvl7pPr>
             <a:lvl8pPr algn="l">
+              <a:buNone/>
               <a:defRPr sz="1725" b="0">
                 <a:solidFill>
                   <a:srgbClr val="D7D3CC"/>
@@ -9089,6 +9577,7 @@
               </a:defRPr>
             </a:lvl8pPr>
             <a:lvl9pPr algn="l">
+              <a:buNone/>
               <a:defRPr sz="1725" b="0">
                 <a:solidFill>
                   <a:srgbClr val="D7D3CC"/>
@@ -9098,6 +9587,7 @@
           </a:lstStyle>
           <a:p xmlns:a="http://schemas.openxmlformats.org/drawingml/2006/main">
             <a:pPr algn="l">
+              <a:buNone/>
               <a:defRPr sz="1725" b="0">
                 <a:solidFill>
                   <a:srgbClr val="D7D3CC"/>
@@ -9149,7 +9639,7 @@
           <p:cNvPr id="3" name="">
             <a:extLst xmlns:a="http://schemas.openxmlformats.org/drawingml/2006/main">
               <a:ext uri="{FF2B5EF4-FFF2-40B4-BE49-F238E27FC236}">
-                <a16:creationId xmlns:a16="http://schemas.microsoft.com/office/drawing/2014/main" id="{6A545DBD-724D-4A6E-BE32-946E8D590EE7}"/>
+                <a16:creationId xmlns:a16="http://schemas.microsoft.com/office/drawing/2014/main" id="{209C0429-F628-4D54-8BB8-61F840500B35}"/>
               </a:ext>
             </a:extLst>
           </p:cNvPr>
@@ -9159,7 +9649,7 @@
           <p:nvPr/>
         </p:nvPicPr>
         <p:blipFill>
-          <a:blip xmlns:r="http://schemas.openxmlformats.org/officeDocument/2006/relationships" xmlns:a="http://schemas.openxmlformats.org/drawingml/2006/main" r:embed="R561556bd30504b4d"/>
+          <a:blip xmlns:r="http://schemas.openxmlformats.org/officeDocument/2006/relationships" xmlns:a="http://schemas.openxmlformats.org/drawingml/2006/main" r:embed="R2f301cc407184f82"/>
           <a:stretch xmlns:a="http://schemas.openxmlformats.org/drawingml/2006/main"/>
         </p:blipFill>
         <p:spPr>
@@ -9460,7 +9950,7 @@
                   <a:srgbClr val="231F20"/>
                 </a:solidFill>
               </a:rPr>
-              <a:t>Why I enjoy this work</a:t>
+              <a:t>Why we love this work</a:t>
             </a:r>
           </a:p>
         </p:txBody>
@@ -10118,7 +10608,7 @@
           <p:cNvPr id="15" name="">
             <a:extLst xmlns:a="http://schemas.openxmlformats.org/drawingml/2006/main">
               <a:ext uri="{FF2B5EF4-FFF2-40B4-BE49-F238E27FC236}">
-                <a16:creationId xmlns:a16="http://schemas.microsoft.com/office/drawing/2014/main" id="{36019803-70F7-4CD8-AE75-B7CC6E0F48C9}"/>
+                <a16:creationId xmlns:a16="http://schemas.microsoft.com/office/drawing/2014/main" id="{B6913B22-0235-4DF5-A331-34DAE9F22432}"/>
               </a:ext>
             </a:extLst>
           </p:cNvPr>
@@ -10128,7 +10618,7 @@
           <p:nvPr/>
         </p:nvPicPr>
         <p:blipFill>
-          <a:blip xmlns:r="http://schemas.openxmlformats.org/officeDocument/2006/relationships" xmlns:a="http://schemas.openxmlformats.org/drawingml/2006/main" r:embed="Rf330716fb49d450d"/>
+          <a:blip xmlns:r="http://schemas.openxmlformats.org/officeDocument/2006/relationships" xmlns:a="http://schemas.openxmlformats.org/drawingml/2006/main" r:embed="Rec087dc33e8d4428"/>
           <a:stretch xmlns:a="http://schemas.openxmlformats.org/drawingml/2006/main"/>
         </p:blipFill>
         <p:spPr>
@@ -10699,7 +11189,7 @@
           <p:cNvPr id="3" name="">
             <a:extLst xmlns:a="http://schemas.openxmlformats.org/drawingml/2006/main">
               <a:ext uri="{FF2B5EF4-FFF2-40B4-BE49-F238E27FC236}">
-                <a16:creationId xmlns:a16="http://schemas.microsoft.com/office/drawing/2014/main" id="{6F3E05DC-FE0A-4B36-89C6-18A4B2BD4764}"/>
+                <a16:creationId xmlns:a16="http://schemas.microsoft.com/office/drawing/2014/main" id="{86F1578E-C3AC-4F07-A0E4-80B6D66775E3}"/>
               </a:ext>
             </a:extLst>
           </p:cNvPr>
@@ -10709,7 +11199,7 @@
           <p:nvPr/>
         </p:nvPicPr>
         <p:blipFill>
-          <a:blip xmlns:r="http://schemas.openxmlformats.org/officeDocument/2006/relationships" xmlns:a="http://schemas.openxmlformats.org/drawingml/2006/main" r:embed="Re1d725d74a6f493f"/>
+          <a:blip xmlns:r="http://schemas.openxmlformats.org/officeDocument/2006/relationships" xmlns:a="http://schemas.openxmlformats.org/drawingml/2006/main" r:embed="Rf9976cc7ad3d4e7c"/>
           <a:stretch xmlns:a="http://schemas.openxmlformats.org/drawingml/2006/main"/>
         </p:blipFill>
         <p:spPr>
@@ -10727,7 +11217,7 @@
           <p:cNvPr id="10" name="">
             <a:extLst xmlns:a="http://schemas.openxmlformats.org/drawingml/2006/main">
               <a:ext uri="{FF2B5EF4-FFF2-40B4-BE49-F238E27FC236}">
-                <a16:creationId xmlns:a16="http://schemas.microsoft.com/office/drawing/2014/main" id="{D9E46664-AA91-471F-A001-835DE7AD5665}"/>
+                <a16:creationId xmlns:a16="http://schemas.microsoft.com/office/drawing/2014/main" id="{7F2CEB92-C02B-4708-9B7F-F8650DE36E3D}"/>
               </a:ext>
             </a:extLst>
           </p:cNvPr>
@@ -10737,7 +11227,7 @@
           <p:nvPr/>
         </p:nvPicPr>
         <p:blipFill>
-          <a:blip xmlns:r="http://schemas.openxmlformats.org/officeDocument/2006/relationships" xmlns:a="http://schemas.openxmlformats.org/drawingml/2006/main" r:embed="R75143a3629424d68"/>
+          <a:blip xmlns:r="http://schemas.openxmlformats.org/officeDocument/2006/relationships" xmlns:a="http://schemas.openxmlformats.org/drawingml/2006/main" r:embed="R853a1dc91ab94517"/>
           <a:stretch xmlns:a="http://schemas.openxmlformats.org/drawingml/2006/main"/>
         </p:blipFill>
         <p:spPr>
@@ -11341,7 +11831,7 @@
           <p:cNvPr id="17" name="">
             <a:extLst xmlns:a="http://schemas.openxmlformats.org/drawingml/2006/main">
               <a:ext uri="{FF2B5EF4-FFF2-40B4-BE49-F238E27FC236}">
-                <a16:creationId xmlns:a16="http://schemas.microsoft.com/office/drawing/2014/main" id="{BC07612A-E600-4F36-A6A1-E602D729E057}"/>
+                <a16:creationId xmlns:a16="http://schemas.microsoft.com/office/drawing/2014/main" id="{A5C5843C-ACC1-480C-B836-F0A1420156ED}"/>
               </a:ext>
             </a:extLst>
           </p:cNvPr>
@@ -11351,7 +11841,7 @@
           <p:nvPr/>
         </p:nvPicPr>
         <p:blipFill>
-          <a:blip xmlns:r="http://schemas.openxmlformats.org/officeDocument/2006/relationships" xmlns:a="http://schemas.openxmlformats.org/drawingml/2006/main" r:embed="R17fd586888534bc7"/>
+          <a:blip xmlns:r="http://schemas.openxmlformats.org/officeDocument/2006/relationships" xmlns:a="http://schemas.openxmlformats.org/drawingml/2006/main" r:embed="Rc50a038bfc0645d0"/>
           <a:stretch xmlns:a="http://schemas.openxmlformats.org/drawingml/2006/main"/>
         </p:blipFill>
         <p:spPr>
@@ -11398,7 +11888,7 @@
           <p:cNvPr id="3" name="">
             <a:extLst xmlns:a="http://schemas.openxmlformats.org/drawingml/2006/main">
               <a:ext uri="{FF2B5EF4-FFF2-40B4-BE49-F238E27FC236}">
-                <a16:creationId xmlns:a16="http://schemas.microsoft.com/office/drawing/2014/main" id="{082EF2CC-5CC8-42F8-8253-EDB2C4EAE16C}"/>
+                <a16:creationId xmlns:a16="http://schemas.microsoft.com/office/drawing/2014/main" id="{9417FDBF-F88C-4D66-B129-92DE44129815}"/>
               </a:ext>
             </a:extLst>
           </p:cNvPr>
@@ -11408,7 +11898,7 @@
           <p:nvPr/>
         </p:nvPicPr>
         <p:blipFill>
-          <a:blip xmlns:r="http://schemas.openxmlformats.org/officeDocument/2006/relationships" xmlns:a="http://schemas.openxmlformats.org/drawingml/2006/main" r:embed="R553278f274814667"/>
+          <a:blip xmlns:r="http://schemas.openxmlformats.org/officeDocument/2006/relationships" xmlns:a="http://schemas.openxmlformats.org/drawingml/2006/main" r:embed="R138ddc231b314744"/>
           <a:stretch xmlns:a="http://schemas.openxmlformats.org/drawingml/2006/main"/>
         </p:blipFill>
         <p:spPr>
@@ -12729,7 +13219,7 @@
           <p:cNvPr id="17" name="">
             <a:extLst xmlns:a="http://schemas.openxmlformats.org/drawingml/2006/main">
               <a:ext uri="{FF2B5EF4-FFF2-40B4-BE49-F238E27FC236}">
-                <a16:creationId xmlns:a16="http://schemas.microsoft.com/office/drawing/2014/main" id="{67797208-E55A-4430-91E1-94E9B6F52104}"/>
+                <a16:creationId xmlns:a16="http://schemas.microsoft.com/office/drawing/2014/main" id="{6B76E267-E94F-4C1D-B81D-19E8C4518F3A}"/>
               </a:ext>
             </a:extLst>
           </p:cNvPr>
@@ -12739,7 +13229,7 @@
           <p:nvPr/>
         </p:nvPicPr>
         <p:blipFill>
-          <a:blip xmlns:r="http://schemas.openxmlformats.org/officeDocument/2006/relationships" xmlns:a="http://schemas.openxmlformats.org/drawingml/2006/main" r:embed="R79aff0ccd0fe463d"/>
+          <a:blip xmlns:r="http://schemas.openxmlformats.org/officeDocument/2006/relationships" xmlns:a="http://schemas.openxmlformats.org/drawingml/2006/main" r:embed="Rd60948dc7fc148a9"/>
           <a:stretch xmlns:a="http://schemas.openxmlformats.org/drawingml/2006/main"/>
         </p:blipFill>
         <p:spPr>
@@ -12917,7 +13407,7 @@
           <p:cNvPr id="3" name="">
             <a:extLst xmlns:a="http://schemas.openxmlformats.org/drawingml/2006/main">
               <a:ext uri="{FF2B5EF4-FFF2-40B4-BE49-F238E27FC236}">
-                <a16:creationId xmlns:a16="http://schemas.microsoft.com/office/drawing/2014/main" id="{C668C342-55EB-41C3-9A22-FD7F99975460}"/>
+                <a16:creationId xmlns:a16="http://schemas.microsoft.com/office/drawing/2014/main" id="{E6B23F57-5A80-4E0A-97F3-8725C655B570}"/>
               </a:ext>
             </a:extLst>
           </p:cNvPr>
@@ -12927,7 +13417,7 @@
           <p:nvPr/>
         </p:nvPicPr>
         <p:blipFill>
-          <a:blip xmlns:r="http://schemas.openxmlformats.org/officeDocument/2006/relationships" xmlns:a="http://schemas.openxmlformats.org/drawingml/2006/main" r:embed="R9dacc05d545a4c09"/>
+          <a:blip xmlns:r="http://schemas.openxmlformats.org/officeDocument/2006/relationships" xmlns:a="http://schemas.openxmlformats.org/drawingml/2006/main" r:embed="R4a77bfccdeab46c5"/>
           <a:stretch xmlns:a="http://schemas.openxmlformats.org/drawingml/2006/main"/>
         </p:blipFill>
         <p:spPr>
@@ -13924,7 +14414,7 @@
           <p:cNvPr id="13" name="">
             <a:extLst xmlns:a="http://schemas.openxmlformats.org/drawingml/2006/main">
               <a:ext uri="{FF2B5EF4-FFF2-40B4-BE49-F238E27FC236}">
-                <a16:creationId xmlns:a16="http://schemas.microsoft.com/office/drawing/2014/main" id="{C2E76B51-BD73-4A66-A2F1-BA86187E5CA6}"/>
+                <a16:creationId xmlns:a16="http://schemas.microsoft.com/office/drawing/2014/main" id="{6749CD49-2CBD-4906-B2E3-9D34812D47B8}"/>
               </a:ext>
             </a:extLst>
           </p:cNvPr>
@@ -13934,7 +14424,7 @@
           <p:nvPr/>
         </p:nvPicPr>
         <p:blipFill>
-          <a:blip xmlns:r="http://schemas.openxmlformats.org/officeDocument/2006/relationships" xmlns:a="http://schemas.openxmlformats.org/drawingml/2006/main" r:embed="Ra1888abc0fba4758"/>
+          <a:blip xmlns:r="http://schemas.openxmlformats.org/officeDocument/2006/relationships" xmlns:a="http://schemas.openxmlformats.org/drawingml/2006/main" r:embed="Rc67ab743a4f84946"/>
           <a:stretch xmlns:a="http://schemas.openxmlformats.org/drawingml/2006/main"/>
         </p:blipFill>
         <p:spPr>
@@ -14117,6 +14607,7 @@
               </a:defRPr>
             </a:defPPr>
             <a:lvl1pPr algn="l">
+              <a:buNone/>
               <a:defRPr sz="1650" b="0">
                 <a:solidFill>
                   <a:srgbClr val="D7D3CC"/>
@@ -14124,6 +14615,7 @@
               </a:defRPr>
             </a:lvl1pPr>
             <a:lvl2pPr algn="l">
+              <a:buNone/>
               <a:defRPr sz="1650" b="0">
                 <a:solidFill>
                   <a:srgbClr val="D7D3CC"/>
@@ -14131,6 +14623,7 @@
               </a:defRPr>
             </a:lvl2pPr>
             <a:lvl3pPr algn="l">
+              <a:buNone/>
               <a:defRPr sz="1650" b="0">
                 <a:solidFill>
                   <a:srgbClr val="D7D3CC"/>
@@ -14138,6 +14631,7 @@
               </a:defRPr>
             </a:lvl3pPr>
             <a:lvl4pPr algn="l">
+              <a:buNone/>
               <a:defRPr sz="1650" b="0">
                 <a:solidFill>
                   <a:srgbClr val="D7D3CC"/>
@@ -14145,6 +14639,7 @@
               </a:defRPr>
             </a:lvl4pPr>
             <a:lvl5pPr algn="l">
+              <a:buNone/>
               <a:defRPr sz="1650" b="0">
                 <a:solidFill>
                   <a:srgbClr val="D7D3CC"/>
@@ -14152,6 +14647,7 @@
               </a:defRPr>
             </a:lvl5pPr>
             <a:lvl6pPr algn="l">
+              <a:buNone/>
               <a:defRPr sz="1650" b="0">
                 <a:solidFill>
                   <a:srgbClr val="D7D3CC"/>
@@ -14159,6 +14655,7 @@
               </a:defRPr>
             </a:lvl6pPr>
             <a:lvl7pPr algn="l">
+              <a:buNone/>
               <a:defRPr sz="1650" b="0">
                 <a:solidFill>
                   <a:srgbClr val="D7D3CC"/>
@@ -14166,6 +14663,7 @@
               </a:defRPr>
             </a:lvl7pPr>
             <a:lvl8pPr algn="l">
+              <a:buNone/>
               <a:defRPr sz="1650" b="0">
                 <a:solidFill>
                   <a:srgbClr val="D7D3CC"/>
@@ -14173,6 +14671,7 @@
               </a:defRPr>
             </a:lvl8pPr>
             <a:lvl9pPr algn="l">
+              <a:buNone/>
               <a:defRPr sz="1650" b="0">
                 <a:solidFill>
                   <a:srgbClr val="D7D3CC"/>
@@ -14182,6 +14681,7 @@
           </a:lstStyle>
           <a:p xmlns:a="http://schemas.openxmlformats.org/drawingml/2006/main">
             <a:pPr algn="l">
+              <a:buNone/>
               <a:defRPr sz="1650" b="0">
                 <a:solidFill>
                   <a:srgbClr val="D7D3CC"/>
@@ -14238,6 +14738,7 @@
               </a:defRPr>
             </a:defPPr>
             <a:lvl1pPr algn="l">
+              <a:buNone/>
               <a:defRPr sz="1650" b="0">
                 <a:solidFill>
                   <a:srgbClr val="D7D3CC"/>
@@ -14245,6 +14746,7 @@
               </a:defRPr>
             </a:lvl1pPr>
             <a:lvl2pPr algn="l">
+              <a:buNone/>
               <a:defRPr sz="1650" b="0">
                 <a:solidFill>
                   <a:srgbClr val="D7D3CC"/>
@@ -14252,6 +14754,7 @@
               </a:defRPr>
             </a:lvl2pPr>
             <a:lvl3pPr algn="l">
+              <a:buNone/>
               <a:defRPr sz="1650" b="0">
                 <a:solidFill>
                   <a:srgbClr val="D7D3CC"/>
@@ -14259,6 +14762,7 @@
               </a:defRPr>
             </a:lvl3pPr>
             <a:lvl4pPr algn="l">
+              <a:buNone/>
               <a:defRPr sz="1650" b="0">
                 <a:solidFill>
                   <a:srgbClr val="D7D3CC"/>
@@ -14266,6 +14770,7 @@
               </a:defRPr>
             </a:lvl4pPr>
             <a:lvl5pPr algn="l">
+              <a:buNone/>
               <a:defRPr sz="1650" b="0">
                 <a:solidFill>
                   <a:srgbClr val="D7D3CC"/>
@@ -14273,6 +14778,7 @@
               </a:defRPr>
             </a:lvl5pPr>
             <a:lvl6pPr algn="l">
+              <a:buNone/>
               <a:defRPr sz="1650" b="0">
                 <a:solidFill>
                   <a:srgbClr val="D7D3CC"/>
@@ -14280,6 +14786,7 @@
               </a:defRPr>
             </a:lvl6pPr>
             <a:lvl7pPr algn="l">
+              <a:buNone/>
               <a:defRPr sz="1650" b="0">
                 <a:solidFill>
                   <a:srgbClr val="D7D3CC"/>
@@ -14287,6 +14794,7 @@
               </a:defRPr>
             </a:lvl7pPr>
             <a:lvl8pPr algn="l">
+              <a:buNone/>
               <a:defRPr sz="1650" b="0">
                 <a:solidFill>
                   <a:srgbClr val="D7D3CC"/>
@@ -14294,6 +14802,7 @@
               </a:defRPr>
             </a:lvl8pPr>
             <a:lvl9pPr algn="l">
+              <a:buNone/>
               <a:defRPr sz="1650" b="0">
                 <a:solidFill>
                   <a:srgbClr val="D7D3CC"/>
@@ -14303,6 +14812,7 @@
           </a:lstStyle>
           <a:p xmlns:a="http://schemas.openxmlformats.org/drawingml/2006/main">
             <a:pPr algn="l">
+              <a:buNone/>
               <a:defRPr sz="1650" b="0">
                 <a:solidFill>
                   <a:srgbClr val="D7D3CC"/>
@@ -14359,6 +14869,7 @@
               </a:defRPr>
             </a:defPPr>
             <a:lvl1pPr algn="l">
+              <a:buNone/>
               <a:defRPr sz="1650" b="0">
                 <a:solidFill>
                   <a:srgbClr val="D7D3CC"/>
@@ -14366,6 +14877,7 @@
               </a:defRPr>
             </a:lvl1pPr>
             <a:lvl2pPr algn="l">
+              <a:buNone/>
               <a:defRPr sz="1650" b="0">
                 <a:solidFill>
                   <a:srgbClr val="D7D3CC"/>
@@ -14373,6 +14885,7 @@
               </a:defRPr>
             </a:lvl2pPr>
             <a:lvl3pPr algn="l">
+              <a:buNone/>
               <a:defRPr sz="1650" b="0">
                 <a:solidFill>
                   <a:srgbClr val="D7D3CC"/>
@@ -14380,6 +14893,7 @@
               </a:defRPr>
             </a:lvl3pPr>
             <a:lvl4pPr algn="l">
+              <a:buNone/>
               <a:defRPr sz="1650" b="0">
                 <a:solidFill>
                   <a:srgbClr val="D7D3CC"/>
@@ -14387,6 +14901,7 @@
               </a:defRPr>
             </a:lvl4pPr>
             <a:lvl5pPr algn="l">
+              <a:buNone/>
               <a:defRPr sz="1650" b="0">
                 <a:solidFill>
                   <a:srgbClr val="D7D3CC"/>
@@ -14394,6 +14909,7 @@
               </a:defRPr>
             </a:lvl5pPr>
             <a:lvl6pPr algn="l">
+              <a:buNone/>
               <a:defRPr sz="1650" b="0">
                 <a:solidFill>
                   <a:srgbClr val="D7D3CC"/>
@@ -14401,6 +14917,7 @@
               </a:defRPr>
             </a:lvl6pPr>
             <a:lvl7pPr algn="l">
+              <a:buNone/>
               <a:defRPr sz="1650" b="0">
                 <a:solidFill>
                   <a:srgbClr val="D7D3CC"/>
@@ -14408,6 +14925,7 @@
               </a:defRPr>
             </a:lvl7pPr>
             <a:lvl8pPr algn="l">
+              <a:buNone/>
               <a:defRPr sz="1650" b="0">
                 <a:solidFill>
                   <a:srgbClr val="D7D3CC"/>
@@ -14415,6 +14933,7 @@
               </a:defRPr>
             </a:lvl8pPr>
             <a:lvl9pPr algn="l">
+              <a:buNone/>
               <a:defRPr sz="1650" b="0">
                 <a:solidFill>
                   <a:srgbClr val="D7D3CC"/>
@@ -14424,6 +14943,7 @@
           </a:lstStyle>
           <a:p xmlns:a="http://schemas.openxmlformats.org/drawingml/2006/main">
             <a:pPr algn="l">
+              <a:buNone/>
               <a:defRPr sz="1650" b="0">
                 <a:solidFill>
                   <a:srgbClr val="D7D3CC"/>
@@ -14480,6 +15000,7 @@
               </a:defRPr>
             </a:defPPr>
             <a:lvl1pPr algn="l">
+              <a:buNone/>
               <a:defRPr sz="1650" b="0">
                 <a:solidFill>
                   <a:srgbClr val="D7D3CC"/>
@@ -14487,6 +15008,7 @@
               </a:defRPr>
             </a:lvl1pPr>
             <a:lvl2pPr algn="l">
+              <a:buNone/>
               <a:defRPr sz="1650" b="0">
                 <a:solidFill>
                   <a:srgbClr val="D7D3CC"/>
@@ -14494,6 +15016,7 @@
               </a:defRPr>
             </a:lvl2pPr>
             <a:lvl3pPr algn="l">
+              <a:buNone/>
               <a:defRPr sz="1650" b="0">
                 <a:solidFill>
                   <a:srgbClr val="D7D3CC"/>
@@ -14501,6 +15024,7 @@
               </a:defRPr>
             </a:lvl3pPr>
             <a:lvl4pPr algn="l">
+              <a:buNone/>
               <a:defRPr sz="1650" b="0">
                 <a:solidFill>
                   <a:srgbClr val="D7D3CC"/>
@@ -14508,6 +15032,7 @@
               </a:defRPr>
             </a:lvl4pPr>
             <a:lvl5pPr algn="l">
+              <a:buNone/>
               <a:defRPr sz="1650" b="0">
                 <a:solidFill>
                   <a:srgbClr val="D7D3CC"/>
@@ -14515,6 +15040,7 @@
               </a:defRPr>
             </a:lvl5pPr>
             <a:lvl6pPr algn="l">
+              <a:buNone/>
               <a:defRPr sz="1650" b="0">
                 <a:solidFill>
                   <a:srgbClr val="D7D3CC"/>
@@ -14522,6 +15048,7 @@
               </a:defRPr>
             </a:lvl6pPr>
             <a:lvl7pPr algn="l">
+              <a:buNone/>
               <a:defRPr sz="1650" b="0">
                 <a:solidFill>
                   <a:srgbClr val="D7D3CC"/>
@@ -14529,6 +15056,7 @@
               </a:defRPr>
             </a:lvl7pPr>
             <a:lvl8pPr algn="l">
+              <a:buNone/>
               <a:defRPr sz="1650" b="0">
                 <a:solidFill>
                   <a:srgbClr val="D7D3CC"/>
@@ -14536,6 +15064,7 @@
               </a:defRPr>
             </a:lvl8pPr>
             <a:lvl9pPr algn="l">
+              <a:buNone/>
               <a:defRPr sz="1650" b="0">
                 <a:solidFill>
                   <a:srgbClr val="D7D3CC"/>
@@ -14545,6 +15074,7 @@
           </a:lstStyle>
           <a:p xmlns:a="http://schemas.openxmlformats.org/drawingml/2006/main">
             <a:pPr algn="l">
+              <a:buNone/>
               <a:defRPr sz="1650" b="0">
                 <a:solidFill>
                   <a:srgbClr val="D7D3CC"/>
@@ -14596,7 +15126,7 @@
           <p:cNvPr id="3" name="">
             <a:extLst xmlns:a="http://schemas.openxmlformats.org/drawingml/2006/main">
               <a:ext uri="{FF2B5EF4-FFF2-40B4-BE49-F238E27FC236}">
-                <a16:creationId xmlns:a16="http://schemas.microsoft.com/office/drawing/2014/main" id="{88E4EB51-04ED-45A7-B24F-400FA6B6A9EB}"/>
+                <a16:creationId xmlns:a16="http://schemas.microsoft.com/office/drawing/2014/main" id="{71E520C8-8C4D-438F-A7F2-D5CE5E3ECF1E}"/>
               </a:ext>
             </a:extLst>
           </p:cNvPr>
@@ -14606,7 +15136,7 @@
           <p:nvPr/>
         </p:nvPicPr>
         <p:blipFill>
-          <a:blip xmlns:r="http://schemas.openxmlformats.org/officeDocument/2006/relationships" xmlns:a="http://schemas.openxmlformats.org/drawingml/2006/main" r:embed="R76284aa954554cd5"/>
+          <a:blip xmlns:r="http://schemas.openxmlformats.org/officeDocument/2006/relationships" xmlns:a="http://schemas.openxmlformats.org/drawingml/2006/main" r:embed="R0c1dae8ebf3440f6"/>
           <a:stretch xmlns:a="http://schemas.openxmlformats.org/drawingml/2006/main"/>
         </p:blipFill>
         <p:spPr>
@@ -14624,7 +15154,7 @@
           <p:cNvPr id="7" name="">
             <a:extLst xmlns:a="http://schemas.openxmlformats.org/drawingml/2006/main">
               <a:ext uri="{FF2B5EF4-FFF2-40B4-BE49-F238E27FC236}">
-                <a16:creationId xmlns:a16="http://schemas.microsoft.com/office/drawing/2014/main" id="{535D5003-4151-429B-9D5A-A806D1215394}"/>
+                <a16:creationId xmlns:a16="http://schemas.microsoft.com/office/drawing/2014/main" id="{1A4FE53C-1958-4FDA-93AB-6938617A3F46}"/>
               </a:ext>
             </a:extLst>
           </p:cNvPr>
@@ -14634,7 +15164,7 @@
           <p:nvPr/>
         </p:nvPicPr>
         <p:blipFill>
-          <a:blip xmlns:r="http://schemas.openxmlformats.org/officeDocument/2006/relationships" xmlns:a="http://schemas.openxmlformats.org/drawingml/2006/main" r:embed="R6b1a45c0f47b4bf2"/>
+          <a:blip xmlns:r="http://schemas.openxmlformats.org/officeDocument/2006/relationships" xmlns:a="http://schemas.openxmlformats.org/drawingml/2006/main" r:embed="Ra48562c9dbe0424d"/>
           <a:stretch xmlns:a="http://schemas.openxmlformats.org/drawingml/2006/main"/>
         </p:blipFill>
         <p:spPr>
@@ -15469,7 +15999,7 @@
           <p:cNvPr id="15" name="">
             <a:extLst xmlns:a="http://schemas.openxmlformats.org/drawingml/2006/main">
               <a:ext uri="{FF2B5EF4-FFF2-40B4-BE49-F238E27FC236}">
-                <a16:creationId xmlns:a16="http://schemas.microsoft.com/office/drawing/2014/main" id="{29E817CA-5F6F-4803-B832-DAD3488AC9A4}"/>
+                <a16:creationId xmlns:a16="http://schemas.microsoft.com/office/drawing/2014/main" id="{D6140392-CB90-4763-85D6-EA42DBE189CA}"/>
               </a:ext>
             </a:extLst>
           </p:cNvPr>
@@ -15479,7 +16009,7 @@
           <p:nvPr/>
         </p:nvPicPr>
         <p:blipFill>
-          <a:blip xmlns:r="http://schemas.openxmlformats.org/officeDocument/2006/relationships" xmlns:a="http://schemas.openxmlformats.org/drawingml/2006/main" r:embed="Rd2ada5a333d8496d"/>
+          <a:blip xmlns:r="http://schemas.openxmlformats.org/officeDocument/2006/relationships" xmlns:a="http://schemas.openxmlformats.org/drawingml/2006/main" r:embed="Ra7213ef0b843400c"/>
           <a:stretch xmlns:a="http://schemas.openxmlformats.org/drawingml/2006/main"/>
         </p:blipFill>
         <p:spPr>
@@ -15591,6 +16121,7 @@
               </a:defRPr>
             </a:defPPr>
             <a:lvl1pPr algn="l">
+              <a:buNone/>
               <a:defRPr sz="1125" b="0">
                 <a:solidFill>
                   <a:srgbClr val="FFFFFF"/>
@@ -15598,6 +16129,7 @@
               </a:defRPr>
             </a:lvl1pPr>
             <a:lvl2pPr algn="l">
+              <a:buNone/>
               <a:defRPr sz="1125" b="0">
                 <a:solidFill>
                   <a:srgbClr val="FFFFFF"/>
@@ -15605,6 +16137,7 @@
               </a:defRPr>
             </a:lvl2pPr>
             <a:lvl3pPr algn="l">
+              <a:buNone/>
               <a:defRPr sz="1125" b="0">
                 <a:solidFill>
                   <a:srgbClr val="FFFFFF"/>
@@ -15612,6 +16145,7 @@
               </a:defRPr>
             </a:lvl3pPr>
             <a:lvl4pPr algn="l">
+              <a:buNone/>
               <a:defRPr sz="1125" b="0">
                 <a:solidFill>
                   <a:srgbClr val="FFFFFF"/>
@@ -15619,6 +16153,7 @@
               </a:defRPr>
             </a:lvl4pPr>
             <a:lvl5pPr algn="l">
+              <a:buNone/>
               <a:defRPr sz="1125" b="0">
                 <a:solidFill>
                   <a:srgbClr val="FFFFFF"/>
@@ -15626,6 +16161,7 @@
               </a:defRPr>
             </a:lvl5pPr>
             <a:lvl6pPr algn="l">
+              <a:buNone/>
               <a:defRPr sz="1125" b="0">
                 <a:solidFill>
                   <a:srgbClr val="FFFFFF"/>
@@ -15633,6 +16169,7 @@
               </a:defRPr>
             </a:lvl6pPr>
             <a:lvl7pPr algn="l">
+              <a:buNone/>
               <a:defRPr sz="1125" b="0">
                 <a:solidFill>
                   <a:srgbClr val="FFFFFF"/>
@@ -15640,6 +16177,7 @@
               </a:defRPr>
             </a:lvl7pPr>
             <a:lvl8pPr algn="l">
+              <a:buNone/>
               <a:defRPr sz="1125" b="0">
                 <a:solidFill>
                   <a:srgbClr val="FFFFFF"/>
@@ -15647,6 +16185,7 @@
               </a:defRPr>
             </a:lvl8pPr>
             <a:lvl9pPr algn="l">
+              <a:buNone/>
               <a:defRPr sz="1125" b="0">
                 <a:solidFill>
                   <a:srgbClr val="FFFFFF"/>
@@ -15656,6 +16195,7 @@
           </a:lstStyle>
           <a:p xmlns:a="http://schemas.openxmlformats.org/drawingml/2006/main">
             <a:pPr algn="l">
+              <a:buNone/>
               <a:defRPr sz="1125" b="0">
                 <a:solidFill>
                   <a:srgbClr val="FFFFFF"/>
@@ -15678,7 +16218,7 @@
           <p:cNvPr id="3" name="">
             <a:extLst xmlns:a="http://schemas.openxmlformats.org/drawingml/2006/main">
               <a:ext uri="{FF2B5EF4-FFF2-40B4-BE49-F238E27FC236}">
-                <a16:creationId xmlns:a16="http://schemas.microsoft.com/office/drawing/2014/main" id="{D146774B-1DBD-4D24-A987-4C41EF707E14}"/>
+                <a16:creationId xmlns:a16="http://schemas.microsoft.com/office/drawing/2014/main" id="{DFC6D5DE-13E6-4C65-A203-C61C10439FDB}"/>
               </a:ext>
             </a:extLst>
           </p:cNvPr>
@@ -15688,7 +16228,7 @@
           <p:nvPr/>
         </p:nvPicPr>
         <p:blipFill>
-          <a:blip xmlns:r="http://schemas.openxmlformats.org/officeDocument/2006/relationships" xmlns:a="http://schemas.openxmlformats.org/drawingml/2006/main" r:embed="Recac151791b34662"/>
+          <a:blip xmlns:r="http://schemas.openxmlformats.org/officeDocument/2006/relationships" xmlns:a="http://schemas.openxmlformats.org/drawingml/2006/main" r:embed="Rd00defa0ae1b4289"/>
           <a:stretch xmlns:a="http://schemas.openxmlformats.org/drawingml/2006/main"/>
         </p:blipFill>
         <p:spPr>
@@ -15740,6 +16280,7 @@
               </a:defRPr>
             </a:defPPr>
             <a:lvl1pPr algn="l">
+              <a:buNone/>
               <a:defRPr sz="3750" b="1">
                 <a:solidFill>
                   <a:srgbClr val="FFFFFF"/>
@@ -15747,6 +16288,7 @@
               </a:defRPr>
             </a:lvl1pPr>
             <a:lvl2pPr algn="l">
+              <a:buNone/>
               <a:defRPr sz="3750" b="1">
                 <a:solidFill>
                   <a:srgbClr val="FFFFFF"/>
@@ -15754,6 +16296,7 @@
               </a:defRPr>
             </a:lvl2pPr>
             <a:lvl3pPr algn="l">
+              <a:buNone/>
               <a:defRPr sz="3750" b="1">
                 <a:solidFill>
                   <a:srgbClr val="FFFFFF"/>
@@ -15761,6 +16304,7 @@
               </a:defRPr>
             </a:lvl3pPr>
             <a:lvl4pPr algn="l">
+              <a:buNone/>
               <a:defRPr sz="3750" b="1">
                 <a:solidFill>
                   <a:srgbClr val="FFFFFF"/>
@@ -15768,6 +16312,7 @@
               </a:defRPr>
             </a:lvl4pPr>
             <a:lvl5pPr algn="l">
+              <a:buNone/>
               <a:defRPr sz="3750" b="1">
                 <a:solidFill>
                   <a:srgbClr val="FFFFFF"/>
@@ -15775,6 +16320,7 @@
               </a:defRPr>
             </a:lvl5pPr>
             <a:lvl6pPr algn="l">
+              <a:buNone/>
               <a:defRPr sz="3750" b="1">
                 <a:solidFill>
                   <a:srgbClr val="FFFFFF"/>
@@ -15782,6 +16328,7 @@
               </a:defRPr>
             </a:lvl6pPr>
             <a:lvl7pPr algn="l">
+              <a:buNone/>
               <a:defRPr sz="3750" b="1">
                 <a:solidFill>
                   <a:srgbClr val="FFFFFF"/>
@@ -15789,6 +16336,7 @@
               </a:defRPr>
             </a:lvl7pPr>
             <a:lvl8pPr algn="l">
+              <a:buNone/>
               <a:defRPr sz="3750" b="1">
                 <a:solidFill>
                   <a:srgbClr val="FFFFFF"/>
@@ -15796,6 +16344,7 @@
               </a:defRPr>
             </a:lvl8pPr>
             <a:lvl9pPr algn="l">
+              <a:buNone/>
               <a:defRPr sz="3750" b="1">
                 <a:solidFill>
                   <a:srgbClr val="FFFFFF"/>
@@ -15805,6 +16354,7 @@
           </a:lstStyle>
           <a:p xmlns:a="http://schemas.openxmlformats.org/drawingml/2006/main">
             <a:pPr algn="l">
+              <a:buNone/>
               <a:defRPr sz="3750" b="1">
                 <a:solidFill>
                   <a:srgbClr val="FFFFFF"/>
@@ -15861,6 +16411,7 @@
               </a:defRPr>
             </a:defPPr>
             <a:lvl1pPr algn="l">
+              <a:buNone/>
               <a:defRPr sz="1725" b="1">
                 <a:solidFill>
                   <a:srgbClr val="B89B68"/>
@@ -15868,6 +16419,7 @@
               </a:defRPr>
             </a:lvl1pPr>
             <a:lvl2pPr algn="l">
+              <a:buNone/>
               <a:defRPr sz="1725" b="1">
                 <a:solidFill>
                   <a:srgbClr val="B89B68"/>
@@ -15875,6 +16427,7 @@
               </a:defRPr>
             </a:lvl2pPr>
             <a:lvl3pPr algn="l">
+              <a:buNone/>
               <a:defRPr sz="1725" b="1">
                 <a:solidFill>
                   <a:srgbClr val="B89B68"/>
@@ -15882,6 +16435,7 @@
               </a:defRPr>
             </a:lvl3pPr>
             <a:lvl4pPr algn="l">
+              <a:buNone/>
               <a:defRPr sz="1725" b="1">
                 <a:solidFill>
                   <a:srgbClr val="B89B68"/>
@@ -15889,6 +16443,7 @@
               </a:defRPr>
             </a:lvl4pPr>
             <a:lvl5pPr algn="l">
+              <a:buNone/>
               <a:defRPr sz="1725" b="1">
                 <a:solidFill>
                   <a:srgbClr val="B89B68"/>
@@ -15896,6 +16451,7 @@
               </a:defRPr>
             </a:lvl5pPr>
             <a:lvl6pPr algn="l">
+              <a:buNone/>
               <a:defRPr sz="1725" b="1">
                 <a:solidFill>
                   <a:srgbClr val="B89B68"/>
@@ -15903,6 +16459,7 @@
               </a:defRPr>
             </a:lvl6pPr>
             <a:lvl7pPr algn="l">
+              <a:buNone/>
               <a:defRPr sz="1725" b="1">
                 <a:solidFill>
                   <a:srgbClr val="B89B68"/>
@@ -15910,6 +16467,7 @@
               </a:defRPr>
             </a:lvl7pPr>
             <a:lvl8pPr algn="l">
+              <a:buNone/>
               <a:defRPr sz="1725" b="1">
                 <a:solidFill>
                   <a:srgbClr val="B89B68"/>
@@ -15917,6 +16475,7 @@
               </a:defRPr>
             </a:lvl8pPr>
             <a:lvl9pPr algn="l">
+              <a:buNone/>
               <a:defRPr sz="1725" b="1">
                 <a:solidFill>
                   <a:srgbClr val="B89B68"/>
@@ -15926,6 +16485,7 @@
           </a:lstStyle>
           <a:p xmlns:a="http://schemas.openxmlformats.org/drawingml/2006/main">
             <a:pPr algn="l">
+              <a:buNone/>
               <a:defRPr sz="1725" b="1">
                 <a:solidFill>
                   <a:srgbClr val="B89B68"/>
@@ -15982,6 +16542,7 @@
               </a:defRPr>
             </a:defPPr>
             <a:lvl1pPr algn="l">
+              <a:buNone/>
               <a:defRPr sz="4200" b="1">
                 <a:solidFill>
                   <a:srgbClr val="FFFFFF"/>
@@ -15989,6 +16550,7 @@
               </a:defRPr>
             </a:lvl1pPr>
             <a:lvl2pPr algn="l">
+              <a:buNone/>
               <a:defRPr sz="4200" b="1">
                 <a:solidFill>
                   <a:srgbClr val="FFFFFF"/>
@@ -15996,6 +16558,7 @@
               </a:defRPr>
             </a:lvl2pPr>
             <a:lvl3pPr algn="l">
+              <a:buNone/>
               <a:defRPr sz="4200" b="1">
                 <a:solidFill>
                   <a:srgbClr val="FFFFFF"/>
@@ -16003,6 +16566,7 @@
               </a:defRPr>
             </a:lvl3pPr>
             <a:lvl4pPr algn="l">
+              <a:buNone/>
               <a:defRPr sz="4200" b="1">
                 <a:solidFill>
                   <a:srgbClr val="FFFFFF"/>
@@ -16010,6 +16574,7 @@
               </a:defRPr>
             </a:lvl4pPr>
             <a:lvl5pPr algn="l">
+              <a:buNone/>
               <a:defRPr sz="4200" b="1">
                 <a:solidFill>
                   <a:srgbClr val="FFFFFF"/>
@@ -16017,6 +16582,7 @@
               </a:defRPr>
             </a:lvl5pPr>
             <a:lvl6pPr algn="l">
+              <a:buNone/>
               <a:defRPr sz="4200" b="1">
                 <a:solidFill>
                   <a:srgbClr val="FFFFFF"/>
@@ -16024,6 +16590,7 @@
               </a:defRPr>
             </a:lvl6pPr>
             <a:lvl7pPr algn="l">
+              <a:buNone/>
               <a:defRPr sz="4200" b="1">
                 <a:solidFill>
                   <a:srgbClr val="FFFFFF"/>
@@ -16031,6 +16598,7 @@
               </a:defRPr>
             </a:lvl7pPr>
             <a:lvl8pPr algn="l">
+              <a:buNone/>
               <a:defRPr sz="4200" b="1">
                 <a:solidFill>
                   <a:srgbClr val="FFFFFF"/>
@@ -16038,6 +16606,7 @@
               </a:defRPr>
             </a:lvl8pPr>
             <a:lvl9pPr algn="l">
+              <a:buNone/>
               <a:defRPr sz="4200" b="1">
                 <a:solidFill>
                   <a:srgbClr val="FFFFFF"/>
@@ -16047,6 +16616,7 @@
           </a:lstStyle>
           <a:p xmlns:a="http://schemas.openxmlformats.org/drawingml/2006/main">
             <a:pPr algn="l">
+              <a:buNone/>
               <a:defRPr sz="4200" b="1">
                 <a:solidFill>
                   <a:srgbClr val="FFFFFF"/>
@@ -16134,6 +16704,7 @@
               </a:defRPr>
             </a:defPPr>
             <a:lvl1pPr algn="l">
+              <a:buNone/>
               <a:defRPr sz="2475" b="0">
                 <a:solidFill>
                   <a:srgbClr val="D7D3CC"/>
@@ -16141,6 +16712,7 @@
               </a:defRPr>
             </a:lvl1pPr>
             <a:lvl2pPr algn="l">
+              <a:buNone/>
               <a:defRPr sz="2475" b="0">
                 <a:solidFill>
                   <a:srgbClr val="D7D3CC"/>
@@ -16148,6 +16720,7 @@
               </a:defRPr>
             </a:lvl2pPr>
             <a:lvl3pPr algn="l">
+              <a:buNone/>
               <a:defRPr sz="2475" b="0">
                 <a:solidFill>
                   <a:srgbClr val="D7D3CC"/>
@@ -16155,6 +16728,7 @@
               </a:defRPr>
             </a:lvl3pPr>
             <a:lvl4pPr algn="l">
+              <a:buNone/>
               <a:defRPr sz="2475" b="0">
                 <a:solidFill>
                   <a:srgbClr val="D7D3CC"/>
@@ -16162,6 +16736,7 @@
               </a:defRPr>
             </a:lvl4pPr>
             <a:lvl5pPr algn="l">
+              <a:buNone/>
               <a:defRPr sz="2475" b="0">
                 <a:solidFill>
                   <a:srgbClr val="D7D3CC"/>
@@ -16169,6 +16744,7 @@
               </a:defRPr>
             </a:lvl5pPr>
             <a:lvl6pPr algn="l">
+              <a:buNone/>
               <a:defRPr sz="2475" b="0">
                 <a:solidFill>
                   <a:srgbClr val="D7D3CC"/>
@@ -16176,6 +16752,7 @@
               </a:defRPr>
             </a:lvl6pPr>
             <a:lvl7pPr algn="l">
+              <a:buNone/>
               <a:defRPr sz="2475" b="0">
                 <a:solidFill>
                   <a:srgbClr val="D7D3CC"/>
@@ -16183,6 +16760,7 @@
               </a:defRPr>
             </a:lvl7pPr>
             <a:lvl8pPr algn="l">
+              <a:buNone/>
               <a:defRPr sz="2475" b="0">
                 <a:solidFill>
                   <a:srgbClr val="D7D3CC"/>
@@ -16190,6 +16768,7 @@
               </a:defRPr>
             </a:lvl8pPr>
             <a:lvl9pPr algn="l">
+              <a:buNone/>
               <a:defRPr sz="2475" b="0">
                 <a:solidFill>
                   <a:srgbClr val="D7D3CC"/>
@@ -16199,6 +16778,7 @@
           </a:lstStyle>
           <a:p xmlns:a="http://schemas.openxmlformats.org/drawingml/2006/main">
             <a:pPr algn="l">
+              <a:buNone/>
               <a:defRPr sz="2475" b="0">
                 <a:solidFill>
                   <a:srgbClr val="D7D3CC"/>
@@ -16255,6 +16835,7 @@
               </a:defRPr>
             </a:defPPr>
             <a:lvl1pPr algn="l">
+              <a:buNone/>
               <a:defRPr sz="2550" b="1">
                 <a:solidFill>
                   <a:srgbClr val="B89B68"/>
@@ -16262,6 +16843,7 @@
               </a:defRPr>
             </a:lvl1pPr>
             <a:lvl2pPr algn="l">
+              <a:buNone/>
               <a:defRPr sz="2550" b="1">
                 <a:solidFill>
                   <a:srgbClr val="B89B68"/>
@@ -16269,6 +16851,7 @@
               </a:defRPr>
             </a:lvl2pPr>
             <a:lvl3pPr algn="l">
+              <a:buNone/>
               <a:defRPr sz="2550" b="1">
                 <a:solidFill>
                   <a:srgbClr val="B89B68"/>
@@ -16276,6 +16859,7 @@
               </a:defRPr>
             </a:lvl3pPr>
             <a:lvl4pPr algn="l">
+              <a:buNone/>
               <a:defRPr sz="2550" b="1">
                 <a:solidFill>
                   <a:srgbClr val="B89B68"/>
@@ -16283,6 +16867,7 @@
               </a:defRPr>
             </a:lvl4pPr>
             <a:lvl5pPr algn="l">
+              <a:buNone/>
               <a:defRPr sz="2550" b="1">
                 <a:solidFill>
                   <a:srgbClr val="B89B68"/>
@@ -16290,6 +16875,7 @@
               </a:defRPr>
             </a:lvl5pPr>
             <a:lvl6pPr algn="l">
+              <a:buNone/>
               <a:defRPr sz="2550" b="1">
                 <a:solidFill>
                   <a:srgbClr val="B89B68"/>
@@ -16297,6 +16883,7 @@
               </a:defRPr>
             </a:lvl6pPr>
             <a:lvl7pPr algn="l">
+              <a:buNone/>
               <a:defRPr sz="2550" b="1">
                 <a:solidFill>
                   <a:srgbClr val="B89B68"/>
@@ -16304,6 +16891,7 @@
               </a:defRPr>
             </a:lvl7pPr>
             <a:lvl8pPr algn="l">
+              <a:buNone/>
               <a:defRPr sz="2550" b="1">
                 <a:solidFill>
                   <a:srgbClr val="B89B68"/>
@@ -16311,6 +16899,7 @@
               </a:defRPr>
             </a:lvl8pPr>
             <a:lvl9pPr algn="l">
+              <a:buNone/>
               <a:defRPr sz="2550" b="1">
                 <a:solidFill>
                   <a:srgbClr val="B89B68"/>
@@ -16320,6 +16909,7 @@
           </a:lstStyle>
           <a:p xmlns:a="http://schemas.openxmlformats.org/drawingml/2006/main">
             <a:pPr algn="l">
+              <a:buNone/>
               <a:defRPr sz="2550" b="1">
                 <a:solidFill>
                   <a:srgbClr val="B89B68"/>

</xml_diff>

<commit_message>
Add co-presenter speech and Wesley speaking cues
</commit_message>
<xml_diff>
--- a/docs/presentation/Engineering_at_The_Kinetic_Group.pptx
+++ b/docs/presentation/Engineering_at_The_Kinetic_Group.pptx
@@ -2,22 +2,22 @@
 <file path=ppt/presentation.xml><?xml version="1.0" encoding="utf-8"?>
 <p:presentation xmlns:p="http://schemas.openxmlformats.org/presentationml/2006/main">
   <p:sldMasterIdLst>
-    <p:sldMasterId xmlns:r="http://schemas.openxmlformats.org/officeDocument/2006/relationships" id="2147483648" r:id="Rede46759d1c74068"/>
+    <p:sldMasterId xmlns:r="http://schemas.openxmlformats.org/officeDocument/2006/relationships" id="2147483648" r:id="Rb5a6074cd6c748a1"/>
   </p:sldMasterIdLst>
   <p:notesMasterIdLst>
-    <p:notesMasterId xmlns:r="http://schemas.openxmlformats.org/officeDocument/2006/relationships" r:id="Ref95a56e606341cf"/>
+    <p:notesMasterId xmlns:r="http://schemas.openxmlformats.org/officeDocument/2006/relationships" r:id="Raeeeb5f1dfa04a99"/>
   </p:notesMasterIdLst>
   <p:sldIdLst>
-    <p:sldId xmlns:r="http://schemas.openxmlformats.org/officeDocument/2006/relationships" id="256" r:id="R40d72490408047b6"/>
-    <p:sldId xmlns:r="http://schemas.openxmlformats.org/officeDocument/2006/relationships" id="257" r:id="R045b43ace8e14d46"/>
-    <p:sldId xmlns:r="http://schemas.openxmlformats.org/officeDocument/2006/relationships" id="258" r:id="R03163fdee49648be"/>
-    <p:sldId xmlns:r="http://schemas.openxmlformats.org/officeDocument/2006/relationships" id="259" r:id="Rcdf20f27e27345c9"/>
-    <p:sldId xmlns:r="http://schemas.openxmlformats.org/officeDocument/2006/relationships" id="260" r:id="Rd10fc1fbb063430c"/>
-    <p:sldId xmlns:r="http://schemas.openxmlformats.org/officeDocument/2006/relationships" id="261" r:id="Rd7a80537863a46b4"/>
-    <p:sldId xmlns:r="http://schemas.openxmlformats.org/officeDocument/2006/relationships" id="262" r:id="Rb78027dc02f44fa8"/>
-    <p:sldId xmlns:r="http://schemas.openxmlformats.org/officeDocument/2006/relationships" id="263" r:id="R2f5368904e35420c"/>
-    <p:sldId xmlns:r="http://schemas.openxmlformats.org/officeDocument/2006/relationships" id="264" r:id="R8d44cebb45074d4c"/>
-    <p:sldId xmlns:r="http://schemas.openxmlformats.org/officeDocument/2006/relationships" id="265" r:id="R3c90913c65ec4bff"/>
+    <p:sldId xmlns:r="http://schemas.openxmlformats.org/officeDocument/2006/relationships" id="256" r:id="R597a1a7181814a26"/>
+    <p:sldId xmlns:r="http://schemas.openxmlformats.org/officeDocument/2006/relationships" id="257" r:id="R8528b334a0904072"/>
+    <p:sldId xmlns:r="http://schemas.openxmlformats.org/officeDocument/2006/relationships" id="258" r:id="Rb093eced8b134d80"/>
+    <p:sldId xmlns:r="http://schemas.openxmlformats.org/officeDocument/2006/relationships" id="259" r:id="Rffd435dc92594a21"/>
+    <p:sldId xmlns:r="http://schemas.openxmlformats.org/officeDocument/2006/relationships" id="260" r:id="R644f5a067690428e"/>
+    <p:sldId xmlns:r="http://schemas.openxmlformats.org/officeDocument/2006/relationships" id="261" r:id="Rf7e03b4f919c4230"/>
+    <p:sldId xmlns:r="http://schemas.openxmlformats.org/officeDocument/2006/relationships" id="262" r:id="R59846c34ef8b4109"/>
+    <p:sldId xmlns:r="http://schemas.openxmlformats.org/officeDocument/2006/relationships" id="263" r:id="Rcbb33221d3e642d0"/>
+    <p:sldId xmlns:r="http://schemas.openxmlformats.org/officeDocument/2006/relationships" id="264" r:id="R426761045f18485a"/>
+    <p:sldId xmlns:r="http://schemas.openxmlformats.org/officeDocument/2006/relationships" id="265" r:id="R982feb5e85c04a46"/>
   </p:sldIdLst>
   <p:sldSz cx="12192000" cy="6858000"/>
   <p:notesSz cx="6858000" cy="9144000"/>
@@ -451,7 +451,7 @@
           <a:lstStyle xmlns:a="http://schemas.openxmlformats.org/drawingml/2006/main"/>
           <a:p xmlns:a="http://schemas.openxmlformats.org/drawingml/2006/main">
             <a:r>
-              <a:t>Brad opens. Introduce Wesley Siharth as an engineer who helped start Remington Vision. Wesley was first tasked with the project as an intern and carried it into his engineering role. Both Brad and Wesley will speak.</a:t>
+              <a:t>Brad opens and introduces Wesley. Wesley introduces himself: Remington Vision was first assigned to him as an intern, and he carried it into his engineering role. WESLEY GAP (15–20 seconds): add in his own words what he works on now or what drew him into engineering. Brad resumes with the purpose of the talk.</a:t>
             </a:r>
           </a:p>
         </p:txBody>
@@ -521,7 +521,7 @@
           <a:lstStyle xmlns:a="http://schemas.openxmlformats.org/drawingml/2006/main"/>
           <a:p xmlns:a="http://schemas.openxmlformats.org/drawingml/2006/main">
             <a:r>
-              <a:t>Brad closes. Invite follow-up with both Brad and Wesley. Brad’s email is on screen; company jobs use the official careers page, while 4Founders is an independent project platform.</a:t>
+              <a:t>Brad gives his email and follow-up paths: official careers page for company roles and the independent 4Founders platform for project connections. Wesley invites questions about engineering and students’ own projects. Brad gives the final thanks.</a:t>
             </a:r>
           </a:p>
         </p:txBody>
@@ -731,7 +731,7 @@
           <a:lstStyle xmlns:a="http://schemas.openxmlformats.org/drawingml/2006/main"/>
           <a:p xmlns:a="http://schemas.openxmlformats.org/drawingml/2006/main">
             <a:r>
-              <a:t>Wesley speaks. Remington Vision was first assigned to him as an intern, and he carried the work into his role as an engineer. Explain why both presenters love the variety, visible results, learning, and ownership in this work.</a:t>
+              <a:t>Brad explains why he loves the work, then hands off to Wesley. Wesley explains why he loves it and how his ownership of Remington Vision grew from intern to engineer. WESLEY GAP (45–60 seconds): one specific problem, what he tried, when he saw progress, and why it mattered to him. Use only public details. Wesley closes the section.</a:t>
             </a:r>
           </a:p>
         </p:txBody>
@@ -801,7 +801,7 @@
           <a:lstStyle xmlns:a="http://schemas.openxmlformats.org/drawingml/2006/main"/>
           <a:p xmlns:a="http://schemas.openxmlformats.org/drawingml/2006/main">
             <a:r>
-              <a:t>Wesley leads the live demonstration. Show the camera image, Gatorade bottle detection, and on-screen sorting result. The demonstration program carries the explanation. This is a demonstration setup, not a production sorting line.</a:t>
+              <a:t>Wesley leads the live demonstration while Brad operates slides. Show a Gatorade bottle under the camera, then a different color; pause after each on-screen sorting result. Let the audience choose a bottle or show another visible feature if the setup supports it. The demonstration setup does not control production sorting hardware.</a:t>
             </a:r>
           </a:p>
         </p:txBody>
@@ -871,7 +871,7 @@
           <a:lstStyle xmlns:a="http://schemas.openxmlformats.org/drawingml/2006/main"/>
           <a:p xmlns:a="http://schemas.openxmlformats.org/drawingml/2006/main">
             <a:r>
-              <a:t>Wesley explains the engineering difficulty after the demo: conditions vary, decisions have to happen at the right pace, and results need to be reliable enough for people to trust. The on-screen sorting decision does not actuate production hardware.</a:t>
+              <a:t>Wesley explains the engineering challenges after the demo: changing conditions, timing, and repeatability. WESLEY GAP (20–30 seconds): point to one behavior the audience just saw and describe a practical challenge solved to make it repeatable, using only public details. Brad then connects this to the broader manufacturing ambition.</a:t>
             </a:r>
           </a:p>
         </p:txBody>
@@ -3524,12 +3524,12 @@
   </p:cSld>
   <p:clrMap bg1="lt1" tx1="dk1" bg2="lt2" tx2="dk2" accent1="accent1" accent2="accent2" accent3="accent3" accent4="accent4" accent5="accent5" accent6="accent6" hlink="hlink" folHlink="folHlink"/>
   <p:sldLayoutIdLst>
-    <p:sldLayoutId xmlns:r="http://schemas.openxmlformats.org/officeDocument/2006/relationships" id="2147483649" r:id="R5c32e10bd4454f07"/>
-    <p:sldLayoutId xmlns:r="http://schemas.openxmlformats.org/officeDocument/2006/relationships" id="2147483650" r:id="R4201aff697014e8a"/>
-    <p:sldLayoutId xmlns:r="http://schemas.openxmlformats.org/officeDocument/2006/relationships" id="2147483651" r:id="Rc3a9cefd27b9443c"/>
-    <p:sldLayoutId xmlns:r="http://schemas.openxmlformats.org/officeDocument/2006/relationships" id="2147483652" r:id="Rd08d1d051eb64f45"/>
-    <p:sldLayoutId xmlns:r="http://schemas.openxmlformats.org/officeDocument/2006/relationships" id="2147483653" r:id="R64cf28eb2029474f"/>
-    <p:sldLayoutId xmlns:r="http://schemas.openxmlformats.org/officeDocument/2006/relationships" id="2147483654" r:id="R1dce60d7d559426e"/>
+    <p:sldLayoutId xmlns:r="http://schemas.openxmlformats.org/officeDocument/2006/relationships" id="2147483649" r:id="Rf74564d163e14f32"/>
+    <p:sldLayoutId xmlns:r="http://schemas.openxmlformats.org/officeDocument/2006/relationships" id="2147483650" r:id="R4ee5456122a54d36"/>
+    <p:sldLayoutId xmlns:r="http://schemas.openxmlformats.org/officeDocument/2006/relationships" id="2147483651" r:id="R6243c8e7bf104e7c"/>
+    <p:sldLayoutId xmlns:r="http://schemas.openxmlformats.org/officeDocument/2006/relationships" id="2147483652" r:id="R89b5447d6eb0417b"/>
+    <p:sldLayoutId xmlns:r="http://schemas.openxmlformats.org/officeDocument/2006/relationships" id="2147483653" r:id="R5811bc7302d443be"/>
+    <p:sldLayoutId xmlns:r="http://schemas.openxmlformats.org/officeDocument/2006/relationships" id="2147483654" r:id="R5f19a8b9da6b47ac"/>
   </p:sldLayoutIdLst>
   <p:txStyles>
     <p:titleStyle>
@@ -4080,7 +4080,7 @@
           <p:cNvPr id="6" name="">
             <a:extLst xmlns:a="http://schemas.openxmlformats.org/drawingml/2006/main">
               <a:ext uri="{FF2B5EF4-FFF2-40B4-BE49-F238E27FC236}">
-                <a16:creationId xmlns:a16="http://schemas.microsoft.com/office/drawing/2014/main" id="{C281F9BE-729D-4EEA-A056-B10B043D5765}"/>
+                <a16:creationId xmlns:a16="http://schemas.microsoft.com/office/drawing/2014/main" id="{C61ABDED-3766-4ECC-ACF4-6132E655255A}"/>
               </a:ext>
             </a:extLst>
           </p:cNvPr>
@@ -4090,7 +4090,7 @@
           <p:nvPr/>
         </p:nvPicPr>
         <p:blipFill>
-          <a:blip xmlns:r="http://schemas.openxmlformats.org/officeDocument/2006/relationships" xmlns:a="http://schemas.openxmlformats.org/drawingml/2006/main" r:embed="R1176cbb55a1d489d"/>
+          <a:blip xmlns:r="http://schemas.openxmlformats.org/officeDocument/2006/relationships" xmlns:a="http://schemas.openxmlformats.org/drawingml/2006/main" r:embed="Rfc8e2a04d1324588"/>
           <a:stretch xmlns:a="http://schemas.openxmlformats.org/drawingml/2006/main"/>
         </p:blipFill>
         <p:spPr>
@@ -4830,6 +4830,7 @@
               </a:defRPr>
             </a:defPPr>
             <a:lvl1pPr algn="l">
+              <a:buNone/>
               <a:defRPr sz="2100" b="1">
                 <a:solidFill>
                   <a:srgbClr val="FFFFFF"/>
@@ -4837,6 +4838,7 @@
               </a:defRPr>
             </a:lvl1pPr>
             <a:lvl2pPr algn="l">
+              <a:buNone/>
               <a:defRPr sz="2100" b="1">
                 <a:solidFill>
                   <a:srgbClr val="FFFFFF"/>
@@ -4844,6 +4846,7 @@
               </a:defRPr>
             </a:lvl2pPr>
             <a:lvl3pPr algn="l">
+              <a:buNone/>
               <a:defRPr sz="2100" b="1">
                 <a:solidFill>
                   <a:srgbClr val="FFFFFF"/>
@@ -4851,6 +4854,7 @@
               </a:defRPr>
             </a:lvl3pPr>
             <a:lvl4pPr algn="l">
+              <a:buNone/>
               <a:defRPr sz="2100" b="1">
                 <a:solidFill>
                   <a:srgbClr val="FFFFFF"/>
@@ -4858,6 +4862,7 @@
               </a:defRPr>
             </a:lvl4pPr>
             <a:lvl5pPr algn="l">
+              <a:buNone/>
               <a:defRPr sz="2100" b="1">
                 <a:solidFill>
                   <a:srgbClr val="FFFFFF"/>
@@ -4865,6 +4870,7 @@
               </a:defRPr>
             </a:lvl5pPr>
             <a:lvl6pPr algn="l">
+              <a:buNone/>
               <a:defRPr sz="2100" b="1">
                 <a:solidFill>
                   <a:srgbClr val="FFFFFF"/>
@@ -4872,6 +4878,7 @@
               </a:defRPr>
             </a:lvl6pPr>
             <a:lvl7pPr algn="l">
+              <a:buNone/>
               <a:defRPr sz="2100" b="1">
                 <a:solidFill>
                   <a:srgbClr val="FFFFFF"/>
@@ -4879,6 +4886,7 @@
               </a:defRPr>
             </a:lvl7pPr>
             <a:lvl8pPr algn="l">
+              <a:buNone/>
               <a:defRPr sz="2100" b="1">
                 <a:solidFill>
                   <a:srgbClr val="FFFFFF"/>
@@ -4886,6 +4894,7 @@
               </a:defRPr>
             </a:lvl8pPr>
             <a:lvl9pPr algn="l">
+              <a:buNone/>
               <a:defRPr sz="2100" b="1">
                 <a:solidFill>
                   <a:srgbClr val="FFFFFF"/>
@@ -4895,6 +4904,7 @@
           </a:lstStyle>
           <a:p xmlns:a="http://schemas.openxmlformats.org/drawingml/2006/main">
             <a:pPr algn="l">
+              <a:buNone/>
               <a:defRPr sz="2100" b="1">
                 <a:solidFill>
                   <a:srgbClr val="FFFFFF"/>
@@ -4951,6 +4961,7 @@
               </a:defRPr>
             </a:defPPr>
             <a:lvl1pPr algn="l">
+              <a:buNone/>
               <a:defRPr sz="1500" b="0">
                 <a:solidFill>
                   <a:srgbClr val="D7D3CC"/>
@@ -4958,6 +4969,7 @@
               </a:defRPr>
             </a:lvl1pPr>
             <a:lvl2pPr algn="l">
+              <a:buNone/>
               <a:defRPr sz="1500" b="0">
                 <a:solidFill>
                   <a:srgbClr val="D7D3CC"/>
@@ -4965,6 +4977,7 @@
               </a:defRPr>
             </a:lvl2pPr>
             <a:lvl3pPr algn="l">
+              <a:buNone/>
               <a:defRPr sz="1500" b="0">
                 <a:solidFill>
                   <a:srgbClr val="D7D3CC"/>
@@ -4972,6 +4985,7 @@
               </a:defRPr>
             </a:lvl3pPr>
             <a:lvl4pPr algn="l">
+              <a:buNone/>
               <a:defRPr sz="1500" b="0">
                 <a:solidFill>
                   <a:srgbClr val="D7D3CC"/>
@@ -4979,6 +4993,7 @@
               </a:defRPr>
             </a:lvl4pPr>
             <a:lvl5pPr algn="l">
+              <a:buNone/>
               <a:defRPr sz="1500" b="0">
                 <a:solidFill>
                   <a:srgbClr val="D7D3CC"/>
@@ -4986,6 +5001,7 @@
               </a:defRPr>
             </a:lvl5pPr>
             <a:lvl6pPr algn="l">
+              <a:buNone/>
               <a:defRPr sz="1500" b="0">
                 <a:solidFill>
                   <a:srgbClr val="D7D3CC"/>
@@ -4993,6 +5009,7 @@
               </a:defRPr>
             </a:lvl6pPr>
             <a:lvl7pPr algn="l">
+              <a:buNone/>
               <a:defRPr sz="1500" b="0">
                 <a:solidFill>
                   <a:srgbClr val="D7D3CC"/>
@@ -5000,6 +5017,7 @@
               </a:defRPr>
             </a:lvl7pPr>
             <a:lvl8pPr algn="l">
+              <a:buNone/>
               <a:defRPr sz="1500" b="0">
                 <a:solidFill>
                   <a:srgbClr val="D7D3CC"/>
@@ -5007,6 +5025,7 @@
               </a:defRPr>
             </a:lvl8pPr>
             <a:lvl9pPr algn="l">
+              <a:buNone/>
               <a:defRPr sz="1500" b="0">
                 <a:solidFill>
                   <a:srgbClr val="D7D3CC"/>
@@ -5016,6 +5035,7 @@
           </a:lstStyle>
           <a:p xmlns:a="http://schemas.openxmlformats.org/drawingml/2006/main">
             <a:pPr algn="l">
+              <a:buNone/>
               <a:defRPr sz="1500" b="0">
                 <a:solidFill>
                   <a:srgbClr val="D7D3CC"/>
@@ -5072,6 +5092,7 @@
               </a:defRPr>
             </a:defPPr>
             <a:lvl1pPr algn="l">
+              <a:buNone/>
               <a:defRPr sz="2100" b="1">
                 <a:solidFill>
                   <a:srgbClr val="FFFFFF"/>
@@ -5079,6 +5100,7 @@
               </a:defRPr>
             </a:lvl1pPr>
             <a:lvl2pPr algn="l">
+              <a:buNone/>
               <a:defRPr sz="2100" b="1">
                 <a:solidFill>
                   <a:srgbClr val="FFFFFF"/>
@@ -5086,6 +5108,7 @@
               </a:defRPr>
             </a:lvl2pPr>
             <a:lvl3pPr algn="l">
+              <a:buNone/>
               <a:defRPr sz="2100" b="1">
                 <a:solidFill>
                   <a:srgbClr val="FFFFFF"/>
@@ -5093,6 +5116,7 @@
               </a:defRPr>
             </a:lvl3pPr>
             <a:lvl4pPr algn="l">
+              <a:buNone/>
               <a:defRPr sz="2100" b="1">
                 <a:solidFill>
                   <a:srgbClr val="FFFFFF"/>
@@ -5100,6 +5124,7 @@
               </a:defRPr>
             </a:lvl4pPr>
             <a:lvl5pPr algn="l">
+              <a:buNone/>
               <a:defRPr sz="2100" b="1">
                 <a:solidFill>
                   <a:srgbClr val="FFFFFF"/>
@@ -5107,6 +5132,7 @@
               </a:defRPr>
             </a:lvl5pPr>
             <a:lvl6pPr algn="l">
+              <a:buNone/>
               <a:defRPr sz="2100" b="1">
                 <a:solidFill>
                   <a:srgbClr val="FFFFFF"/>
@@ -5114,6 +5140,7 @@
               </a:defRPr>
             </a:lvl6pPr>
             <a:lvl7pPr algn="l">
+              <a:buNone/>
               <a:defRPr sz="2100" b="1">
                 <a:solidFill>
                   <a:srgbClr val="FFFFFF"/>
@@ -5121,6 +5148,7 @@
               </a:defRPr>
             </a:lvl7pPr>
             <a:lvl8pPr algn="l">
+              <a:buNone/>
               <a:defRPr sz="2100" b="1">
                 <a:solidFill>
                   <a:srgbClr val="FFFFFF"/>
@@ -5128,6 +5156,7 @@
               </a:defRPr>
             </a:lvl8pPr>
             <a:lvl9pPr algn="l">
+              <a:buNone/>
               <a:defRPr sz="2100" b="1">
                 <a:solidFill>
                   <a:srgbClr val="FFFFFF"/>
@@ -5137,6 +5166,7 @@
           </a:lstStyle>
           <a:p xmlns:a="http://schemas.openxmlformats.org/drawingml/2006/main">
             <a:pPr algn="l">
+              <a:buNone/>
               <a:defRPr sz="2100" b="1">
                 <a:solidFill>
                   <a:srgbClr val="FFFFFF"/>
@@ -5193,6 +5223,7 @@
               </a:defRPr>
             </a:defPPr>
             <a:lvl1pPr algn="l">
+              <a:buNone/>
               <a:defRPr sz="1500" b="0">
                 <a:solidFill>
                   <a:srgbClr val="D7D3CC"/>
@@ -5200,6 +5231,7 @@
               </a:defRPr>
             </a:lvl1pPr>
             <a:lvl2pPr algn="l">
+              <a:buNone/>
               <a:defRPr sz="1500" b="0">
                 <a:solidFill>
                   <a:srgbClr val="D7D3CC"/>
@@ -5207,6 +5239,7 @@
               </a:defRPr>
             </a:lvl2pPr>
             <a:lvl3pPr algn="l">
+              <a:buNone/>
               <a:defRPr sz="1500" b="0">
                 <a:solidFill>
                   <a:srgbClr val="D7D3CC"/>
@@ -5214,6 +5247,7 @@
               </a:defRPr>
             </a:lvl3pPr>
             <a:lvl4pPr algn="l">
+              <a:buNone/>
               <a:defRPr sz="1500" b="0">
                 <a:solidFill>
                   <a:srgbClr val="D7D3CC"/>
@@ -5221,6 +5255,7 @@
               </a:defRPr>
             </a:lvl4pPr>
             <a:lvl5pPr algn="l">
+              <a:buNone/>
               <a:defRPr sz="1500" b="0">
                 <a:solidFill>
                   <a:srgbClr val="D7D3CC"/>
@@ -5228,6 +5263,7 @@
               </a:defRPr>
             </a:lvl5pPr>
             <a:lvl6pPr algn="l">
+              <a:buNone/>
               <a:defRPr sz="1500" b="0">
                 <a:solidFill>
                   <a:srgbClr val="D7D3CC"/>
@@ -5235,6 +5271,7 @@
               </a:defRPr>
             </a:lvl6pPr>
             <a:lvl7pPr algn="l">
+              <a:buNone/>
               <a:defRPr sz="1500" b="0">
                 <a:solidFill>
                   <a:srgbClr val="D7D3CC"/>
@@ -5242,6 +5279,7 @@
               </a:defRPr>
             </a:lvl7pPr>
             <a:lvl8pPr algn="l">
+              <a:buNone/>
               <a:defRPr sz="1500" b="0">
                 <a:solidFill>
                   <a:srgbClr val="D7D3CC"/>
@@ -5249,6 +5287,7 @@
               </a:defRPr>
             </a:lvl8pPr>
             <a:lvl9pPr algn="l">
+              <a:buNone/>
               <a:defRPr sz="1500" b="0">
                 <a:solidFill>
                   <a:srgbClr val="D7D3CC"/>
@@ -5258,6 +5297,7 @@
           </a:lstStyle>
           <a:p xmlns:a="http://schemas.openxmlformats.org/drawingml/2006/main">
             <a:pPr algn="l">
+              <a:buNone/>
               <a:defRPr sz="1500" b="0">
                 <a:solidFill>
                   <a:srgbClr val="D7D3CC"/>
@@ -5309,7 +5349,7 @@
           <p:cNvPr id="3" name="">
             <a:extLst xmlns:a="http://schemas.openxmlformats.org/drawingml/2006/main">
               <a:ext uri="{FF2B5EF4-FFF2-40B4-BE49-F238E27FC236}">
-                <a16:creationId xmlns:a16="http://schemas.microsoft.com/office/drawing/2014/main" id="{2AFEB78C-684E-44C8-A2CE-9348D9B7F914}"/>
+                <a16:creationId xmlns:a16="http://schemas.microsoft.com/office/drawing/2014/main" id="{E2B45AB5-D299-4AB2-8AEA-AFA171D875A2}"/>
               </a:ext>
             </a:extLst>
           </p:cNvPr>
@@ -5319,7 +5359,7 @@
           <p:nvPr/>
         </p:nvPicPr>
         <p:blipFill>
-          <a:blip xmlns:r="http://schemas.openxmlformats.org/officeDocument/2006/relationships" xmlns:a="http://schemas.openxmlformats.org/drawingml/2006/main" r:embed="R03682504381e4ac3"/>
+          <a:blip xmlns:r="http://schemas.openxmlformats.org/officeDocument/2006/relationships" xmlns:a="http://schemas.openxmlformats.org/drawingml/2006/main" r:embed="Rfaf3a2a390a5438c"/>
           <a:stretch xmlns:a="http://schemas.openxmlformats.org/drawingml/2006/main"/>
         </p:blipFill>
         <p:spPr>
@@ -5337,7 +5377,7 @@
           <p:cNvPr id="16" name="">
             <a:extLst xmlns:a="http://schemas.openxmlformats.org/drawingml/2006/main">
               <a:ext uri="{FF2B5EF4-FFF2-40B4-BE49-F238E27FC236}">
-                <a16:creationId xmlns:a16="http://schemas.microsoft.com/office/drawing/2014/main" id="{1C51C999-99FE-447B-A4EA-B4CD3A30702B}"/>
+                <a16:creationId xmlns:a16="http://schemas.microsoft.com/office/drawing/2014/main" id="{C7C82162-4CC3-43D8-93BB-52656653B8B8}"/>
               </a:ext>
             </a:extLst>
           </p:cNvPr>
@@ -5347,7 +5387,7 @@
           <p:nvPr/>
         </p:nvPicPr>
         <p:blipFill>
-          <a:blip xmlns:r="http://schemas.openxmlformats.org/officeDocument/2006/relationships" xmlns:a="http://schemas.openxmlformats.org/drawingml/2006/main" r:embed="R8622f21e6ec64500"/>
+          <a:blip xmlns:r="http://schemas.openxmlformats.org/officeDocument/2006/relationships" xmlns:a="http://schemas.openxmlformats.org/drawingml/2006/main" r:embed="Rbf224fee4ae5465f"/>
           <a:stretch xmlns:a="http://schemas.openxmlformats.org/drawingml/2006/main"/>
         </p:blipFill>
         <p:spPr>
@@ -6737,7 +6777,7 @@
           <p:cNvPr id="29" name="">
             <a:extLst xmlns:a="http://schemas.openxmlformats.org/drawingml/2006/main">
               <a:ext uri="{FF2B5EF4-FFF2-40B4-BE49-F238E27FC236}">
-                <a16:creationId xmlns:a16="http://schemas.microsoft.com/office/drawing/2014/main" id="{5E1C3825-BF41-49C3-B660-391D74D22269}"/>
+                <a16:creationId xmlns:a16="http://schemas.microsoft.com/office/drawing/2014/main" id="{5226836F-E796-41CD-A232-E3494E29E7E9}"/>
               </a:ext>
             </a:extLst>
           </p:cNvPr>
@@ -6747,7 +6787,7 @@
           <p:nvPr/>
         </p:nvPicPr>
         <p:blipFill>
-          <a:blip xmlns:r="http://schemas.openxmlformats.org/officeDocument/2006/relationships" xmlns:a="http://schemas.openxmlformats.org/drawingml/2006/main" r:embed="R7bf7fc33c7d2452f"/>
+          <a:blip xmlns:r="http://schemas.openxmlformats.org/officeDocument/2006/relationships" xmlns:a="http://schemas.openxmlformats.org/drawingml/2006/main" r:embed="R6fad699d6a124cc1"/>
           <a:stretch xmlns:a="http://schemas.openxmlformats.org/drawingml/2006/main"/>
         </p:blipFill>
         <p:spPr>
@@ -6794,7 +6834,7 @@
           <p:cNvPr id="3" name="">
             <a:extLst xmlns:a="http://schemas.openxmlformats.org/drawingml/2006/main">
               <a:ext uri="{FF2B5EF4-FFF2-40B4-BE49-F238E27FC236}">
-                <a16:creationId xmlns:a16="http://schemas.microsoft.com/office/drawing/2014/main" id="{7CD3DAD3-5385-4886-A0E5-40CBF3254DEA}"/>
+                <a16:creationId xmlns:a16="http://schemas.microsoft.com/office/drawing/2014/main" id="{6D22F57C-1761-479D-93E2-6E6116B191E5}"/>
               </a:ext>
             </a:extLst>
           </p:cNvPr>
@@ -6804,7 +6844,7 @@
           <p:nvPr/>
         </p:nvPicPr>
         <p:blipFill>
-          <a:blip xmlns:r="http://schemas.openxmlformats.org/officeDocument/2006/relationships" xmlns:a="http://schemas.openxmlformats.org/drawingml/2006/main" r:embed="Rc6fd4b6133014af4"/>
+          <a:blip xmlns:r="http://schemas.openxmlformats.org/officeDocument/2006/relationships" xmlns:a="http://schemas.openxmlformats.org/drawingml/2006/main" r:embed="Rb6e83ee2901b4360"/>
           <a:stretch xmlns:a="http://schemas.openxmlformats.org/drawingml/2006/main"/>
         </p:blipFill>
         <p:spPr>
@@ -8063,7 +8103,7 @@
           <p:cNvPr id="15" name="">
             <a:extLst xmlns:a="http://schemas.openxmlformats.org/drawingml/2006/main">
               <a:ext uri="{FF2B5EF4-FFF2-40B4-BE49-F238E27FC236}">
-                <a16:creationId xmlns:a16="http://schemas.microsoft.com/office/drawing/2014/main" id="{F14D0DA4-1DE1-4002-8149-4DDA1991BA3F}"/>
+                <a16:creationId xmlns:a16="http://schemas.microsoft.com/office/drawing/2014/main" id="{9E1261F3-BC75-42B2-8D13-D01969E42774}"/>
               </a:ext>
             </a:extLst>
           </p:cNvPr>
@@ -8073,7 +8113,7 @@
           <p:nvPr/>
         </p:nvPicPr>
         <p:blipFill>
-          <a:blip xmlns:r="http://schemas.openxmlformats.org/officeDocument/2006/relationships" xmlns:a="http://schemas.openxmlformats.org/drawingml/2006/main" r:embed="R02736cfe8b554a6a"/>
+          <a:blip xmlns:r="http://schemas.openxmlformats.org/officeDocument/2006/relationships" xmlns:a="http://schemas.openxmlformats.org/drawingml/2006/main" r:embed="R1f8887a097384657"/>
           <a:stretch xmlns:a="http://schemas.openxmlformats.org/drawingml/2006/main"/>
         </p:blipFill>
         <p:spPr>
@@ -8120,7 +8160,7 @@
           <p:cNvPr id="3" name="">
             <a:extLst xmlns:a="http://schemas.openxmlformats.org/drawingml/2006/main">
               <a:ext uri="{FF2B5EF4-FFF2-40B4-BE49-F238E27FC236}">
-                <a16:creationId xmlns:a16="http://schemas.microsoft.com/office/drawing/2014/main" id="{D058BE97-DB7D-4318-90DA-C898E5BB104B}"/>
+                <a16:creationId xmlns:a16="http://schemas.microsoft.com/office/drawing/2014/main" id="{74DAA05D-9933-41C9-929B-E2CD48CE850D}"/>
               </a:ext>
             </a:extLst>
           </p:cNvPr>
@@ -8130,7 +8170,7 @@
           <p:nvPr/>
         </p:nvPicPr>
         <p:blipFill>
-          <a:blip xmlns:r="http://schemas.openxmlformats.org/officeDocument/2006/relationships" xmlns:a="http://schemas.openxmlformats.org/drawingml/2006/main" r:embed="Racacc491cb814f3b"/>
+          <a:blip xmlns:r="http://schemas.openxmlformats.org/officeDocument/2006/relationships" xmlns:a="http://schemas.openxmlformats.org/drawingml/2006/main" r:embed="Re0e1ff77b91e470a"/>
           <a:stretch xmlns:a="http://schemas.openxmlformats.org/drawingml/2006/main"/>
         </p:blipFill>
         <p:spPr>
@@ -9058,7 +9098,7 @@
           <p:cNvPr id="14" name="">
             <a:extLst xmlns:a="http://schemas.openxmlformats.org/drawingml/2006/main">
               <a:ext uri="{FF2B5EF4-FFF2-40B4-BE49-F238E27FC236}">
-                <a16:creationId xmlns:a16="http://schemas.microsoft.com/office/drawing/2014/main" id="{270AE770-4FE8-483A-BDFD-3F57616B1A79}"/>
+                <a16:creationId xmlns:a16="http://schemas.microsoft.com/office/drawing/2014/main" id="{C5784B5E-C6D6-4F91-8BA6-E117152E8BF5}"/>
               </a:ext>
             </a:extLst>
           </p:cNvPr>
@@ -9068,7 +9108,7 @@
           <p:nvPr/>
         </p:nvPicPr>
         <p:blipFill>
-          <a:blip xmlns:r="http://schemas.openxmlformats.org/officeDocument/2006/relationships" xmlns:a="http://schemas.openxmlformats.org/drawingml/2006/main" r:embed="R22bd137d53a0477f"/>
+          <a:blip xmlns:r="http://schemas.openxmlformats.org/officeDocument/2006/relationships" xmlns:a="http://schemas.openxmlformats.org/drawingml/2006/main" r:embed="R6c137fb680044baf"/>
           <a:stretch xmlns:a="http://schemas.openxmlformats.org/drawingml/2006/main"/>
         </p:blipFill>
         <p:spPr>
@@ -9639,7 +9679,7 @@
           <p:cNvPr id="3" name="">
             <a:extLst xmlns:a="http://schemas.openxmlformats.org/drawingml/2006/main">
               <a:ext uri="{FF2B5EF4-FFF2-40B4-BE49-F238E27FC236}">
-                <a16:creationId xmlns:a16="http://schemas.microsoft.com/office/drawing/2014/main" id="{209C0429-F628-4D54-8BB8-61F840500B35}"/>
+                <a16:creationId xmlns:a16="http://schemas.microsoft.com/office/drawing/2014/main" id="{2E17B0A8-734B-49A6-8606-82BB732D35EB}"/>
               </a:ext>
             </a:extLst>
           </p:cNvPr>
@@ -9649,7 +9689,7 @@
           <p:nvPr/>
         </p:nvPicPr>
         <p:blipFill>
-          <a:blip xmlns:r="http://schemas.openxmlformats.org/officeDocument/2006/relationships" xmlns:a="http://schemas.openxmlformats.org/drawingml/2006/main" r:embed="R2f301cc407184f82"/>
+          <a:blip xmlns:r="http://schemas.openxmlformats.org/officeDocument/2006/relationships" xmlns:a="http://schemas.openxmlformats.org/drawingml/2006/main" r:embed="R452df72340634f87"/>
           <a:stretch xmlns:a="http://schemas.openxmlformats.org/drawingml/2006/main"/>
         </p:blipFill>
         <p:spPr>
@@ -10608,7 +10648,7 @@
           <p:cNvPr id="15" name="">
             <a:extLst xmlns:a="http://schemas.openxmlformats.org/drawingml/2006/main">
               <a:ext uri="{FF2B5EF4-FFF2-40B4-BE49-F238E27FC236}">
-                <a16:creationId xmlns:a16="http://schemas.microsoft.com/office/drawing/2014/main" id="{B6913B22-0235-4DF5-A331-34DAE9F22432}"/>
+                <a16:creationId xmlns:a16="http://schemas.microsoft.com/office/drawing/2014/main" id="{5FB3841B-A70D-4BE0-92DD-CA57B312CF36}"/>
               </a:ext>
             </a:extLst>
           </p:cNvPr>
@@ -10618,7 +10658,7 @@
           <p:nvPr/>
         </p:nvPicPr>
         <p:blipFill>
-          <a:blip xmlns:r="http://schemas.openxmlformats.org/officeDocument/2006/relationships" xmlns:a="http://schemas.openxmlformats.org/drawingml/2006/main" r:embed="Rec087dc33e8d4428"/>
+          <a:blip xmlns:r="http://schemas.openxmlformats.org/officeDocument/2006/relationships" xmlns:a="http://schemas.openxmlformats.org/drawingml/2006/main" r:embed="R241131685a8e4ac8"/>
           <a:stretch xmlns:a="http://schemas.openxmlformats.org/drawingml/2006/main"/>
         </p:blipFill>
         <p:spPr>
@@ -11189,7 +11229,7 @@
           <p:cNvPr id="3" name="">
             <a:extLst xmlns:a="http://schemas.openxmlformats.org/drawingml/2006/main">
               <a:ext uri="{FF2B5EF4-FFF2-40B4-BE49-F238E27FC236}">
-                <a16:creationId xmlns:a16="http://schemas.microsoft.com/office/drawing/2014/main" id="{86F1578E-C3AC-4F07-A0E4-80B6D66775E3}"/>
+                <a16:creationId xmlns:a16="http://schemas.microsoft.com/office/drawing/2014/main" id="{1BB4025B-CBC7-40A7-A10F-BB24619CFAC7}"/>
               </a:ext>
             </a:extLst>
           </p:cNvPr>
@@ -11199,7 +11239,7 @@
           <p:nvPr/>
         </p:nvPicPr>
         <p:blipFill>
-          <a:blip xmlns:r="http://schemas.openxmlformats.org/officeDocument/2006/relationships" xmlns:a="http://schemas.openxmlformats.org/drawingml/2006/main" r:embed="Rf9976cc7ad3d4e7c"/>
+          <a:blip xmlns:r="http://schemas.openxmlformats.org/officeDocument/2006/relationships" xmlns:a="http://schemas.openxmlformats.org/drawingml/2006/main" r:embed="Rca5bf9bf7c3e47ac"/>
           <a:stretch xmlns:a="http://schemas.openxmlformats.org/drawingml/2006/main"/>
         </p:blipFill>
         <p:spPr>
@@ -11217,7 +11257,7 @@
           <p:cNvPr id="10" name="">
             <a:extLst xmlns:a="http://schemas.openxmlformats.org/drawingml/2006/main">
               <a:ext uri="{FF2B5EF4-FFF2-40B4-BE49-F238E27FC236}">
-                <a16:creationId xmlns:a16="http://schemas.microsoft.com/office/drawing/2014/main" id="{7F2CEB92-C02B-4708-9B7F-F8650DE36E3D}"/>
+                <a16:creationId xmlns:a16="http://schemas.microsoft.com/office/drawing/2014/main" id="{25FEC65A-EC1A-4ACD-BC74-ABF2A148953C}"/>
               </a:ext>
             </a:extLst>
           </p:cNvPr>
@@ -11227,7 +11267,7 @@
           <p:nvPr/>
         </p:nvPicPr>
         <p:blipFill>
-          <a:blip xmlns:r="http://schemas.openxmlformats.org/officeDocument/2006/relationships" xmlns:a="http://schemas.openxmlformats.org/drawingml/2006/main" r:embed="R853a1dc91ab94517"/>
+          <a:blip xmlns:r="http://schemas.openxmlformats.org/officeDocument/2006/relationships" xmlns:a="http://schemas.openxmlformats.org/drawingml/2006/main" r:embed="R8565e0e0ee524758"/>
           <a:stretch xmlns:a="http://schemas.openxmlformats.org/drawingml/2006/main"/>
         </p:blipFill>
         <p:spPr>
@@ -11831,7 +11871,7 @@
           <p:cNvPr id="17" name="">
             <a:extLst xmlns:a="http://schemas.openxmlformats.org/drawingml/2006/main">
               <a:ext uri="{FF2B5EF4-FFF2-40B4-BE49-F238E27FC236}">
-                <a16:creationId xmlns:a16="http://schemas.microsoft.com/office/drawing/2014/main" id="{A5C5843C-ACC1-480C-B836-F0A1420156ED}"/>
+                <a16:creationId xmlns:a16="http://schemas.microsoft.com/office/drawing/2014/main" id="{4CA3FA1A-E62A-44AA-A1AD-9F44F6E4CE9F}"/>
               </a:ext>
             </a:extLst>
           </p:cNvPr>
@@ -11841,7 +11881,7 @@
           <p:nvPr/>
         </p:nvPicPr>
         <p:blipFill>
-          <a:blip xmlns:r="http://schemas.openxmlformats.org/officeDocument/2006/relationships" xmlns:a="http://schemas.openxmlformats.org/drawingml/2006/main" r:embed="Rc50a038bfc0645d0"/>
+          <a:blip xmlns:r="http://schemas.openxmlformats.org/officeDocument/2006/relationships" xmlns:a="http://schemas.openxmlformats.org/drawingml/2006/main" r:embed="R7e6e9f1d956d42db"/>
           <a:stretch xmlns:a="http://schemas.openxmlformats.org/drawingml/2006/main"/>
         </p:blipFill>
         <p:spPr>
@@ -11888,7 +11928,7 @@
           <p:cNvPr id="3" name="">
             <a:extLst xmlns:a="http://schemas.openxmlformats.org/drawingml/2006/main">
               <a:ext uri="{FF2B5EF4-FFF2-40B4-BE49-F238E27FC236}">
-                <a16:creationId xmlns:a16="http://schemas.microsoft.com/office/drawing/2014/main" id="{9417FDBF-F88C-4D66-B129-92DE44129815}"/>
+                <a16:creationId xmlns:a16="http://schemas.microsoft.com/office/drawing/2014/main" id="{CD18FE0C-79B6-4406-9ADE-45ECDECD2FB6}"/>
               </a:ext>
             </a:extLst>
           </p:cNvPr>
@@ -11898,7 +11938,7 @@
           <p:nvPr/>
         </p:nvPicPr>
         <p:blipFill>
-          <a:blip xmlns:r="http://schemas.openxmlformats.org/officeDocument/2006/relationships" xmlns:a="http://schemas.openxmlformats.org/drawingml/2006/main" r:embed="R138ddc231b314744"/>
+          <a:blip xmlns:r="http://schemas.openxmlformats.org/officeDocument/2006/relationships" xmlns:a="http://schemas.openxmlformats.org/drawingml/2006/main" r:embed="R4f24f81d22fe480a"/>
           <a:stretch xmlns:a="http://schemas.openxmlformats.org/drawingml/2006/main"/>
         </p:blipFill>
         <p:spPr>
@@ -13219,7 +13259,7 @@
           <p:cNvPr id="17" name="">
             <a:extLst xmlns:a="http://schemas.openxmlformats.org/drawingml/2006/main">
               <a:ext uri="{FF2B5EF4-FFF2-40B4-BE49-F238E27FC236}">
-                <a16:creationId xmlns:a16="http://schemas.microsoft.com/office/drawing/2014/main" id="{6B76E267-E94F-4C1D-B81D-19E8C4518F3A}"/>
+                <a16:creationId xmlns:a16="http://schemas.microsoft.com/office/drawing/2014/main" id="{FF502747-4977-466F-9002-5C13B4B923E6}"/>
               </a:ext>
             </a:extLst>
           </p:cNvPr>
@@ -13229,7 +13269,7 @@
           <p:nvPr/>
         </p:nvPicPr>
         <p:blipFill>
-          <a:blip xmlns:r="http://schemas.openxmlformats.org/officeDocument/2006/relationships" xmlns:a="http://schemas.openxmlformats.org/drawingml/2006/main" r:embed="Rd60948dc7fc148a9"/>
+          <a:blip xmlns:r="http://schemas.openxmlformats.org/officeDocument/2006/relationships" xmlns:a="http://schemas.openxmlformats.org/drawingml/2006/main" r:embed="R06dc5d0f440048a1"/>
           <a:stretch xmlns:a="http://schemas.openxmlformats.org/drawingml/2006/main"/>
         </p:blipFill>
         <p:spPr>
@@ -13407,7 +13447,7 @@
           <p:cNvPr id="3" name="">
             <a:extLst xmlns:a="http://schemas.openxmlformats.org/drawingml/2006/main">
               <a:ext uri="{FF2B5EF4-FFF2-40B4-BE49-F238E27FC236}">
-                <a16:creationId xmlns:a16="http://schemas.microsoft.com/office/drawing/2014/main" id="{E6B23F57-5A80-4E0A-97F3-8725C655B570}"/>
+                <a16:creationId xmlns:a16="http://schemas.microsoft.com/office/drawing/2014/main" id="{36F709BE-44EE-4B8B-BC1E-2B87D9EF53C2}"/>
               </a:ext>
             </a:extLst>
           </p:cNvPr>
@@ -13417,7 +13457,7 @@
           <p:nvPr/>
         </p:nvPicPr>
         <p:blipFill>
-          <a:blip xmlns:r="http://schemas.openxmlformats.org/officeDocument/2006/relationships" xmlns:a="http://schemas.openxmlformats.org/drawingml/2006/main" r:embed="R4a77bfccdeab46c5"/>
+          <a:blip xmlns:r="http://schemas.openxmlformats.org/officeDocument/2006/relationships" xmlns:a="http://schemas.openxmlformats.org/drawingml/2006/main" r:embed="Re8b95dd8900441d2"/>
           <a:stretch xmlns:a="http://schemas.openxmlformats.org/drawingml/2006/main"/>
         </p:blipFill>
         <p:spPr>
@@ -14414,7 +14454,7 @@
           <p:cNvPr id="13" name="">
             <a:extLst xmlns:a="http://schemas.openxmlformats.org/drawingml/2006/main">
               <a:ext uri="{FF2B5EF4-FFF2-40B4-BE49-F238E27FC236}">
-                <a16:creationId xmlns:a16="http://schemas.microsoft.com/office/drawing/2014/main" id="{6749CD49-2CBD-4906-B2E3-9D34812D47B8}"/>
+                <a16:creationId xmlns:a16="http://schemas.microsoft.com/office/drawing/2014/main" id="{10C85B9B-3F8A-4C41-8B6E-740345F26602}"/>
               </a:ext>
             </a:extLst>
           </p:cNvPr>
@@ -14424,7 +14464,7 @@
           <p:nvPr/>
         </p:nvPicPr>
         <p:blipFill>
-          <a:blip xmlns:r="http://schemas.openxmlformats.org/officeDocument/2006/relationships" xmlns:a="http://schemas.openxmlformats.org/drawingml/2006/main" r:embed="Rc67ab743a4f84946"/>
+          <a:blip xmlns:r="http://schemas.openxmlformats.org/officeDocument/2006/relationships" xmlns:a="http://schemas.openxmlformats.org/drawingml/2006/main" r:embed="R8a2e8338933547f8"/>
           <a:stretch xmlns:a="http://schemas.openxmlformats.org/drawingml/2006/main"/>
         </p:blipFill>
         <p:spPr>
@@ -15126,7 +15166,7 @@
           <p:cNvPr id="3" name="">
             <a:extLst xmlns:a="http://schemas.openxmlformats.org/drawingml/2006/main">
               <a:ext uri="{FF2B5EF4-FFF2-40B4-BE49-F238E27FC236}">
-                <a16:creationId xmlns:a16="http://schemas.microsoft.com/office/drawing/2014/main" id="{71E520C8-8C4D-438F-A7F2-D5CE5E3ECF1E}"/>
+                <a16:creationId xmlns:a16="http://schemas.microsoft.com/office/drawing/2014/main" id="{856DFAE6-72B8-407D-B815-72CF09F725CD}"/>
               </a:ext>
             </a:extLst>
           </p:cNvPr>
@@ -15136,7 +15176,7 @@
           <p:nvPr/>
         </p:nvPicPr>
         <p:blipFill>
-          <a:blip xmlns:r="http://schemas.openxmlformats.org/officeDocument/2006/relationships" xmlns:a="http://schemas.openxmlformats.org/drawingml/2006/main" r:embed="R0c1dae8ebf3440f6"/>
+          <a:blip xmlns:r="http://schemas.openxmlformats.org/officeDocument/2006/relationships" xmlns:a="http://schemas.openxmlformats.org/drawingml/2006/main" r:embed="R8d97783121f3411f"/>
           <a:stretch xmlns:a="http://schemas.openxmlformats.org/drawingml/2006/main"/>
         </p:blipFill>
         <p:spPr>
@@ -15154,7 +15194,7 @@
           <p:cNvPr id="7" name="">
             <a:extLst xmlns:a="http://schemas.openxmlformats.org/drawingml/2006/main">
               <a:ext uri="{FF2B5EF4-FFF2-40B4-BE49-F238E27FC236}">
-                <a16:creationId xmlns:a16="http://schemas.microsoft.com/office/drawing/2014/main" id="{1A4FE53C-1958-4FDA-93AB-6938617A3F46}"/>
+                <a16:creationId xmlns:a16="http://schemas.microsoft.com/office/drawing/2014/main" id="{B11A55EC-765B-4B2C-89E2-C381BF57D38B}"/>
               </a:ext>
             </a:extLst>
           </p:cNvPr>
@@ -15164,7 +15204,7 @@
           <p:nvPr/>
         </p:nvPicPr>
         <p:blipFill>
-          <a:blip xmlns:r="http://schemas.openxmlformats.org/officeDocument/2006/relationships" xmlns:a="http://schemas.openxmlformats.org/drawingml/2006/main" r:embed="Ra48562c9dbe0424d"/>
+          <a:blip xmlns:r="http://schemas.openxmlformats.org/officeDocument/2006/relationships" xmlns:a="http://schemas.openxmlformats.org/drawingml/2006/main" r:embed="R6dd6e00de20444dd"/>
           <a:stretch xmlns:a="http://schemas.openxmlformats.org/drawingml/2006/main"/>
         </p:blipFill>
         <p:spPr>
@@ -15999,7 +16039,7 @@
           <p:cNvPr id="15" name="">
             <a:extLst xmlns:a="http://schemas.openxmlformats.org/drawingml/2006/main">
               <a:ext uri="{FF2B5EF4-FFF2-40B4-BE49-F238E27FC236}">
-                <a16:creationId xmlns:a16="http://schemas.microsoft.com/office/drawing/2014/main" id="{D6140392-CB90-4763-85D6-EA42DBE189CA}"/>
+                <a16:creationId xmlns:a16="http://schemas.microsoft.com/office/drawing/2014/main" id="{9A7AF54E-4913-49A4-B401-F91639EF1DC7}"/>
               </a:ext>
             </a:extLst>
           </p:cNvPr>
@@ -16009,7 +16049,7 @@
           <p:nvPr/>
         </p:nvPicPr>
         <p:blipFill>
-          <a:blip xmlns:r="http://schemas.openxmlformats.org/officeDocument/2006/relationships" xmlns:a="http://schemas.openxmlformats.org/drawingml/2006/main" r:embed="Ra7213ef0b843400c"/>
+          <a:blip xmlns:r="http://schemas.openxmlformats.org/officeDocument/2006/relationships" xmlns:a="http://schemas.openxmlformats.org/drawingml/2006/main" r:embed="Rdf39e788823b4dde"/>
           <a:stretch xmlns:a="http://schemas.openxmlformats.org/drawingml/2006/main"/>
         </p:blipFill>
         <p:spPr>
@@ -16218,7 +16258,7 @@
           <p:cNvPr id="3" name="">
             <a:extLst xmlns:a="http://schemas.openxmlformats.org/drawingml/2006/main">
               <a:ext uri="{FF2B5EF4-FFF2-40B4-BE49-F238E27FC236}">
-                <a16:creationId xmlns:a16="http://schemas.microsoft.com/office/drawing/2014/main" id="{DFC6D5DE-13E6-4C65-A203-C61C10439FDB}"/>
+                <a16:creationId xmlns:a16="http://schemas.microsoft.com/office/drawing/2014/main" id="{2B3C6D56-E089-41D8-BC58-FB1B621A8271}"/>
               </a:ext>
             </a:extLst>
           </p:cNvPr>
@@ -16228,7 +16268,7 @@
           <p:nvPr/>
         </p:nvPicPr>
         <p:blipFill>
-          <a:blip xmlns:r="http://schemas.openxmlformats.org/officeDocument/2006/relationships" xmlns:a="http://schemas.openxmlformats.org/drawingml/2006/main" r:embed="Rd00defa0ae1b4289"/>
+          <a:blip xmlns:r="http://schemas.openxmlformats.org/officeDocument/2006/relationships" xmlns:a="http://schemas.openxmlformats.org/drawingml/2006/main" r:embed="Rab816bab28474130"/>
           <a:stretch xmlns:a="http://schemas.openxmlformats.org/drawingml/2006/main"/>
         </p:blipFill>
         <p:spPr>

</xml_diff>

<commit_message>
Use Wesley's own account of the work
</commit_message>
<xml_diff>
--- a/docs/presentation/Engineering_at_The_Kinetic_Group.pptx
+++ b/docs/presentation/Engineering_at_The_Kinetic_Group.pptx
@@ -2,22 +2,22 @@
 <file path=ppt/presentation.xml><?xml version="1.0" encoding="utf-8"?>
 <p:presentation xmlns:p="http://schemas.openxmlformats.org/presentationml/2006/main">
   <p:sldMasterIdLst>
-    <p:sldMasterId xmlns:r="http://schemas.openxmlformats.org/officeDocument/2006/relationships" id="2147483648" r:id="Rb5a6074cd6c748a1"/>
+    <p:sldMasterId xmlns:r="http://schemas.openxmlformats.org/officeDocument/2006/relationships" id="2147483648" r:id="R523cd56fe2034176"/>
   </p:sldMasterIdLst>
   <p:notesMasterIdLst>
-    <p:notesMasterId xmlns:r="http://schemas.openxmlformats.org/officeDocument/2006/relationships" r:id="Raeeeb5f1dfa04a99"/>
+    <p:notesMasterId xmlns:r="http://schemas.openxmlformats.org/officeDocument/2006/relationships" r:id="R9fbd5f28c15d4f2f"/>
   </p:notesMasterIdLst>
   <p:sldIdLst>
-    <p:sldId xmlns:r="http://schemas.openxmlformats.org/officeDocument/2006/relationships" id="256" r:id="R597a1a7181814a26"/>
-    <p:sldId xmlns:r="http://schemas.openxmlformats.org/officeDocument/2006/relationships" id="257" r:id="R8528b334a0904072"/>
-    <p:sldId xmlns:r="http://schemas.openxmlformats.org/officeDocument/2006/relationships" id="258" r:id="Rb093eced8b134d80"/>
-    <p:sldId xmlns:r="http://schemas.openxmlformats.org/officeDocument/2006/relationships" id="259" r:id="Rffd435dc92594a21"/>
-    <p:sldId xmlns:r="http://schemas.openxmlformats.org/officeDocument/2006/relationships" id="260" r:id="R644f5a067690428e"/>
-    <p:sldId xmlns:r="http://schemas.openxmlformats.org/officeDocument/2006/relationships" id="261" r:id="Rf7e03b4f919c4230"/>
-    <p:sldId xmlns:r="http://schemas.openxmlformats.org/officeDocument/2006/relationships" id="262" r:id="R59846c34ef8b4109"/>
-    <p:sldId xmlns:r="http://schemas.openxmlformats.org/officeDocument/2006/relationships" id="263" r:id="Rcbb33221d3e642d0"/>
-    <p:sldId xmlns:r="http://schemas.openxmlformats.org/officeDocument/2006/relationships" id="264" r:id="R426761045f18485a"/>
-    <p:sldId xmlns:r="http://schemas.openxmlformats.org/officeDocument/2006/relationships" id="265" r:id="R982feb5e85c04a46"/>
+    <p:sldId xmlns:r="http://schemas.openxmlformats.org/officeDocument/2006/relationships" id="256" r:id="R9a6b1bc1add0475b"/>
+    <p:sldId xmlns:r="http://schemas.openxmlformats.org/officeDocument/2006/relationships" id="257" r:id="Rb203bb90cb7b4125"/>
+    <p:sldId xmlns:r="http://schemas.openxmlformats.org/officeDocument/2006/relationships" id="258" r:id="Rc805728bc2c84f0f"/>
+    <p:sldId xmlns:r="http://schemas.openxmlformats.org/officeDocument/2006/relationships" id="259" r:id="R2637e841f1514a86"/>
+    <p:sldId xmlns:r="http://schemas.openxmlformats.org/officeDocument/2006/relationships" id="260" r:id="R426151c3bb3d4f0c"/>
+    <p:sldId xmlns:r="http://schemas.openxmlformats.org/officeDocument/2006/relationships" id="261" r:id="R3f36ee484a524225"/>
+    <p:sldId xmlns:r="http://schemas.openxmlformats.org/officeDocument/2006/relationships" id="262" r:id="R323337414e6e419b"/>
+    <p:sldId xmlns:r="http://schemas.openxmlformats.org/officeDocument/2006/relationships" id="263" r:id="R386d37de124644d9"/>
+    <p:sldId xmlns:r="http://schemas.openxmlformats.org/officeDocument/2006/relationships" id="264" r:id="R8ac8759bed364f34"/>
+    <p:sldId xmlns:r="http://schemas.openxmlformats.org/officeDocument/2006/relationships" id="265" r:id="R64e2f50c19d248fd"/>
   </p:sldIdLst>
   <p:sldSz cx="12192000" cy="6858000"/>
   <p:notesSz cx="6858000" cy="9144000"/>
@@ -451,7 +451,7 @@
           <a:lstStyle xmlns:a="http://schemas.openxmlformats.org/drawingml/2006/main"/>
           <a:p xmlns:a="http://schemas.openxmlformats.org/drawingml/2006/main">
             <a:r>
-              <a:t>Brad opens and introduces Wesley. Wesley introduces himself: Remington Vision was first assigned to him as an intern, and he carried it into his engineering role. WESLEY GAP (15–20 seconds): add in his own words what he works on now or what drew him into engineering. Brad resumes with the purpose of the talk.</a:t>
+              <a:t>Brad opens and introduces Wesley. Wesley introduces himself as one of the first software interns, first asked to take on Remington Vision, and now an engineer carrying it forward. WESLEY GAP (15–20 seconds): add in his own words what he works on now or what drew him into engineering. Brad resumes with the purpose of the talk.</a:t>
             </a:r>
           </a:p>
         </p:txBody>
@@ -731,7 +731,7 @@
           <a:lstStyle xmlns:a="http://schemas.openxmlformats.org/drawingml/2006/main"/>
           <a:p xmlns:a="http://schemas.openxmlformats.org/drawingml/2006/main">
             <a:r>
-              <a:t>Brad explains why he loves the work, then hands off to Wesley. Wesley explains why he loves it and how his ownership of Remington Vision grew from intern to engineer. WESLEY GAP (45–60 seconds): one specific problem, what he tried, when he saw progress, and why it mattered to him. Use only public details. Wesley closes the section.</a:t>
+              <a:t>Brad explains why he loves the work, then hands off to Wesley. Wesley describes his work with AI and different machines, and says he loves the variety, freedom to explore, ownership, and unexpected opportunities. WESLEY GAP (30–45 seconds): give one concrete example from Remington Vision or another project; name the problem, what he explored, and what he learned. Use only public details. Wesley closes the section.</a:t>
             </a:r>
           </a:p>
         </p:txBody>
@@ -3524,12 +3524,12 @@
   </p:cSld>
   <p:clrMap bg1="lt1" tx1="dk1" bg2="lt2" tx2="dk2" accent1="accent1" accent2="accent2" accent3="accent3" accent4="accent4" accent5="accent5" accent6="accent6" hlink="hlink" folHlink="folHlink"/>
   <p:sldLayoutIdLst>
-    <p:sldLayoutId xmlns:r="http://schemas.openxmlformats.org/officeDocument/2006/relationships" id="2147483649" r:id="Rf74564d163e14f32"/>
-    <p:sldLayoutId xmlns:r="http://schemas.openxmlformats.org/officeDocument/2006/relationships" id="2147483650" r:id="R4ee5456122a54d36"/>
-    <p:sldLayoutId xmlns:r="http://schemas.openxmlformats.org/officeDocument/2006/relationships" id="2147483651" r:id="R6243c8e7bf104e7c"/>
-    <p:sldLayoutId xmlns:r="http://schemas.openxmlformats.org/officeDocument/2006/relationships" id="2147483652" r:id="R89b5447d6eb0417b"/>
-    <p:sldLayoutId xmlns:r="http://schemas.openxmlformats.org/officeDocument/2006/relationships" id="2147483653" r:id="R5811bc7302d443be"/>
-    <p:sldLayoutId xmlns:r="http://schemas.openxmlformats.org/officeDocument/2006/relationships" id="2147483654" r:id="R5f19a8b9da6b47ac"/>
+    <p:sldLayoutId xmlns:r="http://schemas.openxmlformats.org/officeDocument/2006/relationships" id="2147483649" r:id="Rbbaf6b1c57e647cd"/>
+    <p:sldLayoutId xmlns:r="http://schemas.openxmlformats.org/officeDocument/2006/relationships" id="2147483650" r:id="R9d6124f6b0f14e76"/>
+    <p:sldLayoutId xmlns:r="http://schemas.openxmlformats.org/officeDocument/2006/relationships" id="2147483651" r:id="R988536fdef1943ec"/>
+    <p:sldLayoutId xmlns:r="http://schemas.openxmlformats.org/officeDocument/2006/relationships" id="2147483652" r:id="R7df6d23ed04a4e50"/>
+    <p:sldLayoutId xmlns:r="http://schemas.openxmlformats.org/officeDocument/2006/relationships" id="2147483653" r:id="R9feb23122e4b4fea"/>
+    <p:sldLayoutId xmlns:r="http://schemas.openxmlformats.org/officeDocument/2006/relationships" id="2147483654" r:id="R6189482736c3463b"/>
   </p:sldLayoutIdLst>
   <p:txStyles>
     <p:titleStyle>
@@ -4080,7 +4080,7 @@
           <p:cNvPr id="6" name="">
             <a:extLst xmlns:a="http://schemas.openxmlformats.org/drawingml/2006/main">
               <a:ext uri="{FF2B5EF4-FFF2-40B4-BE49-F238E27FC236}">
-                <a16:creationId xmlns:a16="http://schemas.microsoft.com/office/drawing/2014/main" id="{C61ABDED-3766-4ECC-ACF4-6132E655255A}"/>
+                <a16:creationId xmlns:a16="http://schemas.microsoft.com/office/drawing/2014/main" id="{B82B5B49-49E2-4A10-A3A9-FC5FA3A06950}"/>
               </a:ext>
             </a:extLst>
           </p:cNvPr>
@@ -4090,7 +4090,7 @@
           <p:nvPr/>
         </p:nvPicPr>
         <p:blipFill>
-          <a:blip xmlns:r="http://schemas.openxmlformats.org/officeDocument/2006/relationships" xmlns:a="http://schemas.openxmlformats.org/drawingml/2006/main" r:embed="Rfc8e2a04d1324588"/>
+          <a:blip xmlns:r="http://schemas.openxmlformats.org/officeDocument/2006/relationships" xmlns:a="http://schemas.openxmlformats.org/drawingml/2006/main" r:embed="Rb8910521ea0048fc"/>
           <a:stretch xmlns:a="http://schemas.openxmlformats.org/drawingml/2006/main"/>
         </p:blipFill>
         <p:spPr>
@@ -5349,7 +5349,7 @@
           <p:cNvPr id="3" name="">
             <a:extLst xmlns:a="http://schemas.openxmlformats.org/drawingml/2006/main">
               <a:ext uri="{FF2B5EF4-FFF2-40B4-BE49-F238E27FC236}">
-                <a16:creationId xmlns:a16="http://schemas.microsoft.com/office/drawing/2014/main" id="{E2B45AB5-D299-4AB2-8AEA-AFA171D875A2}"/>
+                <a16:creationId xmlns:a16="http://schemas.microsoft.com/office/drawing/2014/main" id="{C315457F-2EE3-467A-8D5E-FB4D72CC5D0B}"/>
               </a:ext>
             </a:extLst>
           </p:cNvPr>
@@ -5359,7 +5359,7 @@
           <p:nvPr/>
         </p:nvPicPr>
         <p:blipFill>
-          <a:blip xmlns:r="http://schemas.openxmlformats.org/officeDocument/2006/relationships" xmlns:a="http://schemas.openxmlformats.org/drawingml/2006/main" r:embed="Rfaf3a2a390a5438c"/>
+          <a:blip xmlns:r="http://schemas.openxmlformats.org/officeDocument/2006/relationships" xmlns:a="http://schemas.openxmlformats.org/drawingml/2006/main" r:embed="R20ddb55cb60e4f43"/>
           <a:stretch xmlns:a="http://schemas.openxmlformats.org/drawingml/2006/main"/>
         </p:blipFill>
         <p:spPr>
@@ -5377,7 +5377,7 @@
           <p:cNvPr id="16" name="">
             <a:extLst xmlns:a="http://schemas.openxmlformats.org/drawingml/2006/main">
               <a:ext uri="{FF2B5EF4-FFF2-40B4-BE49-F238E27FC236}">
-                <a16:creationId xmlns:a16="http://schemas.microsoft.com/office/drawing/2014/main" id="{C7C82162-4CC3-43D8-93BB-52656653B8B8}"/>
+                <a16:creationId xmlns:a16="http://schemas.microsoft.com/office/drawing/2014/main" id="{9ACC4E24-6F9F-43A8-9945-3AA141BB0930}"/>
               </a:ext>
             </a:extLst>
           </p:cNvPr>
@@ -5387,7 +5387,7 @@
           <p:nvPr/>
         </p:nvPicPr>
         <p:blipFill>
-          <a:blip xmlns:r="http://schemas.openxmlformats.org/officeDocument/2006/relationships" xmlns:a="http://schemas.openxmlformats.org/drawingml/2006/main" r:embed="Rbf224fee4ae5465f"/>
+          <a:blip xmlns:r="http://schemas.openxmlformats.org/officeDocument/2006/relationships" xmlns:a="http://schemas.openxmlformats.org/drawingml/2006/main" r:embed="R18a83c704aee4fa8"/>
           <a:stretch xmlns:a="http://schemas.openxmlformats.org/drawingml/2006/main"/>
         </p:blipFill>
         <p:spPr>
@@ -6777,7 +6777,7 @@
           <p:cNvPr id="29" name="">
             <a:extLst xmlns:a="http://schemas.openxmlformats.org/drawingml/2006/main">
               <a:ext uri="{FF2B5EF4-FFF2-40B4-BE49-F238E27FC236}">
-                <a16:creationId xmlns:a16="http://schemas.microsoft.com/office/drawing/2014/main" id="{5226836F-E796-41CD-A232-E3494E29E7E9}"/>
+                <a16:creationId xmlns:a16="http://schemas.microsoft.com/office/drawing/2014/main" id="{664AA859-828E-4031-A4EF-91EDF4C99C74}"/>
               </a:ext>
             </a:extLst>
           </p:cNvPr>
@@ -6787,7 +6787,7 @@
           <p:nvPr/>
         </p:nvPicPr>
         <p:blipFill>
-          <a:blip xmlns:r="http://schemas.openxmlformats.org/officeDocument/2006/relationships" xmlns:a="http://schemas.openxmlformats.org/drawingml/2006/main" r:embed="R6fad699d6a124cc1"/>
+          <a:blip xmlns:r="http://schemas.openxmlformats.org/officeDocument/2006/relationships" xmlns:a="http://schemas.openxmlformats.org/drawingml/2006/main" r:embed="R09a095d0a22b4fc1"/>
           <a:stretch xmlns:a="http://schemas.openxmlformats.org/drawingml/2006/main"/>
         </p:blipFill>
         <p:spPr>
@@ -6834,7 +6834,7 @@
           <p:cNvPr id="3" name="">
             <a:extLst xmlns:a="http://schemas.openxmlformats.org/drawingml/2006/main">
               <a:ext uri="{FF2B5EF4-FFF2-40B4-BE49-F238E27FC236}">
-                <a16:creationId xmlns:a16="http://schemas.microsoft.com/office/drawing/2014/main" id="{6D22F57C-1761-479D-93E2-6E6116B191E5}"/>
+                <a16:creationId xmlns:a16="http://schemas.microsoft.com/office/drawing/2014/main" id="{F9DA8BA7-0CF8-496F-A969-696CDA71BE43}"/>
               </a:ext>
             </a:extLst>
           </p:cNvPr>
@@ -6844,7 +6844,7 @@
           <p:nvPr/>
         </p:nvPicPr>
         <p:blipFill>
-          <a:blip xmlns:r="http://schemas.openxmlformats.org/officeDocument/2006/relationships" xmlns:a="http://schemas.openxmlformats.org/drawingml/2006/main" r:embed="Rb6e83ee2901b4360"/>
+          <a:blip xmlns:r="http://schemas.openxmlformats.org/officeDocument/2006/relationships" xmlns:a="http://schemas.openxmlformats.org/drawingml/2006/main" r:embed="Rfa70c19e444c48aa"/>
           <a:stretch xmlns:a="http://schemas.openxmlformats.org/drawingml/2006/main"/>
         </p:blipFill>
         <p:spPr>
@@ -8103,7 +8103,7 @@
           <p:cNvPr id="15" name="">
             <a:extLst xmlns:a="http://schemas.openxmlformats.org/drawingml/2006/main">
               <a:ext uri="{FF2B5EF4-FFF2-40B4-BE49-F238E27FC236}">
-                <a16:creationId xmlns:a16="http://schemas.microsoft.com/office/drawing/2014/main" id="{9E1261F3-BC75-42B2-8D13-D01969E42774}"/>
+                <a16:creationId xmlns:a16="http://schemas.microsoft.com/office/drawing/2014/main" id="{E57A3ABD-62CB-4CC4-B7AE-22F5ED020DE1}"/>
               </a:ext>
             </a:extLst>
           </p:cNvPr>
@@ -8113,7 +8113,7 @@
           <p:nvPr/>
         </p:nvPicPr>
         <p:blipFill>
-          <a:blip xmlns:r="http://schemas.openxmlformats.org/officeDocument/2006/relationships" xmlns:a="http://schemas.openxmlformats.org/drawingml/2006/main" r:embed="R1f8887a097384657"/>
+          <a:blip xmlns:r="http://schemas.openxmlformats.org/officeDocument/2006/relationships" xmlns:a="http://schemas.openxmlformats.org/drawingml/2006/main" r:embed="Reeba3e616716409f"/>
           <a:stretch xmlns:a="http://schemas.openxmlformats.org/drawingml/2006/main"/>
         </p:blipFill>
         <p:spPr>
@@ -8160,7 +8160,7 @@
           <p:cNvPr id="3" name="">
             <a:extLst xmlns:a="http://schemas.openxmlformats.org/drawingml/2006/main">
               <a:ext uri="{FF2B5EF4-FFF2-40B4-BE49-F238E27FC236}">
-                <a16:creationId xmlns:a16="http://schemas.microsoft.com/office/drawing/2014/main" id="{74DAA05D-9933-41C9-929B-E2CD48CE850D}"/>
+                <a16:creationId xmlns:a16="http://schemas.microsoft.com/office/drawing/2014/main" id="{C463C006-A1AB-43EE-A749-89D3A6BECA45}"/>
               </a:ext>
             </a:extLst>
           </p:cNvPr>
@@ -8170,7 +8170,7 @@
           <p:nvPr/>
         </p:nvPicPr>
         <p:blipFill>
-          <a:blip xmlns:r="http://schemas.openxmlformats.org/officeDocument/2006/relationships" xmlns:a="http://schemas.openxmlformats.org/drawingml/2006/main" r:embed="Re0e1ff77b91e470a"/>
+          <a:blip xmlns:r="http://schemas.openxmlformats.org/officeDocument/2006/relationships" xmlns:a="http://schemas.openxmlformats.org/drawingml/2006/main" r:embed="R43ac989a31004624"/>
           <a:stretch xmlns:a="http://schemas.openxmlformats.org/drawingml/2006/main"/>
         </p:blipFill>
         <p:spPr>
@@ -9098,7 +9098,7 @@
           <p:cNvPr id="14" name="">
             <a:extLst xmlns:a="http://schemas.openxmlformats.org/drawingml/2006/main">
               <a:ext uri="{FF2B5EF4-FFF2-40B4-BE49-F238E27FC236}">
-                <a16:creationId xmlns:a16="http://schemas.microsoft.com/office/drawing/2014/main" id="{C5784B5E-C6D6-4F91-8BA6-E117152E8BF5}"/>
+                <a16:creationId xmlns:a16="http://schemas.microsoft.com/office/drawing/2014/main" id="{FCB42446-C940-47A5-9032-0520A86693E9}"/>
               </a:ext>
             </a:extLst>
           </p:cNvPr>
@@ -9108,7 +9108,7 @@
           <p:nvPr/>
         </p:nvPicPr>
         <p:blipFill>
-          <a:blip xmlns:r="http://schemas.openxmlformats.org/officeDocument/2006/relationships" xmlns:a="http://schemas.openxmlformats.org/drawingml/2006/main" r:embed="R6c137fb680044baf"/>
+          <a:blip xmlns:r="http://schemas.openxmlformats.org/officeDocument/2006/relationships" xmlns:a="http://schemas.openxmlformats.org/drawingml/2006/main" r:embed="R2688039d03b44124"/>
           <a:stretch xmlns:a="http://schemas.openxmlformats.org/drawingml/2006/main"/>
         </p:blipFill>
         <p:spPr>
@@ -9679,7 +9679,7 @@
           <p:cNvPr id="3" name="">
             <a:extLst xmlns:a="http://schemas.openxmlformats.org/drawingml/2006/main">
               <a:ext uri="{FF2B5EF4-FFF2-40B4-BE49-F238E27FC236}">
-                <a16:creationId xmlns:a16="http://schemas.microsoft.com/office/drawing/2014/main" id="{2E17B0A8-734B-49A6-8606-82BB732D35EB}"/>
+                <a16:creationId xmlns:a16="http://schemas.microsoft.com/office/drawing/2014/main" id="{5E559575-1835-4582-9877-E99E9F489CB2}"/>
               </a:ext>
             </a:extLst>
           </p:cNvPr>
@@ -9689,7 +9689,7 @@
           <p:nvPr/>
         </p:nvPicPr>
         <p:blipFill>
-          <a:blip xmlns:r="http://schemas.openxmlformats.org/officeDocument/2006/relationships" xmlns:a="http://schemas.openxmlformats.org/drawingml/2006/main" r:embed="R452df72340634f87"/>
+          <a:blip xmlns:r="http://schemas.openxmlformats.org/officeDocument/2006/relationships" xmlns:a="http://schemas.openxmlformats.org/drawingml/2006/main" r:embed="Rd18a27e72c46454d"/>
           <a:stretch xmlns:a="http://schemas.openxmlformats.org/drawingml/2006/main"/>
         </p:blipFill>
         <p:spPr>
@@ -10648,7 +10648,7 @@
           <p:cNvPr id="15" name="">
             <a:extLst xmlns:a="http://schemas.openxmlformats.org/drawingml/2006/main">
               <a:ext uri="{FF2B5EF4-FFF2-40B4-BE49-F238E27FC236}">
-                <a16:creationId xmlns:a16="http://schemas.microsoft.com/office/drawing/2014/main" id="{5FB3841B-A70D-4BE0-92DD-CA57B312CF36}"/>
+                <a16:creationId xmlns:a16="http://schemas.microsoft.com/office/drawing/2014/main" id="{1318C101-FC56-472B-B1DB-840B0B22AB0F}"/>
               </a:ext>
             </a:extLst>
           </p:cNvPr>
@@ -10658,7 +10658,7 @@
           <p:nvPr/>
         </p:nvPicPr>
         <p:blipFill>
-          <a:blip xmlns:r="http://schemas.openxmlformats.org/officeDocument/2006/relationships" xmlns:a="http://schemas.openxmlformats.org/drawingml/2006/main" r:embed="R241131685a8e4ac8"/>
+          <a:blip xmlns:r="http://schemas.openxmlformats.org/officeDocument/2006/relationships" xmlns:a="http://schemas.openxmlformats.org/drawingml/2006/main" r:embed="Re71057bfe12e4f77"/>
           <a:stretch xmlns:a="http://schemas.openxmlformats.org/drawingml/2006/main"/>
         </p:blipFill>
         <p:spPr>
@@ -11229,7 +11229,7 @@
           <p:cNvPr id="3" name="">
             <a:extLst xmlns:a="http://schemas.openxmlformats.org/drawingml/2006/main">
               <a:ext uri="{FF2B5EF4-FFF2-40B4-BE49-F238E27FC236}">
-                <a16:creationId xmlns:a16="http://schemas.microsoft.com/office/drawing/2014/main" id="{1BB4025B-CBC7-40A7-A10F-BB24619CFAC7}"/>
+                <a16:creationId xmlns:a16="http://schemas.microsoft.com/office/drawing/2014/main" id="{87E6D3A1-AF32-411D-AF36-4BD326C9DF5B}"/>
               </a:ext>
             </a:extLst>
           </p:cNvPr>
@@ -11239,7 +11239,7 @@
           <p:nvPr/>
         </p:nvPicPr>
         <p:blipFill>
-          <a:blip xmlns:r="http://schemas.openxmlformats.org/officeDocument/2006/relationships" xmlns:a="http://schemas.openxmlformats.org/drawingml/2006/main" r:embed="Rca5bf9bf7c3e47ac"/>
+          <a:blip xmlns:r="http://schemas.openxmlformats.org/officeDocument/2006/relationships" xmlns:a="http://schemas.openxmlformats.org/drawingml/2006/main" r:embed="R91832e82746a4dea"/>
           <a:stretch xmlns:a="http://schemas.openxmlformats.org/drawingml/2006/main"/>
         </p:blipFill>
         <p:spPr>
@@ -11257,7 +11257,7 @@
           <p:cNvPr id="10" name="">
             <a:extLst xmlns:a="http://schemas.openxmlformats.org/drawingml/2006/main">
               <a:ext uri="{FF2B5EF4-FFF2-40B4-BE49-F238E27FC236}">
-                <a16:creationId xmlns:a16="http://schemas.microsoft.com/office/drawing/2014/main" id="{25FEC65A-EC1A-4ACD-BC74-ABF2A148953C}"/>
+                <a16:creationId xmlns:a16="http://schemas.microsoft.com/office/drawing/2014/main" id="{BA86C03C-B1E1-4EAE-92CA-91851671E546}"/>
               </a:ext>
             </a:extLst>
           </p:cNvPr>
@@ -11267,7 +11267,7 @@
           <p:nvPr/>
         </p:nvPicPr>
         <p:blipFill>
-          <a:blip xmlns:r="http://schemas.openxmlformats.org/officeDocument/2006/relationships" xmlns:a="http://schemas.openxmlformats.org/drawingml/2006/main" r:embed="R8565e0e0ee524758"/>
+          <a:blip xmlns:r="http://schemas.openxmlformats.org/officeDocument/2006/relationships" xmlns:a="http://schemas.openxmlformats.org/drawingml/2006/main" r:embed="R60d2970f8ef14f27"/>
           <a:stretch xmlns:a="http://schemas.openxmlformats.org/drawingml/2006/main"/>
         </p:blipFill>
         <p:spPr>
@@ -11871,7 +11871,7 @@
           <p:cNvPr id="17" name="">
             <a:extLst xmlns:a="http://schemas.openxmlformats.org/drawingml/2006/main">
               <a:ext uri="{FF2B5EF4-FFF2-40B4-BE49-F238E27FC236}">
-                <a16:creationId xmlns:a16="http://schemas.microsoft.com/office/drawing/2014/main" id="{4CA3FA1A-E62A-44AA-A1AD-9F44F6E4CE9F}"/>
+                <a16:creationId xmlns:a16="http://schemas.microsoft.com/office/drawing/2014/main" id="{4FB06C6D-7C9F-49F7-9789-406950242487}"/>
               </a:ext>
             </a:extLst>
           </p:cNvPr>
@@ -11881,7 +11881,7 @@
           <p:nvPr/>
         </p:nvPicPr>
         <p:blipFill>
-          <a:blip xmlns:r="http://schemas.openxmlformats.org/officeDocument/2006/relationships" xmlns:a="http://schemas.openxmlformats.org/drawingml/2006/main" r:embed="R7e6e9f1d956d42db"/>
+          <a:blip xmlns:r="http://schemas.openxmlformats.org/officeDocument/2006/relationships" xmlns:a="http://schemas.openxmlformats.org/drawingml/2006/main" r:embed="R78802451e2ad4b51"/>
           <a:stretch xmlns:a="http://schemas.openxmlformats.org/drawingml/2006/main"/>
         </p:blipFill>
         <p:spPr>
@@ -11928,7 +11928,7 @@
           <p:cNvPr id="3" name="">
             <a:extLst xmlns:a="http://schemas.openxmlformats.org/drawingml/2006/main">
               <a:ext uri="{FF2B5EF4-FFF2-40B4-BE49-F238E27FC236}">
-                <a16:creationId xmlns:a16="http://schemas.microsoft.com/office/drawing/2014/main" id="{CD18FE0C-79B6-4406-9ADE-45ECDECD2FB6}"/>
+                <a16:creationId xmlns:a16="http://schemas.microsoft.com/office/drawing/2014/main" id="{B467CDAB-AB88-4348-BEB4-5B62FD98CF92}"/>
               </a:ext>
             </a:extLst>
           </p:cNvPr>
@@ -11938,7 +11938,7 @@
           <p:nvPr/>
         </p:nvPicPr>
         <p:blipFill>
-          <a:blip xmlns:r="http://schemas.openxmlformats.org/officeDocument/2006/relationships" xmlns:a="http://schemas.openxmlformats.org/drawingml/2006/main" r:embed="R4f24f81d22fe480a"/>
+          <a:blip xmlns:r="http://schemas.openxmlformats.org/officeDocument/2006/relationships" xmlns:a="http://schemas.openxmlformats.org/drawingml/2006/main" r:embed="R4806ff3065a94813"/>
           <a:stretch xmlns:a="http://schemas.openxmlformats.org/drawingml/2006/main"/>
         </p:blipFill>
         <p:spPr>
@@ -13259,7 +13259,7 @@
           <p:cNvPr id="17" name="">
             <a:extLst xmlns:a="http://schemas.openxmlformats.org/drawingml/2006/main">
               <a:ext uri="{FF2B5EF4-FFF2-40B4-BE49-F238E27FC236}">
-                <a16:creationId xmlns:a16="http://schemas.microsoft.com/office/drawing/2014/main" id="{FF502747-4977-466F-9002-5C13B4B923E6}"/>
+                <a16:creationId xmlns:a16="http://schemas.microsoft.com/office/drawing/2014/main" id="{1A23364D-B047-44D2-BA4B-5AD990CE92DC}"/>
               </a:ext>
             </a:extLst>
           </p:cNvPr>
@@ -13269,7 +13269,7 @@
           <p:nvPr/>
         </p:nvPicPr>
         <p:blipFill>
-          <a:blip xmlns:r="http://schemas.openxmlformats.org/officeDocument/2006/relationships" xmlns:a="http://schemas.openxmlformats.org/drawingml/2006/main" r:embed="R06dc5d0f440048a1"/>
+          <a:blip xmlns:r="http://schemas.openxmlformats.org/officeDocument/2006/relationships" xmlns:a="http://schemas.openxmlformats.org/drawingml/2006/main" r:embed="Rebe1aa55ff794d85"/>
           <a:stretch xmlns:a="http://schemas.openxmlformats.org/drawingml/2006/main"/>
         </p:blipFill>
         <p:spPr>
@@ -13447,7 +13447,7 @@
           <p:cNvPr id="3" name="">
             <a:extLst xmlns:a="http://schemas.openxmlformats.org/drawingml/2006/main">
               <a:ext uri="{FF2B5EF4-FFF2-40B4-BE49-F238E27FC236}">
-                <a16:creationId xmlns:a16="http://schemas.microsoft.com/office/drawing/2014/main" id="{36F709BE-44EE-4B8B-BC1E-2B87D9EF53C2}"/>
+                <a16:creationId xmlns:a16="http://schemas.microsoft.com/office/drawing/2014/main" id="{9438750E-D811-4C1C-9EC5-851EDAAE289E}"/>
               </a:ext>
             </a:extLst>
           </p:cNvPr>
@@ -13457,7 +13457,7 @@
           <p:nvPr/>
         </p:nvPicPr>
         <p:blipFill>
-          <a:blip xmlns:r="http://schemas.openxmlformats.org/officeDocument/2006/relationships" xmlns:a="http://schemas.openxmlformats.org/drawingml/2006/main" r:embed="Re8b95dd8900441d2"/>
+          <a:blip xmlns:r="http://schemas.openxmlformats.org/officeDocument/2006/relationships" xmlns:a="http://schemas.openxmlformats.org/drawingml/2006/main" r:embed="R8e427e0fe75d4f09"/>
           <a:stretch xmlns:a="http://schemas.openxmlformats.org/drawingml/2006/main"/>
         </p:blipFill>
         <p:spPr>
@@ -14454,7 +14454,7 @@
           <p:cNvPr id="13" name="">
             <a:extLst xmlns:a="http://schemas.openxmlformats.org/drawingml/2006/main">
               <a:ext uri="{FF2B5EF4-FFF2-40B4-BE49-F238E27FC236}">
-                <a16:creationId xmlns:a16="http://schemas.microsoft.com/office/drawing/2014/main" id="{10C85B9B-3F8A-4C41-8B6E-740345F26602}"/>
+                <a16:creationId xmlns:a16="http://schemas.microsoft.com/office/drawing/2014/main" id="{0774EF6E-9B44-4169-8ADC-9DCA64233C8C}"/>
               </a:ext>
             </a:extLst>
           </p:cNvPr>
@@ -14464,7 +14464,7 @@
           <p:nvPr/>
         </p:nvPicPr>
         <p:blipFill>
-          <a:blip xmlns:r="http://schemas.openxmlformats.org/officeDocument/2006/relationships" xmlns:a="http://schemas.openxmlformats.org/drawingml/2006/main" r:embed="R8a2e8338933547f8"/>
+          <a:blip xmlns:r="http://schemas.openxmlformats.org/officeDocument/2006/relationships" xmlns:a="http://schemas.openxmlformats.org/drawingml/2006/main" r:embed="Rd3dbb220d3114afb"/>
           <a:stretch xmlns:a="http://schemas.openxmlformats.org/drawingml/2006/main"/>
         </p:blipFill>
         <p:spPr>
@@ -15166,7 +15166,7 @@
           <p:cNvPr id="3" name="">
             <a:extLst xmlns:a="http://schemas.openxmlformats.org/drawingml/2006/main">
               <a:ext uri="{FF2B5EF4-FFF2-40B4-BE49-F238E27FC236}">
-                <a16:creationId xmlns:a16="http://schemas.microsoft.com/office/drawing/2014/main" id="{856DFAE6-72B8-407D-B815-72CF09F725CD}"/>
+                <a16:creationId xmlns:a16="http://schemas.microsoft.com/office/drawing/2014/main" id="{0879377F-4970-4DAA-B4CC-23542988B6CC}"/>
               </a:ext>
             </a:extLst>
           </p:cNvPr>
@@ -15176,7 +15176,7 @@
           <p:nvPr/>
         </p:nvPicPr>
         <p:blipFill>
-          <a:blip xmlns:r="http://schemas.openxmlformats.org/officeDocument/2006/relationships" xmlns:a="http://schemas.openxmlformats.org/drawingml/2006/main" r:embed="R8d97783121f3411f"/>
+          <a:blip xmlns:r="http://schemas.openxmlformats.org/officeDocument/2006/relationships" xmlns:a="http://schemas.openxmlformats.org/drawingml/2006/main" r:embed="Rac896f24e4e84145"/>
           <a:stretch xmlns:a="http://schemas.openxmlformats.org/drawingml/2006/main"/>
         </p:blipFill>
         <p:spPr>
@@ -15194,7 +15194,7 @@
           <p:cNvPr id="7" name="">
             <a:extLst xmlns:a="http://schemas.openxmlformats.org/drawingml/2006/main">
               <a:ext uri="{FF2B5EF4-FFF2-40B4-BE49-F238E27FC236}">
-                <a16:creationId xmlns:a16="http://schemas.microsoft.com/office/drawing/2014/main" id="{B11A55EC-765B-4B2C-89E2-C381BF57D38B}"/>
+                <a16:creationId xmlns:a16="http://schemas.microsoft.com/office/drawing/2014/main" id="{8661A38D-356B-40FF-B3C4-0C397DD7E71C}"/>
               </a:ext>
             </a:extLst>
           </p:cNvPr>
@@ -15204,7 +15204,7 @@
           <p:nvPr/>
         </p:nvPicPr>
         <p:blipFill>
-          <a:blip xmlns:r="http://schemas.openxmlformats.org/officeDocument/2006/relationships" xmlns:a="http://schemas.openxmlformats.org/drawingml/2006/main" r:embed="R6dd6e00de20444dd"/>
+          <a:blip xmlns:r="http://schemas.openxmlformats.org/officeDocument/2006/relationships" xmlns:a="http://schemas.openxmlformats.org/drawingml/2006/main" r:embed="R47498689b2834766"/>
           <a:stretch xmlns:a="http://schemas.openxmlformats.org/drawingml/2006/main"/>
         </p:blipFill>
         <p:spPr>
@@ -16039,7 +16039,7 @@
           <p:cNvPr id="15" name="">
             <a:extLst xmlns:a="http://schemas.openxmlformats.org/drawingml/2006/main">
               <a:ext uri="{FF2B5EF4-FFF2-40B4-BE49-F238E27FC236}">
-                <a16:creationId xmlns:a16="http://schemas.microsoft.com/office/drawing/2014/main" id="{9A7AF54E-4913-49A4-B401-F91639EF1DC7}"/>
+                <a16:creationId xmlns:a16="http://schemas.microsoft.com/office/drawing/2014/main" id="{1A05172A-8469-46C9-96B7-5CDA8D87696C}"/>
               </a:ext>
             </a:extLst>
           </p:cNvPr>
@@ -16049,7 +16049,7 @@
           <p:nvPr/>
         </p:nvPicPr>
         <p:blipFill>
-          <a:blip xmlns:r="http://schemas.openxmlformats.org/officeDocument/2006/relationships" xmlns:a="http://schemas.openxmlformats.org/drawingml/2006/main" r:embed="Rdf39e788823b4dde"/>
+          <a:blip xmlns:r="http://schemas.openxmlformats.org/officeDocument/2006/relationships" xmlns:a="http://schemas.openxmlformats.org/drawingml/2006/main" r:embed="R6fcc6286b52144fc"/>
           <a:stretch xmlns:a="http://schemas.openxmlformats.org/drawingml/2006/main"/>
         </p:blipFill>
         <p:spPr>
@@ -16258,7 +16258,7 @@
           <p:cNvPr id="3" name="">
             <a:extLst xmlns:a="http://schemas.openxmlformats.org/drawingml/2006/main">
               <a:ext uri="{FF2B5EF4-FFF2-40B4-BE49-F238E27FC236}">
-                <a16:creationId xmlns:a16="http://schemas.microsoft.com/office/drawing/2014/main" id="{2B3C6D56-E089-41D8-BC58-FB1B621A8271}"/>
+                <a16:creationId xmlns:a16="http://schemas.microsoft.com/office/drawing/2014/main" id="{0DA5DC3C-6A9B-4D53-8FD4-DFFBAD402AEB}"/>
               </a:ext>
             </a:extLst>
           </p:cNvPr>
@@ -16268,7 +16268,7 @@
           <p:nvPr/>
         </p:nvPicPr>
         <p:blipFill>
-          <a:blip xmlns:r="http://schemas.openxmlformats.org/officeDocument/2006/relationships" xmlns:a="http://schemas.openxmlformats.org/drawingml/2006/main" r:embed="Rab816bab28474130"/>
+          <a:blip xmlns:r="http://schemas.openxmlformats.org/officeDocument/2006/relationships" xmlns:a="http://schemas.openxmlformats.org/drawingml/2006/main" r:embed="R22cda5998970419e"/>
           <a:stretch xmlns:a="http://schemas.openxmlformats.org/drawingml/2006/main"/>
         </p:blipFill>
         <p:spPr>

</xml_diff>

<commit_message>
Polish engineering talk and closing message
</commit_message>
<xml_diff>
--- a/docs/presentation/Engineering_at_The_Kinetic_Group.pptx
+++ b/docs/presentation/Engineering_at_The_Kinetic_Group.pptx
@@ -2,22 +2,22 @@
 <file path=ppt/presentation.xml><?xml version="1.0" encoding="utf-8"?>
 <p:presentation xmlns:p="http://schemas.openxmlformats.org/presentationml/2006/main">
   <p:sldMasterIdLst>
-    <p:sldMasterId xmlns:r="http://schemas.openxmlformats.org/officeDocument/2006/relationships" id="2147483648" r:id="R523cd56fe2034176"/>
+    <p:sldMasterId xmlns:r="http://schemas.openxmlformats.org/officeDocument/2006/relationships" id="2147483648" r:id="Ra56859a29a434a18"/>
   </p:sldMasterIdLst>
   <p:notesMasterIdLst>
-    <p:notesMasterId xmlns:r="http://schemas.openxmlformats.org/officeDocument/2006/relationships" r:id="R9fbd5f28c15d4f2f"/>
+    <p:notesMasterId xmlns:r="http://schemas.openxmlformats.org/officeDocument/2006/relationships" r:id="R2a907b1aa2f84477"/>
   </p:notesMasterIdLst>
   <p:sldIdLst>
-    <p:sldId xmlns:r="http://schemas.openxmlformats.org/officeDocument/2006/relationships" id="256" r:id="R9a6b1bc1add0475b"/>
-    <p:sldId xmlns:r="http://schemas.openxmlformats.org/officeDocument/2006/relationships" id="257" r:id="Rb203bb90cb7b4125"/>
-    <p:sldId xmlns:r="http://schemas.openxmlformats.org/officeDocument/2006/relationships" id="258" r:id="Rc805728bc2c84f0f"/>
-    <p:sldId xmlns:r="http://schemas.openxmlformats.org/officeDocument/2006/relationships" id="259" r:id="R2637e841f1514a86"/>
-    <p:sldId xmlns:r="http://schemas.openxmlformats.org/officeDocument/2006/relationships" id="260" r:id="R426151c3bb3d4f0c"/>
-    <p:sldId xmlns:r="http://schemas.openxmlformats.org/officeDocument/2006/relationships" id="261" r:id="R3f36ee484a524225"/>
-    <p:sldId xmlns:r="http://schemas.openxmlformats.org/officeDocument/2006/relationships" id="262" r:id="R323337414e6e419b"/>
-    <p:sldId xmlns:r="http://schemas.openxmlformats.org/officeDocument/2006/relationships" id="263" r:id="R386d37de124644d9"/>
-    <p:sldId xmlns:r="http://schemas.openxmlformats.org/officeDocument/2006/relationships" id="264" r:id="R8ac8759bed364f34"/>
-    <p:sldId xmlns:r="http://schemas.openxmlformats.org/officeDocument/2006/relationships" id="265" r:id="R64e2f50c19d248fd"/>
+    <p:sldId xmlns:r="http://schemas.openxmlformats.org/officeDocument/2006/relationships" id="256" r:id="R90b6f9f909214c27"/>
+    <p:sldId xmlns:r="http://schemas.openxmlformats.org/officeDocument/2006/relationships" id="257" r:id="R9243a423dead404a"/>
+    <p:sldId xmlns:r="http://schemas.openxmlformats.org/officeDocument/2006/relationships" id="258" r:id="R515616e8f75c440d"/>
+    <p:sldId xmlns:r="http://schemas.openxmlformats.org/officeDocument/2006/relationships" id="259" r:id="R92498b07d3164127"/>
+    <p:sldId xmlns:r="http://schemas.openxmlformats.org/officeDocument/2006/relationships" id="260" r:id="R3eeecab6c7ca4227"/>
+    <p:sldId xmlns:r="http://schemas.openxmlformats.org/officeDocument/2006/relationships" id="261" r:id="R75be4792e224410d"/>
+    <p:sldId xmlns:r="http://schemas.openxmlformats.org/officeDocument/2006/relationships" id="262" r:id="Rd8bd3fe1a7674230"/>
+    <p:sldId xmlns:r="http://schemas.openxmlformats.org/officeDocument/2006/relationships" id="263" r:id="R35bdcb13ee414294"/>
+    <p:sldId xmlns:r="http://schemas.openxmlformats.org/officeDocument/2006/relationships" id="264" r:id="R82db0c6a3b0a4e60"/>
+    <p:sldId xmlns:r="http://schemas.openxmlformats.org/officeDocument/2006/relationships" id="265" r:id="Rff2fc45c47fa4df4"/>
   </p:sldIdLst>
   <p:sldSz cx="12192000" cy="6858000"/>
   <p:notesSz cx="6858000" cy="9144000"/>
@@ -451,7 +451,7 @@
           <a:lstStyle xmlns:a="http://schemas.openxmlformats.org/drawingml/2006/main"/>
           <a:p xmlns:a="http://schemas.openxmlformats.org/drawingml/2006/main">
             <a:r>
-              <a:t>Brad opens and introduces Wesley. Wesley introduces himself as one of the first software interns, first asked to take on Remington Vision, and now an engineer carrying it forward. WESLEY GAP (15–20 seconds): add in his own words what he works on now or what drew him into engineering. Brad resumes with the purpose of the talk.</a:t>
+              <a:t>BRAD: Introduce yourself as lead of small engineering teams across TKG, mainly at Remington. Introduce Wesley. WESLEY: One of the first software interns; Remington Vision began with him as an intern and continues in his engineering role. WESLEY GAP (15–20 seconds): add a personal sentence. BRAD: state the purpose of the talk and invitation to connect.</a:t>
             </a:r>
           </a:p>
         </p:txBody>
@@ -521,7 +521,7 @@
           <a:lstStyle xmlns:a="http://schemas.openxmlformats.org/drawingml/2006/main"/>
           <a:p xmlns:a="http://schemas.openxmlformats.org/drawingml/2006/main">
             <a:r>
-              <a:t>Brad gives his email and follow-up paths: official careers page for company roles and the independent 4Founders platform for project connections. Wesley invites questions about engineering and students’ own projects. Brad gives the final thanks.</a:t>
+              <a:t>BRAD: Give email, official careers page, and independent 4Founders path. WESLEY: Invite engineering questions and student projects. BRAD: Close with the on-screen line: “Our history was made on the factory floor. The future will be, too. Come build and fight with us. Turn AI into action.” Hold this slide for questions.</a:t>
             </a:r>
           </a:p>
         </p:txBody>
@@ -591,7 +591,7 @@
           <a:lstStyle xmlns:a="http://schemas.openxmlformats.org/drawingml/2006/main"/>
           <a:p xmlns:a="http://schemas.openxmlformats.org/drawingml/2006/main">
             <a:r>
-              <a:t>Remington traces its history to 1816: https://www.remington.com/about-us.html . Remington says Lonoke operations began in 1969: https://www.remington.com/big-green-blog/labor-day-special.html . Honor that history. The world has changed, and our ambition is for Remington and The Kinetic Group to keep writing the rules for manufacturing for decades to come. This is an aspiration, not a claim that a new standard already exists.</a:t>
+              <a:t>BRAD: Honor the manufacturing legacy and set the ambition to keep writing the rules for decades to come. Remington traces its history to 1816: https://www.remington.com/about-us.html . Remington says Lonoke operations began in 1969: https://www.remington.com/big-green-blog/labor-day-special.html . This is our ambition, not a claim that we already set a new industry standard.</a:t>
             </a:r>
           </a:p>
         </p:txBody>
@@ -661,7 +661,7 @@
           <a:lstStyle xmlns:a="http://schemas.openxmlformats.org/drawingml/2006/main"/>
           <a:p xmlns:a="http://schemas.openxmlformats.org/drawingml/2006/main">
             <a:r>
-              <a:t>Explain that the work crosses machines, controls, and software. These capabilities meet on the factory floor. Use one approved example to show how an engineering idea becomes something people can actually use.</a:t>
+              <a:t>BRAD: Explain the system simply: machines sense what is happening; software turns signals into a decision; people or equipment act. Small teams across TKG, primarily at Remington, build, test, and improve the full chain with the people who use it. Keep details for questions.</a:t>
             </a:r>
           </a:p>
         </p:txBody>
@@ -731,7 +731,7 @@
           <a:lstStyle xmlns:a="http://schemas.openxmlformats.org/drawingml/2006/main"/>
           <a:p xmlns:a="http://schemas.openxmlformats.org/drawingml/2006/main">
             <a:r>
-              <a:t>Brad explains why he loves the work, then hands off to Wesley. Wesley describes his work with AI and different machines, and says he loves the variety, freedom to explore, ownership, and unexpected opportunities. WESLEY GAP (30–45 seconds): give one concrete example from Remington Vision or another project; name the problem, what he explored, and what he learned. Use only public details. Wesley closes the section.</a:t>
+              <a:t>BRAD: Say why you love the variety and visible impact, then hand off. WESLEY: Use his own points—one of the first software interns; work with AI and different machines; freedom to explore; ownership; unexpected opportunities. WESLEY GAP (30–45 seconds): one concrete public example of a problem, what he explored, and what he learned.</a:t>
             </a:r>
           </a:p>
         </p:txBody>
@@ -801,7 +801,7 @@
           <a:lstStyle xmlns:a="http://schemas.openxmlformats.org/drawingml/2006/main"/>
           <a:p xmlns:a="http://schemas.openxmlformats.org/drawingml/2006/main">
             <a:r>
-              <a:t>Wesley leads the live demonstration while Brad operates slides. Show a Gatorade bottle under the camera, then a different color; pause after each on-screen sorting result. Let the audience choose a bottle or show another visible feature if the setup supports it. The demonstration setup does not control production sorting hardware.</a:t>
+              <a:t>WESLEY leads; BRAD operates slides. Show Gatorade bottles under the camera and the on-screen sorting decision. Pause after each result; invite a choice or another feature if the setup supports it. This is a demonstration setup and does not control a production sorting line.</a:t>
             </a:r>
           </a:p>
         </p:txBody>
@@ -871,7 +871,7 @@
           <a:lstStyle xmlns:a="http://schemas.openxmlformats.org/drawingml/2006/main"/>
           <a:p xmlns:a="http://schemas.openxmlformats.org/drawingml/2006/main">
             <a:r>
-              <a:t>Wesley explains the engineering challenges after the demo: changing conditions, timing, and repeatability. WESLEY GAP (20–30 seconds): point to one behavior the audience just saw and describe a practical challenge solved to make it repeatable, using only public details. Brad then connects this to the broader manufacturing ambition.</a:t>
+              <a:t>WESLEY: Explain variation, timing, and reliability using what the audience just saw. WESLEY GAP (20–30 seconds): a practical challenge solved to make one behavior repeatable; share only public details. BRAD: disciplined engineering is what makes a capability useful in real manufacturing conditions.</a:t>
             </a:r>
           </a:p>
         </p:txBody>
@@ -941,7 +941,7 @@
           <a:lstStyle xmlns:a="http://schemas.openxmlformats.org/drawingml/2006/main"/>
           <a:p xmlns:a="http://schemas.openxmlformats.org/drawingml/2006/main">
             <a:r>
-              <a:t>Brad resumes. Invite people who want to take on these challenges. Opportunities span Remington and The Kinetic Group. Point employment interest to the official careers page.</a:t>
+              <a:t>BRAD: Invite talent across Remington and TKG. Mention mechanical engineering, controls, software, and testing as examples; curiosity and persistence matter too. Direct job applications to the official careers page. Ask students what they have built and want to try next.</a:t>
             </a:r>
           </a:p>
         </p:txBody>
@@ -1011,7 +1011,7 @@
           <a:lstStyle xmlns:a="http://schemas.openxmlformats.org/drawingml/2006/main"/>
           <a:p xmlns:a="http://schemas.openxmlformats.org/drawingml/2006/main">
             <a:r>
-              <a:t>Invite the audience into the separate 4Founders interactive challenge. Ask them to scan the QR code or use the displayed link and PIN. Distinguish this independent project platform from The Kinetic Group careers process.</a:t>
+              <a:t>BRAD: Run the separate 4Founders interactive challenge. Ask audience to scan QR or use the URL and event PIN, then draw, test, and change. Allow about three minutes. 4Founders is an independent project platform; company job applications go through TKG careers.</a:t>
             </a:r>
           </a:p>
         </p:txBody>
@@ -1081,7 +1081,7 @@
           <a:lstStyle xmlns:a="http://schemas.openxmlformats.org/drawingml/2006/main"/>
           <a:p xmlns:a="http://schemas.openxmlformats.org/drawingml/2006/main">
             <a:r>
-              <a:t>Students may have interests beyond the fields just listed. Ask what they want to pursue. If there is a genuine fit, you would be interested in exploring it together, and your organization might even become an early or first customer. Present this as a possibility that depends on the idea and appropriate follow-up, not a commitment.</a:t>
+              <a:t>BRAD: Invite interests beyond the disciplines shown. Ask what students want to pursue. If a real fit emerges, explore a first step together; in the right situation the organization might become their first customer. This is a possibility, not a commitment.</a:t>
             </a:r>
           </a:p>
         </p:txBody>
@@ -3524,12 +3524,12 @@
   </p:cSld>
   <p:clrMap bg1="lt1" tx1="dk1" bg2="lt2" tx2="dk2" accent1="accent1" accent2="accent2" accent3="accent3" accent4="accent4" accent5="accent5" accent6="accent6" hlink="hlink" folHlink="folHlink"/>
   <p:sldLayoutIdLst>
-    <p:sldLayoutId xmlns:r="http://schemas.openxmlformats.org/officeDocument/2006/relationships" id="2147483649" r:id="Rbbaf6b1c57e647cd"/>
-    <p:sldLayoutId xmlns:r="http://schemas.openxmlformats.org/officeDocument/2006/relationships" id="2147483650" r:id="R9d6124f6b0f14e76"/>
-    <p:sldLayoutId xmlns:r="http://schemas.openxmlformats.org/officeDocument/2006/relationships" id="2147483651" r:id="R988536fdef1943ec"/>
-    <p:sldLayoutId xmlns:r="http://schemas.openxmlformats.org/officeDocument/2006/relationships" id="2147483652" r:id="R7df6d23ed04a4e50"/>
-    <p:sldLayoutId xmlns:r="http://schemas.openxmlformats.org/officeDocument/2006/relationships" id="2147483653" r:id="R9feb23122e4b4fea"/>
-    <p:sldLayoutId xmlns:r="http://schemas.openxmlformats.org/officeDocument/2006/relationships" id="2147483654" r:id="R6189482736c3463b"/>
+    <p:sldLayoutId xmlns:r="http://schemas.openxmlformats.org/officeDocument/2006/relationships" id="2147483649" r:id="R99279bb296664de3"/>
+    <p:sldLayoutId xmlns:r="http://schemas.openxmlformats.org/officeDocument/2006/relationships" id="2147483650" r:id="Rb86a3e4fcfec4e98"/>
+    <p:sldLayoutId xmlns:r="http://schemas.openxmlformats.org/officeDocument/2006/relationships" id="2147483651" r:id="Rdcb0a587e88e4f5c"/>
+    <p:sldLayoutId xmlns:r="http://schemas.openxmlformats.org/officeDocument/2006/relationships" id="2147483652" r:id="R6a41971341aa4f11"/>
+    <p:sldLayoutId xmlns:r="http://schemas.openxmlformats.org/officeDocument/2006/relationships" id="2147483653" r:id="R519d8de83f03492a"/>
+    <p:sldLayoutId xmlns:r="http://schemas.openxmlformats.org/officeDocument/2006/relationships" id="2147483654" r:id="R90ad59d010e7494a"/>
   </p:sldLayoutIdLst>
   <p:txStyles>
     <p:titleStyle>
@@ -4080,7 +4080,7 @@
           <p:cNvPr id="6" name="">
             <a:extLst xmlns:a="http://schemas.openxmlformats.org/drawingml/2006/main">
               <a:ext uri="{FF2B5EF4-FFF2-40B4-BE49-F238E27FC236}">
-                <a16:creationId xmlns:a16="http://schemas.microsoft.com/office/drawing/2014/main" id="{B82B5B49-49E2-4A10-A3A9-FC5FA3A06950}"/>
+                <a16:creationId xmlns:a16="http://schemas.microsoft.com/office/drawing/2014/main" id="{BDC7CA3F-3440-4569-9052-ECBF7ECF8932}"/>
               </a:ext>
             </a:extLst>
           </p:cNvPr>
@@ -4090,7 +4090,7 @@
           <p:nvPr/>
         </p:nvPicPr>
         <p:blipFill>
-          <a:blip xmlns:r="http://schemas.openxmlformats.org/officeDocument/2006/relationships" xmlns:a="http://schemas.openxmlformats.org/drawingml/2006/main" r:embed="Rb8910521ea0048fc"/>
+          <a:blip xmlns:r="http://schemas.openxmlformats.org/officeDocument/2006/relationships" xmlns:a="http://schemas.openxmlformats.org/drawingml/2006/main" r:embed="Rcc296eb8e7814d05"/>
           <a:stretch xmlns:a="http://schemas.openxmlformats.org/drawingml/2006/main"/>
         </p:blipFill>
         <p:spPr>
@@ -5349,7 +5349,7 @@
           <p:cNvPr id="3" name="">
             <a:extLst xmlns:a="http://schemas.openxmlformats.org/drawingml/2006/main">
               <a:ext uri="{FF2B5EF4-FFF2-40B4-BE49-F238E27FC236}">
-                <a16:creationId xmlns:a16="http://schemas.microsoft.com/office/drawing/2014/main" id="{C315457F-2EE3-467A-8D5E-FB4D72CC5D0B}"/>
+                <a16:creationId xmlns:a16="http://schemas.microsoft.com/office/drawing/2014/main" id="{3A7C3DCF-42B3-4A82-B664-AC415410E601}"/>
               </a:ext>
             </a:extLst>
           </p:cNvPr>
@@ -5359,7 +5359,7 @@
           <p:nvPr/>
         </p:nvPicPr>
         <p:blipFill>
-          <a:blip xmlns:r="http://schemas.openxmlformats.org/officeDocument/2006/relationships" xmlns:a="http://schemas.openxmlformats.org/drawingml/2006/main" r:embed="R20ddb55cb60e4f43"/>
+          <a:blip xmlns:r="http://schemas.openxmlformats.org/officeDocument/2006/relationships" xmlns:a="http://schemas.openxmlformats.org/drawingml/2006/main" r:embed="R024061993de54301"/>
           <a:stretch xmlns:a="http://schemas.openxmlformats.org/drawingml/2006/main"/>
         </p:blipFill>
         <p:spPr>
@@ -5377,7 +5377,7 @@
           <p:cNvPr id="16" name="">
             <a:extLst xmlns:a="http://schemas.openxmlformats.org/drawingml/2006/main">
               <a:ext uri="{FF2B5EF4-FFF2-40B4-BE49-F238E27FC236}">
-                <a16:creationId xmlns:a16="http://schemas.microsoft.com/office/drawing/2014/main" id="{9ACC4E24-6F9F-43A8-9945-3AA141BB0930}"/>
+                <a16:creationId xmlns:a16="http://schemas.microsoft.com/office/drawing/2014/main" id="{00A30058-B682-4C71-A4C5-98F624D2D354}"/>
               </a:ext>
             </a:extLst>
           </p:cNvPr>
@@ -5387,7 +5387,7 @@
           <p:nvPr/>
         </p:nvPicPr>
         <p:blipFill>
-          <a:blip xmlns:r="http://schemas.openxmlformats.org/officeDocument/2006/relationships" xmlns:a="http://schemas.openxmlformats.org/drawingml/2006/main" r:embed="R18a83c704aee4fa8"/>
+          <a:blip xmlns:r="http://schemas.openxmlformats.org/officeDocument/2006/relationships" xmlns:a="http://schemas.openxmlformats.org/drawingml/2006/main" r:embed="Rbc97134d1c9548f8"/>
           <a:stretch xmlns:a="http://schemas.openxmlformats.org/drawingml/2006/main"/>
         </p:blipFill>
         <p:spPr>
@@ -5819,7 +5819,7 @@
                   <a:srgbClr val="FFFFFF"/>
                 </a:solidFill>
               </a:rPr>
-              <a:t>Let’s continue the conversation.</a:t>
+              <a:t/>
             </a:r>
           </a:p>
         </p:txBody>
@@ -5840,7 +5840,7 @@
         </p:nvSpPr>
         <p:spPr>
           <a:xfrm xmlns:a="http://schemas.openxmlformats.org/drawingml/2006/main">
-            <a:off x="762000" y="3057525"/>
+            <a:off x="762000" y="3800475"/>
             <a:ext cx="10668000" cy="28575"/>
           </a:xfrm>
           <a:prstGeom xmlns:a="http://schemas.openxmlformats.org/drawingml/2006/main" prst="rect">
@@ -5871,7 +5871,7 @@
         </p:nvSpPr>
         <p:spPr>
           <a:xfrm xmlns:a="http://schemas.openxmlformats.org/drawingml/2006/main">
-            <a:off x="762000" y="3457575"/>
+            <a:off x="762000" y="4076700"/>
             <a:ext cx="6048375" cy="333375"/>
           </a:xfrm>
           <a:prstGeom xmlns:a="http://schemas.openxmlformats.org/drawingml/2006/main" prst="rect">
@@ -6002,7 +6002,7 @@
         </p:nvSpPr>
         <p:spPr>
           <a:xfrm xmlns:a="http://schemas.openxmlformats.org/drawingml/2006/main">
-            <a:off x="762000" y="3876675"/>
+            <a:off x="762000" y="4400550"/>
             <a:ext cx="6572250" cy="581025"/>
           </a:xfrm>
           <a:prstGeom xmlns:a="http://schemas.openxmlformats.org/drawingml/2006/main" prst="rect">
@@ -6133,7 +6133,7 @@
         </p:nvSpPr>
         <p:spPr>
           <a:xfrm xmlns:a="http://schemas.openxmlformats.org/drawingml/2006/main">
-            <a:off x="762000" y="4943475"/>
+            <a:off x="762000" y="5153025"/>
             <a:ext cx="6048375" cy="333375"/>
           </a:xfrm>
           <a:prstGeom xmlns:a="http://schemas.openxmlformats.org/drawingml/2006/main" prst="rect">
@@ -6264,7 +6264,7 @@
         </p:nvSpPr>
         <p:spPr>
           <a:xfrm xmlns:a="http://schemas.openxmlformats.org/drawingml/2006/main">
-            <a:off x="762000" y="5362575"/>
+            <a:off x="762000" y="5476875"/>
             <a:ext cx="6715125" cy="581025"/>
           </a:xfrm>
           <a:prstGeom xmlns:a="http://schemas.openxmlformats.org/drawingml/2006/main" prst="rect">
@@ -6395,7 +6395,7 @@
         </p:nvSpPr>
         <p:spPr>
           <a:xfrm xmlns:a="http://schemas.openxmlformats.org/drawingml/2006/main">
-            <a:off x="7667625" y="3457575"/>
+            <a:off x="7667625" y="4076700"/>
             <a:ext cx="3714750" cy="333375"/>
           </a:xfrm>
           <a:prstGeom xmlns:a="http://schemas.openxmlformats.org/drawingml/2006/main" prst="rect">
@@ -6526,7 +6526,7 @@
         </p:nvSpPr>
         <p:spPr>
           <a:xfrm xmlns:a="http://schemas.openxmlformats.org/drawingml/2006/main">
-            <a:off x="7667625" y="3876675"/>
+            <a:off x="7667625" y="4400550"/>
             <a:ext cx="3714750" cy="581025"/>
           </a:xfrm>
           <a:prstGeom xmlns:a="http://schemas.openxmlformats.org/drawingml/2006/main" prst="rect">
@@ -6657,7 +6657,7 @@
         </p:nvSpPr>
         <p:spPr>
           <a:xfrm xmlns:a="http://schemas.openxmlformats.org/drawingml/2006/main">
-            <a:off x="7667625" y="4514850"/>
+            <a:off x="7667625" y="4914900"/>
             <a:ext cx="3714750" cy="523875"/>
           </a:xfrm>
           <a:prstGeom xmlns:a="http://schemas.openxmlformats.org/drawingml/2006/main" prst="rect">
@@ -6777,7 +6777,7 @@
           <p:cNvPr id="29" name="">
             <a:extLst xmlns:a="http://schemas.openxmlformats.org/drawingml/2006/main">
               <a:ext uri="{FF2B5EF4-FFF2-40B4-BE49-F238E27FC236}">
-                <a16:creationId xmlns:a16="http://schemas.microsoft.com/office/drawing/2014/main" id="{664AA859-828E-4031-A4EF-91EDF4C99C74}"/>
+                <a16:creationId xmlns:a16="http://schemas.microsoft.com/office/drawing/2014/main" id="{AF8ACA16-8410-4525-B628-39C534502201}"/>
               </a:ext>
             </a:extLst>
           </p:cNvPr>
@@ -6787,7 +6787,7 @@
           <p:nvPr/>
         </p:nvPicPr>
         <p:blipFill>
-          <a:blip xmlns:r="http://schemas.openxmlformats.org/officeDocument/2006/relationships" xmlns:a="http://schemas.openxmlformats.org/drawingml/2006/main" r:embed="R09a095d0a22b4fc1"/>
+          <a:blip xmlns:r="http://schemas.openxmlformats.org/officeDocument/2006/relationships" xmlns:a="http://schemas.openxmlformats.org/drawingml/2006/main" r:embed="Rdec198fc6a2540c4"/>
           <a:stretch xmlns:a="http://schemas.openxmlformats.org/drawingml/2006/main"/>
         </p:blipFill>
         <p:spPr>
@@ -6800,6 +6800,265 @@
           </a:prstGeom>
         </p:spPr>
       </p:pic>
+      <p:sp>
+        <p:nvSpPr>
+          <p:cNvPr id="30" name="">
+            <a:extLst xmlns:a="http://schemas.openxmlformats.org/drawingml/2006/main">
+              <a:ext uri="{FF2B5EF4-FFF2-40B4-BE49-F238E27FC236}">
+                <a16:creationId xmlns:a16="http://schemas.microsoft.com/office/drawing/2014/main" id="{3034B426-27C1-4BD2-9D16-E8163B48D137}"/>
+              </a:ext>
+            </a:extLst>
+          </p:cNvPr>
+          <p:cNvSpPr>
+            <a:spLocks xmlns:a="http://schemas.openxmlformats.org/drawingml/2006/main" noGrp="1"/>
+          </p:cNvSpPr>
+          <p:nvPr/>
+        </p:nvSpPr>
+        <p:spPr>
+          <a:xfrm xmlns:a="http://schemas.openxmlformats.org/drawingml/2006/main">
+            <a:off x="762000" y="1657350"/>
+            <a:ext cx="10668000" cy="1343025"/>
+          </a:xfrm>
+          <a:prstGeom xmlns:a="http://schemas.openxmlformats.org/drawingml/2006/main" prst="rect">
+            <a:avLst/>
+          </a:prstGeom>
+          <a:noFill xmlns:a="http://schemas.openxmlformats.org/drawingml/2006/main"/>
+          <a:ln xmlns:a="http://schemas.openxmlformats.org/drawingml/2006/main" w="0">
+            <a:noFill/>
+            <a:prstDash val="solid"/>
+          </a:ln>
+        </p:spPr>
+        <p:txBody>
+          <a:bodyPr xmlns:a="http://schemas.openxmlformats.org/drawingml/2006/main" lIns="0" tIns="0" rIns="0" bIns="0"/>
+          <a:lstStyle xmlns:a="http://schemas.openxmlformats.org/drawingml/2006/main">
+            <a:defPPr algn="l">
+              <a:defRPr sz="3375" b="1">
+                <a:solidFill>
+                  <a:srgbClr val="FFFFFF"/>
+                </a:solidFill>
+              </a:defRPr>
+            </a:defPPr>
+            <a:lvl1pPr algn="l">
+              <a:defRPr sz="3375" b="1">
+                <a:solidFill>
+                  <a:srgbClr val="FFFFFF"/>
+                </a:solidFill>
+              </a:defRPr>
+            </a:lvl1pPr>
+            <a:lvl2pPr algn="l">
+              <a:defRPr sz="3375" b="1">
+                <a:solidFill>
+                  <a:srgbClr val="FFFFFF"/>
+                </a:solidFill>
+              </a:defRPr>
+            </a:lvl2pPr>
+            <a:lvl3pPr algn="l">
+              <a:defRPr sz="3375" b="1">
+                <a:solidFill>
+                  <a:srgbClr val="FFFFFF"/>
+                </a:solidFill>
+              </a:defRPr>
+            </a:lvl3pPr>
+            <a:lvl4pPr algn="l">
+              <a:defRPr sz="3375" b="1">
+                <a:solidFill>
+                  <a:srgbClr val="FFFFFF"/>
+                </a:solidFill>
+              </a:defRPr>
+            </a:lvl4pPr>
+            <a:lvl5pPr algn="l">
+              <a:defRPr sz="3375" b="1">
+                <a:solidFill>
+                  <a:srgbClr val="FFFFFF"/>
+                </a:solidFill>
+              </a:defRPr>
+            </a:lvl5pPr>
+            <a:lvl6pPr algn="l">
+              <a:defRPr sz="3375" b="1">
+                <a:solidFill>
+                  <a:srgbClr val="FFFFFF"/>
+                </a:solidFill>
+              </a:defRPr>
+            </a:lvl6pPr>
+            <a:lvl7pPr algn="l">
+              <a:defRPr sz="3375" b="1">
+                <a:solidFill>
+                  <a:srgbClr val="FFFFFF"/>
+                </a:solidFill>
+              </a:defRPr>
+            </a:lvl7pPr>
+            <a:lvl8pPr algn="l">
+              <a:defRPr sz="3375" b="1">
+                <a:solidFill>
+                  <a:srgbClr val="FFFFFF"/>
+                </a:solidFill>
+              </a:defRPr>
+            </a:lvl8pPr>
+            <a:lvl9pPr algn="l">
+              <a:defRPr sz="3375" b="1">
+                <a:solidFill>
+                  <a:srgbClr val="FFFFFF"/>
+                </a:solidFill>
+              </a:defRPr>
+            </a:lvl9pPr>
+          </a:lstStyle>
+          <a:p xmlns:a="http://schemas.openxmlformats.org/drawingml/2006/main">
+            <a:pPr algn="l">
+              <a:defRPr sz="3375" b="1">
+                <a:solidFill>
+                  <a:srgbClr val="FFFFFF"/>
+                </a:solidFill>
+              </a:defRPr>
+            </a:pPr>
+            <a:r>
+              <a:rPr sz="3375" b="1">
+                <a:solidFill>
+                  <a:srgbClr val="FFFFFF"/>
+                </a:solidFill>
+              </a:rPr>
+              <a:t>Our history was made on the factory floor.</a:t>
+            </a:r>
+          </a:p>
+          <a:p xmlns:a="http://schemas.openxmlformats.org/drawingml/2006/main">
+            <a:pPr algn="l">
+              <a:defRPr sz="3375" b="1">
+                <a:solidFill>
+                  <a:srgbClr val="FFFFFF"/>
+                </a:solidFill>
+              </a:defRPr>
+            </a:pPr>
+            <a:r>
+              <a:rPr sz="3375" b="1">
+                <a:solidFill>
+                  <a:srgbClr val="FFFFFF"/>
+                </a:solidFill>
+              </a:rPr>
+              <a:t>The future will be, too.</a:t>
+            </a:r>
+          </a:p>
+        </p:txBody>
+      </p:sp>
+      <p:sp>
+        <p:nvSpPr>
+          <p:cNvPr id="31" name="">
+            <a:extLst xmlns:a="http://schemas.openxmlformats.org/drawingml/2006/main">
+              <a:ext uri="{FF2B5EF4-FFF2-40B4-BE49-F238E27FC236}">
+                <a16:creationId xmlns:a16="http://schemas.microsoft.com/office/drawing/2014/main" id="{75E10C55-1489-4D4E-9126-FB8BDCEF3E3A}"/>
+              </a:ext>
+            </a:extLst>
+          </p:cNvPr>
+          <p:cNvSpPr>
+            <a:spLocks xmlns:a="http://schemas.openxmlformats.org/drawingml/2006/main" noGrp="1"/>
+          </p:cNvSpPr>
+          <p:nvPr/>
+        </p:nvSpPr>
+        <p:spPr>
+          <a:xfrm xmlns:a="http://schemas.openxmlformats.org/drawingml/2006/main">
+            <a:off x="762000" y="3105150"/>
+            <a:ext cx="10668000" cy="552450"/>
+          </a:xfrm>
+          <a:prstGeom xmlns:a="http://schemas.openxmlformats.org/drawingml/2006/main" prst="rect">
+            <a:avLst/>
+          </a:prstGeom>
+          <a:noFill xmlns:a="http://schemas.openxmlformats.org/drawingml/2006/main"/>
+          <a:ln xmlns:a="http://schemas.openxmlformats.org/drawingml/2006/main" w="0">
+            <a:noFill/>
+            <a:prstDash val="solid"/>
+          </a:ln>
+        </p:spPr>
+        <p:txBody>
+          <a:bodyPr xmlns:a="http://schemas.openxmlformats.org/drawingml/2006/main" lIns="0" tIns="0" rIns="0" bIns="0"/>
+          <a:lstStyle xmlns:a="http://schemas.openxmlformats.org/drawingml/2006/main">
+            <a:defPPr algn="l">
+              <a:defRPr sz="2325" b="1">
+                <a:solidFill>
+                  <a:srgbClr val="B89B68"/>
+                </a:solidFill>
+              </a:defRPr>
+            </a:defPPr>
+            <a:lvl1pPr algn="l">
+              <a:defRPr sz="2325" b="1">
+                <a:solidFill>
+                  <a:srgbClr val="B89B68"/>
+                </a:solidFill>
+              </a:defRPr>
+            </a:lvl1pPr>
+            <a:lvl2pPr algn="l">
+              <a:defRPr sz="2325" b="1">
+                <a:solidFill>
+                  <a:srgbClr val="B89B68"/>
+                </a:solidFill>
+              </a:defRPr>
+            </a:lvl2pPr>
+            <a:lvl3pPr algn="l">
+              <a:defRPr sz="2325" b="1">
+                <a:solidFill>
+                  <a:srgbClr val="B89B68"/>
+                </a:solidFill>
+              </a:defRPr>
+            </a:lvl3pPr>
+            <a:lvl4pPr algn="l">
+              <a:defRPr sz="2325" b="1">
+                <a:solidFill>
+                  <a:srgbClr val="B89B68"/>
+                </a:solidFill>
+              </a:defRPr>
+            </a:lvl4pPr>
+            <a:lvl5pPr algn="l">
+              <a:defRPr sz="2325" b="1">
+                <a:solidFill>
+                  <a:srgbClr val="B89B68"/>
+                </a:solidFill>
+              </a:defRPr>
+            </a:lvl5pPr>
+            <a:lvl6pPr algn="l">
+              <a:defRPr sz="2325" b="1">
+                <a:solidFill>
+                  <a:srgbClr val="B89B68"/>
+                </a:solidFill>
+              </a:defRPr>
+            </a:lvl6pPr>
+            <a:lvl7pPr algn="l">
+              <a:defRPr sz="2325" b="1">
+                <a:solidFill>
+                  <a:srgbClr val="B89B68"/>
+                </a:solidFill>
+              </a:defRPr>
+            </a:lvl7pPr>
+            <a:lvl8pPr algn="l">
+              <a:defRPr sz="2325" b="1">
+                <a:solidFill>
+                  <a:srgbClr val="B89B68"/>
+                </a:solidFill>
+              </a:defRPr>
+            </a:lvl8pPr>
+            <a:lvl9pPr algn="l">
+              <a:defRPr sz="2325" b="1">
+                <a:solidFill>
+                  <a:srgbClr val="B89B68"/>
+                </a:solidFill>
+              </a:defRPr>
+            </a:lvl9pPr>
+          </a:lstStyle>
+          <a:p xmlns:a="http://schemas.openxmlformats.org/drawingml/2006/main">
+            <a:pPr algn="l">
+              <a:defRPr sz="2325" b="1">
+                <a:solidFill>
+                  <a:srgbClr val="B89B68"/>
+                </a:solidFill>
+              </a:defRPr>
+            </a:pPr>
+            <a:r>
+              <a:rPr sz="2325" b="1">
+                <a:solidFill>
+                  <a:srgbClr val="B89B68"/>
+                </a:solidFill>
+              </a:rPr>
+              <a:t>Come build and fight with us. Turn AI into action.</a:t>
+            </a:r>
+          </a:p>
+        </p:txBody>
+      </p:sp>
     </p:spTree>
     <p:extLst>
       <p:ext uri="{BB962C8B-B14F-4D97-AF65-F5344CB8AC3E}">
@@ -6834,7 +7093,7 @@
           <p:cNvPr id="3" name="">
             <a:extLst xmlns:a="http://schemas.openxmlformats.org/drawingml/2006/main">
               <a:ext uri="{FF2B5EF4-FFF2-40B4-BE49-F238E27FC236}">
-                <a16:creationId xmlns:a16="http://schemas.microsoft.com/office/drawing/2014/main" id="{F9DA8BA7-0CF8-496F-A969-696CDA71BE43}"/>
+                <a16:creationId xmlns:a16="http://schemas.microsoft.com/office/drawing/2014/main" id="{04DBA283-85BB-4C37-AF65-7B4FA442BD3F}"/>
               </a:ext>
             </a:extLst>
           </p:cNvPr>
@@ -6844,7 +7103,7 @@
           <p:nvPr/>
         </p:nvPicPr>
         <p:blipFill>
-          <a:blip xmlns:r="http://schemas.openxmlformats.org/officeDocument/2006/relationships" xmlns:a="http://schemas.openxmlformats.org/drawingml/2006/main" r:embed="Rfa70c19e444c48aa"/>
+          <a:blip xmlns:r="http://schemas.openxmlformats.org/officeDocument/2006/relationships" xmlns:a="http://schemas.openxmlformats.org/drawingml/2006/main" r:embed="Rbfcb7626e46542ca"/>
           <a:stretch xmlns:a="http://schemas.openxmlformats.org/drawingml/2006/main"/>
         </p:blipFill>
         <p:spPr>
@@ -8103,7 +8362,7 @@
           <p:cNvPr id="15" name="">
             <a:extLst xmlns:a="http://schemas.openxmlformats.org/drawingml/2006/main">
               <a:ext uri="{FF2B5EF4-FFF2-40B4-BE49-F238E27FC236}">
-                <a16:creationId xmlns:a16="http://schemas.microsoft.com/office/drawing/2014/main" id="{E57A3ABD-62CB-4CC4-B7AE-22F5ED020DE1}"/>
+                <a16:creationId xmlns:a16="http://schemas.microsoft.com/office/drawing/2014/main" id="{69B5C29F-85D0-400C-8B5B-B67515260127}"/>
               </a:ext>
             </a:extLst>
           </p:cNvPr>
@@ -8113,7 +8372,7 @@
           <p:nvPr/>
         </p:nvPicPr>
         <p:blipFill>
-          <a:blip xmlns:r="http://schemas.openxmlformats.org/officeDocument/2006/relationships" xmlns:a="http://schemas.openxmlformats.org/drawingml/2006/main" r:embed="Reeba3e616716409f"/>
+          <a:blip xmlns:r="http://schemas.openxmlformats.org/officeDocument/2006/relationships" xmlns:a="http://schemas.openxmlformats.org/drawingml/2006/main" r:embed="Rfe5232a72f58451a"/>
           <a:stretch xmlns:a="http://schemas.openxmlformats.org/drawingml/2006/main"/>
         </p:blipFill>
         <p:spPr>
@@ -8160,7 +8419,7 @@
           <p:cNvPr id="3" name="">
             <a:extLst xmlns:a="http://schemas.openxmlformats.org/drawingml/2006/main">
               <a:ext uri="{FF2B5EF4-FFF2-40B4-BE49-F238E27FC236}">
-                <a16:creationId xmlns:a16="http://schemas.microsoft.com/office/drawing/2014/main" id="{C463C006-A1AB-43EE-A749-89D3A6BECA45}"/>
+                <a16:creationId xmlns:a16="http://schemas.microsoft.com/office/drawing/2014/main" id="{77B7BFB1-40B3-4768-BF9E-3ECF4F58F861}"/>
               </a:ext>
             </a:extLst>
           </p:cNvPr>
@@ -8170,7 +8429,7 @@
           <p:nvPr/>
         </p:nvPicPr>
         <p:blipFill>
-          <a:blip xmlns:r="http://schemas.openxmlformats.org/officeDocument/2006/relationships" xmlns:a="http://schemas.openxmlformats.org/drawingml/2006/main" r:embed="R43ac989a31004624"/>
+          <a:blip xmlns:r="http://schemas.openxmlformats.org/officeDocument/2006/relationships" xmlns:a="http://schemas.openxmlformats.org/drawingml/2006/main" r:embed="Rdccff5d3a59647f7"/>
           <a:stretch xmlns:a="http://schemas.openxmlformats.org/drawingml/2006/main"/>
         </p:blipFill>
         <p:spPr>
@@ -8471,7 +8730,7 @@
                   <a:srgbClr val="FFFFFF"/>
                 </a:solidFill>
               </a:rPr>
-              <a:t>Engineering across TKG</a:t>
+              <a:t>Engineering that reaches the floor</a:t>
             </a:r>
           </a:p>
         </p:txBody>
@@ -8633,7 +8892,7 @@
                   <a:srgbClr val="FFFFFF"/>
                 </a:solidFill>
               </a:rPr>
-              <a:t>Machines</a:t>
+              <a:t>Sense</a:t>
             </a:r>
           </a:p>
         </p:txBody>
@@ -8795,7 +9054,7 @@
                   <a:srgbClr val="FFFFFF"/>
                 </a:solidFill>
               </a:rPr>
-              <a:t>Controls</a:t>
+              <a:t>Decide</a:t>
             </a:r>
           </a:p>
         </p:txBody>
@@ -8957,7 +9216,7 @@
                   <a:srgbClr val="FFFFFF"/>
                 </a:solidFill>
               </a:rPr>
-              <a:t>Software + data</a:t>
+              <a:t>Act</a:t>
             </a:r>
           </a:p>
         </p:txBody>
@@ -9098,7 +9357,7 @@
           <p:cNvPr id="14" name="">
             <a:extLst xmlns:a="http://schemas.openxmlformats.org/drawingml/2006/main">
               <a:ext uri="{FF2B5EF4-FFF2-40B4-BE49-F238E27FC236}">
-                <a16:creationId xmlns:a16="http://schemas.microsoft.com/office/drawing/2014/main" id="{FCB42446-C940-47A5-9032-0520A86693E9}"/>
+                <a16:creationId xmlns:a16="http://schemas.microsoft.com/office/drawing/2014/main" id="{BF1BC0E4-9519-4E16-A994-C7628C9F9D70}"/>
               </a:ext>
             </a:extLst>
           </p:cNvPr>
@@ -9108,7 +9367,7 @@
           <p:nvPr/>
         </p:nvPicPr>
         <p:blipFill>
-          <a:blip xmlns:r="http://schemas.openxmlformats.org/officeDocument/2006/relationships" xmlns:a="http://schemas.openxmlformats.org/drawingml/2006/main" r:embed="R2688039d03b44124"/>
+          <a:blip xmlns:r="http://schemas.openxmlformats.org/officeDocument/2006/relationships" xmlns:a="http://schemas.openxmlformats.org/drawingml/2006/main" r:embed="R30969f12c9c14af1"/>
           <a:stretch xmlns:a="http://schemas.openxmlformats.org/drawingml/2006/main"/>
         </p:blipFill>
         <p:spPr>
@@ -9247,7 +9506,7 @@
                   <a:srgbClr val="D7D3CC"/>
                 </a:solidFill>
               </a:rPr>
-              <a:t>Small teams across TKG. Primarily at Remington.</a:t>
+              <a:t>Small teams across TKG, working primarily at Remington.</a:t>
             </a:r>
           </a:p>
         </p:txBody>
@@ -9378,7 +9637,7 @@
                   <a:srgbClr val="D7D3CC"/>
                 </a:solidFill>
               </a:rPr>
-              <a:t>Equipment built for real production</a:t>
+              <a:t>Machines capture what is happening</a:t>
             </a:r>
           </a:p>
         </p:txBody>
@@ -9509,7 +9768,7 @@
                   <a:srgbClr val="D7D3CC"/>
                 </a:solidFill>
               </a:rPr>
-              <a:t>Sensing, motion, and response</a:t>
+              <a:t>Software turns signals into decisions</a:t>
             </a:r>
           </a:p>
         </p:txBody>
@@ -9640,7 +9899,7 @@
                   <a:srgbClr val="D7D3CC"/>
                 </a:solidFill>
               </a:rPr>
-              <a:t>Information people can act on</a:t>
+              <a:t>People and equipment respond</a:t>
             </a:r>
           </a:p>
         </p:txBody>
@@ -9679,7 +9938,7 @@
           <p:cNvPr id="3" name="">
             <a:extLst xmlns:a="http://schemas.openxmlformats.org/drawingml/2006/main">
               <a:ext uri="{FF2B5EF4-FFF2-40B4-BE49-F238E27FC236}">
-                <a16:creationId xmlns:a16="http://schemas.microsoft.com/office/drawing/2014/main" id="{5E559575-1835-4582-9877-E99E9F489CB2}"/>
+                <a16:creationId xmlns:a16="http://schemas.microsoft.com/office/drawing/2014/main" id="{17685762-9B5E-4DC1-9E16-255D9316B800}"/>
               </a:ext>
             </a:extLst>
           </p:cNvPr>
@@ -9689,7 +9948,7 @@
           <p:nvPr/>
         </p:nvPicPr>
         <p:blipFill>
-          <a:blip xmlns:r="http://schemas.openxmlformats.org/officeDocument/2006/relationships" xmlns:a="http://schemas.openxmlformats.org/drawingml/2006/main" r:embed="Rd18a27e72c46454d"/>
+          <a:blip xmlns:r="http://schemas.openxmlformats.org/officeDocument/2006/relationships" xmlns:a="http://schemas.openxmlformats.org/drawingml/2006/main" r:embed="Rff7ae209073141e4"/>
           <a:stretch xmlns:a="http://schemas.openxmlformats.org/drawingml/2006/main"/>
         </p:blipFill>
         <p:spPr>
@@ -10314,7 +10573,7 @@
                   <a:srgbClr val="231F20"/>
                 </a:solidFill>
               </a:rPr>
-              <a:t>Visible results</a:t>
+              <a:t>Freedom</a:t>
             </a:r>
           </a:p>
         </p:txBody>
@@ -10476,7 +10735,7 @@
                   <a:srgbClr val="231F20"/>
                 </a:solidFill>
               </a:rPr>
-              <a:t>Learning</a:t>
+              <a:t>Growth</a:t>
             </a:r>
           </a:p>
         </p:txBody>
@@ -10648,7 +10907,7 @@
           <p:cNvPr id="15" name="">
             <a:extLst xmlns:a="http://schemas.openxmlformats.org/drawingml/2006/main">
               <a:ext uri="{FF2B5EF4-FFF2-40B4-BE49-F238E27FC236}">
-                <a16:creationId xmlns:a16="http://schemas.microsoft.com/office/drawing/2014/main" id="{1318C101-FC56-472B-B1DB-840B0B22AB0F}"/>
+                <a16:creationId xmlns:a16="http://schemas.microsoft.com/office/drawing/2014/main" id="{61002C78-6CD3-44FE-A8A0-51E2573EC26A}"/>
               </a:ext>
             </a:extLst>
           </p:cNvPr>
@@ -10658,7 +10917,7 @@
           <p:nvPr/>
         </p:nvPicPr>
         <p:blipFill>
-          <a:blip xmlns:r="http://schemas.openxmlformats.org/officeDocument/2006/relationships" xmlns:a="http://schemas.openxmlformats.org/drawingml/2006/main" r:embed="Re71057bfe12e4f77"/>
+          <a:blip xmlns:r="http://schemas.openxmlformats.org/officeDocument/2006/relationships" xmlns:a="http://schemas.openxmlformats.org/drawingml/2006/main" r:embed="R3d70064a7c1d4493"/>
           <a:stretch xmlns:a="http://schemas.openxmlformats.org/drawingml/2006/main"/>
         </p:blipFill>
         <p:spPr>
@@ -10797,7 +11056,7 @@
                   <a:srgbClr val="826941"/>
                 </a:solidFill>
               </a:rPr>
-              <a:t>A different problem every day</a:t>
+              <a:t>AI, software, and machines</a:t>
             </a:r>
           </a:p>
         </p:txBody>
@@ -10928,7 +11187,7 @@
                   <a:srgbClr val="826941"/>
                 </a:solidFill>
               </a:rPr>
-              <a:t>Work you can see on the floor</a:t>
+              <a:t>Room to explore ideas</a:t>
             </a:r>
           </a:p>
         </p:txBody>
@@ -11059,7 +11318,7 @@
                   <a:srgbClr val="826941"/>
                 </a:solidFill>
               </a:rPr>
-              <a:t>Across engineering disciplines</a:t>
+              <a:t>Unexpected opportunities</a:t>
             </a:r>
           </a:p>
         </p:txBody>
@@ -11190,7 +11449,7 @@
                   <a:srgbClr val="826941"/>
                 </a:solidFill>
               </a:rPr>
-              <a:t>We stay with what we build</a:t>
+              <a:t>We carry ideas into use</a:t>
             </a:r>
           </a:p>
         </p:txBody>
@@ -11229,7 +11488,7 @@
           <p:cNvPr id="3" name="">
             <a:extLst xmlns:a="http://schemas.openxmlformats.org/drawingml/2006/main">
               <a:ext uri="{FF2B5EF4-FFF2-40B4-BE49-F238E27FC236}">
-                <a16:creationId xmlns:a16="http://schemas.microsoft.com/office/drawing/2014/main" id="{87E6D3A1-AF32-411D-AF36-4BD326C9DF5B}"/>
+                <a16:creationId xmlns:a16="http://schemas.microsoft.com/office/drawing/2014/main" id="{7E5BBDD5-D9C9-4EE3-AF2F-B79BC157464E}"/>
               </a:ext>
             </a:extLst>
           </p:cNvPr>
@@ -11239,7 +11498,7 @@
           <p:nvPr/>
         </p:nvPicPr>
         <p:blipFill>
-          <a:blip xmlns:r="http://schemas.openxmlformats.org/officeDocument/2006/relationships" xmlns:a="http://schemas.openxmlformats.org/drawingml/2006/main" r:embed="R91832e82746a4dea"/>
+          <a:blip xmlns:r="http://schemas.openxmlformats.org/officeDocument/2006/relationships" xmlns:a="http://schemas.openxmlformats.org/drawingml/2006/main" r:embed="Rffca8ed1f797459d"/>
           <a:stretch xmlns:a="http://schemas.openxmlformats.org/drawingml/2006/main"/>
         </p:blipFill>
         <p:spPr>
@@ -11257,7 +11516,7 @@
           <p:cNvPr id="10" name="">
             <a:extLst xmlns:a="http://schemas.openxmlformats.org/drawingml/2006/main">
               <a:ext uri="{FF2B5EF4-FFF2-40B4-BE49-F238E27FC236}">
-                <a16:creationId xmlns:a16="http://schemas.microsoft.com/office/drawing/2014/main" id="{BA86C03C-B1E1-4EAE-92CA-91851671E546}"/>
+                <a16:creationId xmlns:a16="http://schemas.microsoft.com/office/drawing/2014/main" id="{F3DB8D0F-3077-4938-9D18-DBC7F4690766}"/>
               </a:ext>
             </a:extLst>
           </p:cNvPr>
@@ -11267,7 +11526,7 @@
           <p:nvPr/>
         </p:nvPicPr>
         <p:blipFill>
-          <a:blip xmlns:r="http://schemas.openxmlformats.org/officeDocument/2006/relationships" xmlns:a="http://schemas.openxmlformats.org/drawingml/2006/main" r:embed="R60d2970f8ef14f27"/>
+          <a:blip xmlns:r="http://schemas.openxmlformats.org/officeDocument/2006/relationships" xmlns:a="http://schemas.openxmlformats.org/drawingml/2006/main" r:embed="R46d16be425034d27"/>
           <a:stretch xmlns:a="http://schemas.openxmlformats.org/drawingml/2006/main"/>
         </p:blipFill>
         <p:spPr>
@@ -11871,7 +12130,7 @@
           <p:cNvPr id="17" name="">
             <a:extLst xmlns:a="http://schemas.openxmlformats.org/drawingml/2006/main">
               <a:ext uri="{FF2B5EF4-FFF2-40B4-BE49-F238E27FC236}">
-                <a16:creationId xmlns:a16="http://schemas.microsoft.com/office/drawing/2014/main" id="{4FB06C6D-7C9F-49F7-9789-406950242487}"/>
+                <a16:creationId xmlns:a16="http://schemas.microsoft.com/office/drawing/2014/main" id="{B2A8FB92-C662-4D67-B6C4-6C311C5FDABB}"/>
               </a:ext>
             </a:extLst>
           </p:cNvPr>
@@ -11881,7 +12140,7 @@
           <p:nvPr/>
         </p:nvPicPr>
         <p:blipFill>
-          <a:blip xmlns:r="http://schemas.openxmlformats.org/officeDocument/2006/relationships" xmlns:a="http://schemas.openxmlformats.org/drawingml/2006/main" r:embed="R78802451e2ad4b51"/>
+          <a:blip xmlns:r="http://schemas.openxmlformats.org/officeDocument/2006/relationships" xmlns:a="http://schemas.openxmlformats.org/drawingml/2006/main" r:embed="R78783b45880e45da"/>
           <a:stretch xmlns:a="http://schemas.openxmlformats.org/drawingml/2006/main"/>
         </p:blipFill>
         <p:spPr>
@@ -11928,7 +12187,7 @@
           <p:cNvPr id="3" name="">
             <a:extLst xmlns:a="http://schemas.openxmlformats.org/drawingml/2006/main">
               <a:ext uri="{FF2B5EF4-FFF2-40B4-BE49-F238E27FC236}">
-                <a16:creationId xmlns:a16="http://schemas.microsoft.com/office/drawing/2014/main" id="{B467CDAB-AB88-4348-BEB4-5B62FD98CF92}"/>
+                <a16:creationId xmlns:a16="http://schemas.microsoft.com/office/drawing/2014/main" id="{0691CEAF-96F2-4C44-BB0C-396D4427ADD9}"/>
               </a:ext>
             </a:extLst>
           </p:cNvPr>
@@ -11938,7 +12197,7 @@
           <p:nvPr/>
         </p:nvPicPr>
         <p:blipFill>
-          <a:blip xmlns:r="http://schemas.openxmlformats.org/officeDocument/2006/relationships" xmlns:a="http://schemas.openxmlformats.org/drawingml/2006/main" r:embed="R4806ff3065a94813"/>
+          <a:blip xmlns:r="http://schemas.openxmlformats.org/officeDocument/2006/relationships" xmlns:a="http://schemas.openxmlformats.org/drawingml/2006/main" r:embed="R1b597aaa7ced4637"/>
           <a:stretch xmlns:a="http://schemas.openxmlformats.org/drawingml/2006/main"/>
         </p:blipFill>
         <p:spPr>
@@ -13249,7 +13508,7 @@
                   <a:srgbClr val="231F20"/>
                 </a:solidFill>
               </a:rPr>
-              <a:t>The next era is built here.</a:t>
+              <a:t>The next era has to work in real conditions.</a:t>
             </a:r>
           </a:p>
         </p:txBody>
@@ -13259,7 +13518,7 @@
           <p:cNvPr id="17" name="">
             <a:extLst xmlns:a="http://schemas.openxmlformats.org/drawingml/2006/main">
               <a:ext uri="{FF2B5EF4-FFF2-40B4-BE49-F238E27FC236}">
-                <a16:creationId xmlns:a16="http://schemas.microsoft.com/office/drawing/2014/main" id="{1A23364D-B047-44D2-BA4B-5AD990CE92DC}"/>
+                <a16:creationId xmlns:a16="http://schemas.microsoft.com/office/drawing/2014/main" id="{E861555D-CA4E-4BFE-AC04-BDACEFAF7E23}"/>
               </a:ext>
             </a:extLst>
           </p:cNvPr>
@@ -13269,7 +13528,7 @@
           <p:nvPr/>
         </p:nvPicPr>
         <p:blipFill>
-          <a:blip xmlns:r="http://schemas.openxmlformats.org/officeDocument/2006/relationships" xmlns:a="http://schemas.openxmlformats.org/drawingml/2006/main" r:embed="Rebe1aa55ff794d85"/>
+          <a:blip xmlns:r="http://schemas.openxmlformats.org/officeDocument/2006/relationships" xmlns:a="http://schemas.openxmlformats.org/drawingml/2006/main" r:embed="Rc35f4159e1414703"/>
           <a:stretch xmlns:a="http://schemas.openxmlformats.org/drawingml/2006/main"/>
         </p:blipFill>
         <p:spPr>
@@ -13447,7 +13706,7 @@
           <p:cNvPr id="3" name="">
             <a:extLst xmlns:a="http://schemas.openxmlformats.org/drawingml/2006/main">
               <a:ext uri="{FF2B5EF4-FFF2-40B4-BE49-F238E27FC236}">
-                <a16:creationId xmlns:a16="http://schemas.microsoft.com/office/drawing/2014/main" id="{9438750E-D811-4C1C-9EC5-851EDAAE289E}"/>
+                <a16:creationId xmlns:a16="http://schemas.microsoft.com/office/drawing/2014/main" id="{F43DFADC-A426-4621-9C99-F33B86701D57}"/>
               </a:ext>
             </a:extLst>
           </p:cNvPr>
@@ -13457,7 +13716,7 @@
           <p:nvPr/>
         </p:nvPicPr>
         <p:blipFill>
-          <a:blip xmlns:r="http://schemas.openxmlformats.org/officeDocument/2006/relationships" xmlns:a="http://schemas.openxmlformats.org/drawingml/2006/main" r:embed="R8e427e0fe75d4f09"/>
+          <a:blip xmlns:r="http://schemas.openxmlformats.org/officeDocument/2006/relationships" xmlns:a="http://schemas.openxmlformats.org/drawingml/2006/main" r:embed="R304ca62d2b5440df"/>
           <a:stretch xmlns:a="http://schemas.openxmlformats.org/drawingml/2006/main"/>
         </p:blipFill>
         <p:spPr>
@@ -14454,7 +14713,7 @@
           <p:cNvPr id="13" name="">
             <a:extLst xmlns:a="http://schemas.openxmlformats.org/drawingml/2006/main">
               <a:ext uri="{FF2B5EF4-FFF2-40B4-BE49-F238E27FC236}">
-                <a16:creationId xmlns:a16="http://schemas.microsoft.com/office/drawing/2014/main" id="{0774EF6E-9B44-4169-8ADC-9DCA64233C8C}"/>
+                <a16:creationId xmlns:a16="http://schemas.microsoft.com/office/drawing/2014/main" id="{4167D6F2-59D6-407C-ABC6-0F25804E9CB5}"/>
               </a:ext>
             </a:extLst>
           </p:cNvPr>
@@ -14464,7 +14723,7 @@
           <p:nvPr/>
         </p:nvPicPr>
         <p:blipFill>
-          <a:blip xmlns:r="http://schemas.openxmlformats.org/officeDocument/2006/relationships" xmlns:a="http://schemas.openxmlformats.org/drawingml/2006/main" r:embed="Rd3dbb220d3114afb"/>
+          <a:blip xmlns:r="http://schemas.openxmlformats.org/officeDocument/2006/relationships" xmlns:a="http://schemas.openxmlformats.org/drawingml/2006/main" r:embed="Rd0e994a7eaa14e74"/>
           <a:stretch xmlns:a="http://schemas.openxmlformats.org/drawingml/2006/main"/>
         </p:blipFill>
         <p:spPr>
@@ -15166,7 +15425,7 @@
           <p:cNvPr id="3" name="">
             <a:extLst xmlns:a="http://schemas.openxmlformats.org/drawingml/2006/main">
               <a:ext uri="{FF2B5EF4-FFF2-40B4-BE49-F238E27FC236}">
-                <a16:creationId xmlns:a16="http://schemas.microsoft.com/office/drawing/2014/main" id="{0879377F-4970-4DAA-B4CC-23542988B6CC}"/>
+                <a16:creationId xmlns:a16="http://schemas.microsoft.com/office/drawing/2014/main" id="{06BEE1A5-F72A-48C7-A81D-A93FE4CC5277}"/>
               </a:ext>
             </a:extLst>
           </p:cNvPr>
@@ -15176,7 +15435,7 @@
           <p:nvPr/>
         </p:nvPicPr>
         <p:blipFill>
-          <a:blip xmlns:r="http://schemas.openxmlformats.org/officeDocument/2006/relationships" xmlns:a="http://schemas.openxmlformats.org/drawingml/2006/main" r:embed="Rac896f24e4e84145"/>
+          <a:blip xmlns:r="http://schemas.openxmlformats.org/officeDocument/2006/relationships" xmlns:a="http://schemas.openxmlformats.org/drawingml/2006/main" r:embed="R446f19872c994a0c"/>
           <a:stretch xmlns:a="http://schemas.openxmlformats.org/drawingml/2006/main"/>
         </p:blipFill>
         <p:spPr>
@@ -15194,7 +15453,7 @@
           <p:cNvPr id="7" name="">
             <a:extLst xmlns:a="http://schemas.openxmlformats.org/drawingml/2006/main">
               <a:ext uri="{FF2B5EF4-FFF2-40B4-BE49-F238E27FC236}">
-                <a16:creationId xmlns:a16="http://schemas.microsoft.com/office/drawing/2014/main" id="{8661A38D-356B-40FF-B3C4-0C397DD7E71C}"/>
+                <a16:creationId xmlns:a16="http://schemas.microsoft.com/office/drawing/2014/main" id="{F418FFC9-BE0D-429C-9424-9444D57A63D2}"/>
               </a:ext>
             </a:extLst>
           </p:cNvPr>
@@ -15204,7 +15463,7 @@
           <p:nvPr/>
         </p:nvPicPr>
         <p:blipFill>
-          <a:blip xmlns:r="http://schemas.openxmlformats.org/officeDocument/2006/relationships" xmlns:a="http://schemas.openxmlformats.org/drawingml/2006/main" r:embed="R47498689b2834766"/>
+          <a:blip xmlns:r="http://schemas.openxmlformats.org/officeDocument/2006/relationships" xmlns:a="http://schemas.openxmlformats.org/drawingml/2006/main" r:embed="R88c112d4ad874ee5"/>
           <a:stretch xmlns:a="http://schemas.openxmlformats.org/drawingml/2006/main"/>
         </p:blipFill>
         <p:spPr>
@@ -16039,7 +16298,7 @@
           <p:cNvPr id="15" name="">
             <a:extLst xmlns:a="http://schemas.openxmlformats.org/drawingml/2006/main">
               <a:ext uri="{FF2B5EF4-FFF2-40B4-BE49-F238E27FC236}">
-                <a16:creationId xmlns:a16="http://schemas.microsoft.com/office/drawing/2014/main" id="{1A05172A-8469-46C9-96B7-5CDA8D87696C}"/>
+                <a16:creationId xmlns:a16="http://schemas.microsoft.com/office/drawing/2014/main" id="{B3659B29-5D1F-40C9-858F-F339AE812AA4}"/>
               </a:ext>
             </a:extLst>
           </p:cNvPr>
@@ -16049,7 +16308,7 @@
           <p:nvPr/>
         </p:nvPicPr>
         <p:blipFill>
-          <a:blip xmlns:r="http://schemas.openxmlformats.org/officeDocument/2006/relationships" xmlns:a="http://schemas.openxmlformats.org/drawingml/2006/main" r:embed="R6fcc6286b52144fc"/>
+          <a:blip xmlns:r="http://schemas.openxmlformats.org/officeDocument/2006/relationships" xmlns:a="http://schemas.openxmlformats.org/drawingml/2006/main" r:embed="R20400eceda97480e"/>
           <a:stretch xmlns:a="http://schemas.openxmlformats.org/drawingml/2006/main"/>
         </p:blipFill>
         <p:spPr>
@@ -16258,7 +16517,7 @@
           <p:cNvPr id="3" name="">
             <a:extLst xmlns:a="http://schemas.openxmlformats.org/drawingml/2006/main">
               <a:ext uri="{FF2B5EF4-FFF2-40B4-BE49-F238E27FC236}">
-                <a16:creationId xmlns:a16="http://schemas.microsoft.com/office/drawing/2014/main" id="{0DA5DC3C-6A9B-4D53-8FD4-DFFBAD402AEB}"/>
+                <a16:creationId xmlns:a16="http://schemas.microsoft.com/office/drawing/2014/main" id="{73199EA3-83C2-4657-BF8A-29CFC73D350B}"/>
               </a:ext>
             </a:extLst>
           </p:cNvPr>
@@ -16268,7 +16527,7 @@
           <p:nvPr/>
         </p:nvPicPr>
         <p:blipFill>
-          <a:blip xmlns:r="http://schemas.openxmlformats.org/officeDocument/2006/relationships" xmlns:a="http://schemas.openxmlformats.org/drawingml/2006/main" r:embed="R22cda5998970419e"/>
+          <a:blip xmlns:r="http://schemas.openxmlformats.org/officeDocument/2006/relationships" xmlns:a="http://schemas.openxmlformats.org/drawingml/2006/main" r:embed="R8c6b071e3ae447df"/>
           <a:stretch xmlns:a="http://schemas.openxmlformats.org/drawingml/2006/main"/>
         </p:blipFill>
         <p:spPr>

</xml_diff>

<commit_message>
Align presentation for Brad and Wesley shared demo
</commit_message>
<xml_diff>
--- a/docs/presentation/Engineering_at_The_Kinetic_Group.pptx
+++ b/docs/presentation/Engineering_at_The_Kinetic_Group.pptx
@@ -713,7 +713,7 @@
           <a:lstStyle xmlns:a="http://schemas.openxmlformats.org/drawingml/2006/main"/>
           <a:p xmlns:a="http://schemas.openxmlformats.org/drawingml/2006/main">
             <a:r>
-              <a:t>BRAD: Introduce yourself as lead of small engineering teams across TKG, mainly at Remington. Introduce Wesley. WESLEY: One of the first software interns; Remington Vision began with him as an intern and continues in his engineering role. WESLEY GAP (15–20 seconds): add a personal sentence. BRAD: state the purpose of the talk and invitation to connect.</a:t>
+              <a:t>BRAD: Open the talk. Introduce yourself as the lead of small engineering teams across TKG, mainly at Remington in Lonoke. Introduce Wesley Siharath and his path from software intern to engineer through Remington Vision. Set the purpose: show how engineering reaches the floor, demonstrate the system together, and meet people who want to build the future.</a:t>
             </a:r>
           </a:p>
         </p:txBody>
@@ -853,7 +853,7 @@
           <a:lstStyle xmlns:a="http://schemas.openxmlformats.org/drawingml/2006/main"/>
           <a:p xmlns:a="http://schemas.openxmlformats.org/drawingml/2006/main">
             <a:r>
-              <a:t>BRAD: Honor the manufacturing legacy and set the ambition to keep writing the rules for decades to come. Remington traces its history to 1816: https://www.remington.com/about-us.html . Remington says Lonoke operations began in 1969: https://www.remington.com/big-green-blog/labor-day-special.html . This is our ambition, not a claim that we already set a new industry standard.</a:t>
+              <a:t>BRAD: Honor Remington’s history and Lonoke’s place in it. The world of manufacturing has changed. State the ambition clearly: Remington and The Kinetic Group intend to write the rules for the future of manufacturing for decades to come by building capabilities that work on the floor.</a:t>
             </a:r>
           </a:p>
         </p:txBody>
@@ -993,7 +993,7 @@
           <a:lstStyle xmlns:a="http://schemas.openxmlformats.org/drawingml/2006/main"/>
           <a:p xmlns:a="http://schemas.openxmlformats.org/drawingml/2006/main">
             <a:r>
-              <a:t>BRAD: Say why you love the variety and visible impact, then hand off. WESLEY: Use his own points—one of the first software interns; work with AI and different machines; freedom to explore; ownership; unexpected opportunities. WESLEY GAP (30–45 seconds): one concrete public example of a problem, what he explored, and what he learned.</a:t>
+              <a:t>WESLEY: Explain why you love the work. You began as one of the first software interns and carried Remington Vision into your engineering role. Talk about variety, AI and machines, freedom to explore, ownership, and unexpected opportunities. WESLEY GAP (30–45 seconds): one concrete public example of a problem, what you tried, and what you learned.</a:t>
             </a:r>
           </a:p>
         </p:txBody>
@@ -1063,7 +1063,7 @@
           <a:lstStyle xmlns:a="http://schemas.openxmlformats.org/drawingml/2006/main"/>
           <a:p xmlns:a="http://schemas.openxmlformats.org/drawingml/2006/main">
             <a:r>
-              <a:t>WESLEY leads; BRAD operates slides. Show Gatorade bottles under the camera and the on-screen sorting decision. Pause after each result; invite a choice or another feature if the setup supports it. This is a demonstration setup and does not control a production sorting line.</a:t>
+              <a:t>BRAD + WESLEY: Lead the live demonstration together. Brad introduces the camera-to-decision flow and shows the first Gatorade bottle. Wesley points to the on-screen sorting result and shows a different bottle. Brad invites the audience to predict the result and closes with sense, decide, act. If useful, show another feature. The sorting decision is on screen; this setup does not control a production line.</a:t>
             </a:r>
           </a:p>
         </p:txBody>
@@ -1133,7 +1133,7 @@
           <a:lstStyle xmlns:a="http://schemas.openxmlformats.org/drawingml/2006/main"/>
           <a:p xmlns:a="http://schemas.openxmlformats.org/drawingml/2006/main">
             <a:r>
-              <a:t>WESLEY: Explain variation, timing, and reliability using what the audience just saw. WESLEY GAP (20–30 seconds): a practical challenge solved to make one behavior repeatable; share only public details. BRAD: disciplined engineering is what makes a capability useful in real manufacturing conditions.</a:t>
+              <a:t>WESLEY + BRAD: Wesley explains variation, timing, and reliability using what the audience just saw. WESLEY GAP (20–30 seconds): one concrete challenge or test. Brad explains why a result must keep working in real manufacturing conditions. Connect the work to the ambition to write the rules for the future of manufacturing.</a:t>
             </a:r>
           </a:p>
         </p:txBody>

</xml_diff>

<commit_message>
Give Wesley open-ended speaking cues throughout presentation
</commit_message>
<xml_diff>
--- a/docs/presentation/Engineering_at_The_Kinetic_Group.pptx
+++ b/docs/presentation/Engineering_at_The_Kinetic_Group.pptx
@@ -713,7 +713,7 @@
           <a:lstStyle xmlns:a="http://schemas.openxmlformats.org/drawingml/2006/main"/>
           <a:p xmlns:a="http://schemas.openxmlformats.org/drawingml/2006/main">
             <a:r>
-              <a:t>BRAD: Open the talk. Introduce yourself as the lead of small engineering teams across TKG, mainly at Remington in Lonoke. Introduce Wesley Siharath and his path from software intern to engineer through Remington Vision. Set the purpose: show how engineering reaches the floor, demonstrate the system together, and meet people who want to build the future.</a:t>
+              <a:t>BRAD opens: introduce yourself and your small engineering teams across TKG, mainly at Remington in Lonoke. Introduce Wesley by name, then invite him to introduce himself. WESLEY introduces himself in his own words: his path, current work, and what drew him in. BRAD frames the talk: engineering that reaches the floor, a shared live demo, and an invitation to people who want to build the future.</a:t>
             </a:r>
           </a:p>
         </p:txBody>
@@ -783,7 +783,7 @@
           <a:lstStyle xmlns:a="http://schemas.openxmlformats.org/drawingml/2006/main"/>
           <a:p xmlns:a="http://schemas.openxmlformats.org/drawingml/2006/main">
             <a:r>
-              <a:t>BRAD: Give email, official careers page, and independent 4Founders path. WESLEY: Invite engineering questions and student projects. BRAD: Close with the on-screen line: “Our history was made on the factory floor. The future will be, too. Come build and fight with us. Turn AI into action.” Hold this slide for questions.</a:t>
+              <a:t>BRAD: Give email, official careers page, and independent 4Founders path. WESLEY: In your own words, invite engineering questions and ideas people are building. BRAD: Close with the on-screen line: “Our history was made on the factory floor. The future will be, too. Come build and fight with us. Turn AI into action.” Hold this slide for questions.</a:t>
             </a:r>
           </a:p>
         </p:txBody>
@@ -923,7 +923,7 @@
           <a:lstStyle xmlns:a="http://schemas.openxmlformats.org/drawingml/2006/main"/>
           <a:p xmlns:a="http://schemas.openxmlformats.org/drawingml/2006/main">
             <a:r>
-              <a:t>BRAD: Explain the system simply: machines sense what is happening; software turns signals into a decision; people or equipment act. Small teams across TKG, primarily at Remington, build, test, and improve the full chain with the people who use it. Keep details for questions.</a:t>
+              <a:t>BRAD: Explain the system simply: machines sense what is happening; software turns signals into a decision; people or equipment act. Explain that the full chain must work with the people on the floor. Keep details for questions. Hand off by asking Wesley what makes the work exciting for him.</a:t>
             </a:r>
           </a:p>
         </p:txBody>
@@ -993,7 +993,7 @@
           <a:lstStyle xmlns:a="http://schemas.openxmlformats.org/drawingml/2006/main"/>
           <a:p xmlns:a="http://schemas.openxmlformats.org/drawingml/2006/main">
             <a:r>
-              <a:t>WESLEY: Explain why you love the work. You began as one of the first software interns and carried Remington Vision into your engineering role. Talk about variety, AI and machines, freedom to explore, ownership, and unexpected opportunities. WESLEY GAP (30–45 seconds): one concrete public example of a problem, what you tried, and what you learned.</a:t>
+              <a:t>WESLEY speaks in his own words. Optional anchors from his planned remarks: one of the first software interns; work with AI and different machines; variety; freedom to explore; ownership; unexpected opportunities. Choose one concrete public example of a problem, what you tried, and what you learned. Finish with why you love the work, then move with Brad to the demo.</a:t>
             </a:r>
           </a:p>
         </p:txBody>
@@ -1063,7 +1063,7 @@
           <a:lstStyle xmlns:a="http://schemas.openxmlformats.org/drawingml/2006/main"/>
           <a:p xmlns:a="http://schemas.openxmlformats.org/drawingml/2006/main">
             <a:r>
-              <a:t>BRAD + WESLEY: Lead the live demonstration together. Brad introduces the camera-to-decision flow and shows the first Gatorade bottle. Wesley points to the on-screen sorting result and shows a different bottle. Brad invites the audience to predict the result and closes with sense, decide, act. If useful, show another feature. The sorting decision is on screen; this setup does not control a production line.</a:t>
+              <a:t>BRAD + WESLEY lead the live demonstration together. Brad introduces the camera-to-decision flow and shows the first Gatorade bottle. Wesley chooses the next bottle or feature and narrates what matters in his own words. Brad may ask the audience to predict the result and closes with sense, decide, act. The sorting decision is on screen; this setup does not control a production line.</a:t>
             </a:r>
           </a:p>
         </p:txBody>
@@ -1133,7 +1133,7 @@
           <a:lstStyle xmlns:a="http://schemas.openxmlformats.org/drawingml/2006/main"/>
           <a:p xmlns:a="http://schemas.openxmlformats.org/drawingml/2006/main">
             <a:r>
-              <a:t>WESLEY + BRAD: Wesley explains variation, timing, and reliability using what the audience just saw. WESLEY GAP (20–30 seconds): one concrete challenge or test. Brad explains why a result must keep working in real manufacturing conditions. Connect the work to the ambition to write the rules for the future of manufacturing.</a:t>
+              <a:t>WESLEY + BRAD: Wesley chooses the hard problems that best connect to what the audience saw. Possible anchors: variation, timing, uncertainty, reliability, and one concrete challenge or test. He speaks in his own words and can go deeper if asked. Brad explains why the result must keep working in real manufacturing conditions and ties the challenge to writing the rules for the future of manufacturing.</a:t>
             </a:r>
           </a:p>
         </p:txBody>

</xml_diff>

<commit_message>
Use Brad email only on closing slide
</commit_message>
<xml_diff>
--- a/docs/presentation/Engineering_at_The_Kinetic_Group.pptx
+++ b/docs/presentation/Engineering_at_The_Kinetic_Group.pptx
@@ -783,7 +783,7 @@
           <a:lstStyle xmlns:a="http://schemas.openxmlformats.org/drawingml/2006/main"/>
           <a:p xmlns:a="http://schemas.openxmlformats.org/drawingml/2006/main">
             <a:r>
-              <a:t>BRAD: Give email, official careers page, and independent 4Founders path. WESLEY: In your own words, invite engineering questions and ideas people are building. BRAD: Close with the on-screen line: “Our history was made on the factory floor. The future will be, too. Come build and fight with us. Turn AI into action.” Hold this slide for questions.</a:t>
+              <a:t>BRAD: Point to the email on screen. Invite follow-up from people interested in joining a team, exploring an idea, or asking about the work. WESLEY: In your own words, invite engineering questions and ideas people are building. BRAD: Close with the on-screen line: “Our history was made on the factory floor. The future will be, too. Come build and fight with us. Turn AI into action.” Hold the slide for questions.</a:t>
             </a:r>
           </a:p>
         </p:txBody>
@@ -5409,127 +5409,6 @@
       </p:sp>
       <p:sp>
         <p:nvSpPr>
-          <p:cNvPr id="5" name="">
-            <a:extLst xmlns:a="http://schemas.openxmlformats.org/drawingml/2006/main">
-              <a:ext uri="{FF2B5EF4-FFF2-40B4-BE49-F238E27FC236}">
-                <a16:creationId xmlns:a16="http://schemas.microsoft.com/office/drawing/2014/main" id="{6BB4B1C2-72EC-4F8E-9B95-4A3FB2B2C252}"/>
-              </a:ext>
-            </a:extLst>
-          </p:cNvPr>
-          <p:cNvSpPr>
-            <a:spLocks xmlns:a="http://schemas.openxmlformats.org/drawingml/2006/main" noGrp="1"/>
-          </p:cNvSpPr>
-          <p:nvPr/>
-        </p:nvSpPr>
-        <p:spPr>
-          <a:xfrm xmlns:a="http://schemas.openxmlformats.org/drawingml/2006/main">
-            <a:off x="723900" y="4724400"/>
-            <a:ext cx="4191000" cy="323850"/>
-          </a:xfrm>
-          <a:prstGeom xmlns:a="http://schemas.openxmlformats.org/drawingml/2006/main" prst="rect">
-            <a:avLst/>
-          </a:prstGeom>
-          <a:noFill xmlns:a="http://schemas.openxmlformats.org/drawingml/2006/main"/>
-          <a:ln xmlns:a="http://schemas.openxmlformats.org/drawingml/2006/main" w="0">
-            <a:noFill/>
-            <a:prstDash val="solid"/>
-          </a:ln>
-        </p:spPr>
-        <p:txBody>
-          <a:bodyPr xmlns:a="http://schemas.openxmlformats.org/drawingml/2006/main" lIns="0" tIns="0" rIns="0" bIns="0"/>
-          <a:lstStyle xmlns:a="http://schemas.openxmlformats.org/drawingml/2006/main">
-            <a:defPPr algn="l">
-              <a:defRPr sz="1650" b="1" i="0">
-                <a:solidFill>
-                  <a:srgbClr val="BEA06A"/>
-                </a:solidFill>
-              </a:defRPr>
-            </a:defPPr>
-            <a:lvl1pPr algn="l">
-              <a:defRPr sz="1650" b="1" i="0">
-                <a:solidFill>
-                  <a:srgbClr val="BEA06A"/>
-                </a:solidFill>
-              </a:defRPr>
-            </a:lvl1pPr>
-            <a:lvl2pPr algn="l">
-              <a:defRPr sz="1650" b="1" i="0">
-                <a:solidFill>
-                  <a:srgbClr val="BEA06A"/>
-                </a:solidFill>
-              </a:defRPr>
-            </a:lvl2pPr>
-            <a:lvl3pPr algn="l">
-              <a:defRPr sz="1650" b="1" i="0">
-                <a:solidFill>
-                  <a:srgbClr val="BEA06A"/>
-                </a:solidFill>
-              </a:defRPr>
-            </a:lvl3pPr>
-            <a:lvl4pPr algn="l">
-              <a:defRPr sz="1650" b="1" i="0">
-                <a:solidFill>
-                  <a:srgbClr val="BEA06A"/>
-                </a:solidFill>
-              </a:defRPr>
-            </a:lvl4pPr>
-            <a:lvl5pPr algn="l">
-              <a:defRPr sz="1650" b="1" i="0">
-                <a:solidFill>
-                  <a:srgbClr val="BEA06A"/>
-                </a:solidFill>
-              </a:defRPr>
-            </a:lvl5pPr>
-            <a:lvl6pPr algn="l">
-              <a:defRPr sz="1650" b="1" i="0">
-                <a:solidFill>
-                  <a:srgbClr val="BEA06A"/>
-                </a:solidFill>
-              </a:defRPr>
-            </a:lvl6pPr>
-            <a:lvl7pPr algn="l">
-              <a:defRPr sz="1650" b="1" i="0">
-                <a:solidFill>
-                  <a:srgbClr val="BEA06A"/>
-                </a:solidFill>
-              </a:defRPr>
-            </a:lvl7pPr>
-            <a:lvl8pPr algn="l">
-              <a:defRPr sz="1650" b="1" i="0">
-                <a:solidFill>
-                  <a:srgbClr val="BEA06A"/>
-                </a:solidFill>
-              </a:defRPr>
-            </a:lvl8pPr>
-            <a:lvl9pPr algn="l">
-              <a:defRPr sz="1650" b="1" i="0">
-                <a:solidFill>
-                  <a:srgbClr val="BEA06A"/>
-                </a:solidFill>
-              </a:defRPr>
-            </a:lvl9pPr>
-          </a:lstStyle>
-          <a:p xmlns:a="http://schemas.openxmlformats.org/drawingml/2006/main">
-            <a:pPr algn="l">
-              <a:defRPr sz="1650" b="1" i="0">
-                <a:solidFill>
-                  <a:srgbClr val="BEA06A"/>
-                </a:solidFill>
-              </a:defRPr>
-            </a:pPr>
-            <a:r>
-              <a:rPr sz="1650" b="1" i="0">
-                <a:solidFill>
-                  <a:srgbClr val="BEA06A"/>
-                </a:solidFill>
-              </a:rPr>
-              <a:t>BRAD</a:t>
-            </a:r>
-          </a:p>
-        </p:txBody>
-      </p:sp>
-      <p:sp>
-        <p:nvSpPr>
           <p:cNvPr id="6" name="">
             <a:extLst xmlns:a="http://schemas.openxmlformats.org/drawingml/2006/main">
               <a:ext uri="{FF2B5EF4-FFF2-40B4-BE49-F238E27FC236}">
@@ -5544,8 +5423,8 @@
         </p:nvSpPr>
         <p:spPr>
           <a:xfrm xmlns:a="http://schemas.openxmlformats.org/drawingml/2006/main">
-            <a:off x="723900" y="5038725"/>
-            <a:ext cx="4667250" cy="419100"/>
+            <a:off x="914400" y="5057775"/>
+            <a:ext cx="7315200" cy="552450"/>
           </a:xfrm>
           <a:prstGeom xmlns:a="http://schemas.openxmlformats.org/drawingml/2006/main" prst="rect">
             <a:avLst/>
@@ -5559,71 +5438,71 @@
         <p:txBody>
           <a:bodyPr xmlns:a="http://schemas.openxmlformats.org/drawingml/2006/main" lIns="0" tIns="0" rIns="0" bIns="0"/>
           <a:lstStyle xmlns:a="http://schemas.openxmlformats.org/drawingml/2006/main">
-            <a:defPPr algn="l">
-              <a:defRPr sz="2100" b="1" i="0">
+            <a:defPPr algn="ctr">
+              <a:defRPr sz="2600" b="1" i="0">
                 <a:solidFill>
                   <a:srgbClr val="FFFFFF"/>
                 </a:solidFill>
               </a:defRPr>
             </a:defPPr>
-            <a:lvl1pPr algn="l">
-              <a:defRPr sz="2100" b="1" i="0">
+            <a:lvl1pPr algn="ctr">
+              <a:defRPr sz="2600" b="1" i="0">
                 <a:solidFill>
                   <a:srgbClr val="FFFFFF"/>
                 </a:solidFill>
               </a:defRPr>
             </a:lvl1pPr>
-            <a:lvl2pPr algn="l">
-              <a:defRPr sz="2100" b="1" i="0">
+            <a:lvl2pPr algn="ctr">
+              <a:defRPr sz="2600" b="1" i="0">
                 <a:solidFill>
                   <a:srgbClr val="FFFFFF"/>
                 </a:solidFill>
               </a:defRPr>
             </a:lvl2pPr>
-            <a:lvl3pPr algn="l">
-              <a:defRPr sz="2100" b="1" i="0">
+            <a:lvl3pPr algn="ctr">
+              <a:defRPr sz="2600" b="1" i="0">
                 <a:solidFill>
                   <a:srgbClr val="FFFFFF"/>
                 </a:solidFill>
               </a:defRPr>
             </a:lvl3pPr>
-            <a:lvl4pPr algn="l">
-              <a:defRPr sz="2100" b="1" i="0">
+            <a:lvl4pPr algn="ctr">
+              <a:defRPr sz="2600" b="1" i="0">
                 <a:solidFill>
                   <a:srgbClr val="FFFFFF"/>
                 </a:solidFill>
               </a:defRPr>
             </a:lvl4pPr>
-            <a:lvl5pPr algn="l">
-              <a:defRPr sz="2100" b="1" i="0">
+            <a:lvl5pPr algn="ctr">
+              <a:defRPr sz="2600" b="1" i="0">
                 <a:solidFill>
                   <a:srgbClr val="FFFFFF"/>
                 </a:solidFill>
               </a:defRPr>
             </a:lvl5pPr>
-            <a:lvl6pPr algn="l">
-              <a:defRPr sz="2100" b="1" i="0">
+            <a:lvl6pPr algn="ctr">
+              <a:defRPr sz="2600" b="1" i="0">
                 <a:solidFill>
                   <a:srgbClr val="FFFFFF"/>
                 </a:solidFill>
               </a:defRPr>
             </a:lvl6pPr>
-            <a:lvl7pPr algn="l">
-              <a:defRPr sz="2100" b="1" i="0">
+            <a:lvl7pPr algn="ctr">
+              <a:defRPr sz="2600" b="1" i="0">
                 <a:solidFill>
                   <a:srgbClr val="FFFFFF"/>
                 </a:solidFill>
               </a:defRPr>
             </a:lvl7pPr>
-            <a:lvl8pPr algn="l">
-              <a:defRPr sz="2100" b="1" i="0">
+            <a:lvl8pPr algn="ctr">
+              <a:defRPr sz="2600" b="1" i="0">
                 <a:solidFill>
                   <a:srgbClr val="FFFFFF"/>
                 </a:solidFill>
               </a:defRPr>
             </a:lvl8pPr>
-            <a:lvl9pPr algn="l">
-              <a:defRPr sz="2100" b="1" i="0">
+            <a:lvl9pPr algn="ctr">
+              <a:defRPr sz="2600" b="1" i="0">
                 <a:solidFill>
                   <a:srgbClr val="FFFFFF"/>
                 </a:solidFill>
@@ -5631,504 +5510,20 @@
             </a:lvl9pPr>
           </a:lstStyle>
           <a:p xmlns:a="http://schemas.openxmlformats.org/drawingml/2006/main">
-            <a:pPr algn="l">
-              <a:defRPr sz="2100" b="1" i="0">
+            <a:pPr algn="ctr">
+              <a:defRPr sz="2600" b="1" i="0">
                 <a:solidFill>
                   <a:srgbClr val="FFFFFF"/>
                 </a:solidFill>
               </a:defRPr>
             </a:pPr>
             <a:r>
-              <a:rPr sz="2100" b="1" i="0">
+              <a:rPr sz="2600" b="1" i="0">
                 <a:solidFill>
                   <a:srgbClr val="FFFFFF"/>
                 </a:solidFill>
               </a:rPr>
               <a:t>bdaugherty@tkghunt.com</a:t>
-            </a:r>
-          </a:p>
-        </p:txBody>
-      </p:sp>
-      <p:sp>
-        <p:nvSpPr>
-          <p:cNvPr id="7" name="">
-            <a:extLst xmlns:a="http://schemas.openxmlformats.org/drawingml/2006/main">
-              <a:ext uri="{FF2B5EF4-FFF2-40B4-BE49-F238E27FC236}">
-                <a16:creationId xmlns:a16="http://schemas.microsoft.com/office/drawing/2014/main" id="{29D66A8B-01CA-46BD-87E6-D9B32A693B67}"/>
-              </a:ext>
-            </a:extLst>
-          </p:cNvPr>
-          <p:cNvSpPr>
-            <a:spLocks xmlns:a="http://schemas.openxmlformats.org/drawingml/2006/main" noGrp="1"/>
-          </p:cNvSpPr>
-          <p:nvPr/>
-        </p:nvSpPr>
-        <p:spPr>
-          <a:xfrm xmlns:a="http://schemas.openxmlformats.org/drawingml/2006/main">
-            <a:off x="723900" y="5610225"/>
-            <a:ext cx="4762500" cy="342900"/>
-          </a:xfrm>
-          <a:prstGeom xmlns:a="http://schemas.openxmlformats.org/drawingml/2006/main" prst="rect">
-            <a:avLst/>
-          </a:prstGeom>
-          <a:noFill xmlns:a="http://schemas.openxmlformats.org/drawingml/2006/main"/>
-          <a:ln xmlns:a="http://schemas.openxmlformats.org/drawingml/2006/main" w="0">
-            <a:noFill/>
-            <a:prstDash val="solid"/>
-          </a:ln>
-        </p:spPr>
-        <p:txBody>
-          <a:bodyPr xmlns:a="http://schemas.openxmlformats.org/drawingml/2006/main" lIns="0" tIns="0" rIns="0" bIns="0"/>
-          <a:lstStyle xmlns:a="http://schemas.openxmlformats.org/drawingml/2006/main">
-            <a:defPPr algn="l">
-              <a:defRPr sz="1575" b="0" i="0">
-                <a:solidFill>
-                  <a:srgbClr val="D5D8DA"/>
-                </a:solidFill>
-              </a:defRPr>
-            </a:defPPr>
-            <a:lvl1pPr algn="l">
-              <a:defRPr sz="1575" b="0" i="0">
-                <a:solidFill>
-                  <a:srgbClr val="D5D8DA"/>
-                </a:solidFill>
-              </a:defRPr>
-            </a:lvl1pPr>
-            <a:lvl2pPr algn="l">
-              <a:defRPr sz="1575" b="0" i="0">
-                <a:solidFill>
-                  <a:srgbClr val="D5D8DA"/>
-                </a:solidFill>
-              </a:defRPr>
-            </a:lvl2pPr>
-            <a:lvl3pPr algn="l">
-              <a:defRPr sz="1575" b="0" i="0">
-                <a:solidFill>
-                  <a:srgbClr val="D5D8DA"/>
-                </a:solidFill>
-              </a:defRPr>
-            </a:lvl3pPr>
-            <a:lvl4pPr algn="l">
-              <a:defRPr sz="1575" b="0" i="0">
-                <a:solidFill>
-                  <a:srgbClr val="D5D8DA"/>
-                </a:solidFill>
-              </a:defRPr>
-            </a:lvl4pPr>
-            <a:lvl5pPr algn="l">
-              <a:defRPr sz="1575" b="0" i="0">
-                <a:solidFill>
-                  <a:srgbClr val="D5D8DA"/>
-                </a:solidFill>
-              </a:defRPr>
-            </a:lvl5pPr>
-            <a:lvl6pPr algn="l">
-              <a:defRPr sz="1575" b="0" i="0">
-                <a:solidFill>
-                  <a:srgbClr val="D5D8DA"/>
-                </a:solidFill>
-              </a:defRPr>
-            </a:lvl6pPr>
-            <a:lvl7pPr algn="l">
-              <a:defRPr sz="1575" b="0" i="0">
-                <a:solidFill>
-                  <a:srgbClr val="D5D8DA"/>
-                </a:solidFill>
-              </a:defRPr>
-            </a:lvl7pPr>
-            <a:lvl8pPr algn="l">
-              <a:defRPr sz="1575" b="0" i="0">
-                <a:solidFill>
-                  <a:srgbClr val="D5D8DA"/>
-                </a:solidFill>
-              </a:defRPr>
-            </a:lvl8pPr>
-            <a:lvl9pPr algn="l">
-              <a:defRPr sz="1575" b="0" i="0">
-                <a:solidFill>
-                  <a:srgbClr val="D5D8DA"/>
-                </a:solidFill>
-              </a:defRPr>
-            </a:lvl9pPr>
-          </a:lstStyle>
-          <a:p xmlns:a="http://schemas.openxmlformats.org/drawingml/2006/main">
-            <a:pPr algn="l">
-              <a:defRPr sz="1575" b="0" i="0">
-                <a:solidFill>
-                  <a:srgbClr val="D5D8DA"/>
-                </a:solidFill>
-              </a:defRPr>
-            </a:pPr>
-            <a:r>
-              <a:rPr sz="1575" b="0" i="0">
-                <a:solidFill>
-                  <a:srgbClr val="D5D8DA"/>
-                </a:solidFill>
-              </a:rPr>
-              <a:t>thekineticgroup.com/careers.html</a:t>
-            </a:r>
-          </a:p>
-        </p:txBody>
-      </p:sp>
-      <p:sp>
-        <p:nvSpPr>
-          <p:cNvPr id="8" name="">
-            <a:extLst xmlns:a="http://schemas.openxmlformats.org/drawingml/2006/main">
-              <a:ext uri="{FF2B5EF4-FFF2-40B4-BE49-F238E27FC236}">
-                <a16:creationId xmlns:a16="http://schemas.microsoft.com/office/drawing/2014/main" id="{590BD204-A6D7-45A7-9585-FD92F4A42AD4}"/>
-              </a:ext>
-            </a:extLst>
-          </p:cNvPr>
-          <p:cNvSpPr>
-            <a:spLocks xmlns:a="http://schemas.openxmlformats.org/drawingml/2006/main" noGrp="1"/>
-          </p:cNvSpPr>
-          <p:nvPr/>
-        </p:nvSpPr>
-        <p:spPr>
-          <a:xfrm xmlns:a="http://schemas.openxmlformats.org/drawingml/2006/main">
-            <a:off x="5543550" y="4724400"/>
-            <a:ext cx="2933700" cy="323850"/>
-          </a:xfrm>
-          <a:prstGeom xmlns:a="http://schemas.openxmlformats.org/drawingml/2006/main" prst="rect">
-            <a:avLst/>
-          </a:prstGeom>
-          <a:noFill xmlns:a="http://schemas.openxmlformats.org/drawingml/2006/main"/>
-          <a:ln xmlns:a="http://schemas.openxmlformats.org/drawingml/2006/main" w="0">
-            <a:noFill/>
-            <a:prstDash val="solid"/>
-          </a:ln>
-        </p:spPr>
-        <p:txBody>
-          <a:bodyPr xmlns:a="http://schemas.openxmlformats.org/drawingml/2006/main" lIns="0" tIns="0" rIns="0" bIns="0"/>
-          <a:lstStyle xmlns:a="http://schemas.openxmlformats.org/drawingml/2006/main">
-            <a:defPPr algn="l">
-              <a:defRPr sz="1650" b="1" i="0">
-                <a:solidFill>
-                  <a:srgbClr val="BEA06A"/>
-                </a:solidFill>
-              </a:defRPr>
-            </a:defPPr>
-            <a:lvl1pPr algn="l">
-              <a:defRPr sz="1650" b="1" i="0">
-                <a:solidFill>
-                  <a:srgbClr val="BEA06A"/>
-                </a:solidFill>
-              </a:defRPr>
-            </a:lvl1pPr>
-            <a:lvl2pPr algn="l">
-              <a:defRPr sz="1650" b="1" i="0">
-                <a:solidFill>
-                  <a:srgbClr val="BEA06A"/>
-                </a:solidFill>
-              </a:defRPr>
-            </a:lvl2pPr>
-            <a:lvl3pPr algn="l">
-              <a:defRPr sz="1650" b="1" i="0">
-                <a:solidFill>
-                  <a:srgbClr val="BEA06A"/>
-                </a:solidFill>
-              </a:defRPr>
-            </a:lvl3pPr>
-            <a:lvl4pPr algn="l">
-              <a:defRPr sz="1650" b="1" i="0">
-                <a:solidFill>
-                  <a:srgbClr val="BEA06A"/>
-                </a:solidFill>
-              </a:defRPr>
-            </a:lvl4pPr>
-            <a:lvl5pPr algn="l">
-              <a:defRPr sz="1650" b="1" i="0">
-                <a:solidFill>
-                  <a:srgbClr val="BEA06A"/>
-                </a:solidFill>
-              </a:defRPr>
-            </a:lvl5pPr>
-            <a:lvl6pPr algn="l">
-              <a:defRPr sz="1650" b="1" i="0">
-                <a:solidFill>
-                  <a:srgbClr val="BEA06A"/>
-                </a:solidFill>
-              </a:defRPr>
-            </a:lvl6pPr>
-            <a:lvl7pPr algn="l">
-              <a:defRPr sz="1650" b="1" i="0">
-                <a:solidFill>
-                  <a:srgbClr val="BEA06A"/>
-                </a:solidFill>
-              </a:defRPr>
-            </a:lvl7pPr>
-            <a:lvl8pPr algn="l">
-              <a:defRPr sz="1650" b="1" i="0">
-                <a:solidFill>
-                  <a:srgbClr val="BEA06A"/>
-                </a:solidFill>
-              </a:defRPr>
-            </a:lvl8pPr>
-            <a:lvl9pPr algn="l">
-              <a:defRPr sz="1650" b="1" i="0">
-                <a:solidFill>
-                  <a:srgbClr val="BEA06A"/>
-                </a:solidFill>
-              </a:defRPr>
-            </a:lvl9pPr>
-          </a:lstStyle>
-          <a:p xmlns:a="http://schemas.openxmlformats.org/drawingml/2006/main">
-            <a:pPr algn="l">
-              <a:defRPr sz="1650" b="1" i="0">
-                <a:solidFill>
-                  <a:srgbClr val="BEA06A"/>
-                </a:solidFill>
-              </a:defRPr>
-            </a:pPr>
-            <a:r>
-              <a:rPr sz="1650" b="1" i="0">
-                <a:solidFill>
-                  <a:srgbClr val="BEA06A"/>
-                </a:solidFill>
-              </a:rPr>
-              <a:t>4FOUNDERS</a:t>
-            </a:r>
-          </a:p>
-        </p:txBody>
-      </p:sp>
-      <p:sp>
-        <p:nvSpPr>
-          <p:cNvPr id="9" name="">
-            <a:extLst xmlns:a="http://schemas.openxmlformats.org/drawingml/2006/main">
-              <a:ext uri="{FF2B5EF4-FFF2-40B4-BE49-F238E27FC236}">
-                <a16:creationId xmlns:a16="http://schemas.microsoft.com/office/drawing/2014/main" id="{0AD3077D-1780-44E0-8AE9-7FBE62174054}"/>
-              </a:ext>
-            </a:extLst>
-          </p:cNvPr>
-          <p:cNvSpPr>
-            <a:spLocks xmlns:a="http://schemas.openxmlformats.org/drawingml/2006/main" noGrp="1"/>
-          </p:cNvSpPr>
-          <p:nvPr/>
-        </p:nvSpPr>
-        <p:spPr>
-          <a:xfrm xmlns:a="http://schemas.openxmlformats.org/drawingml/2006/main">
-            <a:off x="5543550" y="5038725"/>
-            <a:ext cx="2924175" cy="419100"/>
-          </a:xfrm>
-          <a:prstGeom xmlns:a="http://schemas.openxmlformats.org/drawingml/2006/main" prst="rect">
-            <a:avLst/>
-          </a:prstGeom>
-          <a:noFill xmlns:a="http://schemas.openxmlformats.org/drawingml/2006/main"/>
-          <a:ln xmlns:a="http://schemas.openxmlformats.org/drawingml/2006/main" w="0">
-            <a:noFill/>
-            <a:prstDash val="solid"/>
-          </a:ln>
-        </p:spPr>
-        <p:txBody>
-          <a:bodyPr xmlns:a="http://schemas.openxmlformats.org/drawingml/2006/main" lIns="0" tIns="0" rIns="0" bIns="0"/>
-          <a:lstStyle xmlns:a="http://schemas.openxmlformats.org/drawingml/2006/main">
-            <a:defPPr algn="l">
-              <a:defRPr sz="2100" b="1" i="0">
-                <a:solidFill>
-                  <a:srgbClr val="FFFFFF"/>
-                </a:solidFill>
-              </a:defRPr>
-            </a:defPPr>
-            <a:lvl1pPr algn="l">
-              <a:defRPr sz="2100" b="1" i="0">
-                <a:solidFill>
-                  <a:srgbClr val="FFFFFF"/>
-                </a:solidFill>
-              </a:defRPr>
-            </a:lvl1pPr>
-            <a:lvl2pPr algn="l">
-              <a:defRPr sz="2100" b="1" i="0">
-                <a:solidFill>
-                  <a:srgbClr val="FFFFFF"/>
-                </a:solidFill>
-              </a:defRPr>
-            </a:lvl2pPr>
-            <a:lvl3pPr algn="l">
-              <a:defRPr sz="2100" b="1" i="0">
-                <a:solidFill>
-                  <a:srgbClr val="FFFFFF"/>
-                </a:solidFill>
-              </a:defRPr>
-            </a:lvl3pPr>
-            <a:lvl4pPr algn="l">
-              <a:defRPr sz="2100" b="1" i="0">
-                <a:solidFill>
-                  <a:srgbClr val="FFFFFF"/>
-                </a:solidFill>
-              </a:defRPr>
-            </a:lvl4pPr>
-            <a:lvl5pPr algn="l">
-              <a:defRPr sz="2100" b="1" i="0">
-                <a:solidFill>
-                  <a:srgbClr val="FFFFFF"/>
-                </a:solidFill>
-              </a:defRPr>
-            </a:lvl5pPr>
-            <a:lvl6pPr algn="l">
-              <a:defRPr sz="2100" b="1" i="0">
-                <a:solidFill>
-                  <a:srgbClr val="FFFFFF"/>
-                </a:solidFill>
-              </a:defRPr>
-            </a:lvl6pPr>
-            <a:lvl7pPr algn="l">
-              <a:defRPr sz="2100" b="1" i="0">
-                <a:solidFill>
-                  <a:srgbClr val="FFFFFF"/>
-                </a:solidFill>
-              </a:defRPr>
-            </a:lvl7pPr>
-            <a:lvl8pPr algn="l">
-              <a:defRPr sz="2100" b="1" i="0">
-                <a:solidFill>
-                  <a:srgbClr val="FFFFFF"/>
-                </a:solidFill>
-              </a:defRPr>
-            </a:lvl8pPr>
-            <a:lvl9pPr algn="l">
-              <a:defRPr sz="2100" b="1" i="0">
-                <a:solidFill>
-                  <a:srgbClr val="FFFFFF"/>
-                </a:solidFill>
-              </a:defRPr>
-            </a:lvl9pPr>
-          </a:lstStyle>
-          <a:p xmlns:a="http://schemas.openxmlformats.org/drawingml/2006/main">
-            <a:pPr algn="l">
-              <a:defRPr sz="2100" b="1" i="0">
-                <a:solidFill>
-                  <a:srgbClr val="FFFFFF"/>
-                </a:solidFill>
-              </a:defRPr>
-            </a:pPr>
-            <a:r>
-              <a:rPr sz="2100" b="1" i="0">
-                <a:solidFill>
-                  <a:srgbClr val="FFFFFF"/>
-                </a:solidFill>
-              </a:rPr>
-              <a:t>4founders.dev</a:t>
-            </a:r>
-          </a:p>
-        </p:txBody>
-      </p:sp>
-      <p:sp>
-        <p:nvSpPr>
-          <p:cNvPr id="10" name="">
-            <a:extLst xmlns:a="http://schemas.openxmlformats.org/drawingml/2006/main">
-              <a:ext uri="{FF2B5EF4-FFF2-40B4-BE49-F238E27FC236}">
-                <a16:creationId xmlns:a16="http://schemas.microsoft.com/office/drawing/2014/main" id="{3512F6D4-7B37-4DE5-AE82-6E29C3AD8006}"/>
-              </a:ext>
-            </a:extLst>
-          </p:cNvPr>
-          <p:cNvSpPr>
-            <a:spLocks xmlns:a="http://schemas.openxmlformats.org/drawingml/2006/main" noGrp="1"/>
-          </p:cNvSpPr>
-          <p:nvPr/>
-        </p:nvSpPr>
-        <p:spPr>
-          <a:xfrm xmlns:a="http://schemas.openxmlformats.org/drawingml/2006/main">
-            <a:off x="5543550" y="5524500"/>
-            <a:ext cx="2981325" cy="381000"/>
-          </a:xfrm>
-          <a:prstGeom xmlns:a="http://schemas.openxmlformats.org/drawingml/2006/main" prst="rect">
-            <a:avLst/>
-          </a:prstGeom>
-          <a:noFill xmlns:a="http://schemas.openxmlformats.org/drawingml/2006/main"/>
-          <a:ln xmlns:a="http://schemas.openxmlformats.org/drawingml/2006/main" w="0">
-            <a:noFill/>
-            <a:prstDash val="solid"/>
-          </a:ln>
-        </p:spPr>
-        <p:txBody>
-          <a:bodyPr xmlns:a="http://schemas.openxmlformats.org/drawingml/2006/main" lIns="0" tIns="0" rIns="0" bIns="0"/>
-          <a:lstStyle xmlns:a="http://schemas.openxmlformats.org/drawingml/2006/main">
-            <a:defPPr algn="l">
-              <a:defRPr sz="1425" b="0" i="0">
-                <a:solidFill>
-                  <a:srgbClr val="D5D8DA"/>
-                </a:solidFill>
-              </a:defRPr>
-            </a:defPPr>
-            <a:lvl1pPr algn="l">
-              <a:defRPr sz="1425" b="0" i="0">
-                <a:solidFill>
-                  <a:srgbClr val="D5D8DA"/>
-                </a:solidFill>
-              </a:defRPr>
-            </a:lvl1pPr>
-            <a:lvl2pPr algn="l">
-              <a:defRPr sz="1425" b="0" i="0">
-                <a:solidFill>
-                  <a:srgbClr val="D5D8DA"/>
-                </a:solidFill>
-              </a:defRPr>
-            </a:lvl2pPr>
-            <a:lvl3pPr algn="l">
-              <a:defRPr sz="1425" b="0" i="0">
-                <a:solidFill>
-                  <a:srgbClr val="D5D8DA"/>
-                </a:solidFill>
-              </a:defRPr>
-            </a:lvl3pPr>
-            <a:lvl4pPr algn="l">
-              <a:defRPr sz="1425" b="0" i="0">
-                <a:solidFill>
-                  <a:srgbClr val="D5D8DA"/>
-                </a:solidFill>
-              </a:defRPr>
-            </a:lvl4pPr>
-            <a:lvl5pPr algn="l">
-              <a:defRPr sz="1425" b="0" i="0">
-                <a:solidFill>
-                  <a:srgbClr val="D5D8DA"/>
-                </a:solidFill>
-              </a:defRPr>
-            </a:lvl5pPr>
-            <a:lvl6pPr algn="l">
-              <a:defRPr sz="1425" b="0" i="0">
-                <a:solidFill>
-                  <a:srgbClr val="D5D8DA"/>
-                </a:solidFill>
-              </a:defRPr>
-            </a:lvl6pPr>
-            <a:lvl7pPr algn="l">
-              <a:defRPr sz="1425" b="0" i="0">
-                <a:solidFill>
-                  <a:srgbClr val="D5D8DA"/>
-                </a:solidFill>
-              </a:defRPr>
-            </a:lvl7pPr>
-            <a:lvl8pPr algn="l">
-              <a:defRPr sz="1425" b="0" i="0">
-                <a:solidFill>
-                  <a:srgbClr val="D5D8DA"/>
-                </a:solidFill>
-              </a:defRPr>
-            </a:lvl8pPr>
-            <a:lvl9pPr algn="l">
-              <a:defRPr sz="1425" b="0" i="0">
-                <a:solidFill>
-                  <a:srgbClr val="D5D8DA"/>
-                </a:solidFill>
-              </a:defRPr>
-            </a:lvl9pPr>
-          </a:lstStyle>
-          <a:p xmlns:a="http://schemas.openxmlformats.org/drawingml/2006/main">
-            <a:pPr algn="l">
-              <a:defRPr sz="1425" b="0" i="0">
-                <a:solidFill>
-                  <a:srgbClr val="D5D8DA"/>
-                </a:solidFill>
-              </a:defRPr>
-            </a:pPr>
-            <a:r>
-              <a:rPr sz="1425" b="0" i="0">
-                <a:solidFill>
-                  <a:srgbClr val="D5D8DA"/>
-                </a:solidFill>
-              </a:rPr>
-              <a:t>Independent project platform</a:t>
             </a:r>
           </a:p>
         </p:txBody>

</xml_diff>

<commit_message>
Refine engineering talk and event-ready presentation
</commit_message>
<xml_diff>
--- a/docs/presentation/Engineering_at_The_Kinetic_Group.pptx
+++ b/docs/presentation/Engineering_at_The_Kinetic_Group.pptx
@@ -2,38 +2,39 @@
 <file path=ppt/presentation.xml><?xml version="1.0" encoding="utf-8"?>
 <p:presentation xmlns:p="http://schemas.openxmlformats.org/presentationml/2006/main" embedTrueTypeFonts="1" saveSubsetFonts="1">
   <p:sldMasterIdLst>
-    <p:sldMasterId xmlns:r="http://schemas.openxmlformats.org/officeDocument/2006/relationships" id="2147483648" r:id="Rab91db12fd854668"/>
+    <p:sldMasterId xmlns:r="http://schemas.openxmlformats.org/officeDocument/2006/relationships" id="2147483648" r:id="R39d90483318c42db"/>
   </p:sldMasterIdLst>
   <p:notesMasterIdLst>
-    <p:notesMasterId xmlns:r="http://schemas.openxmlformats.org/officeDocument/2006/relationships" r:id="Rff7bd0f913c94223"/>
+    <p:notesMasterId xmlns:r="http://schemas.openxmlformats.org/officeDocument/2006/relationships" r:id="R31cb777d4765470f"/>
   </p:notesMasterIdLst>
   <p:sldIdLst>
-    <p:sldId xmlns:r="http://schemas.openxmlformats.org/officeDocument/2006/relationships" id="256" r:id="R8b64e0487ef84c3d"/>
-    <p:sldId xmlns:r="http://schemas.openxmlformats.org/officeDocument/2006/relationships" id="257" r:id="Rc20cc4902f214c4b"/>
-    <p:sldId xmlns:r="http://schemas.openxmlformats.org/officeDocument/2006/relationships" id="258" r:id="R3bc0911fdf5546b4"/>
-    <p:sldId xmlns:r="http://schemas.openxmlformats.org/officeDocument/2006/relationships" id="259" r:id="R426f273bf66045ed"/>
-    <p:sldId xmlns:r="http://schemas.openxmlformats.org/officeDocument/2006/relationships" id="260" r:id="Rd82fe9b0a1344211"/>
-    <p:sldId xmlns:r="http://schemas.openxmlformats.org/officeDocument/2006/relationships" id="261" r:id="R479fa96aacbf4db4"/>
-    <p:sldId xmlns:r="http://schemas.openxmlformats.org/officeDocument/2006/relationships" id="262" r:id="R1d5aea35cfb3417e"/>
-    <p:sldId xmlns:r="http://schemas.openxmlformats.org/officeDocument/2006/relationships" id="263" r:id="R5b47b6cd9fef4bb8"/>
-    <p:sldId xmlns:r="http://schemas.openxmlformats.org/officeDocument/2006/relationships" id="264" r:id="R61b11b502e0541da"/>
-    <p:sldId xmlns:r="http://schemas.openxmlformats.org/officeDocument/2006/relationships" id="265" r:id="R2dc71b158d624412"/>
-    <p:sldId xmlns:r="http://schemas.openxmlformats.org/officeDocument/2006/relationships" id="266" r:id="Rd57aec5258cd44ab"/>
-    <p:sldId xmlns:r="http://schemas.openxmlformats.org/officeDocument/2006/relationships" id="267" r:id="Rf72cb0ac2594476f"/>
-    <p:sldId xmlns:r="http://schemas.openxmlformats.org/officeDocument/2006/relationships" id="268" r:id="R873f3c85cb164df9"/>
-    <p:sldId xmlns:r="http://schemas.openxmlformats.org/officeDocument/2006/relationships" id="269" r:id="R7f7db8f3d1cd48e9"/>
-    <p:sldId xmlns:r="http://schemas.openxmlformats.org/officeDocument/2006/relationships" id="270" r:id="R4d6a4f67563b4904"/>
-    <p:sldId xmlns:r="http://schemas.openxmlformats.org/officeDocument/2006/relationships" id="271" r:id="R2e7d4f22a6d84934"/>
+    <p:sldId xmlns:r="http://schemas.openxmlformats.org/officeDocument/2006/relationships" id="256" r:id="R9a70a15f79814586"/>
+    <p:sldId xmlns:r="http://schemas.openxmlformats.org/officeDocument/2006/relationships" id="257" r:id="R0fe56bb8b7f540ab"/>
+    <p:sldId xmlns:r="http://schemas.openxmlformats.org/officeDocument/2006/relationships" id="258" r:id="Ra9a2213aca20468f"/>
+    <p:sldId xmlns:r="http://schemas.openxmlformats.org/officeDocument/2006/relationships" id="259" r:id="Rc4254491657446f0"/>
+    <p:sldId xmlns:r="http://schemas.openxmlformats.org/officeDocument/2006/relationships" id="260" r:id="Rafb06faae5af4ffc"/>
+    <p:sldId xmlns:r="http://schemas.openxmlformats.org/officeDocument/2006/relationships" id="261" r:id="Rf2d5bbce80ed4581"/>
+    <p:sldId xmlns:r="http://schemas.openxmlformats.org/officeDocument/2006/relationships" id="262" r:id="R4451d23375fe4168"/>
+    <p:sldId xmlns:r="http://schemas.openxmlformats.org/officeDocument/2006/relationships" id="263" r:id="R114ef8414c0a4880"/>
+    <p:sldId xmlns:r="http://schemas.openxmlformats.org/officeDocument/2006/relationships" id="264" r:id="R554cb95b30f54975"/>
+    <p:sldId xmlns:r="http://schemas.openxmlformats.org/officeDocument/2006/relationships" id="265" r:id="Rb9588b635a32486f"/>
+    <p:sldId xmlns:r="http://schemas.openxmlformats.org/officeDocument/2006/relationships" id="266" r:id="R34d7462ebe554960"/>
+    <p:sldId xmlns:r="http://schemas.openxmlformats.org/officeDocument/2006/relationships" id="267" r:id="Ra95796cf23fc4de1"/>
+    <p:sldId xmlns:r="http://schemas.openxmlformats.org/officeDocument/2006/relationships" id="268" r:id="R49f019004b7f4dca"/>
+    <p:sldId xmlns:r="http://schemas.openxmlformats.org/officeDocument/2006/relationships" id="269" r:id="Rebb456c9b43142af"/>
+    <p:sldId xmlns:r="http://schemas.openxmlformats.org/officeDocument/2006/relationships" id="270" r:id="R0258f44c2015421b"/>
+    <p:sldId xmlns:r="http://schemas.openxmlformats.org/officeDocument/2006/relationships" id="271" r:id="Ra26a4f3e169947ab"/>
+    <p:sldId xmlns:r="http://schemas.openxmlformats.org/officeDocument/2006/relationships" id="272" r:id="R28b51150d6be414c"/>
   </p:sldIdLst>
   <p:sldSz cx="9144000" cy="6858000"/>
   <p:notesSz cx="6858000" cy="9144000"/>
   <p:embeddedFontLst>
     <p:embeddedFont>
       <p:font typeface="Libre Franklin"/>
-      <p:regular xmlns:r="http://schemas.openxmlformats.org/officeDocument/2006/relationships" r:id="R6c4b9d5eb60e4c03"/>
-      <p:bold xmlns:r="http://schemas.openxmlformats.org/officeDocument/2006/relationships" r:id="R59c7b299b13a4847"/>
-      <p:italic xmlns:r="http://schemas.openxmlformats.org/officeDocument/2006/relationships" r:id="R1d1d3a81773645e3"/>
-      <p:boldItalic xmlns:r="http://schemas.openxmlformats.org/officeDocument/2006/relationships" r:id="R22a9ecb7de474e52"/>
+      <p:regular xmlns:r="http://schemas.openxmlformats.org/officeDocument/2006/relationships" r:id="R154d929df511407e"/>
+      <p:bold xmlns:r="http://schemas.openxmlformats.org/officeDocument/2006/relationships" r:id="R06085ea0d63e4b9f"/>
+      <p:italic xmlns:r="http://schemas.openxmlformats.org/officeDocument/2006/relationships" r:id="R6fcf90a927204795"/>
+      <p:boldItalic xmlns:r="http://schemas.openxmlformats.org/officeDocument/2006/relationships" r:id="Rbe1fdcf83aab49a1"/>
     </p:embeddedFont>
   </p:embeddedFontLst>
   <p:defaultTextStyle>
@@ -719,7 +720,7 @@
           <a:lstStyle xmlns:a="http://schemas.openxmlformats.org/drawingml/2006/main"/>
           <a:p xmlns:a="http://schemas.openxmlformats.org/drawingml/2006/main">
             <a:r>
-              <a:t>BRAD opens: introduce yourself and your small engineering teams across TKG, mainly at Remington in Lonoke. Introduce Wesley by name, then invite him to introduce himself. WESLEY introduces himself in his own words: his path, current work, and what drew him in. BRAD frames the talk: engineering that reaches the floor, a shared live demo, and an invitation to people who want to build the future.</a:t>
+              <a:t>Brad introduces himself as the leader of small engineering teams across TKG, mainly at Remington. Wesley introduces himself in his own words: one of the first software interns, early Remington Vision work, now an engineer. Brad frames the talk as engineering that reaches the floor.</a:t>
             </a:r>
           </a:p>
         </p:txBody>
@@ -789,7 +790,7 @@
           <a:lstStyle xmlns:a="http://schemas.openxmlformats.org/drawingml/2006/main"/>
           <a:p xmlns:a="http://schemas.openxmlformats.org/drawingml/2006/main">
             <a:r>
-              <a:t>WESLEY speaks in his own words. Optional anchors from his planned remarks: one of the first software interns; work with AI and different machines; variety; freedom to explore; ownership; unexpected opportunities. Choose one concrete public example of a problem, what you tried, and what you learned. Finish with why you love the work, then move with Brad to the demo.</a:t>
+              <a:t>Wesley or Brad: Remi is our local language-model work for engineering questions and tasks. The model is one piece; approved project knowledge, scoped tools, permissions, and verification make it useful. Tell a story about an engineer who has a question and needs a grounded answer or a draft they can inspect. Treat this as a developing capability, not a claim of organization-wide rollout or permission-complete access. Source: Remington Systems Lab showcase narration, Little Chef source guide, and Design DGX RAG Agent Architecture chat.</a:t>
             </a:r>
           </a:p>
         </p:txBody>
@@ -859,7 +860,7 @@
           <a:lstStyle xmlns:a="http://schemas.openxmlformats.org/drawingml/2006/main"/>
           <a:p xmlns:a="http://schemas.openxmlformats.org/drawingml/2006/main">
             <a:r>
-              <a:t>BRAD + WESLEY lead the live demonstration together. Brad introduces the camera-to-decision flow and shows the first Gatorade bottle. Wesley chooses the next bottle or feature and narrates what matters in his own words. Brad may ask the audience to predict the result and closes with sense, decide, act. The sorting decision is on screen; this setup does not control a production line.</a:t>
+              <a:t>Wesley: explain why we love the variety, freedom, ownership, and growth. Introduce your own intern-to-engineer path and choose one real moment. Brad hands off to the demo.</a:t>
             </a:r>
           </a:p>
         </p:txBody>
@@ -929,7 +930,7 @@
           <a:lstStyle xmlns:a="http://schemas.openxmlformats.org/drawingml/2006/main"/>
           <a:p xmlns:a="http://schemas.openxmlformats.org/drawingml/2006/main">
             <a:r>
-              <a:t>Wesley and Brad: The hard problems include variation and timing, but reliability includes the human side. A result must be understandable and useful to the operators and quality teams who rely on it. Return to the centerfire story: trust grows through real use, feedback, and refinement. Do not imply the demo itself is a production line.</a:t>
+              <a:t>Brad and Wesley: demonstrate on-screen sorting with Gatorade bottles. Show camera view, decision, and visible result; invite an audience prediction. This is a demonstration setup, separate from production inspection.</a:t>
             </a:r>
           </a:p>
         </p:txBody>
@@ -999,7 +1000,7 @@
           <a:lstStyle xmlns:a="http://schemas.openxmlformats.org/drawingml/2006/main"/>
           <a:p xmlns:a="http://schemas.openxmlformats.org/drawingml/2006/main">
             <a:r>
-              <a:t>BRAD: Invite talent across Remington and TKG. Mention mechanical engineering, controls, software, and testing as examples; curiosity and persistence matter too. Direct job applications to the official careers page. Ask students what they have built and want to try next.</a:t>
+              <a:t>Wesley and Brad: the floor changes, decisions have to arrive in time, and results have to earn trust. Return to the centerfire story and the human work of listening, showing evidence, and refining with users. Do not imply the demo itself is a production line.</a:t>
             </a:r>
           </a:p>
         </p:txBody>
@@ -1069,7 +1070,7 @@
           <a:lstStyle xmlns:a="http://schemas.openxmlformats.org/drawingml/2006/main"/>
           <a:p xmlns:a="http://schemas.openxmlformats.org/drawingml/2006/main">
             <a:r>
-              <a:t>BRAD: Run the separate 4Founders interactive challenge. Ask audience to scan QR or use the URL and event PIN, then draw, test, and change. Allow about three minutes. 4Founders is an independent project platform; company job applications go through TKG careers.</a:t>
+              <a:t>Brad: invite people across mechanical, controls, software, and testing disciplines to work on these challenges across Remington and TKG. Ask what they want to build next.</a:t>
             </a:r>
           </a:p>
         </p:txBody>
@@ -1139,7 +1140,7 @@
           <a:lstStyle xmlns:a="http://schemas.openxmlformats.org/drawingml/2006/main"/>
           <a:p xmlns:a="http://schemas.openxmlformats.org/drawingml/2006/main">
             <a:r>
-              <a:t>BRAD: Invite interests beyond the disciplines shown. Ask what students want to pursue. If a real fit emerges, explore a first step together; in the right situation the organization might become their first customer. This is a possibility, not a commitment.</a:t>
+              <a:t>Brad: invite the audience to scan the QR for the separate 4Founders activity, enter PIN 877262, and try it themselves. The QR resolves to https://4founders.dev/demo/ai-in-action/. Give the room a few minutes, then ask for one or two reactions.</a:t>
             </a:r>
           </a:p>
         </p:txBody>
@@ -1209,7 +1210,77 @@
           <a:lstStyle xmlns:a="http://schemas.openxmlformats.org/drawingml/2006/main"/>
           <a:p xmlns:a="http://schemas.openxmlformats.org/drawingml/2006/main">
             <a:r>
-              <a:t>BRAD: Point to the email on screen. Invite follow-up from people interested in joining a team, exploring an idea, or asking about the work. WESLEY: In your own words, invite engineering questions and ideas people are building. BRAD: Close with the on-screen line: “Our history was made on the factory floor. The future will be, too. Come build and fight with us. Turn AI into action.” Hold the slide for questions.</a:t>
+              <a:t>Brad: invite interests beyond the roles named. Ask students what they want to pursue. If there is a fit, explore an idea together. The first step is a conversation.</a:t>
+            </a:r>
+          </a:p>
+        </p:txBody>
+      </p:sp>
+      <p:sp>
+        <p:nvSpPr>
+          <p:cNvPr id="4" name="Slide Number Placeholder 3"/>
+          <p:cNvSpPr>
+            <a:spLocks xmlns:a="http://schemas.openxmlformats.org/drawingml/2006/main" noGrp="1"/>
+          </p:cNvSpPr>
+          <p:nvPr>
+            <p:ph type="sldNum" idx="5"/>
+          </p:nvPr>
+        </p:nvSpPr>
+        <p:spPr/>
+        <p:txBody>
+          <a:bodyPr xmlns:a="http://schemas.openxmlformats.org/drawingml/2006/main"/>
+          <a:lstStyle xmlns:a="http://schemas.openxmlformats.org/drawingml/2006/main"/>
+          <a:p xmlns:a="http://schemas.openxmlformats.org/drawingml/2006/main"/>
+        </p:txBody>
+      </p:sp>
+    </p:spTree>
+  </p:cSld>
+  <p:clrMapOvr>
+    <a:masterClrMapping xmlns:a="http://schemas.openxmlformats.org/drawingml/2006/main"/>
+  </p:clrMapOvr>
+</p:notes>
+</file>
+
+<file path=ppt/notesSlides/notesSlide17.xml><?xml version="1.0" encoding="utf-8"?>
+<p:notes xmlns:p="http://schemas.openxmlformats.org/presentationml/2006/main">
+  <p:cSld>
+    <p:spTree>
+      <p:nvGrpSpPr>
+        <p:cNvPr id="1" name=""/>
+        <p:cNvGrpSpPr/>
+        <p:nvPr/>
+      </p:nvGrpSpPr>
+      <p:grpSpPr>
+        <a:xfrm xmlns:a="http://schemas.openxmlformats.org/drawingml/2006/main"/>
+      </p:grpSpPr>
+      <p:sp>
+        <p:nvSpPr>
+          <p:cNvPr id="2" name="Slide Image Placeholder 1"/>
+          <p:cNvSpPr>
+            <a:spLocks xmlns:a="http://schemas.openxmlformats.org/drawingml/2006/main" noGrp="1"/>
+          </p:cNvSpPr>
+          <p:nvPr>
+            <p:ph type="sldImg" idx="0"/>
+          </p:nvPr>
+        </p:nvSpPr>
+        <p:spPr/>
+      </p:sp>
+      <p:sp>
+        <p:nvSpPr>
+          <p:cNvPr id="3" name="Notes Placeholder 2"/>
+          <p:cNvSpPr>
+            <a:spLocks xmlns:a="http://schemas.openxmlformats.org/drawingml/2006/main" noGrp="1"/>
+          </p:cNvSpPr>
+          <p:nvPr>
+            <p:ph type="body" idx="1"/>
+          </p:nvPr>
+        </p:nvSpPr>
+        <p:spPr/>
+        <p:txBody>
+          <a:bodyPr xmlns:a="http://schemas.openxmlformats.org/drawingml/2006/main"/>
+          <a:lstStyle xmlns:a="http://schemas.openxmlformats.org/drawingml/2006/main"/>
+          <a:p xmlns:a="http://schemas.openxmlformats.org/drawingml/2006/main">
+            <a:r>
+              <a:t>Brad: invite follow-up at awhite@tkghunt.com. Wesley can invite engineering questions. Close: Our history was made on the factory floor. The future will be, too. Come build and fight with us. Turn AI into action.</a:t>
             </a:r>
           </a:p>
         </p:txBody>
@@ -1279,7 +1350,7 @@
           <a:lstStyle xmlns:a="http://schemas.openxmlformats.org/drawingml/2006/main"/>
           <a:p xmlns:a="http://schemas.openxmlformats.org/drawingml/2006/main">
             <a:r>
-              <a:t>BRAD: Honor Remington’s history and Lonoke’s place in it. The world of manufacturing has changed. State the ambition clearly: Remington and The Kinetic Group intend to write the rules for the future of manufacturing for decades to come by building capabilities that work on the floor.</a:t>
+              <a:t>Brad: Remington began in 1816; Lonoke operations began in 1969. Remington is one of TKG five ammunition brands, alongside Federal, CCI, Speer, and HEVI-Shot. The company has a deep manufacturing legacy. Our ambition is for Remington and TKG to keep writing the rules for decades to come. Sources: https://www.remington.com/about-us.html and https://www.thekineticgroup.com/</a:t>
             </a:r>
           </a:p>
         </p:txBody>
@@ -1489,7 +1560,7 @@
           <a:lstStyle xmlns:a="http://schemas.openxmlformats.org/drawingml/2006/main"/>
           <a:p xmlns:a="http://schemas.openxmlformats.org/drawingml/2006/main">
             <a:r>
-              <a:t>Brad: Start with an operator or engineer asking: what is happening on the line right now, and what happened earlier? RemSCADA turns machine signals into a consistent, time-stamped history that people can use to see conditions and investigate changes. The hard work is trustworthy collection and interpretation, not a fancy dashboard. This is live and being refined. Call it supervisory information, not a safety controller or guaranteed real-time machine control. Source: Remington Systems Lab showcase narration, RemSCADAv6 source guide; Brad confirmed production use on October 22, 2026.</a:t>
+              <a:t>Brad: Remington is the proving ground for much of our work. SCADA and the two vision inspection systems are live in production. Public Sentiment and Remi tackle different questions beyond the floor. We are small engineering teams working across TKG, with the same standard: each system must help someone make a better decision. Do not suggest sentiment or Remi is inline production control.</a:t>
             </a:r>
           </a:p>
         </p:txBody>
@@ -1559,7 +1630,7 @@
           <a:lstStyle xmlns:a="http://schemas.openxmlformats.org/drawingml/2006/main"/>
           <a:p xmlns:a="http://schemas.openxmlformats.org/drawingml/2006/main">
             <a:r>
-              <a:t>Brad: Centerfire inspection is live in the production flow. A camera captures the view, the vision system evaluates it, and the result reaches the people and equipment that rely on it. The hardest deployment challenge is often human: people need to understand the result, see how it behaves in their work, and have a path to raise concerns. Trust is earned through real use, listening, and refinement. Wesley: add your own experience of working with floor teams, without sharing defect criteria, thresholds, line identifiers, or machine settings. Source: RemVision video narration and source guide; Brad confirmed live centerfire inspection and the trust theme October 22, 2026.</a:t>
+              <a:t>Brad: Start with an operator or engineer asking: what is happening on the line right now, and what happened earlier? RemSCADA turns machine signals into a consistent, time-stamped history that people can use to see conditions and investigate changes. The hard work is trustworthy collection and interpretation, not a fancy dashboard. This is live and being refined. Call it supervisory information, not a safety controller or guaranteed real-time machine control. Source: Remington Systems Lab showcase narration, RemSCADAv6 source guide; Brad confirmed production use on October 22, 2026.</a:t>
             </a:r>
           </a:p>
         </p:txBody>
@@ -1629,7 +1700,7 @@
           <a:lstStyle xmlns:a="http://schemas.openxmlformats.org/drawingml/2006/main"/>
           <a:p xmlns:a="http://schemas.openxmlformats.org/drawingml/2006/main">
             <a:r>
-              <a:t>Wesley or Brad: Another product creates a different visual inspection problem. The engineering pattern stays familiar: capture a useful image, decide from evidence, and return a result in time for the production workflow. This system is live and being polished. Tell one concrete, public-safe story about adapting the system to shotshells, preferably a moment when an early assumption did not survive the floor. Avoid specific defect taxonomy, model thresholds, line rates, or control details. Source: RemVision video narration and source guide; Brad confirmed live shotshell inspection October 22, 2026.</a:t>
+              <a:t>Brad: Centerfire inspection is live in the production flow. A camera captures the view, the vision system evaluates it, and the result reaches the people and equipment that rely on it. The hardest deployment challenge is often human: people need to understand the result, see how it behaves in their work, and have a path to raise concerns. Trust is earned through real use, listening, and refinement. Wesley: add your own experience of working with floor teams, without sharing defect criteria, thresholds, line identifiers, or machine settings. Source: RemVision video narration and source guide; Brad confirmed live centerfire inspection and the trust theme October 22, 2026.</a:t>
             </a:r>
           </a:p>
         </p:txBody>
@@ -1699,7 +1770,7 @@
           <a:lstStyle xmlns:a="http://schemas.openxmlformats.org/drawingml/2006/main"/>
           <a:p xmlns:a="http://schemas.openxmlformats.org/drawingml/2006/main">
             <a:r>
-              <a:t>Brad: Move beyond the factory. Remington and TKG also need to understand what people are saying about their products and brands. Our sentiment project turns collected public discussion into themes and directional signals, while keeping a path to the original sources. A useful story is how a cluster of comments can lead someone to read the actual posts rather than trust a single score. Do not call it a complete view of the market or an inline floor system. Source: Remington Systems Lab showcase narration and Public Sentiment source guide.</a:t>
+              <a:t>Wesley or Brad: Another product creates a different visual inspection problem. The engineering pattern stays familiar: capture a useful image, decide from evidence, and return a result in time for the production workflow. This system is live and being polished. Tell one concrete, public-safe story about adapting the system to shotshells, preferably a moment when an early assumption did not survive the floor. Avoid specific defect taxonomy, model thresholds, line rates, or control details. Source: RemVision video narration and source guide; Brad confirmed live shotshell inspection October 22, 2026.</a:t>
             </a:r>
           </a:p>
         </p:txBody>
@@ -1769,7 +1840,7 @@
           <a:lstStyle xmlns:a="http://schemas.openxmlformats.org/drawingml/2006/main"/>
           <a:p xmlns:a="http://schemas.openxmlformats.org/drawingml/2006/main">
             <a:r>
-              <a:t>Wesley or Brad: Remi is our local language-model work for engineering questions and tasks. The model is one piece; approved project knowledge, scoped tools, permissions, and verification make it useful. Tell a story about an engineer who has a question and needs a grounded answer or a draft they can inspect. Treat this as a developing capability, not a claim of organization-wide rollout or permission-complete access. Source: Remington Systems Lab showcase narration, Little Chef source guide, and Design DGX RAG Agent Architecture chat.</a:t>
+              <a:t>Brad: Move beyond the factory. Remington and TKG also need to understand what people are saying about their products and brands. Our sentiment project turns collected public discussion into themes and directional signals, while keeping a path to the original sources. A useful story is how a cluster of comments can lead someone to read the actual posts rather than trust a single score. Do not call it a complete view of the market or an inline floor system. Source: Remington Systems Lab showcase narration and Public Sentiment source guide.</a:t>
             </a:r>
           </a:p>
         </p:txBody>
@@ -1823,7 +1894,7 @@
           <p:cNvPr id="11" name="Google Shape;11;p14">
             <a:extLst xmlns:a="http://schemas.openxmlformats.org/drawingml/2006/main">
               <a:ext uri="{FF2B5EF4-FFF2-40B4-BE49-F238E27FC236}">
-                <a16:creationId xmlns:a16="http://schemas.microsoft.com/office/drawing/2014/main" id="{3820953D-6025-4502-81A5-DD3440D09939}"/>
+                <a16:creationId xmlns:a16="http://schemas.microsoft.com/office/drawing/2014/main" id="{13F16D52-984E-4CA3-9DB0-8536EC0FC8BF}"/>
               </a:ext>
             </a:extLst>
           </p:cNvPr>
@@ -1833,7 +1904,7 @@
           <p:nvPr/>
         </p:nvPicPr>
         <p:blipFill rotWithShape="1">
-          <a:blip xmlns:r="http://schemas.openxmlformats.org/officeDocument/2006/relationships" xmlns:a="http://schemas.openxmlformats.org/drawingml/2006/main" r:embed="Rd92d413e946d4cd0">
+          <a:blip xmlns:r="http://schemas.openxmlformats.org/officeDocument/2006/relationships" xmlns:a="http://schemas.openxmlformats.org/drawingml/2006/main" r:embed="Reb7bde4383044cab">
             <a:alphaModFix/>
           </a:blip>
           <a:srcRect xmlns:a="http://schemas.openxmlformats.org/drawingml/2006/main" l="0" t="13495" r="9091" b="0"/>
@@ -1857,7 +1928,7 @@
           <p:cNvPr id="12" name="Google Shape;12;p14">
             <a:extLst xmlns:a="http://schemas.openxmlformats.org/drawingml/2006/main">
               <a:ext uri="{FF2B5EF4-FFF2-40B4-BE49-F238E27FC236}">
-                <a16:creationId xmlns:a16="http://schemas.microsoft.com/office/drawing/2014/main" id="{F8843342-33E1-4D86-93BC-730BFB28E5CE}"/>
+                <a16:creationId xmlns:a16="http://schemas.microsoft.com/office/drawing/2014/main" id="{5731DF57-DA0C-49D4-9BA6-A90410253A0F}"/>
               </a:ext>
             </a:extLst>
           </p:cNvPr>
@@ -1867,7 +1938,7 @@
           <p:nvPr/>
         </p:nvPicPr>
         <p:blipFill rotWithShape="1">
-          <a:blip xmlns:r="http://schemas.openxmlformats.org/officeDocument/2006/relationships" xmlns:a="http://schemas.openxmlformats.org/drawingml/2006/main" r:embed="R6366b8ee08364845">
+          <a:blip xmlns:r="http://schemas.openxmlformats.org/officeDocument/2006/relationships" xmlns:a="http://schemas.openxmlformats.org/drawingml/2006/main" r:embed="R13375b3c712b450a">
             <a:alphaModFix/>
           </a:blip>
           <a:srcRect xmlns:a="http://schemas.openxmlformats.org/drawingml/2006/main" l="159" t="0" r="169" b="0"/>
@@ -2085,7 +2156,7 @@
           <p:cNvPr id="15" name="Google Shape;15;p13">
             <a:extLst xmlns:a="http://schemas.openxmlformats.org/drawingml/2006/main">
               <a:ext uri="{FF2B5EF4-FFF2-40B4-BE49-F238E27FC236}">
-                <a16:creationId xmlns:a16="http://schemas.microsoft.com/office/drawing/2014/main" id="{D636856E-E78F-433A-913B-7445D2C46382}"/>
+                <a16:creationId xmlns:a16="http://schemas.microsoft.com/office/drawing/2014/main" id="{53D45A99-FDB1-426D-9DBB-58A8D1FEC54F}"/>
               </a:ext>
             </a:extLst>
           </p:cNvPr>
@@ -2095,7 +2166,7 @@
           <p:nvPr/>
         </p:nvPicPr>
         <p:blipFill rotWithShape="1">
-          <a:blip xmlns:r="http://schemas.openxmlformats.org/officeDocument/2006/relationships" xmlns:a="http://schemas.openxmlformats.org/drawingml/2006/main" r:embed="Rcbf46b3f6d934b73">
+          <a:blip xmlns:r="http://schemas.openxmlformats.org/officeDocument/2006/relationships" xmlns:a="http://schemas.openxmlformats.org/drawingml/2006/main" r:embed="R14722f1354384ff5">
             <a:alphaModFix/>
           </a:blip>
           <a:srcRect xmlns:a="http://schemas.openxmlformats.org/drawingml/2006/main" l="0" t="13495" r="9091" b="0"/>
@@ -2119,7 +2190,7 @@
           <p:cNvPr id="16" name="Google Shape;16;p13">
             <a:extLst xmlns:a="http://schemas.openxmlformats.org/drawingml/2006/main">
               <a:ext uri="{FF2B5EF4-FFF2-40B4-BE49-F238E27FC236}">
-                <a16:creationId xmlns:a16="http://schemas.microsoft.com/office/drawing/2014/main" id="{A5AC7042-0FDC-4FA4-97D1-AB4C2C800A56}"/>
+                <a16:creationId xmlns:a16="http://schemas.microsoft.com/office/drawing/2014/main" id="{6307ABD0-B62C-4D71-AC6F-174AD59C3284}"/>
               </a:ext>
             </a:extLst>
           </p:cNvPr>
@@ -2129,7 +2200,7 @@
           <p:nvPr/>
         </p:nvPicPr>
         <p:blipFill rotWithShape="1">
-          <a:blip xmlns:r="http://schemas.openxmlformats.org/officeDocument/2006/relationships" xmlns:a="http://schemas.openxmlformats.org/drawingml/2006/main" r:embed="R703cdda5bb454eea">
+          <a:blip xmlns:r="http://schemas.openxmlformats.org/officeDocument/2006/relationships" xmlns:a="http://schemas.openxmlformats.org/drawingml/2006/main" r:embed="Rea9760121d474cf6">
             <a:alphaModFix/>
           </a:blip>
           <a:srcRect xmlns:a="http://schemas.openxmlformats.org/drawingml/2006/main" l="159" t="0" r="169" b="0"/>
@@ -2780,7 +2851,7 @@
     <p:bg>
       <p:bgPr>
         <a:blipFill xmlns:a="http://schemas.openxmlformats.org/drawingml/2006/main">
-          <a:blip xmlns:r="http://schemas.openxmlformats.org/officeDocument/2006/relationships" r:embed="Ra279ad52dccb400d">
+          <a:blip xmlns:r="http://schemas.openxmlformats.org/officeDocument/2006/relationships" r:embed="Rccde23de2666420b">
             <a:alphaModFix/>
           </a:blip>
           <a:stretch>
@@ -2803,7 +2874,7 @@
           <p:cNvPr id="21" name="Google Shape;21;p18">
             <a:extLst xmlns:a="http://schemas.openxmlformats.org/drawingml/2006/main">
               <a:ext uri="{FF2B5EF4-FFF2-40B4-BE49-F238E27FC236}">
-                <a16:creationId xmlns:a16="http://schemas.microsoft.com/office/drawing/2014/main" id="{CDB0A5A2-2302-4F62-BF4B-32370E8A463C}"/>
+                <a16:creationId xmlns:a16="http://schemas.microsoft.com/office/drawing/2014/main" id="{74791A5E-3E8B-4C09-B818-DBB70D3FA231}"/>
               </a:ext>
             </a:extLst>
           </p:cNvPr>
@@ -3494,7 +3565,7 @@
     <p:bg>
       <p:bgPr>
         <a:blipFill xmlns:a="http://schemas.openxmlformats.org/drawingml/2006/main">
-          <a:blip xmlns:r="http://schemas.openxmlformats.org/officeDocument/2006/relationships" r:embed="R1262025a8d504834">
+          <a:blip xmlns:r="http://schemas.openxmlformats.org/officeDocument/2006/relationships" r:embed="R92961b587b194794">
             <a:alphaModFix/>
           </a:blip>
           <a:stretch>
@@ -3647,7 +3718,7 @@
     <p:bg>
       <p:bgPr>
         <a:blipFill xmlns:a="http://schemas.openxmlformats.org/drawingml/2006/main">
-          <a:blip xmlns:r="http://schemas.openxmlformats.org/officeDocument/2006/relationships" r:embed="Re93a10b338134053">
+          <a:blip xmlns:r="http://schemas.openxmlformats.org/officeDocument/2006/relationships" r:embed="R28162c10bc2840a2">
             <a:alphaModFix/>
           </a:blip>
           <a:stretch>
@@ -3863,11 +3934,11 @@
   </p:cSld>
   <p:clrMap bg1="lt1" tx1="dk1" bg2="dk2" tx2="lt2" accent1="accent1" accent2="accent2" accent3="accent3" accent4="accent4" accent5="accent5" accent6="accent6" hlink="hlink" folHlink="folHlink"/>
   <p:sldLayoutIdLst>
-    <p:sldLayoutId xmlns:r="http://schemas.openxmlformats.org/officeDocument/2006/relationships" id="2147483649" r:id="R95759e68c9a24775"/>
-    <p:sldLayoutId xmlns:r="http://schemas.openxmlformats.org/officeDocument/2006/relationships" id="2147483650" r:id="Rd17f149b9bd4457c"/>
-    <p:sldLayoutId xmlns:r="http://schemas.openxmlformats.org/officeDocument/2006/relationships" id="2147483651" r:id="R38c6b08a2ec642eb"/>
-    <p:sldLayoutId xmlns:r="http://schemas.openxmlformats.org/officeDocument/2006/relationships" id="2147483652" r:id="Re42838aa75894d73"/>
-    <p:sldLayoutId xmlns:r="http://schemas.openxmlformats.org/officeDocument/2006/relationships" id="2147483653" r:id="Rae6ee4cc66cc4a8e"/>
+    <p:sldLayoutId xmlns:r="http://schemas.openxmlformats.org/officeDocument/2006/relationships" id="2147483649" r:id="R9b3f26b4108440e4"/>
+    <p:sldLayoutId xmlns:r="http://schemas.openxmlformats.org/officeDocument/2006/relationships" id="2147483650" r:id="R217fa8e0d4d6454b"/>
+    <p:sldLayoutId xmlns:r="http://schemas.openxmlformats.org/officeDocument/2006/relationships" id="2147483651" r:id="Rb5117dd4bfc347ce"/>
+    <p:sldLayoutId xmlns:r="http://schemas.openxmlformats.org/officeDocument/2006/relationships" id="2147483652" r:id="R45db141282be46ff"/>
+    <p:sldLayoutId xmlns:r="http://schemas.openxmlformats.org/officeDocument/2006/relationships" id="2147483653" r:id="R55ba73ee301b4c28"/>
   </p:sldLayoutIdLst>
   <p:hf hdr="0" ftr="0" dt="0"/>
   <p:txStyles>
@@ -5375,6 +5446,650 @@
       </p:grpSpPr>
       <p:sp>
         <p:nvSpPr>
+          <p:cNvPr id="6" name="">
+            <a:extLst xmlns:a="http://schemas.openxmlformats.org/drawingml/2006/main">
+              <a:ext uri="{FF2B5EF4-FFF2-40B4-BE49-F238E27FC236}">
+                <a16:creationId xmlns:a16="http://schemas.microsoft.com/office/drawing/2014/main" id="{9B1156EA-8987-49A4-8E46-F402BF5C6DF7}"/>
+              </a:ext>
+            </a:extLst>
+          </p:cNvPr>
+          <p:cNvSpPr>
+            <a:spLocks xmlns:a="http://schemas.openxmlformats.org/drawingml/2006/main" noGrp="1"/>
+          </p:cNvSpPr>
+          <p:nvPr/>
+        </p:nvSpPr>
+        <p:spPr>
+          <a:xfrm xmlns:a="http://schemas.openxmlformats.org/drawingml/2006/main">
+            <a:off x="704850" y="1495425"/>
+            <a:ext cx="7743825" cy="619125"/>
+          </a:xfrm>
+          <a:prstGeom xmlns:a="http://schemas.openxmlformats.org/drawingml/2006/main" prst="rect">
+            <a:avLst/>
+          </a:prstGeom>
+          <a:noFill xmlns:a="http://schemas.openxmlformats.org/drawingml/2006/main"/>
+          <a:ln xmlns:a="http://schemas.openxmlformats.org/drawingml/2006/main" w="0">
+            <a:noFill/>
+            <a:prstDash val="solid"/>
+          </a:ln>
+        </p:spPr>
+        <p:txBody>
+          <a:bodyPr xmlns:a="http://schemas.openxmlformats.org/drawingml/2006/main" lIns="0" tIns="0" rIns="0" bIns="0"/>
+          <a:lstStyle xmlns:a="http://schemas.openxmlformats.org/drawingml/2006/main">
+            <a:defPPr algn="l">
+              <a:defRPr sz="3000" b="0" i="0">
+                <a:solidFill>
+                  <a:srgbClr val="FFFFFF"/>
+                </a:solidFill>
+              </a:defRPr>
+            </a:defPPr>
+            <a:lvl1pPr algn="l">
+              <a:defRPr sz="3000" b="0" i="0">
+                <a:solidFill>
+                  <a:srgbClr val="FFFFFF"/>
+                </a:solidFill>
+              </a:defRPr>
+            </a:lvl1pPr>
+            <a:lvl2pPr algn="l">
+              <a:defRPr sz="3000" b="0" i="0">
+                <a:solidFill>
+                  <a:srgbClr val="FFFFFF"/>
+                </a:solidFill>
+              </a:defRPr>
+            </a:lvl2pPr>
+            <a:lvl3pPr algn="l">
+              <a:defRPr sz="3000" b="0" i="0">
+                <a:solidFill>
+                  <a:srgbClr val="FFFFFF"/>
+                </a:solidFill>
+              </a:defRPr>
+            </a:lvl3pPr>
+            <a:lvl4pPr algn="l">
+              <a:defRPr sz="3000" b="0" i="0">
+                <a:solidFill>
+                  <a:srgbClr val="FFFFFF"/>
+                </a:solidFill>
+              </a:defRPr>
+            </a:lvl4pPr>
+            <a:lvl5pPr algn="l">
+              <a:defRPr sz="3000" b="0" i="0">
+                <a:solidFill>
+                  <a:srgbClr val="FFFFFF"/>
+                </a:solidFill>
+              </a:defRPr>
+            </a:lvl5pPr>
+            <a:lvl6pPr algn="l">
+              <a:defRPr sz="3000" b="0" i="0">
+                <a:solidFill>
+                  <a:srgbClr val="FFFFFF"/>
+                </a:solidFill>
+              </a:defRPr>
+            </a:lvl6pPr>
+            <a:lvl7pPr algn="l">
+              <a:defRPr sz="3000" b="0" i="0">
+                <a:solidFill>
+                  <a:srgbClr val="FFFFFF"/>
+                </a:solidFill>
+              </a:defRPr>
+            </a:lvl7pPr>
+            <a:lvl8pPr algn="l">
+              <a:defRPr sz="3000" b="0" i="0">
+                <a:solidFill>
+                  <a:srgbClr val="FFFFFF"/>
+                </a:solidFill>
+              </a:defRPr>
+            </a:lvl8pPr>
+            <a:lvl9pPr algn="l">
+              <a:defRPr sz="3000" b="0" i="0">
+                <a:solidFill>
+                  <a:srgbClr val="FFFFFF"/>
+                </a:solidFill>
+              </a:defRPr>
+            </a:lvl9pPr>
+          </a:lstStyle>
+          <a:p xmlns:a="http://schemas.openxmlformats.org/drawingml/2006/main">
+            <a:pPr algn="l">
+              <a:defRPr sz="3000" b="0" i="0">
+                <a:solidFill>
+                  <a:srgbClr val="FFFFFF"/>
+                </a:solidFill>
+              </a:defRPr>
+            </a:pPr>
+            <a:r>
+              <a:rPr sz="3000" b="0" i="0">
+                <a:solidFill>
+                  <a:srgbClr val="FFFFFF"/>
+                </a:solidFill>
+              </a:rPr>
+              <a:t>Remi</a:t>
+            </a:r>
+          </a:p>
+        </p:txBody>
+      </p:sp>
+      <p:sp>
+        <p:nvSpPr>
+          <p:cNvPr id="2" name="">
+            <a:extLst xmlns:a="http://schemas.openxmlformats.org/drawingml/2006/main">
+              <a:ext uri="{FF2B5EF4-FFF2-40B4-BE49-F238E27FC236}">
+                <a16:creationId xmlns:a16="http://schemas.microsoft.com/office/drawing/2014/main" id="{86696325-598A-4F15-8C00-2733D0A384FD}"/>
+              </a:ext>
+            </a:extLst>
+          </p:cNvPr>
+          <p:cNvSpPr>
+            <a:spLocks xmlns:a="http://schemas.openxmlformats.org/drawingml/2006/main" noGrp="1"/>
+          </p:cNvSpPr>
+          <p:nvPr/>
+        </p:nvSpPr>
+        <p:spPr>
+          <a:xfrm xmlns:a="http://schemas.openxmlformats.org/drawingml/2006/main">
+            <a:off x="723900" y="2676525"/>
+            <a:ext cx="7734300" cy="1257300"/>
+          </a:xfrm>
+          <a:prstGeom xmlns:a="http://schemas.openxmlformats.org/drawingml/2006/main" prst="rect">
+            <a:avLst/>
+          </a:prstGeom>
+          <a:noFill xmlns:a="http://schemas.openxmlformats.org/drawingml/2006/main"/>
+          <a:ln xmlns:a="http://schemas.openxmlformats.org/drawingml/2006/main" w="0">
+            <a:noFill/>
+            <a:prstDash val="solid"/>
+          </a:ln>
+        </p:spPr>
+        <p:txBody>
+          <a:bodyPr xmlns:a="http://schemas.openxmlformats.org/drawingml/2006/main" lIns="0" tIns="0" rIns="0" bIns="0"/>
+          <a:lstStyle xmlns:a="http://schemas.openxmlformats.org/drawingml/2006/main">
+            <a:defPPr algn="l">
+              <a:defRPr sz="3075" b="1" i="0">
+                <a:solidFill>
+                  <a:srgbClr val="FFFFFF"/>
+                </a:solidFill>
+              </a:defRPr>
+            </a:defPPr>
+            <a:lvl1pPr algn="l">
+              <a:defRPr sz="3075" b="1" i="0">
+                <a:solidFill>
+                  <a:srgbClr val="FFFFFF"/>
+                </a:solidFill>
+              </a:defRPr>
+            </a:lvl1pPr>
+            <a:lvl2pPr algn="l">
+              <a:defRPr sz="3075" b="1" i="0">
+                <a:solidFill>
+                  <a:srgbClr val="FFFFFF"/>
+                </a:solidFill>
+              </a:defRPr>
+            </a:lvl2pPr>
+            <a:lvl3pPr algn="l">
+              <a:defRPr sz="3075" b="1" i="0">
+                <a:solidFill>
+                  <a:srgbClr val="FFFFFF"/>
+                </a:solidFill>
+              </a:defRPr>
+            </a:lvl3pPr>
+            <a:lvl4pPr algn="l">
+              <a:defRPr sz="3075" b="1" i="0">
+                <a:solidFill>
+                  <a:srgbClr val="FFFFFF"/>
+                </a:solidFill>
+              </a:defRPr>
+            </a:lvl4pPr>
+            <a:lvl5pPr algn="l">
+              <a:defRPr sz="3075" b="1" i="0">
+                <a:solidFill>
+                  <a:srgbClr val="FFFFFF"/>
+                </a:solidFill>
+              </a:defRPr>
+            </a:lvl5pPr>
+            <a:lvl6pPr algn="l">
+              <a:defRPr sz="3075" b="1" i="0">
+                <a:solidFill>
+                  <a:srgbClr val="FFFFFF"/>
+                </a:solidFill>
+              </a:defRPr>
+            </a:lvl6pPr>
+            <a:lvl7pPr algn="l">
+              <a:defRPr sz="3075" b="1" i="0">
+                <a:solidFill>
+                  <a:srgbClr val="FFFFFF"/>
+                </a:solidFill>
+              </a:defRPr>
+            </a:lvl7pPr>
+            <a:lvl8pPr algn="l">
+              <a:defRPr sz="3075" b="1" i="0">
+                <a:solidFill>
+                  <a:srgbClr val="FFFFFF"/>
+                </a:solidFill>
+              </a:defRPr>
+            </a:lvl8pPr>
+            <a:lvl9pPr algn="l">
+              <a:defRPr sz="3075" b="1" i="0">
+                <a:solidFill>
+                  <a:srgbClr val="FFFFFF"/>
+                </a:solidFill>
+              </a:defRPr>
+            </a:lvl9pPr>
+          </a:lstStyle>
+          <a:p xmlns:a="http://schemas.openxmlformats.org/drawingml/2006/main">
+            <a:pPr algn="l">
+              <a:defRPr sz="3075" b="1" i="0">
+                <a:solidFill>
+                  <a:srgbClr val="FFFFFF"/>
+                </a:solidFill>
+              </a:defRPr>
+            </a:pPr>
+            <a:r>
+              <a:rPr sz="3075" b="1" i="0">
+                <a:solidFill>
+                  <a:srgbClr val="FFFFFF"/>
+                </a:solidFill>
+              </a:rPr>
+              <a:t>Engineering knowledge,</a:t>
+            </a:r>
+          </a:p>
+          <a:p xmlns:a="http://schemas.openxmlformats.org/drawingml/2006/main">
+            <a:pPr algn="l">
+              <a:defRPr sz="3075" b="1" i="0">
+                <a:solidFill>
+                  <a:srgbClr val="FFFFFF"/>
+                </a:solidFill>
+              </a:defRPr>
+            </a:pPr>
+            <a:r>
+              <a:rPr sz="3075" b="1" i="0">
+                <a:solidFill>
+                  <a:srgbClr val="FFFFFF"/>
+                </a:solidFill>
+              </a:rPr>
+              <a:t>close to the work.</a:t>
+            </a:r>
+          </a:p>
+        </p:txBody>
+      </p:sp>
+      <p:sp>
+        <p:nvSpPr>
+          <p:cNvPr id="3" name="">
+            <a:extLst xmlns:a="http://schemas.openxmlformats.org/drawingml/2006/main">
+              <a:ext uri="{FF2B5EF4-FFF2-40B4-BE49-F238E27FC236}">
+                <a16:creationId xmlns:a16="http://schemas.microsoft.com/office/drawing/2014/main" id="{0318606F-670A-4B99-B01B-F0EEADE2C436}"/>
+              </a:ext>
+            </a:extLst>
+          </p:cNvPr>
+          <p:cNvSpPr>
+            <a:spLocks xmlns:a="http://schemas.openxmlformats.org/drawingml/2006/main" noGrp="1"/>
+          </p:cNvSpPr>
+          <p:nvPr/>
+        </p:nvSpPr>
+        <p:spPr>
+          <a:xfrm xmlns:a="http://schemas.openxmlformats.org/drawingml/2006/main">
+            <a:off x="723900" y="4371975"/>
+            <a:ext cx="7734300" cy="666750"/>
+          </a:xfrm>
+          <a:prstGeom xmlns:a="http://schemas.openxmlformats.org/drawingml/2006/main" prst="rect">
+            <a:avLst/>
+          </a:prstGeom>
+          <a:noFill xmlns:a="http://schemas.openxmlformats.org/drawingml/2006/main"/>
+          <a:ln xmlns:a="http://schemas.openxmlformats.org/drawingml/2006/main" w="0">
+            <a:noFill/>
+            <a:prstDash val="solid"/>
+          </a:ln>
+        </p:spPr>
+        <p:txBody>
+          <a:bodyPr xmlns:a="http://schemas.openxmlformats.org/drawingml/2006/main" lIns="0" tIns="0" rIns="0" bIns="0"/>
+          <a:lstStyle xmlns:a="http://schemas.openxmlformats.org/drawingml/2006/main">
+            <a:defPPr algn="l">
+              <a:defRPr sz="2250" b="0" i="0">
+                <a:solidFill>
+                  <a:srgbClr val="BEA06A"/>
+                </a:solidFill>
+              </a:defRPr>
+            </a:defPPr>
+            <a:lvl1pPr algn="l">
+              <a:defRPr sz="2250" b="0" i="0">
+                <a:solidFill>
+                  <a:srgbClr val="BEA06A"/>
+                </a:solidFill>
+              </a:defRPr>
+            </a:lvl1pPr>
+            <a:lvl2pPr algn="l">
+              <a:defRPr sz="2250" b="0" i="0">
+                <a:solidFill>
+                  <a:srgbClr val="BEA06A"/>
+                </a:solidFill>
+              </a:defRPr>
+            </a:lvl2pPr>
+            <a:lvl3pPr algn="l">
+              <a:defRPr sz="2250" b="0" i="0">
+                <a:solidFill>
+                  <a:srgbClr val="BEA06A"/>
+                </a:solidFill>
+              </a:defRPr>
+            </a:lvl3pPr>
+            <a:lvl4pPr algn="l">
+              <a:defRPr sz="2250" b="0" i="0">
+                <a:solidFill>
+                  <a:srgbClr val="BEA06A"/>
+                </a:solidFill>
+              </a:defRPr>
+            </a:lvl4pPr>
+            <a:lvl5pPr algn="l">
+              <a:defRPr sz="2250" b="0" i="0">
+                <a:solidFill>
+                  <a:srgbClr val="BEA06A"/>
+                </a:solidFill>
+              </a:defRPr>
+            </a:lvl5pPr>
+            <a:lvl6pPr algn="l">
+              <a:defRPr sz="2250" b="0" i="0">
+                <a:solidFill>
+                  <a:srgbClr val="BEA06A"/>
+                </a:solidFill>
+              </a:defRPr>
+            </a:lvl6pPr>
+            <a:lvl7pPr algn="l">
+              <a:defRPr sz="2250" b="0" i="0">
+                <a:solidFill>
+                  <a:srgbClr val="BEA06A"/>
+                </a:solidFill>
+              </a:defRPr>
+            </a:lvl7pPr>
+            <a:lvl8pPr algn="l">
+              <a:defRPr sz="2250" b="0" i="0">
+                <a:solidFill>
+                  <a:srgbClr val="BEA06A"/>
+                </a:solidFill>
+              </a:defRPr>
+            </a:lvl8pPr>
+            <a:lvl9pPr algn="l">
+              <a:defRPr sz="2250" b="0" i="0">
+                <a:solidFill>
+                  <a:srgbClr val="BEA06A"/>
+                </a:solidFill>
+              </a:defRPr>
+            </a:lvl9pPr>
+          </a:lstStyle>
+          <a:p xmlns:a="http://schemas.openxmlformats.org/drawingml/2006/main">
+            <a:pPr algn="l">
+              <a:defRPr sz="2250" b="0" i="0">
+                <a:solidFill>
+                  <a:srgbClr val="BEA06A"/>
+                </a:solidFill>
+              </a:defRPr>
+            </a:pPr>
+            <a:r>
+              <a:rPr sz="2250" b="0" i="0">
+                <a:solidFill>
+                  <a:srgbClr val="BEA06A"/>
+                </a:solidFill>
+              </a:rPr>
+              <a:t>Ask. Find project knowledge. Verify.</a:t>
+            </a:r>
+          </a:p>
+        </p:txBody>
+      </p:sp>
+      <p:sp>
+        <p:nvSpPr>
+          <p:cNvPr id="4" name="">
+            <a:extLst xmlns:a="http://schemas.openxmlformats.org/drawingml/2006/main">
+              <a:ext uri="{FF2B5EF4-FFF2-40B4-BE49-F238E27FC236}">
+                <a16:creationId xmlns:a16="http://schemas.microsoft.com/office/drawing/2014/main" id="{1804FC08-3AF6-454F-AA56-391A3E4FB909}"/>
+              </a:ext>
+            </a:extLst>
+          </p:cNvPr>
+          <p:cNvSpPr>
+            <a:spLocks xmlns:a="http://schemas.openxmlformats.org/drawingml/2006/main" noGrp="1"/>
+          </p:cNvSpPr>
+          <p:nvPr/>
+        </p:nvSpPr>
+        <p:spPr>
+          <a:xfrm xmlns:a="http://schemas.openxmlformats.org/drawingml/2006/main">
+            <a:off x="723900" y="5400675"/>
+            <a:ext cx="7677150" cy="476250"/>
+          </a:xfrm>
+          <a:prstGeom xmlns:a="http://schemas.openxmlformats.org/drawingml/2006/main" prst="rect">
+            <a:avLst/>
+          </a:prstGeom>
+          <a:noFill xmlns:a="http://schemas.openxmlformats.org/drawingml/2006/main"/>
+          <a:ln xmlns:a="http://schemas.openxmlformats.org/drawingml/2006/main" w="0">
+            <a:noFill/>
+            <a:prstDash val="solid"/>
+          </a:ln>
+        </p:spPr>
+        <p:txBody>
+          <a:bodyPr xmlns:a="http://schemas.openxmlformats.org/drawingml/2006/main" lIns="0" tIns="0" rIns="0" bIns="0"/>
+          <a:lstStyle xmlns:a="http://schemas.openxmlformats.org/drawingml/2006/main">
+            <a:defPPr algn="l">
+              <a:defRPr sz="1875" b="0" i="0">
+                <a:solidFill>
+                  <a:srgbClr val="D5D8DA"/>
+                </a:solidFill>
+              </a:defRPr>
+            </a:defPPr>
+            <a:lvl1pPr algn="l">
+              <a:defRPr sz="1875" b="0" i="0">
+                <a:solidFill>
+                  <a:srgbClr val="D5D8DA"/>
+                </a:solidFill>
+              </a:defRPr>
+            </a:lvl1pPr>
+            <a:lvl2pPr algn="l">
+              <a:defRPr sz="1875" b="0" i="0">
+                <a:solidFill>
+                  <a:srgbClr val="D5D8DA"/>
+                </a:solidFill>
+              </a:defRPr>
+            </a:lvl2pPr>
+            <a:lvl3pPr algn="l">
+              <a:defRPr sz="1875" b="0" i="0">
+                <a:solidFill>
+                  <a:srgbClr val="D5D8DA"/>
+                </a:solidFill>
+              </a:defRPr>
+            </a:lvl3pPr>
+            <a:lvl4pPr algn="l">
+              <a:defRPr sz="1875" b="0" i="0">
+                <a:solidFill>
+                  <a:srgbClr val="D5D8DA"/>
+                </a:solidFill>
+              </a:defRPr>
+            </a:lvl4pPr>
+            <a:lvl5pPr algn="l">
+              <a:defRPr sz="1875" b="0" i="0">
+                <a:solidFill>
+                  <a:srgbClr val="D5D8DA"/>
+                </a:solidFill>
+              </a:defRPr>
+            </a:lvl5pPr>
+            <a:lvl6pPr algn="l">
+              <a:defRPr sz="1875" b="0" i="0">
+                <a:solidFill>
+                  <a:srgbClr val="D5D8DA"/>
+                </a:solidFill>
+              </a:defRPr>
+            </a:lvl6pPr>
+            <a:lvl7pPr algn="l">
+              <a:defRPr sz="1875" b="0" i="0">
+                <a:solidFill>
+                  <a:srgbClr val="D5D8DA"/>
+                </a:solidFill>
+              </a:defRPr>
+            </a:lvl7pPr>
+            <a:lvl8pPr algn="l">
+              <a:defRPr sz="1875" b="0" i="0">
+                <a:solidFill>
+                  <a:srgbClr val="D5D8DA"/>
+                </a:solidFill>
+              </a:defRPr>
+            </a:lvl8pPr>
+            <a:lvl9pPr algn="l">
+              <a:defRPr sz="1875" b="0" i="0">
+                <a:solidFill>
+                  <a:srgbClr val="D5D8DA"/>
+                </a:solidFill>
+              </a:defRPr>
+            </a:lvl9pPr>
+          </a:lstStyle>
+          <a:p xmlns:a="http://schemas.openxmlformats.org/drawingml/2006/main">
+            <a:pPr algn="l">
+              <a:defRPr sz="1875" b="0" i="0">
+                <a:solidFill>
+                  <a:srgbClr val="D5D8DA"/>
+                </a:solidFill>
+              </a:defRPr>
+            </a:pPr>
+            <a:r>
+              <a:rPr sz="1875" b="0" i="0">
+                <a:solidFill>
+                  <a:srgbClr val="D5D8DA"/>
+                </a:solidFill>
+              </a:rPr>
+              <a:t>Local model and scoped tools for engineering.</a:t>
+            </a:r>
+          </a:p>
+        </p:txBody>
+      </p:sp>
+      <p:sp>
+        <p:nvSpPr>
+          <p:cNvPr id="5" name="">
+            <a:extLst xmlns:a="http://schemas.openxmlformats.org/drawingml/2006/main">
+              <a:ext uri="{FF2B5EF4-FFF2-40B4-BE49-F238E27FC236}">
+                <a16:creationId xmlns:a16="http://schemas.microsoft.com/office/drawing/2014/main" id="{DCF0F68B-4A7D-4791-A107-E1828180AAF5}"/>
+              </a:ext>
+            </a:extLst>
+          </p:cNvPr>
+          <p:cNvSpPr>
+            <a:spLocks xmlns:a="http://schemas.openxmlformats.org/drawingml/2006/main" noGrp="1"/>
+          </p:cNvSpPr>
+          <p:nvPr/>
+        </p:nvSpPr>
+        <p:spPr>
+          <a:xfrm xmlns:a="http://schemas.openxmlformats.org/drawingml/2006/main">
+            <a:off x="161925" y="6372225"/>
+            <a:ext cx="552450" cy="419100"/>
+          </a:xfrm>
+          <a:prstGeom xmlns:a="http://schemas.openxmlformats.org/drawingml/2006/main" prst="rect">
+            <a:avLst/>
+          </a:prstGeom>
+          <a:noFill xmlns:a="http://schemas.openxmlformats.org/drawingml/2006/main"/>
+          <a:ln xmlns:a="http://schemas.openxmlformats.org/drawingml/2006/main" w="0">
+            <a:noFill/>
+            <a:prstDash val="solid"/>
+          </a:ln>
+        </p:spPr>
+        <p:txBody>
+          <a:bodyPr xmlns:a="http://schemas.openxmlformats.org/drawingml/2006/main" lIns="0" tIns="0" rIns="0" bIns="0"/>
+          <a:lstStyle xmlns:a="http://schemas.openxmlformats.org/drawingml/2006/main">
+            <a:defPPr algn="l">
+              <a:defRPr sz="1125" b="1" i="0">
+                <a:solidFill>
+                  <a:srgbClr val="000000"/>
+                </a:solidFill>
+              </a:defRPr>
+            </a:defPPr>
+            <a:lvl1pPr algn="l">
+              <a:defRPr sz="1125" b="1" i="0">
+                <a:solidFill>
+                  <a:srgbClr val="000000"/>
+                </a:solidFill>
+              </a:defRPr>
+            </a:lvl1pPr>
+            <a:lvl2pPr algn="l">
+              <a:defRPr sz="1125" b="1" i="0">
+                <a:solidFill>
+                  <a:srgbClr val="000000"/>
+                </a:solidFill>
+              </a:defRPr>
+            </a:lvl2pPr>
+            <a:lvl3pPr algn="l">
+              <a:defRPr sz="1125" b="1" i="0">
+                <a:solidFill>
+                  <a:srgbClr val="000000"/>
+                </a:solidFill>
+              </a:defRPr>
+            </a:lvl3pPr>
+            <a:lvl4pPr algn="l">
+              <a:defRPr sz="1125" b="1" i="0">
+                <a:solidFill>
+                  <a:srgbClr val="000000"/>
+                </a:solidFill>
+              </a:defRPr>
+            </a:lvl4pPr>
+            <a:lvl5pPr algn="l">
+              <a:defRPr sz="1125" b="1" i="0">
+                <a:solidFill>
+                  <a:srgbClr val="000000"/>
+                </a:solidFill>
+              </a:defRPr>
+            </a:lvl5pPr>
+            <a:lvl6pPr algn="l">
+              <a:defRPr sz="1125" b="1" i="0">
+                <a:solidFill>
+                  <a:srgbClr val="000000"/>
+                </a:solidFill>
+              </a:defRPr>
+            </a:lvl6pPr>
+            <a:lvl7pPr algn="l">
+              <a:defRPr sz="1125" b="1" i="0">
+                <a:solidFill>
+                  <a:srgbClr val="000000"/>
+                </a:solidFill>
+              </a:defRPr>
+            </a:lvl7pPr>
+            <a:lvl8pPr algn="l">
+              <a:defRPr sz="1125" b="1" i="0">
+                <a:solidFill>
+                  <a:srgbClr val="000000"/>
+                </a:solidFill>
+              </a:defRPr>
+            </a:lvl8pPr>
+            <a:lvl9pPr algn="l">
+              <a:defRPr sz="1125" b="1" i="0">
+                <a:solidFill>
+                  <a:srgbClr val="000000"/>
+                </a:solidFill>
+              </a:defRPr>
+            </a:lvl9pPr>
+          </a:lstStyle>
+          <a:p xmlns:a="http://schemas.openxmlformats.org/drawingml/2006/main">
+            <a:pPr algn="l">
+              <a:defRPr sz="1125" b="1" i="0">
+                <a:solidFill>
+                  <a:srgbClr val="000000"/>
+                </a:solidFill>
+              </a:defRPr>
+            </a:pPr>
+            <a:r>
+              <a:rPr sz="1125" b="1" i="0">
+                <a:solidFill>
+                  <a:srgbClr val="000000"/>
+                </a:solidFill>
+              </a:rPr>
+              <a:t>10</a:t>
+            </a:r>
+          </a:p>
+        </p:txBody>
+      </p:sp>
+    </p:spTree>
+    <p:extLst>
+      <p:ext uri="{BB962C8B-B14F-4D97-AF65-F5344CB8AC3E}">
+        <p14:creationId xmlns:p14="http://schemas.microsoft.com/office/powerpoint/2010/main" val="497082280"/>
+      </p:ext>
+    </p:extLst>
+  </p:cSld>
+</p:sld>
+</file>
+
+<file path=ppt/slides/slide11.xml><?xml version="1.0" encoding="utf-8"?>
+<p:sld xmlns:p="http://schemas.openxmlformats.org/presentationml/2006/main">
+  <p:cSld>
+    <p:spTree>
+      <p:nvGrpSpPr>
+        <p:cNvPr id="1" name=""/>
+        <p:cNvGrpSpPr/>
+        <p:nvPr/>
+      </p:nvGrpSpPr>
+      <p:grpSpPr>
+        <a:xfrm xmlns:a="http://schemas.openxmlformats.org/drawingml/2006/main"/>
+      </p:grpSpPr>
+      <p:sp>
+        <p:nvSpPr>
           <p:cNvPr id="11" name="">
             <a:extLst xmlns:a="http://schemas.openxmlformats.org/drawingml/2006/main">
               <a:ext uri="{FF2B5EF4-FFF2-40B4-BE49-F238E27FC236}">
@@ -5630,7 +6345,7 @@
                   <a:srgbClr val="000000"/>
                 </a:solidFill>
               </a:rPr>
-              <a:t>10</a:t>
+              <a:t>11</a:t>
             </a:r>
           </a:p>
         </p:txBody>
@@ -6693,7 +7408,7 @@
 </p:sld>
 </file>
 
-<file path=ppt/slides/slide11.xml><?xml version="1.0" encoding="utf-8"?>
+<file path=ppt/slides/slide12.xml><?xml version="1.0" encoding="utf-8"?>
 <p:sld xmlns:p="http://schemas.openxmlformats.org/presentationml/2006/main">
   <p:cSld>
     <p:spTree>
@@ -6962,7 +7677,7 @@
                   <a:srgbClr val="000000"/>
                 </a:solidFill>
               </a:rPr>
-              <a:t>11</a:t>
+              <a:t>12</a:t>
             </a:r>
           </a:p>
         </p:txBody>
@@ -7239,7 +7954,7 @@
 </p:sld>
 </file>
 
-<file path=ppt/slides/slide12.xml><?xml version="1.0" encoding="utf-8"?>
+<file path=ppt/slides/slide13.xml><?xml version="1.0" encoding="utf-8"?>
 <p:sld xmlns:p="http://schemas.openxmlformats.org/presentationml/2006/main">
   <p:cSld>
     <p:spTree>
@@ -7508,7 +8223,7 @@
                   <a:srgbClr val="000000"/>
                 </a:solidFill>
               </a:rPr>
-              <a:t>12</a:t>
+              <a:t>13</a:t>
             </a:r>
           </a:p>
         </p:txBody>
@@ -8571,7 +9286,7 @@
 </p:sld>
 </file>
 
-<file path=ppt/slides/slide13.xml><?xml version="1.0" encoding="utf-8"?>
+<file path=ppt/slides/slide14.xml><?xml version="1.0" encoding="utf-8"?>
 <p:sld xmlns:p="http://schemas.openxmlformats.org/presentationml/2006/main">
   <p:cSld>
     <p:spTree>
@@ -8840,7 +9555,7 @@
                   <a:srgbClr val="000000"/>
                 </a:solidFill>
               </a:rPr>
-              <a:t>13</a:t>
+              <a:t>14</a:t>
             </a:r>
           </a:p>
         </p:txBody>
@@ -10165,7 +10880,7 @@
 </p:sld>
 </file>
 
-<file path=ppt/slides/slide14.xml><?xml version="1.0" encoding="utf-8"?>
+<file path=ppt/slides/slide15.xml><?xml version="1.0" encoding="utf-8"?>
 <p:sld xmlns:p="http://schemas.openxmlformats.org/presentationml/2006/main">
   <p:cSld>
     <p:spTree>
@@ -10303,7 +11018,7 @@
                   <a:srgbClr val="FFFFFF"/>
                 </a:solidFill>
               </a:rPr>
-              <a:t>Try it yourself</a:t>
+              <a:t>4Founders challenge</a:t>
             </a:r>
           </a:p>
         </p:txBody>
@@ -10434,7 +11149,7 @@
                   <a:srgbClr val="000000"/>
                 </a:solidFill>
               </a:rPr>
-              <a:t>14</a:t>
+              <a:t>15</a:t>
             </a:r>
           </a:p>
         </p:txBody>
@@ -10565,7 +11280,7 @@
                   <a:srgbClr val="FFFFFF"/>
                 </a:solidFill>
               </a:rPr>
-              <a:t>Draw. Test. Change.</a:t>
+              <a:t>Try it yourself</a:t>
             </a:r>
           </a:p>
         </p:txBody>
@@ -10706,7 +11421,7 @@
           <p:cNvPr id="5" name="">
             <a:extLst xmlns:a="http://schemas.openxmlformats.org/drawingml/2006/main">
               <a:ext uri="{FF2B5EF4-FFF2-40B4-BE49-F238E27FC236}">
-                <a16:creationId xmlns:a16="http://schemas.microsoft.com/office/drawing/2014/main" id="{A5D8DE07-B7EB-4602-9996-F851FEEE0061}"/>
+                <a16:creationId xmlns:a16="http://schemas.microsoft.com/office/drawing/2014/main" id="{17A57D48-9186-4AB0-A73C-9A9F9454AD3D}"/>
               </a:ext>
             </a:extLst>
           </p:cNvPr>
@@ -10716,7 +11431,7 @@
           <p:nvPr/>
         </p:nvPicPr>
         <p:blipFill>
-          <a:blip xmlns:r="http://schemas.openxmlformats.org/officeDocument/2006/relationships" xmlns:a="http://schemas.openxmlformats.org/drawingml/2006/main" r:embed="Re39a86eda55140e9"/>
+          <a:blip xmlns:r="http://schemas.openxmlformats.org/officeDocument/2006/relationships" xmlns:a="http://schemas.openxmlformats.org/drawingml/2006/main" r:embed="R8fedd732672d4a84"/>
           <a:stretch xmlns:a="http://schemas.openxmlformats.org/drawingml/2006/main"/>
         </p:blipFill>
         <p:spPr>
@@ -10745,8 +11460,8 @@
         </p:nvSpPr>
         <p:spPr>
           <a:xfrm xmlns:a="http://schemas.openxmlformats.org/drawingml/2006/main">
-            <a:off x="5762625" y="5314950"/>
-            <a:ext cx="2762250" cy="457200"/>
+            <a:off x="5762625" y="5429250"/>
+            <a:ext cx="2762250" cy="657225"/>
           </a:xfrm>
           <a:prstGeom xmlns:a="http://schemas.openxmlformats.org/drawingml/2006/main" prst="rect">
             <a:avLst/>
@@ -10761,7 +11476,7 @@
           <a:bodyPr xmlns:a="http://schemas.openxmlformats.org/drawingml/2006/main" lIns="0" tIns="0" rIns="0" bIns="0"/>
           <a:lstStyle xmlns:a="http://schemas.openxmlformats.org/drawingml/2006/main">
             <a:defPPr algn="l">
-              <a:defRPr sz="2025" b="1" i="0">
+              <a:defRPr sz="3450" b="1" i="0">
                 <a:solidFill>
                   <a:srgbClr val="FFFFFF"/>
                 </a:solidFill>
@@ -10843,19 +11558,140 @@
           <a:p xmlns:a="http://schemas.openxmlformats.org/drawingml/2006/main">
             <a:pPr algn="l">
               <a:buNone/>
-              <a:defRPr sz="2025" b="1" i="0">
+              <a:defRPr sz="3450" b="1" i="0">
                 <a:solidFill>
                   <a:srgbClr val="FFFFFF"/>
                 </a:solidFill>
               </a:defRPr>
             </a:pPr>
             <a:r>
-              <a:rPr sz="2025" b="1" i="0">
+              <a:rPr sz="3450" b="1" i="0">
                 <a:solidFill>
                   <a:srgbClr val="FFFFFF"/>
                 </a:solidFill>
               </a:rPr>
-              <a:t>EVENT PIN  877262</a:t>
+              <a:t>877262</a:t>
+            </a:r>
+          </a:p>
+        </p:txBody>
+      </p:sp>
+      <p:sp>
+        <p:nvSpPr>
+          <p:cNvPr id="8" name="">
+            <a:extLst xmlns:a="http://schemas.openxmlformats.org/drawingml/2006/main">
+              <a:ext uri="{FF2B5EF4-FFF2-40B4-BE49-F238E27FC236}">
+                <a16:creationId xmlns:a16="http://schemas.microsoft.com/office/drawing/2014/main" id="{7344E057-B53A-4742-A1BE-84D64E78BC78}"/>
+              </a:ext>
+            </a:extLst>
+          </p:cNvPr>
+          <p:cNvSpPr>
+            <a:spLocks xmlns:a="http://schemas.openxmlformats.org/drawingml/2006/main" noGrp="1"/>
+          </p:cNvSpPr>
+          <p:nvPr/>
+        </p:nvSpPr>
+        <p:spPr>
+          <a:xfrm xmlns:a="http://schemas.openxmlformats.org/drawingml/2006/main">
+            <a:off x="5762625" y="5124450"/>
+            <a:ext cx="2762250" cy="285750"/>
+          </a:xfrm>
+          <a:prstGeom xmlns:a="http://schemas.openxmlformats.org/drawingml/2006/main" prst="rect">
+            <a:avLst/>
+          </a:prstGeom>
+          <a:noFill xmlns:a="http://schemas.openxmlformats.org/drawingml/2006/main"/>
+          <a:ln xmlns:a="http://schemas.openxmlformats.org/drawingml/2006/main" w="0">
+            <a:noFill/>
+            <a:prstDash val="solid"/>
+          </a:ln>
+        </p:spPr>
+        <p:txBody>
+          <a:bodyPr xmlns:a="http://schemas.openxmlformats.org/drawingml/2006/main" lIns="0" tIns="0" rIns="0" bIns="0"/>
+          <a:lstStyle xmlns:a="http://schemas.openxmlformats.org/drawingml/2006/main">
+            <a:defPPr algn="l">
+              <a:defRPr sz="1575" b="1" i="0">
+                <a:solidFill>
+                  <a:srgbClr val="BEA06A"/>
+                </a:solidFill>
+              </a:defRPr>
+            </a:defPPr>
+            <a:lvl1pPr algn="l">
+              <a:defRPr sz="1575" b="1" i="0">
+                <a:solidFill>
+                  <a:srgbClr val="BEA06A"/>
+                </a:solidFill>
+              </a:defRPr>
+            </a:lvl1pPr>
+            <a:lvl2pPr algn="l">
+              <a:defRPr sz="1575" b="1" i="0">
+                <a:solidFill>
+                  <a:srgbClr val="BEA06A"/>
+                </a:solidFill>
+              </a:defRPr>
+            </a:lvl2pPr>
+            <a:lvl3pPr algn="l">
+              <a:defRPr sz="1575" b="1" i="0">
+                <a:solidFill>
+                  <a:srgbClr val="BEA06A"/>
+                </a:solidFill>
+              </a:defRPr>
+            </a:lvl3pPr>
+            <a:lvl4pPr algn="l">
+              <a:defRPr sz="1575" b="1" i="0">
+                <a:solidFill>
+                  <a:srgbClr val="BEA06A"/>
+                </a:solidFill>
+              </a:defRPr>
+            </a:lvl4pPr>
+            <a:lvl5pPr algn="l">
+              <a:defRPr sz="1575" b="1" i="0">
+                <a:solidFill>
+                  <a:srgbClr val="BEA06A"/>
+                </a:solidFill>
+              </a:defRPr>
+            </a:lvl5pPr>
+            <a:lvl6pPr algn="l">
+              <a:defRPr sz="1575" b="1" i="0">
+                <a:solidFill>
+                  <a:srgbClr val="BEA06A"/>
+                </a:solidFill>
+              </a:defRPr>
+            </a:lvl6pPr>
+            <a:lvl7pPr algn="l">
+              <a:defRPr sz="1575" b="1" i="0">
+                <a:solidFill>
+                  <a:srgbClr val="BEA06A"/>
+                </a:solidFill>
+              </a:defRPr>
+            </a:lvl7pPr>
+            <a:lvl8pPr algn="l">
+              <a:defRPr sz="1575" b="1" i="0">
+                <a:solidFill>
+                  <a:srgbClr val="BEA06A"/>
+                </a:solidFill>
+              </a:defRPr>
+            </a:lvl8pPr>
+            <a:lvl9pPr algn="l">
+              <a:defRPr sz="1575" b="1" i="0">
+                <a:solidFill>
+                  <a:srgbClr val="BEA06A"/>
+                </a:solidFill>
+              </a:defRPr>
+            </a:lvl9pPr>
+          </a:lstStyle>
+          <a:p xmlns:a="http://schemas.openxmlformats.org/drawingml/2006/main">
+            <a:pPr algn="l">
+              <a:defRPr sz="1575" b="1" i="0">
+                <a:solidFill>
+                  <a:srgbClr val="BEA06A"/>
+                </a:solidFill>
+              </a:defRPr>
+            </a:pPr>
+            <a:r>
+              <a:rPr sz="1575" b="1" i="0">
+                <a:solidFill>
+                  <a:srgbClr val="BEA06A"/>
+                </a:solidFill>
+              </a:rPr>
+              <a:t>EVENT PIN</a:t>
             </a:r>
           </a:p>
         </p:txBody>
@@ -10870,7 +11706,7 @@
 </p:sld>
 </file>
 
-<file path=ppt/slides/slide15.xml><?xml version="1.0" encoding="utf-8"?>
+<file path=ppt/slides/slide16.xml><?xml version="1.0" encoding="utf-8"?>
 <p:sld xmlns:p="http://schemas.openxmlformats.org/presentationml/2006/main">
   <p:cSld>
     <p:spTree>
@@ -11139,7 +11975,7 @@
                   <a:srgbClr val="000000"/>
                 </a:solidFill>
               </a:rPr>
-              <a:t>15</a:t>
+              <a:t>16</a:t>
             </a:r>
           </a:p>
         </p:txBody>
@@ -11532,7 +12368,7 @@
                   <a:srgbClr val="BEA06A"/>
                 </a:solidFill>
               </a:rPr>
-              <a:t>We could even become your first customer.</a:t>
+              <a:t>Let's start a conversation.</a:t>
             </a:r>
           </a:p>
         </p:txBody>
@@ -11547,7 +12383,7 @@
 </p:sld>
 </file>
 
-<file path=ppt/slides/slide16.xml><?xml version="1.0" encoding="utf-8"?>
+<file path=ppt/slides/slide17.xml><?xml version="1.0" encoding="utf-8"?>
 <p:sld xmlns:p="http://schemas.openxmlformats.org/presentationml/2006/main">
   <p:cSld>
     <p:spTree>
@@ -11816,7 +12652,7 @@
                   <a:srgbClr val="000000"/>
                 </a:solidFill>
               </a:rPr>
-              <a:t>16</a:t>
+              <a:t>17</a:t>
             </a:r>
           </a:p>
         </p:txBody>
@@ -12227,7 +13063,7 @@
                   <a:srgbClr val="FFFFFF"/>
                 </a:solidFill>
               </a:rPr>
-              <a:t>bdaugherty@tkghunt.com</a:t>
+              <a:t>awhite@tkghunt.com</a:t>
             </a:r>
           </a:p>
         </p:txBody>
@@ -13438,7 +14274,7 @@
           <p:cNvPr id="11" name="">
             <a:extLst xmlns:a="http://schemas.openxmlformats.org/drawingml/2006/main">
               <a:ext uri="{FF2B5EF4-FFF2-40B4-BE49-F238E27FC236}">
-                <a16:creationId xmlns:a16="http://schemas.microsoft.com/office/drawing/2014/main" id="{D3D849C0-5F9F-4478-8E01-A37E945D045A}"/>
+                <a16:creationId xmlns:a16="http://schemas.microsoft.com/office/drawing/2014/main" id="{4F10A49B-1807-4AE6-B554-7F74A182FBB9}"/>
               </a:ext>
             </a:extLst>
           </p:cNvPr>
@@ -13549,7 +14385,7 @@
                   <a:srgbClr val="D5D8DA"/>
                 </a:solidFill>
               </a:rPr>
-              <a:t>Generations of skill in Arkansas built this foundation.</a:t>
+              <a:t>Remington is one of five TKG ammunition brands.</a:t>
             </a:r>
           </a:p>
         </p:txBody>
@@ -13581,7 +14417,7 @@
           <p:cNvPr id="6" name="">
             <a:extLst xmlns:a="http://schemas.openxmlformats.org/drawingml/2006/main">
               <a:ext uri="{FF2B5EF4-FFF2-40B4-BE49-F238E27FC236}">
-                <a16:creationId xmlns:a16="http://schemas.microsoft.com/office/drawing/2014/main" id="{B9A0D6B5-0E7E-4F2B-AC05-B73E1135517F}"/>
+                <a16:creationId xmlns:a16="http://schemas.microsoft.com/office/drawing/2014/main" id="{BD22FF75-5B25-47DA-9C89-F014C4B1A032}"/>
               </a:ext>
             </a:extLst>
           </p:cNvPr>
@@ -13702,7 +14538,7 @@
           <p:cNvPr id="2" name="">
             <a:extLst xmlns:a="http://schemas.openxmlformats.org/drawingml/2006/main">
               <a:ext uri="{FF2B5EF4-FFF2-40B4-BE49-F238E27FC236}">
-                <a16:creationId xmlns:a16="http://schemas.microsoft.com/office/drawing/2014/main" id="{81D5A79B-1CD2-4921-8F6A-0B1F628BF8F6}"/>
+                <a16:creationId xmlns:a16="http://schemas.microsoft.com/office/drawing/2014/main" id="{9617ED25-3782-4F93-B42D-EB969BFB6419}"/>
               </a:ext>
             </a:extLst>
           </p:cNvPr>
@@ -13823,7 +14659,7 @@
           <p:cNvPr id="3" name="">
             <a:extLst xmlns:a="http://schemas.openxmlformats.org/drawingml/2006/main">
               <a:ext uri="{FF2B5EF4-FFF2-40B4-BE49-F238E27FC236}">
-                <a16:creationId xmlns:a16="http://schemas.microsoft.com/office/drawing/2014/main" id="{835CE6D9-D778-4D01-BB6A-BEDFEF1CD622}"/>
+                <a16:creationId xmlns:a16="http://schemas.microsoft.com/office/drawing/2014/main" id="{8BA32C32-AFFD-404C-81BF-4A0718BF792A}"/>
               </a:ext>
             </a:extLst>
           </p:cNvPr>
@@ -13961,7 +14797,7 @@
           <p:cNvPr id="4" name="">
             <a:extLst xmlns:a="http://schemas.openxmlformats.org/drawingml/2006/main">
               <a:ext uri="{FF2B5EF4-FFF2-40B4-BE49-F238E27FC236}">
-                <a16:creationId xmlns:a16="http://schemas.microsoft.com/office/drawing/2014/main" id="{B8CB1A15-850A-48B0-B137-4AD0AC9D2217}"/>
+                <a16:creationId xmlns:a16="http://schemas.microsoft.com/office/drawing/2014/main" id="{867EFB6A-CFD9-4C2B-A4E4-A5FB7FD41BB8}"/>
               </a:ext>
             </a:extLst>
           </p:cNvPr>
@@ -14082,7 +14918,7 @@
           <p:cNvPr id="5" name="">
             <a:extLst xmlns:a="http://schemas.openxmlformats.org/drawingml/2006/main">
               <a:ext uri="{FF2B5EF4-FFF2-40B4-BE49-F238E27FC236}">
-                <a16:creationId xmlns:a16="http://schemas.microsoft.com/office/drawing/2014/main" id="{55B4D544-1296-4C71-B1CC-0ACDC246F2C8}"/>
+                <a16:creationId xmlns:a16="http://schemas.microsoft.com/office/drawing/2014/main" id="{A468379D-915A-4138-A97D-416741AE5643}"/>
               </a:ext>
             </a:extLst>
           </p:cNvPr>
@@ -14201,7 +15037,7 @@
     </p:spTree>
     <p:extLst>
       <p:ext uri="{BB962C8B-B14F-4D97-AF65-F5344CB8AC3E}">
-        <p14:creationId xmlns:p14="http://schemas.microsoft.com/office/powerpoint/2010/main" val="46201472"/>
+        <p14:creationId xmlns:p14="http://schemas.microsoft.com/office/powerpoint/2010/main" val="576258420"/>
       </p:ext>
     </p:extLst>
   </p:cSld>
@@ -15477,10 +16313,10 @@
       </p:grpSpPr>
       <p:sp>
         <p:nvSpPr>
-          <p:cNvPr id="6" name="">
+          <p:cNvPr id="8" name="">
             <a:extLst xmlns:a="http://schemas.openxmlformats.org/drawingml/2006/main">
               <a:ext uri="{FF2B5EF4-FFF2-40B4-BE49-F238E27FC236}">
-                <a16:creationId xmlns:a16="http://schemas.microsoft.com/office/drawing/2014/main" id="{C551FB01-8FB1-47A8-B591-A8D02A574AC3}"/>
+                <a16:creationId xmlns:a16="http://schemas.microsoft.com/office/drawing/2014/main" id="{4202D145-63A5-4D8D-AFAA-8E1DDA390D36}"/>
               </a:ext>
             </a:extLst>
           </p:cNvPr>
@@ -15591,6 +16427,926 @@
                   <a:srgbClr val="FFFFFF"/>
                 </a:solidFill>
               </a:rPr>
+              <a:t>The work spans the organization</a:t>
+            </a:r>
+          </a:p>
+        </p:txBody>
+      </p:sp>
+      <p:sp>
+        <p:nvSpPr>
+          <p:cNvPr id="2" name="">
+            <a:extLst xmlns:a="http://schemas.openxmlformats.org/drawingml/2006/main">
+              <a:ext uri="{FF2B5EF4-FFF2-40B4-BE49-F238E27FC236}">
+                <a16:creationId xmlns:a16="http://schemas.microsoft.com/office/drawing/2014/main" id="{76D95F68-FF4A-47B2-B52E-82565A65E4FF}"/>
+              </a:ext>
+            </a:extLst>
+          </p:cNvPr>
+          <p:cNvSpPr>
+            <a:spLocks xmlns:a="http://schemas.openxmlformats.org/drawingml/2006/main" noGrp="1"/>
+          </p:cNvSpPr>
+          <p:nvPr/>
+        </p:nvSpPr>
+        <p:spPr>
+          <a:xfrm xmlns:a="http://schemas.openxmlformats.org/drawingml/2006/main">
+            <a:off x="723900" y="2771775"/>
+            <a:ext cx="3857625" cy="495300"/>
+          </a:xfrm>
+          <a:prstGeom xmlns:a="http://schemas.openxmlformats.org/drawingml/2006/main" prst="rect">
+            <a:avLst/>
+          </a:prstGeom>
+          <a:noFill xmlns:a="http://schemas.openxmlformats.org/drawingml/2006/main"/>
+          <a:ln xmlns:a="http://schemas.openxmlformats.org/drawingml/2006/main" w="0">
+            <a:noFill/>
+            <a:prstDash val="solid"/>
+          </a:ln>
+        </p:spPr>
+        <p:txBody>
+          <a:bodyPr xmlns:a="http://schemas.openxmlformats.org/drawingml/2006/main" lIns="0" tIns="0" rIns="0" bIns="0"/>
+          <a:lstStyle xmlns:a="http://schemas.openxmlformats.org/drawingml/2006/main">
+            <a:defPPr algn="l">
+              <a:defRPr sz="2325" b="1" i="0">
+                <a:solidFill>
+                  <a:srgbClr val="BEA06A"/>
+                </a:solidFill>
+              </a:defRPr>
+            </a:defPPr>
+            <a:lvl1pPr algn="l">
+              <a:defRPr sz="2325" b="1" i="0">
+                <a:solidFill>
+                  <a:srgbClr val="BEA06A"/>
+                </a:solidFill>
+              </a:defRPr>
+            </a:lvl1pPr>
+            <a:lvl2pPr algn="l">
+              <a:defRPr sz="2325" b="1" i="0">
+                <a:solidFill>
+                  <a:srgbClr val="BEA06A"/>
+                </a:solidFill>
+              </a:defRPr>
+            </a:lvl2pPr>
+            <a:lvl3pPr algn="l">
+              <a:defRPr sz="2325" b="1" i="0">
+                <a:solidFill>
+                  <a:srgbClr val="BEA06A"/>
+                </a:solidFill>
+              </a:defRPr>
+            </a:lvl3pPr>
+            <a:lvl4pPr algn="l">
+              <a:defRPr sz="2325" b="1" i="0">
+                <a:solidFill>
+                  <a:srgbClr val="BEA06A"/>
+                </a:solidFill>
+              </a:defRPr>
+            </a:lvl4pPr>
+            <a:lvl5pPr algn="l">
+              <a:defRPr sz="2325" b="1" i="0">
+                <a:solidFill>
+                  <a:srgbClr val="BEA06A"/>
+                </a:solidFill>
+              </a:defRPr>
+            </a:lvl5pPr>
+            <a:lvl6pPr algn="l">
+              <a:defRPr sz="2325" b="1" i="0">
+                <a:solidFill>
+                  <a:srgbClr val="BEA06A"/>
+                </a:solidFill>
+              </a:defRPr>
+            </a:lvl6pPr>
+            <a:lvl7pPr algn="l">
+              <a:defRPr sz="2325" b="1" i="0">
+                <a:solidFill>
+                  <a:srgbClr val="BEA06A"/>
+                </a:solidFill>
+              </a:defRPr>
+            </a:lvl7pPr>
+            <a:lvl8pPr algn="l">
+              <a:defRPr sz="2325" b="1" i="0">
+                <a:solidFill>
+                  <a:srgbClr val="BEA06A"/>
+                </a:solidFill>
+              </a:defRPr>
+            </a:lvl8pPr>
+            <a:lvl9pPr algn="l">
+              <a:defRPr sz="2325" b="1" i="0">
+                <a:solidFill>
+                  <a:srgbClr val="BEA06A"/>
+                </a:solidFill>
+              </a:defRPr>
+            </a:lvl9pPr>
+          </a:lstStyle>
+          <a:p xmlns:a="http://schemas.openxmlformats.org/drawingml/2006/main">
+            <a:pPr algn="l">
+              <a:defRPr sz="2325" b="1" i="0">
+                <a:solidFill>
+                  <a:srgbClr val="BEA06A"/>
+                </a:solidFill>
+              </a:defRPr>
+            </a:pPr>
+            <a:r>
+              <a:rPr sz="2325" b="1" i="0">
+                <a:solidFill>
+                  <a:srgbClr val="BEA06A"/>
+                </a:solidFill>
+              </a:rPr>
+              <a:t>LIVE IN PRODUCTION</a:t>
+            </a:r>
+          </a:p>
+        </p:txBody>
+      </p:sp>
+      <p:sp>
+        <p:nvSpPr>
+          <p:cNvPr id="3" name="">
+            <a:extLst xmlns:a="http://schemas.openxmlformats.org/drawingml/2006/main">
+              <a:ext uri="{FF2B5EF4-FFF2-40B4-BE49-F238E27FC236}">
+                <a16:creationId xmlns:a16="http://schemas.microsoft.com/office/drawing/2014/main" id="{57934EC7-4A7E-4795-ADF5-F5311C550969}"/>
+              </a:ext>
+            </a:extLst>
+          </p:cNvPr>
+          <p:cNvSpPr>
+            <a:spLocks xmlns:a="http://schemas.openxmlformats.org/drawingml/2006/main" noGrp="1"/>
+          </p:cNvSpPr>
+          <p:nvPr/>
+        </p:nvSpPr>
+        <p:spPr>
+          <a:xfrm xmlns:a="http://schemas.openxmlformats.org/drawingml/2006/main">
+            <a:off x="723900" y="3400425"/>
+            <a:ext cx="3857625" cy="1428750"/>
+          </a:xfrm>
+          <a:prstGeom xmlns:a="http://schemas.openxmlformats.org/drawingml/2006/main" prst="rect">
+            <a:avLst/>
+          </a:prstGeom>
+          <a:noFill xmlns:a="http://schemas.openxmlformats.org/drawingml/2006/main"/>
+          <a:ln xmlns:a="http://schemas.openxmlformats.org/drawingml/2006/main" w="0">
+            <a:noFill/>
+            <a:prstDash val="solid"/>
+          </a:ln>
+        </p:spPr>
+        <p:txBody>
+          <a:bodyPr xmlns:a="http://schemas.openxmlformats.org/drawingml/2006/main" lIns="0" tIns="0" rIns="0" bIns="0"/>
+          <a:lstStyle xmlns:a="http://schemas.openxmlformats.org/drawingml/2006/main">
+            <a:defPPr algn="l">
+              <a:defRPr sz="2025" b="0" i="0">
+                <a:solidFill>
+                  <a:srgbClr val="FFFFFF"/>
+                </a:solidFill>
+              </a:defRPr>
+            </a:defPPr>
+            <a:lvl1pPr algn="l">
+              <a:defRPr sz="2025" b="0" i="0">
+                <a:solidFill>
+                  <a:srgbClr val="FFFFFF"/>
+                </a:solidFill>
+              </a:defRPr>
+            </a:lvl1pPr>
+            <a:lvl2pPr algn="l">
+              <a:defRPr sz="2025" b="0" i="0">
+                <a:solidFill>
+                  <a:srgbClr val="FFFFFF"/>
+                </a:solidFill>
+              </a:defRPr>
+            </a:lvl2pPr>
+            <a:lvl3pPr algn="l">
+              <a:defRPr sz="2025" b="0" i="0">
+                <a:solidFill>
+                  <a:srgbClr val="FFFFFF"/>
+                </a:solidFill>
+              </a:defRPr>
+            </a:lvl3pPr>
+            <a:lvl4pPr algn="l">
+              <a:defRPr sz="2025" b="0" i="0">
+                <a:solidFill>
+                  <a:srgbClr val="FFFFFF"/>
+                </a:solidFill>
+              </a:defRPr>
+            </a:lvl4pPr>
+            <a:lvl5pPr algn="l">
+              <a:defRPr sz="2025" b="0" i="0">
+                <a:solidFill>
+                  <a:srgbClr val="FFFFFF"/>
+                </a:solidFill>
+              </a:defRPr>
+            </a:lvl5pPr>
+            <a:lvl6pPr algn="l">
+              <a:defRPr sz="2025" b="0" i="0">
+                <a:solidFill>
+                  <a:srgbClr val="FFFFFF"/>
+                </a:solidFill>
+              </a:defRPr>
+            </a:lvl6pPr>
+            <a:lvl7pPr algn="l">
+              <a:defRPr sz="2025" b="0" i="0">
+                <a:solidFill>
+                  <a:srgbClr val="FFFFFF"/>
+                </a:solidFill>
+              </a:defRPr>
+            </a:lvl7pPr>
+            <a:lvl8pPr algn="l">
+              <a:defRPr sz="2025" b="0" i="0">
+                <a:solidFill>
+                  <a:srgbClr val="FFFFFF"/>
+                </a:solidFill>
+              </a:defRPr>
+            </a:lvl8pPr>
+            <a:lvl9pPr algn="l">
+              <a:defRPr sz="2025" b="0" i="0">
+                <a:solidFill>
+                  <a:srgbClr val="FFFFFF"/>
+                </a:solidFill>
+              </a:defRPr>
+            </a:lvl9pPr>
+          </a:lstStyle>
+          <a:p xmlns:a="http://schemas.openxmlformats.org/drawingml/2006/main">
+            <a:pPr algn="l">
+              <a:defRPr sz="2025" b="0" i="0">
+                <a:solidFill>
+                  <a:srgbClr val="FFFFFF"/>
+                </a:solidFill>
+              </a:defRPr>
+            </a:pPr>
+            <a:r>
+              <a:rPr sz="2025" b="0" i="0">
+                <a:solidFill>
+                  <a:srgbClr val="FFFFFF"/>
+                </a:solidFill>
+              </a:rPr>
+              <a:t>SCADA</a:t>
+            </a:r>
+          </a:p>
+          <a:p xmlns:a="http://schemas.openxmlformats.org/drawingml/2006/main">
+            <a:pPr algn="l">
+              <a:defRPr sz="2025" b="0" i="0">
+                <a:solidFill>
+                  <a:srgbClr val="FFFFFF"/>
+                </a:solidFill>
+              </a:defRPr>
+            </a:pPr>
+            <a:r>
+              <a:rPr sz="2025" b="0" i="0">
+                <a:solidFill>
+                  <a:srgbClr val="FFFFFF"/>
+                </a:solidFill>
+              </a:rPr>
+              <a:t>Centerfire inspection</a:t>
+            </a:r>
+          </a:p>
+          <a:p xmlns:a="http://schemas.openxmlformats.org/drawingml/2006/main">
+            <a:pPr algn="l">
+              <a:defRPr sz="2025" b="0" i="0">
+                <a:solidFill>
+                  <a:srgbClr val="FFFFFF"/>
+                </a:solidFill>
+              </a:defRPr>
+            </a:pPr>
+            <a:r>
+              <a:rPr sz="2025" b="0" i="0">
+                <a:solidFill>
+                  <a:srgbClr val="FFFFFF"/>
+                </a:solidFill>
+              </a:rPr>
+              <a:t>Shotshell inspection</a:t>
+            </a:r>
+          </a:p>
+        </p:txBody>
+      </p:sp>
+      <p:sp>
+        <p:nvSpPr>
+          <p:cNvPr id="4" name="">
+            <a:extLst xmlns:a="http://schemas.openxmlformats.org/drawingml/2006/main">
+              <a:ext uri="{FF2B5EF4-FFF2-40B4-BE49-F238E27FC236}">
+                <a16:creationId xmlns:a16="http://schemas.microsoft.com/office/drawing/2014/main" id="{B3E9516A-69ED-4901-B7FE-B330CE25572C}"/>
+              </a:ext>
+            </a:extLst>
+          </p:cNvPr>
+          <p:cNvSpPr>
+            <a:spLocks xmlns:a="http://schemas.openxmlformats.org/drawingml/2006/main" noGrp="1"/>
+          </p:cNvSpPr>
+          <p:nvPr/>
+        </p:nvSpPr>
+        <p:spPr>
+          <a:xfrm xmlns:a="http://schemas.openxmlformats.org/drawingml/2006/main">
+            <a:off x="4953000" y="2771775"/>
+            <a:ext cx="3676650" cy="495300"/>
+          </a:xfrm>
+          <a:prstGeom xmlns:a="http://schemas.openxmlformats.org/drawingml/2006/main" prst="rect">
+            <a:avLst/>
+          </a:prstGeom>
+          <a:noFill xmlns:a="http://schemas.openxmlformats.org/drawingml/2006/main"/>
+          <a:ln xmlns:a="http://schemas.openxmlformats.org/drawingml/2006/main" w="0">
+            <a:noFill/>
+            <a:prstDash val="solid"/>
+          </a:ln>
+        </p:spPr>
+        <p:txBody>
+          <a:bodyPr xmlns:a="http://schemas.openxmlformats.org/drawingml/2006/main" lIns="0" tIns="0" rIns="0" bIns="0"/>
+          <a:lstStyle xmlns:a="http://schemas.openxmlformats.org/drawingml/2006/main">
+            <a:defPPr algn="l">
+              <a:defRPr sz="2325" b="1" i="0">
+                <a:solidFill>
+                  <a:srgbClr val="BEA06A"/>
+                </a:solidFill>
+              </a:defRPr>
+            </a:defPPr>
+            <a:lvl1pPr algn="l">
+              <a:defRPr sz="2325" b="1" i="0">
+                <a:solidFill>
+                  <a:srgbClr val="BEA06A"/>
+                </a:solidFill>
+              </a:defRPr>
+            </a:lvl1pPr>
+            <a:lvl2pPr algn="l">
+              <a:defRPr sz="2325" b="1" i="0">
+                <a:solidFill>
+                  <a:srgbClr val="BEA06A"/>
+                </a:solidFill>
+              </a:defRPr>
+            </a:lvl2pPr>
+            <a:lvl3pPr algn="l">
+              <a:defRPr sz="2325" b="1" i="0">
+                <a:solidFill>
+                  <a:srgbClr val="BEA06A"/>
+                </a:solidFill>
+              </a:defRPr>
+            </a:lvl3pPr>
+            <a:lvl4pPr algn="l">
+              <a:defRPr sz="2325" b="1" i="0">
+                <a:solidFill>
+                  <a:srgbClr val="BEA06A"/>
+                </a:solidFill>
+              </a:defRPr>
+            </a:lvl4pPr>
+            <a:lvl5pPr algn="l">
+              <a:defRPr sz="2325" b="1" i="0">
+                <a:solidFill>
+                  <a:srgbClr val="BEA06A"/>
+                </a:solidFill>
+              </a:defRPr>
+            </a:lvl5pPr>
+            <a:lvl6pPr algn="l">
+              <a:defRPr sz="2325" b="1" i="0">
+                <a:solidFill>
+                  <a:srgbClr val="BEA06A"/>
+                </a:solidFill>
+              </a:defRPr>
+            </a:lvl6pPr>
+            <a:lvl7pPr algn="l">
+              <a:defRPr sz="2325" b="1" i="0">
+                <a:solidFill>
+                  <a:srgbClr val="BEA06A"/>
+                </a:solidFill>
+              </a:defRPr>
+            </a:lvl7pPr>
+            <a:lvl8pPr algn="l">
+              <a:defRPr sz="2325" b="1" i="0">
+                <a:solidFill>
+                  <a:srgbClr val="BEA06A"/>
+                </a:solidFill>
+              </a:defRPr>
+            </a:lvl8pPr>
+            <a:lvl9pPr algn="l">
+              <a:defRPr sz="2325" b="1" i="0">
+                <a:solidFill>
+                  <a:srgbClr val="BEA06A"/>
+                </a:solidFill>
+              </a:defRPr>
+            </a:lvl9pPr>
+          </a:lstStyle>
+          <a:p xmlns:a="http://schemas.openxmlformats.org/drawingml/2006/main">
+            <a:pPr algn="l">
+              <a:defRPr sz="2325" b="1" i="0">
+                <a:solidFill>
+                  <a:srgbClr val="BEA06A"/>
+                </a:solidFill>
+              </a:defRPr>
+            </a:pPr>
+            <a:r>
+              <a:rPr sz="2325" b="1" i="0">
+                <a:solidFill>
+                  <a:srgbClr val="BEA06A"/>
+                </a:solidFill>
+              </a:rPr>
+              <a:t>OTHER CAPABILITIES</a:t>
+            </a:r>
+          </a:p>
+        </p:txBody>
+      </p:sp>
+      <p:sp>
+        <p:nvSpPr>
+          <p:cNvPr id="5" name="">
+            <a:extLst xmlns:a="http://schemas.openxmlformats.org/drawingml/2006/main">
+              <a:ext uri="{FF2B5EF4-FFF2-40B4-BE49-F238E27FC236}">
+                <a16:creationId xmlns:a16="http://schemas.microsoft.com/office/drawing/2014/main" id="{961F9EAF-EDCD-41D9-9D0E-FC4877219D99}"/>
+              </a:ext>
+            </a:extLst>
+          </p:cNvPr>
+          <p:cNvSpPr>
+            <a:spLocks xmlns:a="http://schemas.openxmlformats.org/drawingml/2006/main" noGrp="1"/>
+          </p:cNvSpPr>
+          <p:nvPr/>
+        </p:nvSpPr>
+        <p:spPr>
+          <a:xfrm xmlns:a="http://schemas.openxmlformats.org/drawingml/2006/main">
+            <a:off x="4953000" y="3400425"/>
+            <a:ext cx="3619500" cy="1047750"/>
+          </a:xfrm>
+          <a:prstGeom xmlns:a="http://schemas.openxmlformats.org/drawingml/2006/main" prst="rect">
+            <a:avLst/>
+          </a:prstGeom>
+          <a:noFill xmlns:a="http://schemas.openxmlformats.org/drawingml/2006/main"/>
+          <a:ln xmlns:a="http://schemas.openxmlformats.org/drawingml/2006/main" w="0">
+            <a:noFill/>
+            <a:prstDash val="solid"/>
+          </a:ln>
+        </p:spPr>
+        <p:txBody>
+          <a:bodyPr xmlns:a="http://schemas.openxmlformats.org/drawingml/2006/main" lIns="0" tIns="0" rIns="0" bIns="0"/>
+          <a:lstStyle xmlns:a="http://schemas.openxmlformats.org/drawingml/2006/main">
+            <a:defPPr algn="l">
+              <a:defRPr sz="2025" b="0" i="0">
+                <a:solidFill>
+                  <a:srgbClr val="FFFFFF"/>
+                </a:solidFill>
+              </a:defRPr>
+            </a:defPPr>
+            <a:lvl1pPr algn="l">
+              <a:defRPr sz="2025" b="0" i="0">
+                <a:solidFill>
+                  <a:srgbClr val="FFFFFF"/>
+                </a:solidFill>
+              </a:defRPr>
+            </a:lvl1pPr>
+            <a:lvl2pPr algn="l">
+              <a:defRPr sz="2025" b="0" i="0">
+                <a:solidFill>
+                  <a:srgbClr val="FFFFFF"/>
+                </a:solidFill>
+              </a:defRPr>
+            </a:lvl2pPr>
+            <a:lvl3pPr algn="l">
+              <a:defRPr sz="2025" b="0" i="0">
+                <a:solidFill>
+                  <a:srgbClr val="FFFFFF"/>
+                </a:solidFill>
+              </a:defRPr>
+            </a:lvl3pPr>
+            <a:lvl4pPr algn="l">
+              <a:defRPr sz="2025" b="0" i="0">
+                <a:solidFill>
+                  <a:srgbClr val="FFFFFF"/>
+                </a:solidFill>
+              </a:defRPr>
+            </a:lvl4pPr>
+            <a:lvl5pPr algn="l">
+              <a:defRPr sz="2025" b="0" i="0">
+                <a:solidFill>
+                  <a:srgbClr val="FFFFFF"/>
+                </a:solidFill>
+              </a:defRPr>
+            </a:lvl5pPr>
+            <a:lvl6pPr algn="l">
+              <a:defRPr sz="2025" b="0" i="0">
+                <a:solidFill>
+                  <a:srgbClr val="FFFFFF"/>
+                </a:solidFill>
+              </a:defRPr>
+            </a:lvl6pPr>
+            <a:lvl7pPr algn="l">
+              <a:defRPr sz="2025" b="0" i="0">
+                <a:solidFill>
+                  <a:srgbClr val="FFFFFF"/>
+                </a:solidFill>
+              </a:defRPr>
+            </a:lvl7pPr>
+            <a:lvl8pPr algn="l">
+              <a:defRPr sz="2025" b="0" i="0">
+                <a:solidFill>
+                  <a:srgbClr val="FFFFFF"/>
+                </a:solidFill>
+              </a:defRPr>
+            </a:lvl8pPr>
+            <a:lvl9pPr algn="l">
+              <a:defRPr sz="2025" b="0" i="0">
+                <a:solidFill>
+                  <a:srgbClr val="FFFFFF"/>
+                </a:solidFill>
+              </a:defRPr>
+            </a:lvl9pPr>
+          </a:lstStyle>
+          <a:p xmlns:a="http://schemas.openxmlformats.org/drawingml/2006/main">
+            <a:pPr algn="l">
+              <a:defRPr sz="2025" b="0" i="0">
+                <a:solidFill>
+                  <a:srgbClr val="FFFFFF"/>
+                </a:solidFill>
+              </a:defRPr>
+            </a:pPr>
+            <a:r>
+              <a:rPr sz="2025" b="0" i="0">
+                <a:solidFill>
+                  <a:srgbClr val="FFFFFF"/>
+                </a:solidFill>
+              </a:rPr>
+              <a:t>Public sentiment</a:t>
+            </a:r>
+          </a:p>
+          <a:p xmlns:a="http://schemas.openxmlformats.org/drawingml/2006/main">
+            <a:pPr algn="l">
+              <a:defRPr sz="2025" b="0" i="0">
+                <a:solidFill>
+                  <a:srgbClr val="FFFFFF"/>
+                </a:solidFill>
+              </a:defRPr>
+            </a:pPr>
+            <a:r>
+              <a:rPr sz="2025" b="0" i="0">
+                <a:solidFill>
+                  <a:srgbClr val="FFFFFF"/>
+                </a:solidFill>
+              </a:rPr>
+              <a:t>Remi</a:t>
+            </a:r>
+          </a:p>
+        </p:txBody>
+      </p:sp>
+      <p:sp>
+        <p:nvSpPr>
+          <p:cNvPr id="6" name="">
+            <a:extLst xmlns:a="http://schemas.openxmlformats.org/drawingml/2006/main">
+              <a:ext uri="{FF2B5EF4-FFF2-40B4-BE49-F238E27FC236}">
+                <a16:creationId xmlns:a16="http://schemas.microsoft.com/office/drawing/2014/main" id="{C90BB98B-14F2-4C32-9D6E-77ECFB3534F5}"/>
+              </a:ext>
+            </a:extLst>
+          </p:cNvPr>
+          <p:cNvSpPr>
+            <a:spLocks xmlns:a="http://schemas.openxmlformats.org/drawingml/2006/main" noGrp="1"/>
+          </p:cNvSpPr>
+          <p:nvPr/>
+        </p:nvSpPr>
+        <p:spPr>
+          <a:xfrm xmlns:a="http://schemas.openxmlformats.org/drawingml/2006/main">
+            <a:off x="723900" y="5362575"/>
+            <a:ext cx="7810500" cy="581025"/>
+          </a:xfrm>
+          <a:prstGeom xmlns:a="http://schemas.openxmlformats.org/drawingml/2006/main" prst="rect">
+            <a:avLst/>
+          </a:prstGeom>
+          <a:noFill xmlns:a="http://schemas.openxmlformats.org/drawingml/2006/main"/>
+          <a:ln xmlns:a="http://schemas.openxmlformats.org/drawingml/2006/main" w="0">
+            <a:noFill/>
+            <a:prstDash val="solid"/>
+          </a:ln>
+        </p:spPr>
+        <p:txBody>
+          <a:bodyPr xmlns:a="http://schemas.openxmlformats.org/drawingml/2006/main" lIns="0" tIns="0" rIns="0" bIns="0"/>
+          <a:lstStyle xmlns:a="http://schemas.openxmlformats.org/drawingml/2006/main">
+            <a:defPPr algn="l">
+              <a:defRPr sz="2100" b="1" i="0">
+                <a:solidFill>
+                  <a:srgbClr val="FFFFFF"/>
+                </a:solidFill>
+              </a:defRPr>
+            </a:defPPr>
+            <a:lvl1pPr algn="l">
+              <a:defRPr sz="2100" b="1" i="0">
+                <a:solidFill>
+                  <a:srgbClr val="FFFFFF"/>
+                </a:solidFill>
+              </a:defRPr>
+            </a:lvl1pPr>
+            <a:lvl2pPr algn="l">
+              <a:defRPr sz="2100" b="1" i="0">
+                <a:solidFill>
+                  <a:srgbClr val="FFFFFF"/>
+                </a:solidFill>
+              </a:defRPr>
+            </a:lvl2pPr>
+            <a:lvl3pPr algn="l">
+              <a:defRPr sz="2100" b="1" i="0">
+                <a:solidFill>
+                  <a:srgbClr val="FFFFFF"/>
+                </a:solidFill>
+              </a:defRPr>
+            </a:lvl3pPr>
+            <a:lvl4pPr algn="l">
+              <a:defRPr sz="2100" b="1" i="0">
+                <a:solidFill>
+                  <a:srgbClr val="FFFFFF"/>
+                </a:solidFill>
+              </a:defRPr>
+            </a:lvl4pPr>
+            <a:lvl5pPr algn="l">
+              <a:defRPr sz="2100" b="1" i="0">
+                <a:solidFill>
+                  <a:srgbClr val="FFFFFF"/>
+                </a:solidFill>
+              </a:defRPr>
+            </a:lvl5pPr>
+            <a:lvl6pPr algn="l">
+              <a:defRPr sz="2100" b="1" i="0">
+                <a:solidFill>
+                  <a:srgbClr val="FFFFFF"/>
+                </a:solidFill>
+              </a:defRPr>
+            </a:lvl6pPr>
+            <a:lvl7pPr algn="l">
+              <a:defRPr sz="2100" b="1" i="0">
+                <a:solidFill>
+                  <a:srgbClr val="FFFFFF"/>
+                </a:solidFill>
+              </a:defRPr>
+            </a:lvl7pPr>
+            <a:lvl8pPr algn="l">
+              <a:defRPr sz="2100" b="1" i="0">
+                <a:solidFill>
+                  <a:srgbClr val="FFFFFF"/>
+                </a:solidFill>
+              </a:defRPr>
+            </a:lvl8pPr>
+            <a:lvl9pPr algn="l">
+              <a:defRPr sz="2100" b="1" i="0">
+                <a:solidFill>
+                  <a:srgbClr val="FFFFFF"/>
+                </a:solidFill>
+              </a:defRPr>
+            </a:lvl9pPr>
+          </a:lstStyle>
+          <a:p xmlns:a="http://schemas.openxmlformats.org/drawingml/2006/main">
+            <a:pPr algn="l">
+              <a:defRPr sz="2100" b="1" i="0">
+                <a:solidFill>
+                  <a:srgbClr val="FFFFFF"/>
+                </a:solidFill>
+              </a:defRPr>
+            </a:pPr>
+            <a:r>
+              <a:rPr sz="2100" b="1" i="0">
+                <a:solidFill>
+                  <a:srgbClr val="FFFFFF"/>
+                </a:solidFill>
+              </a:rPr>
+              <a:t>Each system helps someone make a better decision.</a:t>
+            </a:r>
+          </a:p>
+        </p:txBody>
+      </p:sp>
+      <p:sp>
+        <p:nvSpPr>
+          <p:cNvPr id="7" name="">
+            <a:extLst xmlns:a="http://schemas.openxmlformats.org/drawingml/2006/main">
+              <a:ext uri="{FF2B5EF4-FFF2-40B4-BE49-F238E27FC236}">
+                <a16:creationId xmlns:a16="http://schemas.microsoft.com/office/drawing/2014/main" id="{97DCA6FC-32C0-4710-8448-724E5C7CFABB}"/>
+              </a:ext>
+            </a:extLst>
+          </p:cNvPr>
+          <p:cNvSpPr>
+            <a:spLocks xmlns:a="http://schemas.openxmlformats.org/drawingml/2006/main" noGrp="1"/>
+          </p:cNvSpPr>
+          <p:nvPr/>
+        </p:nvSpPr>
+        <p:spPr>
+          <a:xfrm xmlns:a="http://schemas.openxmlformats.org/drawingml/2006/main">
+            <a:off x="161925" y="6372225"/>
+            <a:ext cx="552450" cy="419100"/>
+          </a:xfrm>
+          <a:prstGeom xmlns:a="http://schemas.openxmlformats.org/drawingml/2006/main" prst="rect">
+            <a:avLst/>
+          </a:prstGeom>
+          <a:noFill xmlns:a="http://schemas.openxmlformats.org/drawingml/2006/main"/>
+          <a:ln xmlns:a="http://schemas.openxmlformats.org/drawingml/2006/main" w="0">
+            <a:noFill/>
+            <a:prstDash val="solid"/>
+          </a:ln>
+        </p:spPr>
+        <p:txBody>
+          <a:bodyPr xmlns:a="http://schemas.openxmlformats.org/drawingml/2006/main" lIns="0" tIns="0" rIns="0" bIns="0"/>
+          <a:lstStyle xmlns:a="http://schemas.openxmlformats.org/drawingml/2006/main">
+            <a:defPPr algn="l">
+              <a:defRPr sz="1125" b="1" i="0">
+                <a:solidFill>
+                  <a:srgbClr val="000000"/>
+                </a:solidFill>
+              </a:defRPr>
+            </a:defPPr>
+            <a:lvl1pPr algn="l">
+              <a:defRPr sz="1125" b="1" i="0">
+                <a:solidFill>
+                  <a:srgbClr val="000000"/>
+                </a:solidFill>
+              </a:defRPr>
+            </a:lvl1pPr>
+            <a:lvl2pPr algn="l">
+              <a:defRPr sz="1125" b="1" i="0">
+                <a:solidFill>
+                  <a:srgbClr val="000000"/>
+                </a:solidFill>
+              </a:defRPr>
+            </a:lvl2pPr>
+            <a:lvl3pPr algn="l">
+              <a:defRPr sz="1125" b="1" i="0">
+                <a:solidFill>
+                  <a:srgbClr val="000000"/>
+                </a:solidFill>
+              </a:defRPr>
+            </a:lvl3pPr>
+            <a:lvl4pPr algn="l">
+              <a:defRPr sz="1125" b="1" i="0">
+                <a:solidFill>
+                  <a:srgbClr val="000000"/>
+                </a:solidFill>
+              </a:defRPr>
+            </a:lvl4pPr>
+            <a:lvl5pPr algn="l">
+              <a:defRPr sz="1125" b="1" i="0">
+                <a:solidFill>
+                  <a:srgbClr val="000000"/>
+                </a:solidFill>
+              </a:defRPr>
+            </a:lvl5pPr>
+            <a:lvl6pPr algn="l">
+              <a:defRPr sz="1125" b="1" i="0">
+                <a:solidFill>
+                  <a:srgbClr val="000000"/>
+                </a:solidFill>
+              </a:defRPr>
+            </a:lvl6pPr>
+            <a:lvl7pPr algn="l">
+              <a:defRPr sz="1125" b="1" i="0">
+                <a:solidFill>
+                  <a:srgbClr val="000000"/>
+                </a:solidFill>
+              </a:defRPr>
+            </a:lvl7pPr>
+            <a:lvl8pPr algn="l">
+              <a:defRPr sz="1125" b="1" i="0">
+                <a:solidFill>
+                  <a:srgbClr val="000000"/>
+                </a:solidFill>
+              </a:defRPr>
+            </a:lvl8pPr>
+            <a:lvl9pPr algn="l">
+              <a:defRPr sz="1125" b="1" i="0">
+                <a:solidFill>
+                  <a:srgbClr val="000000"/>
+                </a:solidFill>
+              </a:defRPr>
+            </a:lvl9pPr>
+          </a:lstStyle>
+          <a:p xmlns:a="http://schemas.openxmlformats.org/drawingml/2006/main">
+            <a:pPr algn="l">
+              <a:defRPr sz="1125" b="1" i="0">
+                <a:solidFill>
+                  <a:srgbClr val="000000"/>
+                </a:solidFill>
+              </a:defRPr>
+            </a:pPr>
+            <a:r>
+              <a:rPr sz="1125" b="1" i="0">
+                <a:solidFill>
+                  <a:srgbClr val="000000"/>
+                </a:solidFill>
+              </a:rPr>
+              <a:t>5</a:t>
+            </a:r>
+          </a:p>
+        </p:txBody>
+      </p:sp>
+    </p:spTree>
+    <p:extLst>
+      <p:ext uri="{BB962C8B-B14F-4D97-AF65-F5344CB8AC3E}">
+        <p14:creationId xmlns:p14="http://schemas.microsoft.com/office/powerpoint/2010/main" val="2072561181"/>
+      </p:ext>
+    </p:extLst>
+  </p:cSld>
+</p:sld>
+</file>
+
+<file path=ppt/slides/slide6.xml><?xml version="1.0" encoding="utf-8"?>
+<p:sld xmlns:p="http://schemas.openxmlformats.org/presentationml/2006/main">
+  <p:cSld>
+    <p:spTree>
+      <p:nvGrpSpPr>
+        <p:cNvPr id="1" name=""/>
+        <p:cNvGrpSpPr/>
+        <p:nvPr/>
+      </p:nvGrpSpPr>
+      <p:grpSpPr>
+        <a:xfrm xmlns:a="http://schemas.openxmlformats.org/drawingml/2006/main"/>
+      </p:grpSpPr>
+      <p:sp>
+        <p:nvSpPr>
+          <p:cNvPr id="6" name="">
+            <a:extLst xmlns:a="http://schemas.openxmlformats.org/drawingml/2006/main">
+              <a:ext uri="{FF2B5EF4-FFF2-40B4-BE49-F238E27FC236}">
+                <a16:creationId xmlns:a16="http://schemas.microsoft.com/office/drawing/2014/main" id="{9D43181C-CCD5-40EE-8B1D-5028DB3B80D6}"/>
+              </a:ext>
+            </a:extLst>
+          </p:cNvPr>
+          <p:cNvSpPr>
+            <a:spLocks xmlns:a="http://schemas.openxmlformats.org/drawingml/2006/main" noGrp="1"/>
+          </p:cNvSpPr>
+          <p:nvPr/>
+        </p:nvSpPr>
+        <p:spPr>
+          <a:xfrm xmlns:a="http://schemas.openxmlformats.org/drawingml/2006/main">
+            <a:off x="704850" y="1495425"/>
+            <a:ext cx="7743825" cy="619125"/>
+          </a:xfrm>
+          <a:prstGeom xmlns:a="http://schemas.openxmlformats.org/drawingml/2006/main" prst="rect">
+            <a:avLst/>
+          </a:prstGeom>
+          <a:noFill xmlns:a="http://schemas.openxmlformats.org/drawingml/2006/main"/>
+          <a:ln xmlns:a="http://schemas.openxmlformats.org/drawingml/2006/main" w="0">
+            <a:noFill/>
+            <a:prstDash val="solid"/>
+          </a:ln>
+        </p:spPr>
+        <p:txBody>
+          <a:bodyPr xmlns:a="http://schemas.openxmlformats.org/drawingml/2006/main" lIns="0" tIns="0" rIns="0" bIns="0"/>
+          <a:lstStyle xmlns:a="http://schemas.openxmlformats.org/drawingml/2006/main">
+            <a:defPPr algn="l">
+              <a:defRPr sz="3000" b="0" i="0">
+                <a:solidFill>
+                  <a:srgbClr val="FFFFFF"/>
+                </a:solidFill>
+              </a:defRPr>
+            </a:defPPr>
+            <a:lvl1pPr algn="l">
+              <a:defRPr sz="3000" b="0" i="0">
+                <a:solidFill>
+                  <a:srgbClr val="FFFFFF"/>
+                </a:solidFill>
+              </a:defRPr>
+            </a:lvl1pPr>
+            <a:lvl2pPr algn="l">
+              <a:defRPr sz="3000" b="0" i="0">
+                <a:solidFill>
+                  <a:srgbClr val="FFFFFF"/>
+                </a:solidFill>
+              </a:defRPr>
+            </a:lvl2pPr>
+            <a:lvl3pPr algn="l">
+              <a:defRPr sz="3000" b="0" i="0">
+                <a:solidFill>
+                  <a:srgbClr val="FFFFFF"/>
+                </a:solidFill>
+              </a:defRPr>
+            </a:lvl3pPr>
+            <a:lvl4pPr algn="l">
+              <a:defRPr sz="3000" b="0" i="0">
+                <a:solidFill>
+                  <a:srgbClr val="FFFFFF"/>
+                </a:solidFill>
+              </a:defRPr>
+            </a:lvl4pPr>
+            <a:lvl5pPr algn="l">
+              <a:defRPr sz="3000" b="0" i="0">
+                <a:solidFill>
+                  <a:srgbClr val="FFFFFF"/>
+                </a:solidFill>
+              </a:defRPr>
+            </a:lvl5pPr>
+            <a:lvl6pPr algn="l">
+              <a:defRPr sz="3000" b="0" i="0">
+                <a:solidFill>
+                  <a:srgbClr val="FFFFFF"/>
+                </a:solidFill>
+              </a:defRPr>
+            </a:lvl6pPr>
+            <a:lvl7pPr algn="l">
+              <a:defRPr sz="3000" b="0" i="0">
+                <a:solidFill>
+                  <a:srgbClr val="FFFFFF"/>
+                </a:solidFill>
+              </a:defRPr>
+            </a:lvl7pPr>
+            <a:lvl8pPr algn="l">
+              <a:defRPr sz="3000" b="0" i="0">
+                <a:solidFill>
+                  <a:srgbClr val="FFFFFF"/>
+                </a:solidFill>
+              </a:defRPr>
+            </a:lvl8pPr>
+            <a:lvl9pPr algn="l">
+              <a:defRPr sz="3000" b="0" i="0">
+                <a:solidFill>
+                  <a:srgbClr val="FFFFFF"/>
+                </a:solidFill>
+              </a:defRPr>
+            </a:lvl9pPr>
+          </a:lstStyle>
+          <a:p xmlns:a="http://schemas.openxmlformats.org/drawingml/2006/main">
+            <a:pPr algn="l">
+              <a:defRPr sz="3000" b="0" i="0">
+                <a:solidFill>
+                  <a:srgbClr val="FFFFFF"/>
+                </a:solidFill>
+              </a:defRPr>
+            </a:pPr>
+            <a:r>
+              <a:rPr sz="3000" b="0" i="0">
+                <a:solidFill>
+                  <a:srgbClr val="FFFFFF"/>
+                </a:solidFill>
+              </a:rPr>
               <a:t>SCADA</a:t>
             </a:r>
           </a:p>
@@ -15601,7 +17357,7 @@
           <p:cNvPr id="2" name="">
             <a:extLst xmlns:a="http://schemas.openxmlformats.org/drawingml/2006/main">
               <a:ext uri="{FF2B5EF4-FFF2-40B4-BE49-F238E27FC236}">
-                <a16:creationId xmlns:a16="http://schemas.microsoft.com/office/drawing/2014/main" id="{03F95EFC-E01C-4D09-8A27-1D05BD7EE80D}"/>
+                <a16:creationId xmlns:a16="http://schemas.microsoft.com/office/drawing/2014/main" id="{35F0749F-02D0-4D41-B541-8FA81365D06F}"/>
               </a:ext>
             </a:extLst>
           </p:cNvPr>
@@ -15739,7 +17495,7 @@
           <p:cNvPr id="3" name="">
             <a:extLst xmlns:a="http://schemas.openxmlformats.org/drawingml/2006/main">
               <a:ext uri="{FF2B5EF4-FFF2-40B4-BE49-F238E27FC236}">
-                <a16:creationId xmlns:a16="http://schemas.microsoft.com/office/drawing/2014/main" id="{39CEB94D-D5D8-44DB-BCC4-E06D98190309}"/>
+                <a16:creationId xmlns:a16="http://schemas.microsoft.com/office/drawing/2014/main" id="{3978D215-6A06-4B35-921B-F13758577C45}"/>
               </a:ext>
             </a:extLst>
           </p:cNvPr>
@@ -15860,7 +17616,7 @@
           <p:cNvPr id="4" name="">
             <a:extLst xmlns:a="http://schemas.openxmlformats.org/drawingml/2006/main">
               <a:ext uri="{FF2B5EF4-FFF2-40B4-BE49-F238E27FC236}">
-                <a16:creationId xmlns:a16="http://schemas.microsoft.com/office/drawing/2014/main" id="{03FAF914-2876-4660-84E8-53044E86433A}"/>
+                <a16:creationId xmlns:a16="http://schemas.microsoft.com/office/drawing/2014/main" id="{20DF886C-83CE-4E2C-8BFB-B3E148DCD62F}"/>
               </a:ext>
             </a:extLst>
           </p:cNvPr>
@@ -15981,7 +17737,7 @@
           <p:cNvPr id="5" name="">
             <a:extLst xmlns:a="http://schemas.openxmlformats.org/drawingml/2006/main">
               <a:ext uri="{FF2B5EF4-FFF2-40B4-BE49-F238E27FC236}">
-                <a16:creationId xmlns:a16="http://schemas.microsoft.com/office/drawing/2014/main" id="{57CC94BF-9826-4781-9EB8-5C9F68D104D9}"/>
+                <a16:creationId xmlns:a16="http://schemas.microsoft.com/office/drawing/2014/main" id="{12CBA38E-E543-4AB0-9043-72C3D9800C98}"/>
               </a:ext>
             </a:extLst>
           </p:cNvPr>
@@ -16092,7 +17848,7 @@
                   <a:srgbClr val="000000"/>
                 </a:solidFill>
               </a:rPr>
-              <a:t>5</a:t>
+              <a:t>6</a:t>
             </a:r>
           </a:p>
         </p:txBody>
@@ -16100,14 +17856,14 @@
     </p:spTree>
     <p:extLst>
       <p:ext uri="{BB962C8B-B14F-4D97-AF65-F5344CB8AC3E}">
-        <p14:creationId xmlns:p14="http://schemas.microsoft.com/office/powerpoint/2010/main" val="1690709477"/>
+        <p14:creationId xmlns:p14="http://schemas.microsoft.com/office/powerpoint/2010/main" val="907198175"/>
       </p:ext>
     </p:extLst>
   </p:cSld>
 </p:sld>
 </file>
 
-<file path=ppt/slides/slide6.xml><?xml version="1.0" encoding="utf-8"?>
+<file path=ppt/slides/slide7.xml><?xml version="1.0" encoding="utf-8"?>
 <p:sld xmlns:p="http://schemas.openxmlformats.org/presentationml/2006/main">
   <p:cSld>
     <p:spTree>
@@ -16124,7 +17880,7 @@
           <p:cNvPr id="6" name="">
             <a:extLst xmlns:a="http://schemas.openxmlformats.org/drawingml/2006/main">
               <a:ext uri="{FF2B5EF4-FFF2-40B4-BE49-F238E27FC236}">
-                <a16:creationId xmlns:a16="http://schemas.microsoft.com/office/drawing/2014/main" id="{C6A55543-0F7F-4253-894A-C076BE59934C}"/>
+                <a16:creationId xmlns:a16="http://schemas.microsoft.com/office/drawing/2014/main" id="{5A47B281-DF16-4F21-9F61-FAEF3D12CBF2}"/>
               </a:ext>
             </a:extLst>
           </p:cNvPr>
@@ -16245,7 +18001,7 @@
           <p:cNvPr id="2" name="">
             <a:extLst xmlns:a="http://schemas.openxmlformats.org/drawingml/2006/main">
               <a:ext uri="{FF2B5EF4-FFF2-40B4-BE49-F238E27FC236}">
-                <a16:creationId xmlns:a16="http://schemas.microsoft.com/office/drawing/2014/main" id="{926C9F3D-1388-48E1-9FEE-AB4AF078F39E}"/>
+                <a16:creationId xmlns:a16="http://schemas.microsoft.com/office/drawing/2014/main" id="{913F532E-68E3-41BB-BCF3-2E00BE7C661B}"/>
               </a:ext>
             </a:extLst>
           </p:cNvPr>
@@ -16383,7 +18139,7 @@
           <p:cNvPr id="3" name="">
             <a:extLst xmlns:a="http://schemas.openxmlformats.org/drawingml/2006/main">
               <a:ext uri="{FF2B5EF4-FFF2-40B4-BE49-F238E27FC236}">
-                <a16:creationId xmlns:a16="http://schemas.microsoft.com/office/drawing/2014/main" id="{86869661-7923-4666-A624-BF6B59767AB3}"/>
+                <a16:creationId xmlns:a16="http://schemas.microsoft.com/office/drawing/2014/main" id="{E2379997-D0B0-440C-BDA3-F8AAC3654CF4}"/>
               </a:ext>
             </a:extLst>
           </p:cNvPr>
@@ -16504,7 +18260,7 @@
           <p:cNvPr id="4" name="">
             <a:extLst xmlns:a="http://schemas.openxmlformats.org/drawingml/2006/main">
               <a:ext uri="{FF2B5EF4-FFF2-40B4-BE49-F238E27FC236}">
-                <a16:creationId xmlns:a16="http://schemas.microsoft.com/office/drawing/2014/main" id="{CF2374BB-8E29-4381-A769-0118BB21ACC0}"/>
+                <a16:creationId xmlns:a16="http://schemas.microsoft.com/office/drawing/2014/main" id="{D454F285-D6E4-4C44-B0B0-7CCEDC912140}"/>
               </a:ext>
             </a:extLst>
           </p:cNvPr>
@@ -16625,7 +18381,7 @@
           <p:cNvPr id="5" name="">
             <a:extLst xmlns:a="http://schemas.openxmlformats.org/drawingml/2006/main">
               <a:ext uri="{FF2B5EF4-FFF2-40B4-BE49-F238E27FC236}">
-                <a16:creationId xmlns:a16="http://schemas.microsoft.com/office/drawing/2014/main" id="{06DB4208-BDE1-4E55-BCB0-BCA695E4BBF2}"/>
+                <a16:creationId xmlns:a16="http://schemas.microsoft.com/office/drawing/2014/main" id="{9A25501B-5C46-45C4-B809-E769A3926639}"/>
               </a:ext>
             </a:extLst>
           </p:cNvPr>
@@ -16736,7 +18492,7 @@
                   <a:srgbClr val="000000"/>
                 </a:solidFill>
               </a:rPr>
-              <a:t>6</a:t>
+              <a:t>7</a:t>
             </a:r>
           </a:p>
         </p:txBody>
@@ -16744,14 +18500,14 @@
     </p:spTree>
     <p:extLst>
       <p:ext uri="{BB962C8B-B14F-4D97-AF65-F5344CB8AC3E}">
-        <p14:creationId xmlns:p14="http://schemas.microsoft.com/office/powerpoint/2010/main" val="121681602"/>
+        <p14:creationId xmlns:p14="http://schemas.microsoft.com/office/powerpoint/2010/main" val="994694381"/>
       </p:ext>
     </p:extLst>
   </p:cSld>
 </p:sld>
 </file>
 
-<file path=ppt/slides/slide7.xml><?xml version="1.0" encoding="utf-8"?>
+<file path=ppt/slides/slide8.xml><?xml version="1.0" encoding="utf-8"?>
 <p:sld xmlns:p="http://schemas.openxmlformats.org/presentationml/2006/main">
   <p:cSld>
     <p:spTree>
@@ -16768,7 +18524,7 @@
           <p:cNvPr id="6" name="">
             <a:extLst xmlns:a="http://schemas.openxmlformats.org/drawingml/2006/main">
               <a:ext uri="{FF2B5EF4-FFF2-40B4-BE49-F238E27FC236}">
-                <a16:creationId xmlns:a16="http://schemas.microsoft.com/office/drawing/2014/main" id="{197C40AE-E39E-4789-AD36-45F6CD21CE83}"/>
+                <a16:creationId xmlns:a16="http://schemas.microsoft.com/office/drawing/2014/main" id="{2CB9929E-941A-4352-94E3-21AE8B4A1F44}"/>
               </a:ext>
             </a:extLst>
           </p:cNvPr>
@@ -16889,7 +18645,7 @@
           <p:cNvPr id="2" name="">
             <a:extLst xmlns:a="http://schemas.openxmlformats.org/drawingml/2006/main">
               <a:ext uri="{FF2B5EF4-FFF2-40B4-BE49-F238E27FC236}">
-                <a16:creationId xmlns:a16="http://schemas.microsoft.com/office/drawing/2014/main" id="{C84E4475-AD51-4130-BC1F-08D755212D35}"/>
+                <a16:creationId xmlns:a16="http://schemas.microsoft.com/office/drawing/2014/main" id="{568EBA13-2702-4735-BD69-FF7AD1E9BAB1}"/>
               </a:ext>
             </a:extLst>
           </p:cNvPr>
@@ -17027,7 +18783,7 @@
           <p:cNvPr id="3" name="">
             <a:extLst xmlns:a="http://schemas.openxmlformats.org/drawingml/2006/main">
               <a:ext uri="{FF2B5EF4-FFF2-40B4-BE49-F238E27FC236}">
-                <a16:creationId xmlns:a16="http://schemas.microsoft.com/office/drawing/2014/main" id="{276AE210-F0E0-4F6E-A338-A685E8166E78}"/>
+                <a16:creationId xmlns:a16="http://schemas.microsoft.com/office/drawing/2014/main" id="{962D2FF8-ED40-4461-B307-7A960585C20F}"/>
               </a:ext>
             </a:extLst>
           </p:cNvPr>
@@ -17148,7 +18904,7 @@
           <p:cNvPr id="4" name="">
             <a:extLst xmlns:a="http://schemas.openxmlformats.org/drawingml/2006/main">
               <a:ext uri="{FF2B5EF4-FFF2-40B4-BE49-F238E27FC236}">
-                <a16:creationId xmlns:a16="http://schemas.microsoft.com/office/drawing/2014/main" id="{54BE6D36-C7F3-4EA4-83B7-AE6184F55252}"/>
+                <a16:creationId xmlns:a16="http://schemas.microsoft.com/office/drawing/2014/main" id="{2E5668E9-61AA-4359-BB77-949880F817AE}"/>
               </a:ext>
             </a:extLst>
           </p:cNvPr>
@@ -17269,7 +19025,7 @@
           <p:cNvPr id="5" name="">
             <a:extLst xmlns:a="http://schemas.openxmlformats.org/drawingml/2006/main">
               <a:ext uri="{FF2B5EF4-FFF2-40B4-BE49-F238E27FC236}">
-                <a16:creationId xmlns:a16="http://schemas.microsoft.com/office/drawing/2014/main" id="{5D7C745D-7A94-4624-B451-C5C2175DCFCD}"/>
+                <a16:creationId xmlns:a16="http://schemas.microsoft.com/office/drawing/2014/main" id="{BF02ACA2-F7EB-4C35-8D8C-83905A212148}"/>
               </a:ext>
             </a:extLst>
           </p:cNvPr>
@@ -17380,7 +19136,7 @@
                   <a:srgbClr val="000000"/>
                 </a:solidFill>
               </a:rPr>
-              <a:t>7</a:t>
+              <a:t>8</a:t>
             </a:r>
           </a:p>
         </p:txBody>
@@ -17388,14 +19144,14 @@
     </p:spTree>
     <p:extLst>
       <p:ext uri="{BB962C8B-B14F-4D97-AF65-F5344CB8AC3E}">
-        <p14:creationId xmlns:p14="http://schemas.microsoft.com/office/powerpoint/2010/main" val="817615270"/>
+        <p14:creationId xmlns:p14="http://schemas.microsoft.com/office/powerpoint/2010/main" val="1955991026"/>
       </p:ext>
     </p:extLst>
   </p:cSld>
 </p:sld>
 </file>
 
-<file path=ppt/slides/slide8.xml><?xml version="1.0" encoding="utf-8"?>
+<file path=ppt/slides/slide9.xml><?xml version="1.0" encoding="utf-8"?>
 <p:sld xmlns:p="http://schemas.openxmlformats.org/presentationml/2006/main">
   <p:cSld>
     <p:spTree>
@@ -17412,7 +19168,7 @@
           <p:cNvPr id="6" name="">
             <a:extLst xmlns:a="http://schemas.openxmlformats.org/drawingml/2006/main">
               <a:ext uri="{FF2B5EF4-FFF2-40B4-BE49-F238E27FC236}">
-                <a16:creationId xmlns:a16="http://schemas.microsoft.com/office/drawing/2014/main" id="{A9169A71-A6A6-4D68-A8E6-A77BFDCC1A50}"/>
+                <a16:creationId xmlns:a16="http://schemas.microsoft.com/office/drawing/2014/main" id="{DA15C80C-203E-40F7-8212-EC5B148D63AA}"/>
               </a:ext>
             </a:extLst>
           </p:cNvPr>
@@ -17533,7 +19289,7 @@
           <p:cNvPr id="2" name="">
             <a:extLst xmlns:a="http://schemas.openxmlformats.org/drawingml/2006/main">
               <a:ext uri="{FF2B5EF4-FFF2-40B4-BE49-F238E27FC236}">
-                <a16:creationId xmlns:a16="http://schemas.microsoft.com/office/drawing/2014/main" id="{8BC55663-6D9E-4CB9-A0C0-CD82593429E5}"/>
+                <a16:creationId xmlns:a16="http://schemas.microsoft.com/office/drawing/2014/main" id="{71F5E8C9-0B99-47C7-AC32-66FEBE80E7DA}"/>
               </a:ext>
             </a:extLst>
           </p:cNvPr>
@@ -17671,7 +19427,7 @@
           <p:cNvPr id="3" name="">
             <a:extLst xmlns:a="http://schemas.openxmlformats.org/drawingml/2006/main">
               <a:ext uri="{FF2B5EF4-FFF2-40B4-BE49-F238E27FC236}">
-                <a16:creationId xmlns:a16="http://schemas.microsoft.com/office/drawing/2014/main" id="{970F8F99-6B76-406C-B124-329BF7799FD4}"/>
+                <a16:creationId xmlns:a16="http://schemas.microsoft.com/office/drawing/2014/main" id="{6BBEBB02-563D-4498-93E6-658D69AB738A}"/>
               </a:ext>
             </a:extLst>
           </p:cNvPr>
@@ -17792,7 +19548,7 @@
           <p:cNvPr id="4" name="">
             <a:extLst xmlns:a="http://schemas.openxmlformats.org/drawingml/2006/main">
               <a:ext uri="{FF2B5EF4-FFF2-40B4-BE49-F238E27FC236}">
-                <a16:creationId xmlns:a16="http://schemas.microsoft.com/office/drawing/2014/main" id="{2A7FD83D-EC31-488F-A857-5182A136457F}"/>
+                <a16:creationId xmlns:a16="http://schemas.microsoft.com/office/drawing/2014/main" id="{C5A5BDA2-0D55-48A0-A674-76A219CF9A99}"/>
               </a:ext>
             </a:extLst>
           </p:cNvPr>
@@ -17913,7 +19669,7 @@
           <p:cNvPr id="5" name="">
             <a:extLst xmlns:a="http://schemas.openxmlformats.org/drawingml/2006/main">
               <a:ext uri="{FF2B5EF4-FFF2-40B4-BE49-F238E27FC236}">
-                <a16:creationId xmlns:a16="http://schemas.microsoft.com/office/drawing/2014/main" id="{213CBF53-273E-4CB1-9E7D-E925F4C5B27C}"/>
+                <a16:creationId xmlns:a16="http://schemas.microsoft.com/office/drawing/2014/main" id="{87A350F8-8E5E-434E-AF17-D17239863896}"/>
               </a:ext>
             </a:extLst>
           </p:cNvPr>
@@ -18024,650 +19780,6 @@
                   <a:srgbClr val="000000"/>
                 </a:solidFill>
               </a:rPr>
-              <a:t>8</a:t>
-            </a:r>
-          </a:p>
-        </p:txBody>
-      </p:sp>
-    </p:spTree>
-    <p:extLst>
-      <p:ext uri="{BB962C8B-B14F-4D97-AF65-F5344CB8AC3E}">
-        <p14:creationId xmlns:p14="http://schemas.microsoft.com/office/powerpoint/2010/main" val="888670725"/>
-      </p:ext>
-    </p:extLst>
-  </p:cSld>
-</p:sld>
-</file>
-
-<file path=ppt/slides/slide9.xml><?xml version="1.0" encoding="utf-8"?>
-<p:sld xmlns:p="http://schemas.openxmlformats.org/presentationml/2006/main">
-  <p:cSld>
-    <p:spTree>
-      <p:nvGrpSpPr>
-        <p:cNvPr id="1" name=""/>
-        <p:cNvGrpSpPr/>
-        <p:nvPr/>
-      </p:nvGrpSpPr>
-      <p:grpSpPr>
-        <a:xfrm xmlns:a="http://schemas.openxmlformats.org/drawingml/2006/main"/>
-      </p:grpSpPr>
-      <p:sp>
-        <p:nvSpPr>
-          <p:cNvPr id="6" name="">
-            <a:extLst xmlns:a="http://schemas.openxmlformats.org/drawingml/2006/main">
-              <a:ext uri="{FF2B5EF4-FFF2-40B4-BE49-F238E27FC236}">
-                <a16:creationId xmlns:a16="http://schemas.microsoft.com/office/drawing/2014/main" id="{6AF223D5-A488-414E-A462-5C4A1E42C6AE}"/>
-              </a:ext>
-            </a:extLst>
-          </p:cNvPr>
-          <p:cNvSpPr>
-            <a:spLocks xmlns:a="http://schemas.openxmlformats.org/drawingml/2006/main" noGrp="1"/>
-          </p:cNvSpPr>
-          <p:nvPr/>
-        </p:nvSpPr>
-        <p:spPr>
-          <a:xfrm xmlns:a="http://schemas.openxmlformats.org/drawingml/2006/main">
-            <a:off x="704850" y="1495425"/>
-            <a:ext cx="7743825" cy="619125"/>
-          </a:xfrm>
-          <a:prstGeom xmlns:a="http://schemas.openxmlformats.org/drawingml/2006/main" prst="rect">
-            <a:avLst/>
-          </a:prstGeom>
-          <a:noFill xmlns:a="http://schemas.openxmlformats.org/drawingml/2006/main"/>
-          <a:ln xmlns:a="http://schemas.openxmlformats.org/drawingml/2006/main" w="0">
-            <a:noFill/>
-            <a:prstDash val="solid"/>
-          </a:ln>
-        </p:spPr>
-        <p:txBody>
-          <a:bodyPr xmlns:a="http://schemas.openxmlformats.org/drawingml/2006/main" lIns="0" tIns="0" rIns="0" bIns="0"/>
-          <a:lstStyle xmlns:a="http://schemas.openxmlformats.org/drawingml/2006/main">
-            <a:defPPr algn="l">
-              <a:defRPr sz="3000" b="0" i="0">
-                <a:solidFill>
-                  <a:srgbClr val="FFFFFF"/>
-                </a:solidFill>
-              </a:defRPr>
-            </a:defPPr>
-            <a:lvl1pPr algn="l">
-              <a:defRPr sz="3000" b="0" i="0">
-                <a:solidFill>
-                  <a:srgbClr val="FFFFFF"/>
-                </a:solidFill>
-              </a:defRPr>
-            </a:lvl1pPr>
-            <a:lvl2pPr algn="l">
-              <a:defRPr sz="3000" b="0" i="0">
-                <a:solidFill>
-                  <a:srgbClr val="FFFFFF"/>
-                </a:solidFill>
-              </a:defRPr>
-            </a:lvl2pPr>
-            <a:lvl3pPr algn="l">
-              <a:defRPr sz="3000" b="0" i="0">
-                <a:solidFill>
-                  <a:srgbClr val="FFFFFF"/>
-                </a:solidFill>
-              </a:defRPr>
-            </a:lvl3pPr>
-            <a:lvl4pPr algn="l">
-              <a:defRPr sz="3000" b="0" i="0">
-                <a:solidFill>
-                  <a:srgbClr val="FFFFFF"/>
-                </a:solidFill>
-              </a:defRPr>
-            </a:lvl4pPr>
-            <a:lvl5pPr algn="l">
-              <a:defRPr sz="3000" b="0" i="0">
-                <a:solidFill>
-                  <a:srgbClr val="FFFFFF"/>
-                </a:solidFill>
-              </a:defRPr>
-            </a:lvl5pPr>
-            <a:lvl6pPr algn="l">
-              <a:defRPr sz="3000" b="0" i="0">
-                <a:solidFill>
-                  <a:srgbClr val="FFFFFF"/>
-                </a:solidFill>
-              </a:defRPr>
-            </a:lvl6pPr>
-            <a:lvl7pPr algn="l">
-              <a:defRPr sz="3000" b="0" i="0">
-                <a:solidFill>
-                  <a:srgbClr val="FFFFFF"/>
-                </a:solidFill>
-              </a:defRPr>
-            </a:lvl7pPr>
-            <a:lvl8pPr algn="l">
-              <a:defRPr sz="3000" b="0" i="0">
-                <a:solidFill>
-                  <a:srgbClr val="FFFFFF"/>
-                </a:solidFill>
-              </a:defRPr>
-            </a:lvl8pPr>
-            <a:lvl9pPr algn="l">
-              <a:defRPr sz="3000" b="0" i="0">
-                <a:solidFill>
-                  <a:srgbClr val="FFFFFF"/>
-                </a:solidFill>
-              </a:defRPr>
-            </a:lvl9pPr>
-          </a:lstStyle>
-          <a:p xmlns:a="http://schemas.openxmlformats.org/drawingml/2006/main">
-            <a:pPr algn="l">
-              <a:defRPr sz="3000" b="0" i="0">
-                <a:solidFill>
-                  <a:srgbClr val="FFFFFF"/>
-                </a:solidFill>
-              </a:defRPr>
-            </a:pPr>
-            <a:r>
-              <a:rPr sz="3000" b="0" i="0">
-                <a:solidFill>
-                  <a:srgbClr val="FFFFFF"/>
-                </a:solidFill>
-              </a:rPr>
-              <a:t>Remi</a:t>
-            </a:r>
-          </a:p>
-        </p:txBody>
-      </p:sp>
-      <p:sp>
-        <p:nvSpPr>
-          <p:cNvPr id="2" name="">
-            <a:extLst xmlns:a="http://schemas.openxmlformats.org/drawingml/2006/main">
-              <a:ext uri="{FF2B5EF4-FFF2-40B4-BE49-F238E27FC236}">
-                <a16:creationId xmlns:a16="http://schemas.microsoft.com/office/drawing/2014/main" id="{1BFEDFD2-0146-4D95-BA97-A7B47EEB3B64}"/>
-              </a:ext>
-            </a:extLst>
-          </p:cNvPr>
-          <p:cNvSpPr>
-            <a:spLocks xmlns:a="http://schemas.openxmlformats.org/drawingml/2006/main" noGrp="1"/>
-          </p:cNvSpPr>
-          <p:nvPr/>
-        </p:nvSpPr>
-        <p:spPr>
-          <a:xfrm xmlns:a="http://schemas.openxmlformats.org/drawingml/2006/main">
-            <a:off x="723900" y="2676525"/>
-            <a:ext cx="7734300" cy="1257300"/>
-          </a:xfrm>
-          <a:prstGeom xmlns:a="http://schemas.openxmlformats.org/drawingml/2006/main" prst="rect">
-            <a:avLst/>
-          </a:prstGeom>
-          <a:noFill xmlns:a="http://schemas.openxmlformats.org/drawingml/2006/main"/>
-          <a:ln xmlns:a="http://schemas.openxmlformats.org/drawingml/2006/main" w="0">
-            <a:noFill/>
-            <a:prstDash val="solid"/>
-          </a:ln>
-        </p:spPr>
-        <p:txBody>
-          <a:bodyPr xmlns:a="http://schemas.openxmlformats.org/drawingml/2006/main" lIns="0" tIns="0" rIns="0" bIns="0"/>
-          <a:lstStyle xmlns:a="http://schemas.openxmlformats.org/drawingml/2006/main">
-            <a:defPPr algn="l">
-              <a:defRPr sz="3075" b="1" i="0">
-                <a:solidFill>
-                  <a:srgbClr val="FFFFFF"/>
-                </a:solidFill>
-              </a:defRPr>
-            </a:defPPr>
-            <a:lvl1pPr algn="l">
-              <a:defRPr sz="3075" b="1" i="0">
-                <a:solidFill>
-                  <a:srgbClr val="FFFFFF"/>
-                </a:solidFill>
-              </a:defRPr>
-            </a:lvl1pPr>
-            <a:lvl2pPr algn="l">
-              <a:defRPr sz="3075" b="1" i="0">
-                <a:solidFill>
-                  <a:srgbClr val="FFFFFF"/>
-                </a:solidFill>
-              </a:defRPr>
-            </a:lvl2pPr>
-            <a:lvl3pPr algn="l">
-              <a:defRPr sz="3075" b="1" i="0">
-                <a:solidFill>
-                  <a:srgbClr val="FFFFFF"/>
-                </a:solidFill>
-              </a:defRPr>
-            </a:lvl3pPr>
-            <a:lvl4pPr algn="l">
-              <a:defRPr sz="3075" b="1" i="0">
-                <a:solidFill>
-                  <a:srgbClr val="FFFFFF"/>
-                </a:solidFill>
-              </a:defRPr>
-            </a:lvl4pPr>
-            <a:lvl5pPr algn="l">
-              <a:defRPr sz="3075" b="1" i="0">
-                <a:solidFill>
-                  <a:srgbClr val="FFFFFF"/>
-                </a:solidFill>
-              </a:defRPr>
-            </a:lvl5pPr>
-            <a:lvl6pPr algn="l">
-              <a:defRPr sz="3075" b="1" i="0">
-                <a:solidFill>
-                  <a:srgbClr val="FFFFFF"/>
-                </a:solidFill>
-              </a:defRPr>
-            </a:lvl6pPr>
-            <a:lvl7pPr algn="l">
-              <a:defRPr sz="3075" b="1" i="0">
-                <a:solidFill>
-                  <a:srgbClr val="FFFFFF"/>
-                </a:solidFill>
-              </a:defRPr>
-            </a:lvl7pPr>
-            <a:lvl8pPr algn="l">
-              <a:defRPr sz="3075" b="1" i="0">
-                <a:solidFill>
-                  <a:srgbClr val="FFFFFF"/>
-                </a:solidFill>
-              </a:defRPr>
-            </a:lvl8pPr>
-            <a:lvl9pPr algn="l">
-              <a:defRPr sz="3075" b="1" i="0">
-                <a:solidFill>
-                  <a:srgbClr val="FFFFFF"/>
-                </a:solidFill>
-              </a:defRPr>
-            </a:lvl9pPr>
-          </a:lstStyle>
-          <a:p xmlns:a="http://schemas.openxmlformats.org/drawingml/2006/main">
-            <a:pPr algn="l">
-              <a:defRPr sz="3075" b="1" i="0">
-                <a:solidFill>
-                  <a:srgbClr val="FFFFFF"/>
-                </a:solidFill>
-              </a:defRPr>
-            </a:pPr>
-            <a:r>
-              <a:rPr sz="3075" b="1" i="0">
-                <a:solidFill>
-                  <a:srgbClr val="FFFFFF"/>
-                </a:solidFill>
-              </a:rPr>
-              <a:t>Engineering knowledge,</a:t>
-            </a:r>
-          </a:p>
-          <a:p xmlns:a="http://schemas.openxmlformats.org/drawingml/2006/main">
-            <a:pPr algn="l">
-              <a:defRPr sz="3075" b="1" i="0">
-                <a:solidFill>
-                  <a:srgbClr val="FFFFFF"/>
-                </a:solidFill>
-              </a:defRPr>
-            </a:pPr>
-            <a:r>
-              <a:rPr sz="3075" b="1" i="0">
-                <a:solidFill>
-                  <a:srgbClr val="FFFFFF"/>
-                </a:solidFill>
-              </a:rPr>
-              <a:t>close to the work.</a:t>
-            </a:r>
-          </a:p>
-        </p:txBody>
-      </p:sp>
-      <p:sp>
-        <p:nvSpPr>
-          <p:cNvPr id="3" name="">
-            <a:extLst xmlns:a="http://schemas.openxmlformats.org/drawingml/2006/main">
-              <a:ext uri="{FF2B5EF4-FFF2-40B4-BE49-F238E27FC236}">
-                <a16:creationId xmlns:a16="http://schemas.microsoft.com/office/drawing/2014/main" id="{BD8213E9-5644-4047-95F1-E472A38048AB}"/>
-              </a:ext>
-            </a:extLst>
-          </p:cNvPr>
-          <p:cNvSpPr>
-            <a:spLocks xmlns:a="http://schemas.openxmlformats.org/drawingml/2006/main" noGrp="1"/>
-          </p:cNvSpPr>
-          <p:nvPr/>
-        </p:nvSpPr>
-        <p:spPr>
-          <a:xfrm xmlns:a="http://schemas.openxmlformats.org/drawingml/2006/main">
-            <a:off x="723900" y="4371975"/>
-            <a:ext cx="7734300" cy="666750"/>
-          </a:xfrm>
-          <a:prstGeom xmlns:a="http://schemas.openxmlformats.org/drawingml/2006/main" prst="rect">
-            <a:avLst/>
-          </a:prstGeom>
-          <a:noFill xmlns:a="http://schemas.openxmlformats.org/drawingml/2006/main"/>
-          <a:ln xmlns:a="http://schemas.openxmlformats.org/drawingml/2006/main" w="0">
-            <a:noFill/>
-            <a:prstDash val="solid"/>
-          </a:ln>
-        </p:spPr>
-        <p:txBody>
-          <a:bodyPr xmlns:a="http://schemas.openxmlformats.org/drawingml/2006/main" lIns="0" tIns="0" rIns="0" bIns="0"/>
-          <a:lstStyle xmlns:a="http://schemas.openxmlformats.org/drawingml/2006/main">
-            <a:defPPr algn="l">
-              <a:defRPr sz="2250" b="0" i="0">
-                <a:solidFill>
-                  <a:srgbClr val="BEA06A"/>
-                </a:solidFill>
-              </a:defRPr>
-            </a:defPPr>
-            <a:lvl1pPr algn="l">
-              <a:defRPr sz="2250" b="0" i="0">
-                <a:solidFill>
-                  <a:srgbClr val="BEA06A"/>
-                </a:solidFill>
-              </a:defRPr>
-            </a:lvl1pPr>
-            <a:lvl2pPr algn="l">
-              <a:defRPr sz="2250" b="0" i="0">
-                <a:solidFill>
-                  <a:srgbClr val="BEA06A"/>
-                </a:solidFill>
-              </a:defRPr>
-            </a:lvl2pPr>
-            <a:lvl3pPr algn="l">
-              <a:defRPr sz="2250" b="0" i="0">
-                <a:solidFill>
-                  <a:srgbClr val="BEA06A"/>
-                </a:solidFill>
-              </a:defRPr>
-            </a:lvl3pPr>
-            <a:lvl4pPr algn="l">
-              <a:defRPr sz="2250" b="0" i="0">
-                <a:solidFill>
-                  <a:srgbClr val="BEA06A"/>
-                </a:solidFill>
-              </a:defRPr>
-            </a:lvl4pPr>
-            <a:lvl5pPr algn="l">
-              <a:defRPr sz="2250" b="0" i="0">
-                <a:solidFill>
-                  <a:srgbClr val="BEA06A"/>
-                </a:solidFill>
-              </a:defRPr>
-            </a:lvl5pPr>
-            <a:lvl6pPr algn="l">
-              <a:defRPr sz="2250" b="0" i="0">
-                <a:solidFill>
-                  <a:srgbClr val="BEA06A"/>
-                </a:solidFill>
-              </a:defRPr>
-            </a:lvl6pPr>
-            <a:lvl7pPr algn="l">
-              <a:defRPr sz="2250" b="0" i="0">
-                <a:solidFill>
-                  <a:srgbClr val="BEA06A"/>
-                </a:solidFill>
-              </a:defRPr>
-            </a:lvl7pPr>
-            <a:lvl8pPr algn="l">
-              <a:defRPr sz="2250" b="0" i="0">
-                <a:solidFill>
-                  <a:srgbClr val="BEA06A"/>
-                </a:solidFill>
-              </a:defRPr>
-            </a:lvl8pPr>
-            <a:lvl9pPr algn="l">
-              <a:defRPr sz="2250" b="0" i="0">
-                <a:solidFill>
-                  <a:srgbClr val="BEA06A"/>
-                </a:solidFill>
-              </a:defRPr>
-            </a:lvl9pPr>
-          </a:lstStyle>
-          <a:p xmlns:a="http://schemas.openxmlformats.org/drawingml/2006/main">
-            <a:pPr algn="l">
-              <a:defRPr sz="2250" b="0" i="0">
-                <a:solidFill>
-                  <a:srgbClr val="BEA06A"/>
-                </a:solidFill>
-              </a:defRPr>
-            </a:pPr>
-            <a:r>
-              <a:rPr sz="2250" b="0" i="0">
-                <a:solidFill>
-                  <a:srgbClr val="BEA06A"/>
-                </a:solidFill>
-              </a:rPr>
-              <a:t>Ask. Find project knowledge. Verify.</a:t>
-            </a:r>
-          </a:p>
-        </p:txBody>
-      </p:sp>
-      <p:sp>
-        <p:nvSpPr>
-          <p:cNvPr id="4" name="">
-            <a:extLst xmlns:a="http://schemas.openxmlformats.org/drawingml/2006/main">
-              <a:ext uri="{FF2B5EF4-FFF2-40B4-BE49-F238E27FC236}">
-                <a16:creationId xmlns:a16="http://schemas.microsoft.com/office/drawing/2014/main" id="{8315D9D2-247B-4CDB-982B-84685C618977}"/>
-              </a:ext>
-            </a:extLst>
-          </p:cNvPr>
-          <p:cNvSpPr>
-            <a:spLocks xmlns:a="http://schemas.openxmlformats.org/drawingml/2006/main" noGrp="1"/>
-          </p:cNvSpPr>
-          <p:nvPr/>
-        </p:nvSpPr>
-        <p:spPr>
-          <a:xfrm xmlns:a="http://schemas.openxmlformats.org/drawingml/2006/main">
-            <a:off x="723900" y="5400675"/>
-            <a:ext cx="7677150" cy="476250"/>
-          </a:xfrm>
-          <a:prstGeom xmlns:a="http://schemas.openxmlformats.org/drawingml/2006/main" prst="rect">
-            <a:avLst/>
-          </a:prstGeom>
-          <a:noFill xmlns:a="http://schemas.openxmlformats.org/drawingml/2006/main"/>
-          <a:ln xmlns:a="http://schemas.openxmlformats.org/drawingml/2006/main" w="0">
-            <a:noFill/>
-            <a:prstDash val="solid"/>
-          </a:ln>
-        </p:spPr>
-        <p:txBody>
-          <a:bodyPr xmlns:a="http://schemas.openxmlformats.org/drawingml/2006/main" lIns="0" tIns="0" rIns="0" bIns="0"/>
-          <a:lstStyle xmlns:a="http://schemas.openxmlformats.org/drawingml/2006/main">
-            <a:defPPr algn="l">
-              <a:defRPr sz="1875" b="0" i="0">
-                <a:solidFill>
-                  <a:srgbClr val="D5D8DA"/>
-                </a:solidFill>
-              </a:defRPr>
-            </a:defPPr>
-            <a:lvl1pPr algn="l">
-              <a:defRPr sz="1875" b="0" i="0">
-                <a:solidFill>
-                  <a:srgbClr val="D5D8DA"/>
-                </a:solidFill>
-              </a:defRPr>
-            </a:lvl1pPr>
-            <a:lvl2pPr algn="l">
-              <a:defRPr sz="1875" b="0" i="0">
-                <a:solidFill>
-                  <a:srgbClr val="D5D8DA"/>
-                </a:solidFill>
-              </a:defRPr>
-            </a:lvl2pPr>
-            <a:lvl3pPr algn="l">
-              <a:defRPr sz="1875" b="0" i="0">
-                <a:solidFill>
-                  <a:srgbClr val="D5D8DA"/>
-                </a:solidFill>
-              </a:defRPr>
-            </a:lvl3pPr>
-            <a:lvl4pPr algn="l">
-              <a:defRPr sz="1875" b="0" i="0">
-                <a:solidFill>
-                  <a:srgbClr val="D5D8DA"/>
-                </a:solidFill>
-              </a:defRPr>
-            </a:lvl4pPr>
-            <a:lvl5pPr algn="l">
-              <a:defRPr sz="1875" b="0" i="0">
-                <a:solidFill>
-                  <a:srgbClr val="D5D8DA"/>
-                </a:solidFill>
-              </a:defRPr>
-            </a:lvl5pPr>
-            <a:lvl6pPr algn="l">
-              <a:defRPr sz="1875" b="0" i="0">
-                <a:solidFill>
-                  <a:srgbClr val="D5D8DA"/>
-                </a:solidFill>
-              </a:defRPr>
-            </a:lvl6pPr>
-            <a:lvl7pPr algn="l">
-              <a:defRPr sz="1875" b="0" i="0">
-                <a:solidFill>
-                  <a:srgbClr val="D5D8DA"/>
-                </a:solidFill>
-              </a:defRPr>
-            </a:lvl7pPr>
-            <a:lvl8pPr algn="l">
-              <a:defRPr sz="1875" b="0" i="0">
-                <a:solidFill>
-                  <a:srgbClr val="D5D8DA"/>
-                </a:solidFill>
-              </a:defRPr>
-            </a:lvl8pPr>
-            <a:lvl9pPr algn="l">
-              <a:defRPr sz="1875" b="0" i="0">
-                <a:solidFill>
-                  <a:srgbClr val="D5D8DA"/>
-                </a:solidFill>
-              </a:defRPr>
-            </a:lvl9pPr>
-          </a:lstStyle>
-          <a:p xmlns:a="http://schemas.openxmlformats.org/drawingml/2006/main">
-            <a:pPr algn="l">
-              <a:defRPr sz="1875" b="0" i="0">
-                <a:solidFill>
-                  <a:srgbClr val="D5D8DA"/>
-                </a:solidFill>
-              </a:defRPr>
-            </a:pPr>
-            <a:r>
-              <a:rPr sz="1875" b="0" i="0">
-                <a:solidFill>
-                  <a:srgbClr val="D5D8DA"/>
-                </a:solidFill>
-              </a:rPr>
-              <a:t>Local model and scoped tools for engineering.</a:t>
-            </a:r>
-          </a:p>
-        </p:txBody>
-      </p:sp>
-      <p:sp>
-        <p:nvSpPr>
-          <p:cNvPr id="5" name="">
-            <a:extLst xmlns:a="http://schemas.openxmlformats.org/drawingml/2006/main">
-              <a:ext uri="{FF2B5EF4-FFF2-40B4-BE49-F238E27FC236}">
-                <a16:creationId xmlns:a16="http://schemas.microsoft.com/office/drawing/2014/main" id="{DA675A15-AC6E-4B3B-A3C6-661491364A59}"/>
-              </a:ext>
-            </a:extLst>
-          </p:cNvPr>
-          <p:cNvSpPr>
-            <a:spLocks xmlns:a="http://schemas.openxmlformats.org/drawingml/2006/main" noGrp="1"/>
-          </p:cNvSpPr>
-          <p:nvPr/>
-        </p:nvSpPr>
-        <p:spPr>
-          <a:xfrm xmlns:a="http://schemas.openxmlformats.org/drawingml/2006/main">
-            <a:off x="161925" y="6372225"/>
-            <a:ext cx="552450" cy="419100"/>
-          </a:xfrm>
-          <a:prstGeom xmlns:a="http://schemas.openxmlformats.org/drawingml/2006/main" prst="rect">
-            <a:avLst/>
-          </a:prstGeom>
-          <a:noFill xmlns:a="http://schemas.openxmlformats.org/drawingml/2006/main"/>
-          <a:ln xmlns:a="http://schemas.openxmlformats.org/drawingml/2006/main" w="0">
-            <a:noFill/>
-            <a:prstDash val="solid"/>
-          </a:ln>
-        </p:spPr>
-        <p:txBody>
-          <a:bodyPr xmlns:a="http://schemas.openxmlformats.org/drawingml/2006/main" lIns="0" tIns="0" rIns="0" bIns="0"/>
-          <a:lstStyle xmlns:a="http://schemas.openxmlformats.org/drawingml/2006/main">
-            <a:defPPr algn="l">
-              <a:defRPr sz="1125" b="1" i="0">
-                <a:solidFill>
-                  <a:srgbClr val="000000"/>
-                </a:solidFill>
-              </a:defRPr>
-            </a:defPPr>
-            <a:lvl1pPr algn="l">
-              <a:defRPr sz="1125" b="1" i="0">
-                <a:solidFill>
-                  <a:srgbClr val="000000"/>
-                </a:solidFill>
-              </a:defRPr>
-            </a:lvl1pPr>
-            <a:lvl2pPr algn="l">
-              <a:defRPr sz="1125" b="1" i="0">
-                <a:solidFill>
-                  <a:srgbClr val="000000"/>
-                </a:solidFill>
-              </a:defRPr>
-            </a:lvl2pPr>
-            <a:lvl3pPr algn="l">
-              <a:defRPr sz="1125" b="1" i="0">
-                <a:solidFill>
-                  <a:srgbClr val="000000"/>
-                </a:solidFill>
-              </a:defRPr>
-            </a:lvl3pPr>
-            <a:lvl4pPr algn="l">
-              <a:defRPr sz="1125" b="1" i="0">
-                <a:solidFill>
-                  <a:srgbClr val="000000"/>
-                </a:solidFill>
-              </a:defRPr>
-            </a:lvl4pPr>
-            <a:lvl5pPr algn="l">
-              <a:defRPr sz="1125" b="1" i="0">
-                <a:solidFill>
-                  <a:srgbClr val="000000"/>
-                </a:solidFill>
-              </a:defRPr>
-            </a:lvl5pPr>
-            <a:lvl6pPr algn="l">
-              <a:defRPr sz="1125" b="1" i="0">
-                <a:solidFill>
-                  <a:srgbClr val="000000"/>
-                </a:solidFill>
-              </a:defRPr>
-            </a:lvl6pPr>
-            <a:lvl7pPr algn="l">
-              <a:defRPr sz="1125" b="1" i="0">
-                <a:solidFill>
-                  <a:srgbClr val="000000"/>
-                </a:solidFill>
-              </a:defRPr>
-            </a:lvl7pPr>
-            <a:lvl8pPr algn="l">
-              <a:defRPr sz="1125" b="1" i="0">
-                <a:solidFill>
-                  <a:srgbClr val="000000"/>
-                </a:solidFill>
-              </a:defRPr>
-            </a:lvl8pPr>
-            <a:lvl9pPr algn="l">
-              <a:defRPr sz="1125" b="1" i="0">
-                <a:solidFill>
-                  <a:srgbClr val="000000"/>
-                </a:solidFill>
-              </a:defRPr>
-            </a:lvl9pPr>
-          </a:lstStyle>
-          <a:p xmlns:a="http://schemas.openxmlformats.org/drawingml/2006/main">
-            <a:pPr algn="l">
-              <a:defRPr sz="1125" b="1" i="0">
-                <a:solidFill>
-                  <a:srgbClr val="000000"/>
-                </a:solidFill>
-              </a:defRPr>
-            </a:pPr>
-            <a:r>
-              <a:rPr sz="1125" b="1" i="0">
-                <a:solidFill>
-                  <a:srgbClr val="000000"/>
-                </a:solidFill>
-              </a:rPr>
               <a:t>9</a:t>
             </a:r>
           </a:p>
@@ -18676,7 +19788,7 @@
     </p:spTree>
     <p:extLst>
       <p:ext uri="{BB962C8B-B14F-4D97-AF65-F5344CB8AC3E}">
-        <p14:creationId xmlns:p14="http://schemas.microsoft.com/office/powerpoint/2010/main" val="503739956"/>
+        <p14:creationId xmlns:p14="http://schemas.microsoft.com/office/powerpoint/2010/main" val="1027846116"/>
       </p:ext>
     </p:extLst>
   </p:cSld>

</xml_diff>

<commit_message>
Tell the internship-to-inspection story and finish with 4Founders QR slides
</commit_message>
<xml_diff>
--- a/docs/presentation/Engineering_at_The_Kinetic_Group.pptx
+++ b/docs/presentation/Engineering_at_The_Kinetic_Group.pptx
@@ -21,9 +21,9 @@
     <p:sldId id="267" r:id="Ra95796cf23fc4de1"/>
     <p:sldId id="268" r:id="R49f019004b7f4dca"/>
     <p:sldId id="269" r:id="Rebb456c9b43142af"/>
+    <p:sldId id="272" r:id="R28b51150d6be414c"/>
+    <p:sldId id="271" r:id="Ra26a4f3e169947ab"/>
     <p:sldId id="270" r:id="R0258f44c2015421b"/>
-    <p:sldId id="271" r:id="Ra26a4f3e169947ab"/>
-    <p:sldId id="272" r:id="R28b51150d6be414c"/>
   </p:sldIdLst>
   <p:sldSz cx="9144000" cy="6858000"/>
   <p:notesSz cx="6858000" cy="9144000"/>
@@ -719,7 +719,7 @@
           <a:lstStyle/>
           <a:p>
             <a:r>
-              <a:t>Brad advances slides and watches the clock. Story: their foundation, our engineering, a real result, reliability others can trust.</a:t>
+              <a:t>Story-led talk. Demo 0:16–0:36; close 0:40; homepage QR 0:40–0:41; final-slide activity 0:41–0:49; questions to 1:00.</a:t>
             </a:r>
           </a:p>
           <a:p>
@@ -729,7 +729,7 @@
           </a:p>
           <a:p>
             <a:r>
-              <a:t>Cue: Introductions, internship, and work reaching the floor.</a:t>
+              <a:t>Cue: Introduce the people, then begin where you actually started.</a:t>
             </a:r>
           </a:p>
           <a:p>
@@ -739,7 +739,7 @@
           </a:p>
           <a:p>
             <a:r>
-              <a:t>Brad: “I am Brad Daugherty. I am an electrical engineer at Remington. I work mostly at the Lonoke site but do support projects across our organization. I’m here with Wesley Siharath, who helped start our Remington Vision work. Wesley, tell everyone a little about yourself and how you got started here.”</a:t>
+              <a:t>Brad: “Good morning. I'm Brad Daugherty, an electrical engineer at Remington. Most of my work is in Lonoke, and I support projects across The Kinetic Group. This is Wesley Siharath, who helped start our Remington Vision work.”</a:t>
             </a:r>
           </a:p>
           <a:p>
@@ -749,7 +749,7 @@
           </a:p>
           <a:p>
             <a:r>
-              <a:t>Wesley: “Hi, I’m Wesley Siharath. I’m an engineer here at Remington. I got started as an intern focused on software, with some prototyping on machines.”</a:t>
+              <a:t>“We could spend this hour showing you a list of projects. I want to start with how we got here, because I did not begin as somebody who knew how to build AI systems.”</a:t>
             </a:r>
           </a:p>
           <a:p>
@@ -759,17 +759,7 @@
           </a:p>
           <a:p>
             <a:r>
-              <a:t>“I came on full time this February, and now I work on AI tools and machines. One of the things that drew me here was being able to build a solution and see it put to use on the floor.”</a:t>
-            </a:r>
-          </a:p>
-          <a:p>
-            <a:r>
-              <a:t/>
-            </a:r>
-          </a:p>
-          <a:p>
-            <a:r>
-              <a:t>Brad: “That is the story we want to show: how software becomes something useful on the floor, and what it takes to keep it working.”</a:t>
+              <a:t>Bridge: “I started as a mechanical engineering intern.”</a:t>
             </a:r>
           </a:p>
         </p:txBody>
@@ -839,7 +829,7 @@
           <a:lstStyle/>
           <a:p>
             <a:r>
-              <a:t>Cue: Retrieve project material, generate an answer, check the source.</a:t>
+              <a:t>Cue: Remi / Little Chef. Project knowledge with sources.</a:t>
             </a:r>
           </a:p>
           <a:p>
@@ -859,7 +849,17 @@
           </a:p>
           <a:p>
             <a:r>
-              <a:t>Brad: “Here the integration problem is keeping the answer connected to evidence and controlling what the tools can do.”</a:t>
+              <a:t>Brad: “As the work grows, finding what we already know becomes another engineering problem. We want the answer to stay connected to the evidence behind it.”</a:t>
+            </a:r>
+          </a:p>
+          <a:p>
+            <a:r>
+              <a:t/>
+            </a:r>
+          </a:p>
+          <a:p>
+            <a:r>
+              <a:t>Delivery: Keep this brief. The optional REMI demonstration remains separate and needs a real rehearsal before use.</a:t>
             </a:r>
           </a:p>
         </p:txBody>
@@ -929,7 +929,7 @@
           <a:lstStyle/>
           <a:p>
             <a:r>
-              <a:t>Cue: Variety, freedom, ownership, and a real result. Demo at 0:12.</a:t>
+              <a:t>Cue: Variety, freedom, ownership. Start the demo at 0:16.</a:t>
             </a:r>
           </a:p>
           <a:p>
@@ -969,7 +969,7 @@
           </a:p>
           <a:p>
             <a:r>
-              <a:t>“One moment that really stuck with me was seeing a real reject come through and watching our system toss it out. Seeing something I helped build actually do its job was an amazing feeling.”</a:t>
+              <a:t>“Following ideas through and seeing people get invested feels like helping pave the way for Remington. I enjoy figuring it out.”</a:t>
             </a:r>
           </a:p>
           <a:p>
@@ -979,17 +979,7 @@
           </a:p>
           <a:p>
             <a:r>
-              <a:t>“Following ideas through and seeing people get invested feels like helping pave the way for Remington. I enjoy figuring it out.”</a:t>
-            </a:r>
-          </a:p>
-          <a:p>
-            <a:r>
-              <a:t/>
-            </a:r>
-          </a:p>
-          <a:p>
-            <a:r>
-              <a:t>Brad: “Let's show that connection between an image, a decision, and a visible result.”</a:t>
+              <a:t>Brad: “That is what being given a chance opened up for us. Let's show you a small example of the work.”</a:t>
             </a:r>
           </a:p>
         </p:txBody>
@@ -1059,7 +1049,7 @@
           <a:lstStyle/>
           <a:p>
             <a:r>
-              <a:t>Cue: Detection, color prediction, track, decision, one variation. 0:12–0:32.</a:t>
+              <a:t>Cue: The demo illustrates the story. 0:16–0:36.</a:t>
             </a:r>
           </a:p>
           <a:p>
@@ -1069,7 +1059,7 @@
           </a:p>
           <a:p>
             <a:r>
-              <a:t>Before the event: Rehearse the exact application build, camera, two bottles, and one variation. The repository's standard mode uses YOLOX bottle detection and a trained color model. The generic bundled bottle locator does not predict colors. Describe the mode actually shown. Keep the core demonstration on screen; include physical movement only if the complete event setup has been validated.</a:t>
+              <a:t>Before the event: Rehearse the exact application build, camera, props, and one variation. Describe only the mode being shown. The documented standard sorter uses trained color predictions; a generic bottle locator alone cannot predict colors. A visual-tracking build can show boxes, labels, and track identity without color sorting. Include physical action only after the complete event setup is validated. The event setup is separate from the production inspection systems.</a:t>
             </a:r>
           </a:p>
           <a:p>
@@ -1079,7 +1069,7 @@
           </a:p>
           <a:p>
             <a:r>
-              <a:t>Opening, 2 minutes. Brad: “This is a separate event demo using Gatorade bottles. We detect the bottle, associate evidence with its track, and apply a color rule to produce an on-screen sort decision. First, predict the result. Then we will change one condition and look at what happened.”</a:t>
+              <a:t>Opening, about 2 minutes. Brad: “These bottles give us a simple way to show the kind of work we have been talking about. Watch what the camera sees, what the software produces, and what changes when we change a condition. First, make a prediction.”</a:t>
             </a:r>
           </a:p>
           <a:p>
@@ -1089,7 +1079,7 @@
           </a:p>
           <a:p>
             <a:r>
-              <a:t>Baseline, 4 minutes. Brad states the pass color and asks for predictions for two contrasting bottles. Wesley points out the bottle box, model color prediction, track, and displayed decision. In the standard repository mode, unknown color diverts. Show what this build actually did.</a:t>
+              <a:t>Baseline, about 4 minutes: Show two clear observations or outcomes supported by the actual build. Wesley points to the box, label or model evidence, tracked identity, and any actual decision. If showing a tested sorting mode, Brad states the pass rule and contrasts two bottles. If showing tracking, use the rehearsed identity/position sequence. Call a displayed decision on-screen; describe a physical action only when it actually occurs.</a:t>
             </a:r>
           </a:p>
           <a:p>
@@ -1099,7 +1089,7 @@
           </a:p>
           <a:p>
             <a:r>
-              <a:t>Variation, 4 minutes. Change one pretested orientation or position. Ask for a prediction. Compare the evidence with the baseline. If the result is surprising: “That gives us something useful to test.”</a:t>
+              <a:t>One planned variation, about 4 minutes: Change one rehearsed orientation, position, or other condition. Ask for a prediction and compare the evidence. If surprised: “That gives us something useful to test.”</a:t>
             </a:r>
           </a:p>
           <a:p>
@@ -1109,7 +1099,7 @@
           </a:p>
           <a:p>
             <a:r>
-              <a:t>Engineering discussion, 8 minutes. Brad: “What would you test before relying on this all day?” Wesley connects answers to lighting, missed detections, timing, and the information an operator needs. If confidence comes up, explain that the model score is not automatically a calibrated probability. If physical timing comes up, explain that the demo estimates arrival from distance and measured speed; it does not independently measure physical actuator position.</a:t>
+              <a:t>Guided discussion, about 8 minutes. Brad: “What would you test before asking someone to rely on this all day?” Wesley connects answers to lighting, missed detections, timing, and the operator's evidence. A model score is not automatically a calibrated probability. A timing estimate does not independently establish physical position.</a:t>
             </a:r>
           </a:p>
           <a:p>
@@ -1119,7 +1109,7 @@
           </a:p>
           <a:p>
             <a:r>
-              <a:t>Transition, 2 minutes. Brad: “The image, model, tracking, and response each have to hold up. Wesley's experience on the floor is where those requirements become concrete.” Return to slide 12 by 0:32.</a:t>
+              <a:t>Exit, about 2 minutes. Brad: “You have seen a small version of the problem: make something work, change the conditions, and find out what still needs attention. Wesley, this is where your point about reliability comes in.” Return to slide 12 by 0:36.</a:t>
             </a:r>
           </a:p>
           <a:p>
@@ -1129,7 +1119,7 @@
           </a:p>
           <a:p>
             <a:r>
-              <a:t>Recovery: Show the camera view and last successful result. Ask what the audience would inspect first. Move on within two minutes. Optional barcodes and physical motion are outside the core sequence.</a:t>
+              <a:t>Recovery: Show the camera view and last successful result. Ask what the audience would inspect first. Move on within two minutes. Barcodes, extra features, sentiment, and REMI are not required in this default block.</a:t>
             </a:r>
           </a:p>
         </p:txBody>
@@ -1199,7 +1189,7 @@
           <a:lstStyle/>
           <a:p>
             <a:r>
-              <a:t>Cue: Timing, signals, sunlight, and confidence.</a:t>
+              <a:t>Cue: Reliability is what lets the work leave our hands.</a:t>
             </a:r>
           </a:p>
           <a:p>
@@ -1259,7 +1249,7 @@
           </a:p>
           <a:p>
             <a:r>
-              <a:t>Brad: “That is the step from a prototype we operate ourselves to a system other people can rely on.”</a:t>
+              <a:t>Brad: “That is the difference between something we can demonstrate ourselves and something other people can rely on.”</a:t>
             </a:r>
           </a:p>
         </p:txBody>
@@ -1329,7 +1319,7 @@
           <a:lstStyle/>
           <a:p>
             <a:r>
-              <a:t>Cue: Mechanical, controls, software, and testing. Activity at 0:35.</a:t>
+              <a:t>Cue: Mechanical, controls, software, testing. Invite people who are still learning.</a:t>
             </a:r>
           </a:p>
           <a:p>
@@ -1339,7 +1329,17 @@
           </a:p>
           <a:p>
             <a:r>
-              <a:t>Brad: “These problems cross mechanical engineering, controls, software, and testing. We want people who will follow a problem from the first question through deployment and improvement. Tell us what you have built and what you want to take on next.”</a:t>
+              <a:t>Brad: “I started as a mechanical engineering intern who did not know how to do this. Wesley came in through software and machine prototyping. The work needs mechanical engineering, controls, software, and testing.”</a:t>
+            </a:r>
+          </a:p>
+          <a:p>
+            <a:r>
+              <a:t/>
+            </a:r>
+          </a:p>
+          <a:p>
+            <a:r>
+              <a:t>“Tell us what you have built, what you are trying to learn, and what problem you want to take on. Your starting point may look different from ours.”</a:t>
             </a:r>
           </a:p>
         </p:txBody>
@@ -1409,7 +1409,7 @@
           <a:lstStyle/>
           <a:p>
             <a:r>
-              <a:t>Cue: Scan, PIN, try, share. 0:35–0:43.</a:t>
+              <a:t>Cue: Final slide. Interactive lab QR, URL, and PIN stay visible through questions. 0:41–0:49 activity.</a:t>
             </a:r>
           </a:p>
           <a:p>
@@ -1419,7 +1419,7 @@
           </a:p>
           <a:p>
             <a:r>
-              <a:t>Brad: “Scan the QR code or open the URL on screen. Enter PIN 877262. Try the Audience Lab and notice what matches or surprises your expectations.”</a:t>
+              <a:t>Brad: “Scan this code for the interactive demo, or open 4founders.dev/demo/ai-in-action/. Enter PIN 877262. Try the Audience Lab and notice what matches or surprises your expectations.”</a:t>
             </a:r>
           </a:p>
           <a:p>
@@ -1429,7 +1429,7 @@
           </a:p>
           <a:p>
             <a:r>
-              <a:t>Give 4–5 minutes. Wesley helps with access. Brad keeps the QR and PIN visible, then takes two or three observations. Ask: “What would you change before people used this every day?”</a:t>
+              <a:t>Give 4–5 minutes. Wesley helps with access. Brad keeps the final slide visible, then takes two or three observations: “What would you change before people used this every day?”</a:t>
             </a:r>
           </a:p>
           <a:p>
@@ -1439,7 +1439,47 @@
           </a:p>
           <a:p>
             <a:r>
-              <a:t>Backup URL: 4founders.dev/demo/ai-in-action/ (https://4founders.dev/demo/ai-in-action/). Recheck access and scan before the event. If access fails, show one prepared example and ask the room to predict it.</a:t>
+              <a:t>Brad: “We have time for questions. What are you curious about, or what are you trying to build?” Hold this final slide through 1:00 so the QR and PIN remain available.</a:t>
+            </a:r>
+          </a:p>
+          <a:p>
+            <a:r>
+              <a:t/>
+            </a:r>
+          </a:p>
+          <a:p>
+            <a:r>
+              <a:t>Access fallback: Show one prepared example and ask for a prediction. Recheck the live URL, PIN, and projector scan before the event. The QR destination is verified in the file; service access still needs the event check.</a:t>
+            </a:r>
+          </a:p>
+          <a:p>
+            <a:r>
+              <a:t/>
+            </a:r>
+          </a:p>
+          <a:p>
+            <a:r>
+              <a:t>Brad supplied the internship/OCR story, full-time school in Fayetteville, Friday–Monday work in Lonoke, inspection frustration, Keyence/Cognex experience, new CSG management approval, and call to Wesley in this chat on October 22, 2026. The script presents these as his personal experience, without adding dates, results, or performance comparisons. Wesley's supplied introduction, ownership remarks, real-reject moment, reliability remarks, and invitation are retained; additional story prompts remain his to fill.</a:t>
+            </a:r>
+          </a:p>
+          <a:p>
+            <a:r>
+              <a:t/>
+            </a:r>
+          </a:p>
+          <a:p>
+            <a:r>
+              <a:t>Technical capabilities follow the existing project documentation: RemingtonVision for capture/labeling/YOLOX training and inference; Public Sentiment for VADER/domain scoring and source review; Little Chef README and docs/KNOWLEDGE.md for retrieval, citations, and scoped tools. The bottle demo README (https://github.com/YeChamo/part-tracking-demo-ualr/blob/main/README.md) distinguishes documented modes. No production settings, inspection criteria, accuracy metrics, or private architecture have been added.</a:t>
+            </a:r>
+          </a:p>
+          <a:p>
+            <a:r>
+              <a:t/>
+            </a:r>
+          </a:p>
+          <a:p>
+            <a:r>
+              <a:t>The historical OCR/SCADA anecdote is part of Brad's origin story; a standalone SCADA project slide remains removed. Sentiment and REMI live inserts remain optional and separate. The homepage QR and lab QR have distinct destinations. This revision does not establish hardware or venue readiness.</a:t>
             </a:r>
           </a:p>
         </p:txBody>
@@ -1509,7 +1549,7 @@
           <a:lstStyle/>
           <a:p>
             <a:r>
-              <a:t>Cue: Problem, affected person, first experiment.</a:t>
+              <a:t>Cue: Homepage QR. This is not the interactive lab link. About 1 minute.</a:t>
             </a:r>
           </a:p>
           <a:p>
@@ -1519,7 +1559,27 @@
           </a:p>
           <a:p>
             <a:r>
-              <a:t>Brad: “Your idea may go beyond the projects we showed. Tell us the problem, who it affects, and what you want to try. If there is a fit, let us explore it together.”</a:t>
+              <a:t>Brad: “This code takes you to the 4Founders home page: 4founders.dev. You can open it now or save it for later.”</a:t>
+            </a:r>
+          </a:p>
+          <a:p>
+            <a:r>
+              <a:t/>
+            </a:r>
+          </a:p>
+          <a:p>
+            <a:r>
+              <a:t>Give the room a moment to scan. The QR encodes https://4founders.dev/. Do not describe unverified homepage features. The next slide is the separate event activity.</a:t>
+            </a:r>
+          </a:p>
+          <a:p>
+            <a:r>
+              <a:t/>
+            </a:r>
+          </a:p>
+          <a:p>
+            <a:r>
+              <a:t>Bridge: “The last slide takes you straight to the interactive demo.”</a:t>
             </a:r>
           </a:p>
         </p:txBody>
@@ -1589,7 +1649,7 @@
           <a:lstStyle/>
           <a:p>
             <a:r>
-              <a:t>Cue: awhite@tkghunt.com, questions, internship, and ideas. Hold for questions at 0:44.</a:t>
+              <a:t>Cue: Close the story before the two QR slides. Finish by about 0:40.</a:t>
             </a:r>
           </a:p>
           <a:p>
@@ -1599,7 +1659,7 @@
           </a:p>
           <a:p>
             <a:r>
-              <a:t>Brad: “Reach us at awhite@tkghunt.com. We’ll be here afterward if anyone wants to connect. Wesley, anything you’d like to add?”</a:t>
+              <a:t>Brad: “Reach us at awhite@tkghunt.com. We'll be here afterward. Wesley, anything you'd like to add?”</a:t>
             </a:r>
           </a:p>
           <a:p>
@@ -1619,7 +1679,7 @@
           </a:p>
           <a:p>
             <a:r>
-              <a:t>Brad: “The generations before us built the foundation. We want to build what the next generation can stand on. Our history was made on the factory floor. The future will be, too. Come build and fight with us. Turn AI into action.”</a:t>
+              <a:t>Brad: “We started with a rough OCR application, a problem we could not solve yet, and a chance to try. I called Wesley, and we got to build from there. The generations before us built the foundation. We want to build what the next generation can stand on.”</a:t>
             </a:r>
           </a:p>
           <a:p>
@@ -1629,7 +1689,7 @@
           </a:p>
           <a:p>
             <a:r>
-              <a:t>The supplied deck and Brad's project descriptions establish the company context and that the two inspection systems are live and still being refined. Remington's company history (https://www.remington.com/about-us.html) and employee history (https://www.remington.com/big-green-blog/labor-day-special.html) are the existing sources for the 1816 origin and 1969 Lonoke start.</a:t>
+              <a:t>“Our history was made on the factory floor. The future will be, too. Come build and fight with us. Turn AI into action.”</a:t>
             </a:r>
           </a:p>
           <a:p>
@@ -1639,17 +1699,7 @@
           </a:p>
           <a:p>
             <a:r>
-              <a:t>Technical descriptions were checked against the supplied local project documentation: RemingtonVision README (capture, labeling, YOLOX training/inference, and deployment options); Public Sentiment README (collection, VADER/domain scoring, storage, and dashboard); Little Chef README and docs/KNOWLEDGE.md (local model, retrieval, citations, and scoped tools). These describe software capabilities, not a claim that every feature is deployed on every production line. No inspection criteria, process settings, performance metrics, or production architecture have been added.</a:t>
-            </a:r>
-          </a:p>
-          <a:p>
-            <a:r>
-              <a:t/>
-            </a:r>
-          </a:p>
-          <a:p>
-            <a:r>
-              <a:t>The bottle demo description follows the repository README (https://github.com/YeChamo/part-tracking-demo-ualr/blob/main/README.md). This revision does not establish live hardware, camera, or venue readiness. Wesley supplied his four personal sections; his wording is retained.</a:t>
+              <a:t>Bridge: “Before we finish, here are two ways to keep exploring.”</a:t>
             </a:r>
           </a:p>
         </p:txBody>
@@ -1719,7 +1769,7 @@
           <a:lstStyle/>
           <a:p>
             <a:r>
-              <a:t>Cue: 1816, Lonoke 1969, and our turn to contribute.</a:t>
+              <a:t>Cue: Mechanical intern. Full-time school in Fayetteville. Full-time work in Lonoke, Friday–Monday. OCR.</a:t>
             </a:r>
           </a:p>
           <a:p>
@@ -1729,7 +1779,37 @@
           </a:p>
           <a:p>
             <a:r>
-              <a:t>Brad: “Remington's history goes back to 1816. Lonoke has been part of it since 1969. We inherited generations of work in machinery and manufacturing. Our contribution is to connect that experience with cameras, controls, and software. Remington is one of five TKG ammunition brands, so the problems we support extend beyond one site.”</a:t>
+              <a:t>Brad: “I was a mechanical engineering intern, going to school full time in Fayetteville and working full time in Lonoke, Friday through Monday. I did not know what I was doing yet. I was learning as I went.”</a:t>
+            </a:r>
+          </a:p>
+          <a:p>
+            <a:r>
+              <a:t/>
+            </a:r>
+          </a:p>
+          <a:p>
+            <a:r>
+              <a:t>“The first application was OCR: pulling data off HMI web servers. That was my first AI application, and probably the worst SCADA system the world has ever seen.”</a:t>
+            </a:r>
+          </a:p>
+          <a:p>
+            <a:r>
+              <a:t/>
+            </a:r>
+          </a:p>
+          <a:p>
+            <a:r>
+              <a:t>Delivery: Pause after the joke. Let the room react; do not explain it twice. For anyone unfamiliar with the terms: “OCR reads text from an image. An HMI is the screen people use to see and operate a machine.”</a:t>
+            </a:r>
+          </a:p>
+          <a:p>
+            <a:r>
+              <a:t/>
+            </a:r>
+          </a:p>
+          <a:p>
+            <a:r>
+              <a:t>Brad: “It was rough, but I was building something around a problem I could see. At the same time, I was struggling with inspection projects.”</a:t>
             </a:r>
           </a:p>
         </p:txBody>
@@ -1799,7 +1879,7 @@
           <a:lstStyle/>
           <a:p>
             <a:r>
-              <a:t>Cue: Real machinery, real operators, real consequences.</a:t>
+              <a:t>Cue: Off-the-shelf inspection. Keyence and Cognex. Frustration and perspective.</a:t>
             </a:r>
           </a:p>
           <a:p>
@@ -1809,7 +1889,47 @@
           </a:p>
           <a:p>
             <a:r>
-              <a:t>Brad: “We work around energetic materials and moving machinery. That makes timing, clear information, and recovery part of the engineering problem. We build with operators, maintenance, quality, and safety. The software has to fit their workflow and the established safeguards.”</a:t>
+              <a:t>Brad: “I was working with off-the-shelf inspection systems, including Keyence and Cognex. I was told it was crazy to make our own AI, and that I needed to make the existing solutions work.”</a:t>
+            </a:r>
+          </a:p>
+          <a:p>
+            <a:r>
+              <a:t/>
+            </a:r>
+          </a:p>
+          <a:p>
+            <a:r>
+              <a:t>“I spent nearly a year on it and could not get where I needed to go. I did not fully understand the systems. I felt defeated.”</a:t>
+            </a:r>
+          </a:p>
+          <a:p>
+            <a:r>
+              <a:t/>
+            </a:r>
+          </a:p>
+          <a:p>
+            <a:r>
+              <a:t>“What I did not appreciate at the time was that I was walking in the shoes of experienced engineers who had struggled with these kinds of problems before me. I thought I was the problem.”</a:t>
+            </a:r>
+          </a:p>
+          <a:p>
+            <a:r>
+              <a:t/>
+            </a:r>
+          </a:p>
+          <a:p>
+            <a:r>
+              <a:t>Delivery: This is your experience with that application and your learning at the time. Keep the emphasis on what you struggled to understand and accomplish. Let the pause after “defeated” carry the moment.</a:t>
+            </a:r>
+          </a:p>
+          <a:p>
+            <a:r>
+              <a:t/>
+            </a:r>
+          </a:p>
+          <a:p>
+            <a:r>
+              <a:t>Bridge: “Eventually, I could not keep approaching it the same way.”</a:t>
             </a:r>
           </a:p>
         </p:txBody>
@@ -1879,7 +1999,7 @@
           <a:lstStyle/>
           <a:p>
             <a:r>
-              <a:t>Cue: Capture, inference, decision, response.</a:t>
+              <a:t>Cue: Propose another approach. New CSG management approves. Go get an intern.</a:t>
             </a:r>
           </a:p>
           <a:p>
@@ -1889,7 +2009,37 @@
           </a:p>
           <a:p>
             <a:r>
-              <a:t>Brad: “Sense, decide, act. For a vision system, that means acquiring an image, running inference, interpreting the output, and delivering a result in time for the workflow. A model result is one step in that chain. Camera conditions, signals, software latency, and the response all have to fit together. We test the whole chain and show people the evidence behind the result.”</a:t>
+              <a:t>Brad: “I proposed that we build it ourselves. Under the new CSG management, that proposal was actually approved.”</a:t>
+            </a:r>
+          </a:p>
+          <a:p>
+            <a:r>
+              <a:t/>
+            </a:r>
+          </a:p>
+          <a:p>
+            <a:r>
+              <a:t>“They told me to go get an intern.”</a:t>
+            </a:r>
+          </a:p>
+          <a:p>
+            <a:r>
+              <a:t/>
+            </a:r>
+          </a:p>
+          <a:p>
+            <a:r>
+              <a:t>Delivery: Pause. This is the turn in the story.</a:t>
+            </a:r>
+          </a:p>
+          <a:p>
+            <a:r>
+              <a:t/>
+            </a:r>
+          </a:p>
+          <a:p>
+            <a:r>
+              <a:t>Brad: “So I called Wesley. He decided to come down to central Arkansas and take on the project with me.”</a:t>
             </a:r>
           </a:p>
         </p:txBody>
@@ -1959,7 +2109,7 @@
           <a:lstStyle/>
           <a:p>
             <a:r>
-              <a:t>Cue: Two live inspection systems, two broader capabilities. Finish by 0:05.</a:t>
+              <a:t>Cue: Give Wesley ownership of the next chapter.</a:t>
             </a:r>
           </a:p>
           <a:p>
@@ -1969,7 +2119,47 @@
           </a:p>
           <a:p>
             <a:r>
-              <a:t>Brad: “Centerfire and shotshell inspection are live and still being refined. Public sentiment and Remi apply software to different questions: what customers are saying, and how engineers find project knowledge. The common problem is making the evidence useful to someone making a decision.”</a:t>
+              <a:t>Brad: “Wesley, I've told them how I got to that phone call. Take it from here. Tell them how you got started and where the project went from there.”</a:t>
+            </a:r>
+          </a:p>
+          <a:p>
+            <a:r>
+              <a:t/>
+            </a:r>
+          </a:p>
+          <a:p>
+            <a:r>
+              <a:t>Wesley: “Hi, I’m Wesley Siharath. I’m an engineer here at Remington. I got started as an intern focused on software, with some prototyping on machines.”</a:t>
+            </a:r>
+          </a:p>
+          <a:p>
+            <a:r>
+              <a:t/>
+            </a:r>
+          </a:p>
+          <a:p>
+            <a:r>
+              <a:t>“I came on full time this February, and now I work on AI tools and machines. One of the things that drew me here was being able to build a solution and see it put to use on the floor.”</a:t>
+            </a:r>
+          </a:p>
+          <a:p>
+            <a:r>
+              <a:t/>
+            </a:r>
+          </a:p>
+          <a:p>
+            <a:r>
+              <a:t>Wesley's story slot, 30–60 seconds: [Add your own memory of Brad's call, coming to central Arkansas, or the first problem you tackled together. What did you think you were taking on? Choose one real moment; the short introduction above is enough if you do not add a story.]</a:t>
+            </a:r>
+          </a:p>
+          <a:p>
+            <a:r>
+              <a:t/>
+            </a:r>
+          </a:p>
+          <a:p>
+            <a:r>
+              <a:t>Bridge for Wesley: “The moment that made it real for me was seeing the system do its job.”</a:t>
             </a:r>
           </a:p>
         </p:txBody>
@@ -2039,7 +2229,7 @@
           <a:lstStyle/>
           <a:p>
             <a:r>
-              <a:t>Cue: Vision pipeline, visible evidence, operator trust.</a:t>
+              <a:t>Cue: Centerfire inspection. The real reject is the payoff.</a:t>
             </a:r>
           </a:p>
           <a:p>
@@ -2049,7 +2239,7 @@
           </a:p>
           <a:p>
             <a:r>
-              <a:t>Brad: “Remington Vision brings image capture, labeling, model training, and inference into one toolset. It uses YOLOX detection models and supports workstation and edge deployment. The model is only part of the system. The result has to reach a usable workflow, and people need to understand what the camera saw.”</a:t>
+              <a:t>Wesley: “One moment that really stuck with me was seeing a real reject come through and watching our system toss it out. Seeing something I helped build actually do its job was an amazing feeling.”</a:t>
             </a:r>
           </a:p>
           <a:p>
@@ -2059,6 +2249,26 @@
           </a:p>
           <a:p>
             <a:r>
+              <a:t>Wesley's story slot, up to 30 seconds: [What could the room picture about that moment? Add what you personally saw or felt. Do not invent performance numbers or describe an unapproved inspection criterion.]</a:t>
+            </a:r>
+          </a:p>
+          <a:p>
+            <a:r>
+              <a:t/>
+            </a:r>
+          </a:p>
+          <a:p>
+            <a:r>
+              <a:t>Brad: “That is the connection we had been trying to make: an image, a model result, and something useful happening on the floor. The tools now cover image capture, labeling, model training, and inference with YOLOX detection models.”</a:t>
+            </a:r>
+          </a:p>
+          <a:p>
+            <a:r>
+              <a:t/>
+            </a:r>
+          </a:p>
+          <a:p>
+            <a:r>
               <a:t>Wesley: “On the floor we show operators what the system sees, listen when something is confusing, and make changes they can judge for themselves.”</a:t>
             </a:r>
           </a:p>
@@ -2069,7 +2279,7 @@
           </a:p>
           <a:p>
             <a:r>
-              <a:t>Brad: “That feedback is part of commissioning and continued improvement. It is how the technical result earns trust.”</a:t>
+              <a:t>Brad: “The result working is a milestone. Earning the confidence of the people using it is more work.”</a:t>
             </a:r>
           </a:p>
         </p:txBody>
@@ -2139,7 +2349,7 @@
           <a:lstStyle/>
           <a:p>
             <a:r>
-              <a:t>Cue: A different product changes the image and the data.</a:t>
+              <a:t>Cue: Shotshell inspection. Reuse the tooling; learn the application again.</a:t>
             </a:r>
           </a:p>
           <a:p>
@@ -2159,7 +2369,17 @@
           </a:p>
           <a:p>
             <a:r>
-              <a:t>Brad: “This is also live and being refined. Reusing software still leaves real integration work.”</a:t>
+              <a:t>Optional Wesley story slot: [One short example of something that had to change for the different product. Use an example you are comfortable sharing.]</a:t>
+            </a:r>
+          </a:p>
+          <a:p>
+            <a:r>
+              <a:t/>
+            </a:r>
+          </a:p>
+          <a:p>
+            <a:r>
+              <a:t>Brad: “Centerfire and shotshell inspection are live and still being refined. What we learned on one project gave us a starting point for the next, and the next application still had to earn its result.”</a:t>
             </a:r>
           </a:p>
         </p:txBody>
@@ -2229,7 +2449,7 @@
           <a:lstStyle/>
           <a:p>
             <a:r>
-              <a:t>Cue: Collect, score, retain the source.</a:t>
+              <a:t>Cue: Public sentiment. A brief example of where the same approach led.</a:t>
             </a:r>
           </a:p>
           <a:p>
@@ -2239,7 +2459,27 @@
           </a:p>
           <a:p>
             <a:r>
-              <a:t>Brad: “The sentiment project collects public discussion, scores sentiment and product themes, and stores the results for review. The scoring uses VADER with a domain vocabulary. A trend gives the team somewhere to investigate. Keeping the original comments available lets people check what the score actually represents.”</a:t>
+              <a:t>Brad: “The questions grew beyond images of parts. Sometimes the information is what people are saying publicly about products. The sentiment project collects discussion, uses VADER with domain vocabulary to score it, and keeps the original comments available.”</a:t>
+            </a:r>
+          </a:p>
+          <a:p>
+            <a:r>
+              <a:t/>
+            </a:r>
+          </a:p>
+          <a:p>
+            <a:r>
+              <a:t>“The same lesson applies: give somebody a useful place to investigate, and let them inspect the evidence.”</a:t>
+            </a:r>
+          </a:p>
+          <a:p>
+            <a:r>
+              <a:t/>
+            </a:r>
+          </a:p>
+          <a:p>
+            <a:r>
+              <a:t>Delivery: Keep this to about 30–45 seconds. The optional sentiment demonstration is prepared separately; it is not part of this default sequence.</a:t>
             </a:r>
           </a:p>
         </p:txBody>
@@ -7945,7 +8185,7 @@
                   <a:srgbClr val="FFFFFF"/>
                 </a:solidFill>
               </a:rPr>
-              <a:t>Live demonstration</a:t>
+              <a:t>What we learned, live</a:t>
             </a:r>
           </a:p>
         </p:txBody>
@@ -8207,7 +8447,7 @@
                   <a:srgbClr val="FFFFFF"/>
                 </a:solidFill>
               </a:rPr>
-              <a:t>CAMERA  →  AI  →  ACTION</a:t>
+              <a:t>CAMERA  →  AI  →  RESULT</a:t>
             </a:r>
           </a:p>
         </p:txBody>
@@ -8338,7 +8578,7 @@
                   <a:srgbClr val="BEA06A"/>
                 </a:solidFill>
               </a:rPr>
-              <a:t>Gatorade bottles  ·  on-screen sorting</a:t>
+              <a:t>Gatorade bottles  ·  detection and tracking</a:t>
             </a:r>
           </a:p>
         </p:txBody>
@@ -9823,7 +10063,7 @@
                   <a:srgbClr val="FFFFFF"/>
                 </a:solidFill>
               </a:rPr>
-              <a:t>Come fight for what is next</a:t>
+              <a:t>Your starting point could look different</a:t>
             </a:r>
           </a:p>
         </p:txBody>
@@ -11417,7 +11657,7 @@
                   <a:srgbClr val="FFFFFF"/>
                 </a:solidFill>
               </a:rPr>
-              <a:t>4Founders challenge</a:t>
+              <a:t>Your turn to explore</a:t>
             </a:r>
           </a:p>
         </p:txBody>
@@ -11548,7 +11788,7 @@
                   <a:srgbClr val="000000"/>
                 </a:solidFill>
               </a:rPr>
-              <a:t>14</a:t>
+              <a:t>16</a:t>
             </a:r>
           </a:p>
         </p:txBody>
@@ -11809,6 +12049,7 @@
                 <a:solidFill>
                   <a:srgbClr val="BEA06A"/>
                 </a:solidFill>
+                <a:hlinkClick r:id="rIdStoryWeb"/>
               </a:rPr>
               <a:t>4founders.dev/demo/ai-in-action/</a:t>
             </a:r>
@@ -11823,6 +12064,7 @@
                 <ns2:creationId id="{17A57D48-9186-4AB0-A73C-9A9F9454AD3D}"/>
               </a:ext>
             </a:extLst>
+            <a:hlinkClick r:id="rIdStoryWeb"/>
           </p:cNvPr>
           <p:cNvPicPr>
             <a:picLocks noChangeAspect="1"/>
@@ -12106,7 +12348,7 @@
 </file>
 
 <file path=ppt/slides/slide16.xml><?xml version="1.0" encoding="utf-8"?>
-<p:sld xmlns:a="http://schemas.openxmlformats.org/drawingml/2006/main" xmlns:ns2="http://schemas.microsoft.com/office/drawing/2014/main" xmlns:ns3="http://schemas.microsoft.com/office/powerpoint/2010/main" xmlns:p="http://schemas.openxmlformats.org/presentationml/2006/main">
+<p:sld xmlns:a="http://schemas.openxmlformats.org/drawingml/2006/main" xmlns:ns2="http://schemas.microsoft.com/office/drawing/2014/main" xmlns:ns4="http://schemas.microsoft.com/office/powerpoint/2010/main" xmlns:p="http://schemas.openxmlformats.org/presentationml/2006/main" xmlns:r="http://schemas.openxmlformats.org/officeDocument/2006/relationships">
   <p:cSld>
     <p:spTree>
       <p:nvGrpSpPr>
@@ -12119,10 +12361,10 @@
       </p:grpSpPr>
       <p:sp>
         <p:nvSpPr>
-          <p:cNvPr id="6" name="">
+          <p:cNvPr id="7" name="">
             <a:extLst>
               <a:ext uri="{FF2B5EF4-FFF2-40B4-BE49-F238E27FC236}">
-                <ns2:creationId id="{2C7DA5FD-739D-4644-9148-F19D032919FA}"/>
+                <ns2:creationId id="{287C6A6B-6B23-40C0-AEE8-90C1BFAE7CED}"/>
               </a:ext>
             </a:extLst>
           </p:cNvPr>
@@ -12243,7 +12485,7 @@
                   <a:srgbClr val="FFFFFF"/>
                 </a:solidFill>
               </a:rPr>
-              <a:t>Bring us your idea</a:t>
+              <a:t>Explore 4Founders</a:t>
             </a:r>
           </a:p>
         </p:txBody>
@@ -12253,7 +12495,7 @@
           <p:cNvPr id="2" name="">
             <a:extLst>
               <a:ext uri="{FF2B5EF4-FFF2-40B4-BE49-F238E27FC236}">
-                <ns2:creationId id="{BF7AB287-9579-4376-952A-319BD45DDE16}"/>
+                <ns2:creationId id="{EDC48AD8-F7C5-412A-8DC6-42D0167FFA0F}"/>
               </a:ext>
             </a:extLst>
           </p:cNvPr>
@@ -12384,7 +12626,7 @@
           <p:cNvPr id="3" name="">
             <a:extLst>
               <a:ext uri="{FF2B5EF4-FFF2-40B4-BE49-F238E27FC236}">
-                <ns2:creationId id="{56E2B49B-822B-4239-9D3F-90141AA845C0}"/>
+                <ns2:creationId id="{E76D5AFE-7436-4C33-9D1D-D8D4182FDCF0}"/>
               </a:ext>
             </a:extLst>
           </p:cNvPr>
@@ -12395,8 +12637,300 @@
         </p:nvSpPr>
         <p:spPr>
           <a:xfrm>
-            <a:off x="723900" y="2895600"/>
-            <a:ext cx="7924800" cy="723900"/>
+            <a:off x="723900" y="2876550"/>
+            <a:ext cx="4648200" cy="685800"/>
+          </a:xfrm>
+          <a:prstGeom prst="rect">
+            <a:avLst/>
+          </a:prstGeom>
+          <a:noFill/>
+          <a:ln w="0">
+            <a:noFill/>
+            <a:prstDash val="solid"/>
+          </a:ln>
+        </p:spPr>
+        <p:txBody>
+          <a:bodyPr lIns="0" tIns="0" rIns="0" bIns="0"/>
+          <a:lstStyle>
+            <a:defPPr algn="l">
+              <a:defRPr sz="3225" b="1" i="0">
+                <a:solidFill>
+                  <a:srgbClr val="FFFFFF"/>
+                </a:solidFill>
+              </a:defRPr>
+            </a:defPPr>
+            <a:lvl1pPr algn="l">
+              <a:buNone/>
+              <a:defRPr sz="3225" b="1" i="0">
+                <a:solidFill>
+                  <a:srgbClr val="FFFFFF"/>
+                </a:solidFill>
+              </a:defRPr>
+            </a:lvl1pPr>
+            <a:lvl2pPr algn="l">
+              <a:buNone/>
+              <a:defRPr sz="3225" b="1" i="0">
+                <a:solidFill>
+                  <a:srgbClr val="FFFFFF"/>
+                </a:solidFill>
+              </a:defRPr>
+            </a:lvl2pPr>
+            <a:lvl3pPr algn="l">
+              <a:buNone/>
+              <a:defRPr sz="3225" b="1" i="0">
+                <a:solidFill>
+                  <a:srgbClr val="FFFFFF"/>
+                </a:solidFill>
+              </a:defRPr>
+            </a:lvl3pPr>
+            <a:lvl4pPr algn="l">
+              <a:buNone/>
+              <a:defRPr sz="3225" b="1" i="0">
+                <a:solidFill>
+                  <a:srgbClr val="FFFFFF"/>
+                </a:solidFill>
+              </a:defRPr>
+            </a:lvl4pPr>
+            <a:lvl5pPr algn="l">
+              <a:buNone/>
+              <a:defRPr sz="3225" b="1" i="0">
+                <a:solidFill>
+                  <a:srgbClr val="FFFFFF"/>
+                </a:solidFill>
+              </a:defRPr>
+            </a:lvl5pPr>
+            <a:lvl6pPr algn="l">
+              <a:buNone/>
+              <a:defRPr sz="3225" b="1" i="0">
+                <a:solidFill>
+                  <a:srgbClr val="FFFFFF"/>
+                </a:solidFill>
+              </a:defRPr>
+            </a:lvl6pPr>
+            <a:lvl7pPr algn="l">
+              <a:buNone/>
+              <a:defRPr sz="3225" b="1" i="0">
+                <a:solidFill>
+                  <a:srgbClr val="FFFFFF"/>
+                </a:solidFill>
+              </a:defRPr>
+            </a:lvl7pPr>
+            <a:lvl8pPr algn="l">
+              <a:buNone/>
+              <a:defRPr sz="3225" b="1" i="0">
+                <a:solidFill>
+                  <a:srgbClr val="FFFFFF"/>
+                </a:solidFill>
+              </a:defRPr>
+            </a:lvl8pPr>
+            <a:lvl9pPr algn="l">
+              <a:buNone/>
+              <a:defRPr sz="3225" b="1" i="0">
+                <a:solidFill>
+                  <a:srgbClr val="FFFFFF"/>
+                </a:solidFill>
+              </a:defRPr>
+            </a:lvl9pPr>
+          </a:lstStyle>
+          <a:p>
+            <a:pPr algn="l">
+              <a:buNone/>
+              <a:defRPr sz="3225" b="1" i="0">
+                <a:solidFill>
+                  <a:srgbClr val="FFFFFF"/>
+                </a:solidFill>
+              </a:defRPr>
+            </a:pPr>
+            <a:r>
+              <a:rPr sz="3225" b="1" i="0">
+                <a:solidFill>
+                  <a:srgbClr val="FFFFFF"/>
+                </a:solidFill>
+              </a:rPr>
+              <a:t>Keep exploring</a:t>
+            </a:r>
+          </a:p>
+        </p:txBody>
+      </p:sp>
+      <p:sp>
+        <p:nvSpPr>
+          <p:cNvPr id="4" name="">
+            <a:extLst>
+              <a:ext uri="{FF2B5EF4-FFF2-40B4-BE49-F238E27FC236}">
+                <ns2:creationId id="{BA074521-D12E-4C92-96A7-2ED041BE9680}"/>
+              </a:ext>
+            </a:extLst>
+          </p:cNvPr>
+          <p:cNvSpPr>
+            <a:spLocks noGrp="1"/>
+          </p:cNvSpPr>
+          <p:nvPr/>
+        </p:nvSpPr>
+        <p:spPr>
+          <a:xfrm>
+            <a:off x="723900" y="5295900"/>
+            <a:ext cx="4819650" cy="447675"/>
+          </a:xfrm>
+          <a:prstGeom prst="rect">
+            <a:avLst/>
+          </a:prstGeom>
+          <a:noFill/>
+          <a:ln w="0">
+            <a:noFill/>
+            <a:prstDash val="solid"/>
+          </a:ln>
+        </p:spPr>
+        <p:txBody>
+          <a:bodyPr lIns="0" tIns="0" rIns="0" bIns="0"/>
+          <a:lstStyle>
+            <a:defPPr algn="l">
+              <a:defRPr sz="1875" b="0" i="0">
+                <a:solidFill>
+                  <a:srgbClr val="BEA06A"/>
+                </a:solidFill>
+              </a:defRPr>
+            </a:defPPr>
+            <a:lvl1pPr algn="l">
+              <a:buNone/>
+              <a:defRPr sz="1875" b="0" i="0">
+                <a:solidFill>
+                  <a:srgbClr val="BEA06A"/>
+                </a:solidFill>
+              </a:defRPr>
+            </a:lvl1pPr>
+            <a:lvl2pPr algn="l">
+              <a:buNone/>
+              <a:defRPr sz="1875" b="0" i="0">
+                <a:solidFill>
+                  <a:srgbClr val="BEA06A"/>
+                </a:solidFill>
+              </a:defRPr>
+            </a:lvl2pPr>
+            <a:lvl3pPr algn="l">
+              <a:buNone/>
+              <a:defRPr sz="1875" b="0" i="0">
+                <a:solidFill>
+                  <a:srgbClr val="BEA06A"/>
+                </a:solidFill>
+              </a:defRPr>
+            </a:lvl3pPr>
+            <a:lvl4pPr algn="l">
+              <a:buNone/>
+              <a:defRPr sz="1875" b="0" i="0">
+                <a:solidFill>
+                  <a:srgbClr val="BEA06A"/>
+                </a:solidFill>
+              </a:defRPr>
+            </a:lvl4pPr>
+            <a:lvl5pPr algn="l">
+              <a:buNone/>
+              <a:defRPr sz="1875" b="0" i="0">
+                <a:solidFill>
+                  <a:srgbClr val="BEA06A"/>
+                </a:solidFill>
+              </a:defRPr>
+            </a:lvl5pPr>
+            <a:lvl6pPr algn="l">
+              <a:buNone/>
+              <a:defRPr sz="1875" b="0" i="0">
+                <a:solidFill>
+                  <a:srgbClr val="BEA06A"/>
+                </a:solidFill>
+              </a:defRPr>
+            </a:lvl6pPr>
+            <a:lvl7pPr algn="l">
+              <a:buNone/>
+              <a:defRPr sz="1875" b="0" i="0">
+                <a:solidFill>
+                  <a:srgbClr val="BEA06A"/>
+                </a:solidFill>
+              </a:defRPr>
+            </a:lvl7pPr>
+            <a:lvl8pPr algn="l">
+              <a:buNone/>
+              <a:defRPr sz="1875" b="0" i="0">
+                <a:solidFill>
+                  <a:srgbClr val="BEA06A"/>
+                </a:solidFill>
+              </a:defRPr>
+            </a:lvl8pPr>
+            <a:lvl9pPr algn="l">
+              <a:buNone/>
+              <a:defRPr sz="1875" b="0" i="0">
+                <a:solidFill>
+                  <a:srgbClr val="BEA06A"/>
+                </a:solidFill>
+              </a:defRPr>
+            </a:lvl9pPr>
+          </a:lstStyle>
+          <a:p>
+            <a:pPr algn="l">
+              <a:buNone/>
+              <a:defRPr sz="1875" b="0" i="0">
+                <a:solidFill>
+                  <a:srgbClr val="BEA06A"/>
+                </a:solidFill>
+              </a:defRPr>
+            </a:pPr>
+            <a:r>
+              <a:rPr sz="1875" b="0" i="0">
+                <a:solidFill>
+                  <a:srgbClr val="BEA06A"/>
+                </a:solidFill>
+                <a:hlinkClick r:id="rIdStoryWeb"/>
+              </a:rPr>
+              <a:t>4founders.dev</a:t>
+            </a:r>
+          </a:p>
+        </p:txBody>
+      </p:sp>
+      <p:pic>
+        <p:nvPicPr>
+          <p:cNvPr id="5" name="">
+            <a:extLst>
+              <a:ext uri="{FF2B5EF4-FFF2-40B4-BE49-F238E27FC236}">
+                <ns2:creationId id="{17A57D48-9186-4AB0-A73C-9A9F9454AD3D}"/>
+              </a:ext>
+            </a:extLst>
+            <a:hlinkClick r:id="rIdStoryWeb"/>
+          </p:cNvPr>
+          <p:cNvPicPr>
+            <a:picLocks noChangeAspect="1"/>
+          </p:cNvPicPr>
+          <p:nvPr/>
+        </p:nvPicPr>
+        <p:blipFill>
+          <a:blip r:embed="R8fedd732672d4a84"/>
+          <a:stretch/>
+        </p:blipFill>
+        <p:spPr>
+          <a:xfrm>
+            <a:off x="5753100" y="2590800"/>
+            <a:ext cx="2466975" cy="2466975"/>
+          </a:xfrm>
+          <a:prstGeom prst="rect">
+            <a:avLst/>
+          </a:prstGeom>
+        </p:spPr>
+      </p:pic>
+      <p:sp>
+        <p:nvSpPr>
+          <p:cNvPr id="6" name="">
+            <a:extLst>
+              <a:ext uri="{FF2B5EF4-FFF2-40B4-BE49-F238E27FC236}">
+                <ns2:creationId id="{0A967C52-65BE-4CF8-A216-CA089985A1E8}"/>
+              </a:ext>
+            </a:extLst>
+          </p:cNvPr>
+          <p:cNvSpPr>
+            <a:spLocks noGrp="1"/>
+          </p:cNvSpPr>
+          <p:nvPr/>
+        </p:nvSpPr>
+        <p:spPr>
+          <a:xfrm>
+            <a:off x="5762625" y="5429250"/>
+            <a:ext cx="2762250" cy="657225"/>
           </a:xfrm>
           <a:prstGeom prst="rect">
             <a:avLst/>
@@ -12419,7 +12953,7 @@
             </a:defPPr>
             <a:lvl1pPr algn="l">
               <a:buNone/>
-              <a:defRPr sz="3450" b="1" i="0">
+              <a:defRPr sz="2025" b="1" i="0">
                 <a:solidFill>
                   <a:srgbClr val="FFFFFF"/>
                 </a:solidFill>
@@ -12427,7 +12961,7 @@
             </a:lvl1pPr>
             <a:lvl2pPr algn="l">
               <a:buNone/>
-              <a:defRPr sz="3450" b="1" i="0">
+              <a:defRPr sz="2025" b="1" i="0">
                 <a:solidFill>
                   <a:srgbClr val="FFFFFF"/>
                 </a:solidFill>
@@ -12435,7 +12969,7 @@
             </a:lvl2pPr>
             <a:lvl3pPr algn="l">
               <a:buNone/>
-              <a:defRPr sz="3450" b="1" i="0">
+              <a:defRPr sz="2025" b="1" i="0">
                 <a:solidFill>
                   <a:srgbClr val="FFFFFF"/>
                 </a:solidFill>
@@ -12443,7 +12977,7 @@
             </a:lvl3pPr>
             <a:lvl4pPr algn="l">
               <a:buNone/>
-              <a:defRPr sz="3450" b="1" i="0">
+              <a:defRPr sz="2025" b="1" i="0">
                 <a:solidFill>
                   <a:srgbClr val="FFFFFF"/>
                 </a:solidFill>
@@ -12451,7 +12985,7 @@
             </a:lvl4pPr>
             <a:lvl5pPr algn="l">
               <a:buNone/>
-              <a:defRPr sz="3450" b="1" i="0">
+              <a:defRPr sz="2025" b="1" i="0">
                 <a:solidFill>
                   <a:srgbClr val="FFFFFF"/>
                 </a:solidFill>
@@ -12459,7 +12993,7 @@
             </a:lvl5pPr>
             <a:lvl6pPr algn="l">
               <a:buNone/>
-              <a:defRPr sz="3450" b="1" i="0">
+              <a:defRPr sz="2025" b="1" i="0">
                 <a:solidFill>
                   <a:srgbClr val="FFFFFF"/>
                 </a:solidFill>
@@ -12467,7 +13001,7 @@
             </a:lvl6pPr>
             <a:lvl7pPr algn="l">
               <a:buNone/>
-              <a:defRPr sz="3450" b="1" i="0">
+              <a:defRPr sz="2025" b="1" i="0">
                 <a:solidFill>
                   <a:srgbClr val="FFFFFF"/>
                 </a:solidFill>
@@ -12475,7 +13009,7 @@
             </a:lvl7pPr>
             <a:lvl8pPr algn="l">
               <a:buNone/>
-              <a:defRPr sz="3450" b="1" i="0">
+              <a:defRPr sz="2025" b="1" i="0">
                 <a:solidFill>
                   <a:srgbClr val="FFFFFF"/>
                 </a:solidFill>
@@ -12483,7 +13017,7 @@
             </a:lvl8pPr>
             <a:lvl9pPr algn="l">
               <a:buNone/>
-              <a:defRPr sz="3450" b="1" i="0">
+              <a:defRPr sz="2025" b="1" i="0">
                 <a:solidFill>
                   <a:srgbClr val="FFFFFF"/>
                 </a:solidFill>
@@ -12505,17 +13039,17 @@
                   <a:srgbClr val="FFFFFF"/>
                 </a:solidFill>
               </a:rPr>
-              <a:t>What do you want to pursue?</a:t>
+              <a:t>4Founders</a:t>
             </a:r>
           </a:p>
         </p:txBody>
       </p:sp>
       <p:sp>
         <p:nvSpPr>
-          <p:cNvPr id="4" name="">
+          <p:cNvPr id="8" name="">
             <a:extLst>
               <a:ext uri="{FF2B5EF4-FFF2-40B4-BE49-F238E27FC236}">
-                <ns2:creationId id="{4CFBB8BB-8520-4CA8-A41E-07E3DB8946B4}"/>
+                <ns2:creationId id="{7344E057-B53A-4742-A1BE-84D64E78BC78}"/>
               </a:ext>
             </a:extLst>
           </p:cNvPr>
@@ -12526,8 +13060,8 @@
         </p:nvSpPr>
         <p:spPr>
           <a:xfrm>
-            <a:off x="723900" y="4114800"/>
-            <a:ext cx="7848600" cy="571500"/>
+            <a:off x="5762625" y="5124450"/>
+            <a:ext cx="2762250" cy="285750"/>
           </a:xfrm>
           <a:prstGeom prst="rect">
             <a:avLst/>
@@ -12542,232 +13076,91 @@
           <a:bodyPr lIns="0" tIns="0" rIns="0" bIns="0"/>
           <a:lstStyle>
             <a:defPPr algn="l">
-              <a:defRPr sz="2100" b="0" i="0">
-                <a:solidFill>
-                  <a:srgbClr val="D5D8DA"/>
+              <a:defRPr sz="1575" b="1" i="0">
+                <a:solidFill>
+                  <a:srgbClr val="BEA06A"/>
                 </a:solidFill>
               </a:defRPr>
             </a:defPPr>
             <a:lvl1pPr algn="l">
-              <a:buNone/>
-              <a:defRPr sz="2100" b="0" i="0">
-                <a:solidFill>
-                  <a:srgbClr val="D5D8DA"/>
+              <a:defRPr sz="1575" b="1" i="0">
+                <a:solidFill>
+                  <a:srgbClr val="BEA06A"/>
                 </a:solidFill>
               </a:defRPr>
             </a:lvl1pPr>
             <a:lvl2pPr algn="l">
-              <a:buNone/>
-              <a:defRPr sz="2100" b="0" i="0">
-                <a:solidFill>
-                  <a:srgbClr val="D5D8DA"/>
+              <a:defRPr sz="1575" b="1" i="0">
+                <a:solidFill>
+                  <a:srgbClr val="BEA06A"/>
                 </a:solidFill>
               </a:defRPr>
             </a:lvl2pPr>
             <a:lvl3pPr algn="l">
-              <a:buNone/>
-              <a:defRPr sz="2100" b="0" i="0">
-                <a:solidFill>
-                  <a:srgbClr val="D5D8DA"/>
+              <a:defRPr sz="1575" b="1" i="0">
+                <a:solidFill>
+                  <a:srgbClr val="BEA06A"/>
                 </a:solidFill>
               </a:defRPr>
             </a:lvl3pPr>
             <a:lvl4pPr algn="l">
-              <a:buNone/>
-              <a:defRPr sz="2100" b="0" i="0">
-                <a:solidFill>
-                  <a:srgbClr val="D5D8DA"/>
+              <a:defRPr sz="1575" b="1" i="0">
+                <a:solidFill>
+                  <a:srgbClr val="BEA06A"/>
                 </a:solidFill>
               </a:defRPr>
             </a:lvl4pPr>
             <a:lvl5pPr algn="l">
-              <a:buNone/>
-              <a:defRPr sz="2100" b="0" i="0">
-                <a:solidFill>
-                  <a:srgbClr val="D5D8DA"/>
+              <a:defRPr sz="1575" b="1" i="0">
+                <a:solidFill>
+                  <a:srgbClr val="BEA06A"/>
                 </a:solidFill>
               </a:defRPr>
             </a:lvl5pPr>
             <a:lvl6pPr algn="l">
-              <a:buNone/>
-              <a:defRPr sz="2100" b="0" i="0">
-                <a:solidFill>
-                  <a:srgbClr val="D5D8DA"/>
+              <a:defRPr sz="1575" b="1" i="0">
+                <a:solidFill>
+                  <a:srgbClr val="BEA06A"/>
                 </a:solidFill>
               </a:defRPr>
             </a:lvl6pPr>
             <a:lvl7pPr algn="l">
-              <a:buNone/>
-              <a:defRPr sz="2100" b="0" i="0">
-                <a:solidFill>
-                  <a:srgbClr val="D5D8DA"/>
+              <a:defRPr sz="1575" b="1" i="0">
+                <a:solidFill>
+                  <a:srgbClr val="BEA06A"/>
                 </a:solidFill>
               </a:defRPr>
             </a:lvl7pPr>
             <a:lvl8pPr algn="l">
-              <a:buNone/>
-              <a:defRPr sz="2100" b="0" i="0">
-                <a:solidFill>
-                  <a:srgbClr val="D5D8DA"/>
+              <a:defRPr sz="1575" b="1" i="0">
+                <a:solidFill>
+                  <a:srgbClr val="BEA06A"/>
                 </a:solidFill>
               </a:defRPr>
             </a:lvl8pPr>
             <a:lvl9pPr algn="l">
-              <a:buNone/>
-              <a:defRPr sz="2100" b="0" i="0">
-                <a:solidFill>
-                  <a:srgbClr val="D5D8DA"/>
+              <a:defRPr sz="1575" b="1" i="0">
+                <a:solidFill>
+                  <a:srgbClr val="BEA06A"/>
                 </a:solidFill>
               </a:defRPr>
             </a:lvl9pPr>
           </a:lstStyle>
           <a:p>
             <a:pPr algn="l">
-              <a:buNone/>
-              <a:defRPr sz="2100" b="0" i="0">
-                <a:solidFill>
-                  <a:srgbClr val="D5D8DA"/>
+              <a:defRPr sz="1575" b="1" i="0">
+                <a:solidFill>
+                  <a:srgbClr val="BEA06A"/>
                 </a:solidFill>
               </a:defRPr>
             </a:pPr>
             <a:r>
-              <a:rPr sz="2100" b="0" i="0">
-                <a:solidFill>
-                  <a:srgbClr val="D5D8DA"/>
+              <a:rPr sz="1575" b="1" i="0">
+                <a:solidFill>
+                  <a:srgbClr val="BEA06A"/>
                 </a:solidFill>
               </a:rPr>
-              <a:t>If there is a fit, let us explore it together.</a:t>
-            </a:r>
-          </a:p>
-        </p:txBody>
-      </p:sp>
-      <p:sp>
-        <p:nvSpPr>
-          <p:cNvPr id="5" name="">
-            <a:extLst>
-              <a:ext uri="{FF2B5EF4-FFF2-40B4-BE49-F238E27FC236}">
-                <ns2:creationId id="{1596F5A7-D059-44DA-A1C5-74978F5E65C4}"/>
-              </a:ext>
-            </a:extLst>
-          </p:cNvPr>
-          <p:cNvSpPr>
-            <a:spLocks noGrp="1"/>
-          </p:cNvSpPr>
-          <p:nvPr/>
-        </p:nvSpPr>
-        <p:spPr>
-          <a:xfrm>
-            <a:off x="723900" y="5210175"/>
-            <a:ext cx="7905750" cy="571500"/>
-          </a:xfrm>
-          <a:prstGeom prst="rect">
-            <a:avLst/>
-          </a:prstGeom>
-          <a:noFill/>
-          <a:ln w="0">
-            <a:noFill/>
-            <a:prstDash val="solid"/>
-          </a:ln>
-        </p:spPr>
-        <p:txBody>
-          <a:bodyPr lIns="0" tIns="0" rIns="0" bIns="0"/>
-          <a:lstStyle>
-            <a:defPPr algn="l">
-              <a:defRPr sz="2325" b="1" i="0">
-                <a:solidFill>
-                  <a:srgbClr val="BEA06A"/>
-                </a:solidFill>
-              </a:defRPr>
-            </a:defPPr>
-            <a:lvl1pPr algn="l">
-              <a:buNone/>
-              <a:defRPr sz="2325" b="1" i="0">
-                <a:solidFill>
-                  <a:srgbClr val="BEA06A"/>
-                </a:solidFill>
-              </a:defRPr>
-            </a:lvl1pPr>
-            <a:lvl2pPr algn="l">
-              <a:buNone/>
-              <a:defRPr sz="2325" b="1" i="0">
-                <a:solidFill>
-                  <a:srgbClr val="BEA06A"/>
-                </a:solidFill>
-              </a:defRPr>
-            </a:lvl2pPr>
-            <a:lvl3pPr algn="l">
-              <a:buNone/>
-              <a:defRPr sz="2325" b="1" i="0">
-                <a:solidFill>
-                  <a:srgbClr val="BEA06A"/>
-                </a:solidFill>
-              </a:defRPr>
-            </a:lvl3pPr>
-            <a:lvl4pPr algn="l">
-              <a:buNone/>
-              <a:defRPr sz="2325" b="1" i="0">
-                <a:solidFill>
-                  <a:srgbClr val="BEA06A"/>
-                </a:solidFill>
-              </a:defRPr>
-            </a:lvl4pPr>
-            <a:lvl5pPr algn="l">
-              <a:buNone/>
-              <a:defRPr sz="2325" b="1" i="0">
-                <a:solidFill>
-                  <a:srgbClr val="BEA06A"/>
-                </a:solidFill>
-              </a:defRPr>
-            </a:lvl5pPr>
-            <a:lvl6pPr algn="l">
-              <a:buNone/>
-              <a:defRPr sz="2325" b="1" i="0">
-                <a:solidFill>
-                  <a:srgbClr val="BEA06A"/>
-                </a:solidFill>
-              </a:defRPr>
-            </a:lvl6pPr>
-            <a:lvl7pPr algn="l">
-              <a:buNone/>
-              <a:defRPr sz="2325" b="1" i="0">
-                <a:solidFill>
-                  <a:srgbClr val="BEA06A"/>
-                </a:solidFill>
-              </a:defRPr>
-            </a:lvl7pPr>
-            <a:lvl8pPr algn="l">
-              <a:buNone/>
-              <a:defRPr sz="2325" b="1" i="0">
-                <a:solidFill>
-                  <a:srgbClr val="BEA06A"/>
-                </a:solidFill>
-              </a:defRPr>
-            </a:lvl8pPr>
-            <a:lvl9pPr algn="l">
-              <a:buNone/>
-              <a:defRPr sz="2325" b="1" i="0">
-                <a:solidFill>
-                  <a:srgbClr val="BEA06A"/>
-                </a:solidFill>
-              </a:defRPr>
-            </a:lvl9pPr>
-          </a:lstStyle>
-          <a:p>
-            <a:pPr algn="l">
-              <a:buNone/>
-              <a:defRPr sz="2325" b="1" i="0">
-                <a:solidFill>
-                  <a:srgbClr val="BEA06A"/>
-                </a:solidFill>
-              </a:defRPr>
-            </a:pPr>
-            <a:r>
-              <a:rPr sz="2325" b="1" i="0">
-                <a:solidFill>
-                  <a:srgbClr val="BEA06A"/>
-                </a:solidFill>
-              </a:rPr>
-              <a:t>Let's start a conversation.</a:t>
+              <a:t>HOMEPAGE</a:t>
             </a:r>
           </a:p>
         </p:txBody>
@@ -12775,7 +13168,7 @@
     </p:spTree>
     <p:extLst>
       <p:ext uri="{BB962C8B-B14F-4D97-AF65-F5344CB8AC3E}">
-        <ns3:creationId val="50657743"/>
+        <ns4:creationId val="23656252"/>
       </p:ext>
     </p:extLst>
   </p:cSld>
@@ -13051,7 +13444,7 @@
                   <a:srgbClr val="000000"/>
                 </a:solidFill>
               </a:rPr>
-              <a:t>16</a:t>
+              <a:t>14</a:t>
             </a:r>
           </a:p>
         </p:txBody>
@@ -13478,7 +13871,7 @@
 </file>
 
 <file path=ppt/slides/slide2.xml><?xml version="1.0" encoding="utf-8"?>
-<p:sld xmlns:p="http://schemas.openxmlformats.org/presentationml/2006/main">
+<p:sld xmlns:a="http://schemas.openxmlformats.org/drawingml/2006/main" xmlns:ns2="http://schemas.microsoft.com/office/drawing/2014/main" xmlns:ns3="http://schemas.microsoft.com/office/powerpoint/2010/main" xmlns:p="http://schemas.openxmlformats.org/presentationml/2006/main">
   <p:cSld>
     <p:spTree>
       <p:nvGrpSpPr>
@@ -13487,39 +13880,39 @@
         <p:nvPr/>
       </p:nvGrpSpPr>
       <p:grpSpPr>
-        <a:xfrm xmlns:a="http://schemas.openxmlformats.org/drawingml/2006/main"/>
+        <a:xfrm/>
       </p:grpSpPr>
       <p:sp>
         <p:nvSpPr>
           <p:cNvPr id="10" name="">
-            <a:extLst xmlns:a="http://schemas.openxmlformats.org/drawingml/2006/main">
+            <a:extLst>
               <a:ext uri="{FF2B5EF4-FFF2-40B4-BE49-F238E27FC236}">
-                <a16:creationId xmlns:a16="http://schemas.microsoft.com/office/drawing/2014/main" id="{0AC693DC-ADB3-44BD-B760-D12C9945D0C8}"/>
+                <ns2:creationId id="{0AC693DC-ADB3-44BD-B760-D12C9945D0C8}"/>
               </a:ext>
             </a:extLst>
           </p:cNvPr>
           <p:cNvSpPr>
-            <a:spLocks xmlns:a="http://schemas.openxmlformats.org/drawingml/2006/main" noGrp="1"/>
+            <a:spLocks noGrp="1"/>
           </p:cNvSpPr>
           <p:nvPr/>
         </p:nvSpPr>
         <p:spPr>
-          <a:xfrm xmlns:a="http://schemas.openxmlformats.org/drawingml/2006/main">
+          <a:xfrm>
             <a:off x="704850" y="1495425"/>
             <a:ext cx="7743825" cy="619125"/>
           </a:xfrm>
-          <a:prstGeom xmlns:a="http://schemas.openxmlformats.org/drawingml/2006/main" prst="rect">
+          <a:prstGeom prst="rect">
             <a:avLst/>
           </a:prstGeom>
-          <a:noFill xmlns:a="http://schemas.openxmlformats.org/drawingml/2006/main"/>
-          <a:ln xmlns:a="http://schemas.openxmlformats.org/drawingml/2006/main" w="0">
+          <a:noFill/>
+          <a:ln w="0">
             <a:noFill/>
             <a:prstDash val="solid"/>
           </a:ln>
         </p:spPr>
         <p:txBody>
-          <a:bodyPr xmlns:a="http://schemas.openxmlformats.org/drawingml/2006/main" lIns="0" tIns="0" rIns="0" bIns="0"/>
-          <a:lstStyle xmlns:a="http://schemas.openxmlformats.org/drawingml/2006/main">
+          <a:bodyPr lIns="0" tIns="0" rIns="0" bIns="0"/>
+          <a:lstStyle>
             <a:defPPr algn="l">
               <a:defRPr sz="3000" b="0" i="0">
                 <a:solidFill>
@@ -13600,7 +13993,7 @@
               </a:defRPr>
             </a:lvl9pPr>
           </a:lstStyle>
-          <a:p xmlns:a="http://schemas.openxmlformats.org/drawingml/2006/main">
+          <a:p>
             <a:pPr algn="l">
               <a:buNone/>
               <a:defRPr sz="3000" b="0" i="0">
@@ -13615,7 +14008,7 @@
                   <a:srgbClr val="FFFFFF"/>
                 </a:solidFill>
               </a:rPr>
-              <a:t>Writing the next rules</a:t>
+              <a:t>My first AI application</a:t>
             </a:r>
           </a:p>
         </p:txBody>
@@ -13623,34 +14016,34 @@
       <p:sp>
         <p:nvSpPr>
           <p:cNvPr id="2" name="">
-            <a:extLst xmlns:a="http://schemas.openxmlformats.org/drawingml/2006/main">
+            <a:extLst>
               <a:ext uri="{FF2B5EF4-FFF2-40B4-BE49-F238E27FC236}">
-                <a16:creationId xmlns:a16="http://schemas.microsoft.com/office/drawing/2014/main" id="{12D3E71C-AF76-4283-BA53-B68DB0444A6C}"/>
+                <ns2:creationId id="{12D3E71C-AF76-4283-BA53-B68DB0444A6C}"/>
               </a:ext>
             </a:extLst>
           </p:cNvPr>
           <p:cNvSpPr>
-            <a:spLocks xmlns:a="http://schemas.openxmlformats.org/drawingml/2006/main" noGrp="1"/>
+            <a:spLocks noGrp="1"/>
           </p:cNvSpPr>
           <p:nvPr/>
         </p:nvSpPr>
         <p:spPr>
-          <a:xfrm xmlns:a="http://schemas.openxmlformats.org/drawingml/2006/main">
+          <a:xfrm>
             <a:off x="161925" y="6372225"/>
             <a:ext cx="552450" cy="419100"/>
           </a:xfrm>
-          <a:prstGeom xmlns:a="http://schemas.openxmlformats.org/drawingml/2006/main" prst="rect">
+          <a:prstGeom prst="rect">
             <a:avLst/>
           </a:prstGeom>
-          <a:noFill xmlns:a="http://schemas.openxmlformats.org/drawingml/2006/main"/>
-          <a:ln xmlns:a="http://schemas.openxmlformats.org/drawingml/2006/main" w="0">
+          <a:noFill/>
+          <a:ln w="0">
             <a:noFill/>
             <a:prstDash val="solid"/>
           </a:ln>
         </p:spPr>
         <p:txBody>
-          <a:bodyPr xmlns:a="http://schemas.openxmlformats.org/drawingml/2006/main" lIns="0" tIns="0" rIns="0" bIns="0"/>
-          <a:lstStyle xmlns:a="http://schemas.openxmlformats.org/drawingml/2006/main">
+          <a:bodyPr lIns="0" tIns="0" rIns="0" bIns="0"/>
+          <a:lstStyle>
             <a:defPPr algn="l">
               <a:defRPr sz="1125" b="1" i="0">
                 <a:solidFill>
@@ -13731,7 +14124,7 @@
               </a:defRPr>
             </a:lvl9pPr>
           </a:lstStyle>
-          <a:p xmlns:a="http://schemas.openxmlformats.org/drawingml/2006/main">
+          <a:p>
             <a:pPr algn="l">
               <a:buNone/>
               <a:defRPr sz="1125" b="1" i="0">
@@ -13754,34 +14147,34 @@
       <p:sp>
         <p:nvSpPr>
           <p:cNvPr id="3" name="">
-            <a:extLst xmlns:a="http://schemas.openxmlformats.org/drawingml/2006/main">
+            <a:extLst>
               <a:ext uri="{FF2B5EF4-FFF2-40B4-BE49-F238E27FC236}">
-                <a16:creationId xmlns:a16="http://schemas.microsoft.com/office/drawing/2014/main" id="{49832774-3187-4D2C-A6F6-52F25DFA0796}"/>
+                <ns2:creationId id="{49832774-3187-4D2C-A6F6-52F25DFA0796}"/>
               </a:ext>
             </a:extLst>
           </p:cNvPr>
           <p:cNvSpPr>
-            <a:spLocks xmlns:a="http://schemas.openxmlformats.org/drawingml/2006/main" noGrp="1"/>
+            <a:spLocks noGrp="1"/>
           </p:cNvSpPr>
           <p:nvPr/>
         </p:nvSpPr>
         <p:spPr>
-          <a:xfrm xmlns:a="http://schemas.openxmlformats.org/drawingml/2006/main">
+          <a:xfrm>
             <a:off x="723900" y="2781300"/>
             <a:ext cx="2476500" cy="742950"/>
           </a:xfrm>
-          <a:prstGeom xmlns:a="http://schemas.openxmlformats.org/drawingml/2006/main" prst="rect">
+          <a:prstGeom prst="rect">
             <a:avLst/>
           </a:prstGeom>
-          <a:noFill xmlns:a="http://schemas.openxmlformats.org/drawingml/2006/main"/>
-          <a:ln xmlns:a="http://schemas.openxmlformats.org/drawingml/2006/main" w="0">
+          <a:noFill/>
+          <a:ln w="0">
             <a:noFill/>
             <a:prstDash val="solid"/>
           </a:ln>
         </p:spPr>
         <p:txBody>
-          <a:bodyPr xmlns:a="http://schemas.openxmlformats.org/drawingml/2006/main" lIns="0" tIns="0" rIns="0" bIns="0"/>
-          <a:lstStyle xmlns:a="http://schemas.openxmlformats.org/drawingml/2006/main">
+          <a:bodyPr lIns="0" tIns="0" rIns="0" bIns="0"/>
+          <a:lstStyle>
             <a:defPPr algn="l">
               <a:defRPr sz="4200" b="1" i="0">
                 <a:solidFill>
@@ -13862,7 +14255,7 @@
               </a:defRPr>
             </a:lvl9pPr>
           </a:lstStyle>
-          <a:p xmlns:a="http://schemas.openxmlformats.org/drawingml/2006/main">
+          <a:p>
             <a:pPr algn="l">
               <a:buNone/>
               <a:defRPr sz="4200" b="1" i="0">
@@ -13877,7 +14270,7 @@
                   <a:srgbClr val="BEA06A"/>
                 </a:solidFill>
               </a:rPr>
-              <a:t>1816</a:t>
+              <a:t>SCHOOL</a:t>
             </a:r>
           </a:p>
         </p:txBody>
@@ -13885,34 +14278,34 @@
       <p:sp>
         <p:nvSpPr>
           <p:cNvPr id="4" name="">
-            <a:extLst xmlns:a="http://schemas.openxmlformats.org/drawingml/2006/main">
+            <a:extLst>
               <a:ext uri="{FF2B5EF4-FFF2-40B4-BE49-F238E27FC236}">
-                <a16:creationId xmlns:a16="http://schemas.microsoft.com/office/drawing/2014/main" id="{421BD8B3-06FE-4F59-B92D-DF17072E027D}"/>
+                <ns2:creationId id="{421BD8B3-06FE-4F59-B92D-DF17072E027D}"/>
               </a:ext>
             </a:extLst>
           </p:cNvPr>
           <p:cNvSpPr>
-            <a:spLocks xmlns:a="http://schemas.openxmlformats.org/drawingml/2006/main" noGrp="1"/>
+            <a:spLocks noGrp="1"/>
           </p:cNvSpPr>
           <p:nvPr/>
         </p:nvSpPr>
         <p:spPr>
-          <a:xfrm xmlns:a="http://schemas.openxmlformats.org/drawingml/2006/main">
+          <a:xfrm>
             <a:off x="723900" y="3600450"/>
             <a:ext cx="2571750" cy="447675"/>
           </a:xfrm>
-          <a:prstGeom xmlns:a="http://schemas.openxmlformats.org/drawingml/2006/main" prst="rect">
+          <a:prstGeom prst="rect">
             <a:avLst/>
           </a:prstGeom>
-          <a:noFill xmlns:a="http://schemas.openxmlformats.org/drawingml/2006/main"/>
-          <a:ln xmlns:a="http://schemas.openxmlformats.org/drawingml/2006/main" w="0">
+          <a:noFill/>
+          <a:ln w="0">
             <a:noFill/>
             <a:prstDash val="solid"/>
           </a:ln>
         </p:spPr>
         <p:txBody>
-          <a:bodyPr xmlns:a="http://schemas.openxmlformats.org/drawingml/2006/main" lIns="0" tIns="0" rIns="0" bIns="0"/>
-          <a:lstStyle xmlns:a="http://schemas.openxmlformats.org/drawingml/2006/main">
+          <a:bodyPr lIns="0" tIns="0" rIns="0" bIns="0"/>
+          <a:lstStyle>
             <a:defPPr algn="l">
               <a:defRPr sz="1875" b="0" i="0">
                 <a:solidFill>
@@ -13993,7 +14386,7 @@
               </a:defRPr>
             </a:lvl9pPr>
           </a:lstStyle>
-          <a:p xmlns:a="http://schemas.openxmlformats.org/drawingml/2006/main">
+          <a:p>
             <a:pPr algn="l">
               <a:buNone/>
               <a:defRPr sz="1875" b="0" i="0">
@@ -14008,7 +14401,7 @@
                   <a:srgbClr val="FFFFFF"/>
                 </a:solidFill>
               </a:rPr>
-              <a:t>Remington</a:t>
+              <a:t>Fayetteville</a:t>
             </a:r>
           </a:p>
         </p:txBody>
@@ -14016,34 +14409,34 @@
       <p:sp>
         <p:nvSpPr>
           <p:cNvPr id="5" name="">
-            <a:extLst xmlns:a="http://schemas.openxmlformats.org/drawingml/2006/main">
+            <a:extLst>
               <a:ext uri="{FF2B5EF4-FFF2-40B4-BE49-F238E27FC236}">
-                <a16:creationId xmlns:a16="http://schemas.microsoft.com/office/drawing/2014/main" id="{764AA312-8600-4239-839A-62BFEBAC26C2}"/>
+                <ns2:creationId id="{764AA312-8600-4239-839A-62BFEBAC26C2}"/>
               </a:ext>
             </a:extLst>
           </p:cNvPr>
           <p:cNvSpPr>
-            <a:spLocks xmlns:a="http://schemas.openxmlformats.org/drawingml/2006/main" noGrp="1"/>
+            <a:spLocks noGrp="1"/>
           </p:cNvSpPr>
           <p:nvPr/>
         </p:nvSpPr>
         <p:spPr>
-          <a:xfrm xmlns:a="http://schemas.openxmlformats.org/drawingml/2006/main">
+          <a:xfrm>
             <a:off x="3429000" y="2781300"/>
             <a:ext cx="2476500" cy="742950"/>
           </a:xfrm>
-          <a:prstGeom xmlns:a="http://schemas.openxmlformats.org/drawingml/2006/main" prst="rect">
+          <a:prstGeom prst="rect">
             <a:avLst/>
           </a:prstGeom>
-          <a:noFill xmlns:a="http://schemas.openxmlformats.org/drawingml/2006/main"/>
-          <a:ln xmlns:a="http://schemas.openxmlformats.org/drawingml/2006/main" w="0">
+          <a:noFill/>
+          <a:ln w="0">
             <a:noFill/>
             <a:prstDash val="solid"/>
           </a:ln>
         </p:spPr>
         <p:txBody>
-          <a:bodyPr xmlns:a="http://schemas.openxmlformats.org/drawingml/2006/main" lIns="0" tIns="0" rIns="0" bIns="0"/>
-          <a:lstStyle xmlns:a="http://schemas.openxmlformats.org/drawingml/2006/main">
+          <a:bodyPr lIns="0" tIns="0" rIns="0" bIns="0"/>
+          <a:lstStyle>
             <a:defPPr algn="l">
               <a:defRPr sz="4200" b="1" i="0">
                 <a:solidFill>
@@ -14124,7 +14517,7 @@
               </a:defRPr>
             </a:lvl9pPr>
           </a:lstStyle>
-          <a:p xmlns:a="http://schemas.openxmlformats.org/drawingml/2006/main">
+          <a:p>
             <a:pPr algn="l">
               <a:buNone/>
               <a:defRPr sz="4200" b="1" i="0">
@@ -14139,7 +14532,7 @@
                   <a:srgbClr val="BEA06A"/>
                 </a:solidFill>
               </a:rPr>
-              <a:t>1969</a:t>
+              <a:t>WORK</a:t>
             </a:r>
           </a:p>
         </p:txBody>
@@ -14147,34 +14540,34 @@
       <p:sp>
         <p:nvSpPr>
           <p:cNvPr id="6" name="">
-            <a:extLst xmlns:a="http://schemas.openxmlformats.org/drawingml/2006/main">
+            <a:extLst>
               <a:ext uri="{FF2B5EF4-FFF2-40B4-BE49-F238E27FC236}">
-                <a16:creationId xmlns:a16="http://schemas.microsoft.com/office/drawing/2014/main" id="{20E15801-E743-4600-BC18-DB830F99A579}"/>
+                <ns2:creationId id="{20E15801-E743-4600-BC18-DB830F99A579}"/>
               </a:ext>
             </a:extLst>
           </p:cNvPr>
           <p:cNvSpPr>
-            <a:spLocks xmlns:a="http://schemas.openxmlformats.org/drawingml/2006/main" noGrp="1"/>
+            <a:spLocks noGrp="1"/>
           </p:cNvSpPr>
           <p:nvPr/>
         </p:nvSpPr>
         <p:spPr>
-          <a:xfrm xmlns:a="http://schemas.openxmlformats.org/drawingml/2006/main">
+          <a:xfrm>
             <a:off x="3429000" y="3600450"/>
             <a:ext cx="2571750" cy="447675"/>
           </a:xfrm>
-          <a:prstGeom xmlns:a="http://schemas.openxmlformats.org/drawingml/2006/main" prst="rect">
+          <a:prstGeom prst="rect">
             <a:avLst/>
           </a:prstGeom>
-          <a:noFill xmlns:a="http://schemas.openxmlformats.org/drawingml/2006/main"/>
-          <a:ln xmlns:a="http://schemas.openxmlformats.org/drawingml/2006/main" w="0">
+          <a:noFill/>
+          <a:ln w="0">
             <a:noFill/>
             <a:prstDash val="solid"/>
           </a:ln>
         </p:spPr>
         <p:txBody>
-          <a:bodyPr xmlns:a="http://schemas.openxmlformats.org/drawingml/2006/main" lIns="0" tIns="0" rIns="0" bIns="0"/>
-          <a:lstStyle xmlns:a="http://schemas.openxmlformats.org/drawingml/2006/main">
+          <a:bodyPr lIns="0" tIns="0" rIns="0" bIns="0"/>
+          <a:lstStyle>
             <a:defPPr algn="l">
               <a:defRPr sz="1875" b="0" i="0">
                 <a:solidFill>
@@ -14255,7 +14648,7 @@
               </a:defRPr>
             </a:lvl9pPr>
           </a:lstStyle>
-          <a:p xmlns:a="http://schemas.openxmlformats.org/drawingml/2006/main">
+          <a:p>
             <a:pPr algn="l">
               <a:buNone/>
               <a:defRPr sz="1875" b="0" i="0">
@@ -14270,7 +14663,7 @@
                   <a:srgbClr val="FFFFFF"/>
                 </a:solidFill>
               </a:rPr>
-              <a:t>Lonoke, Arkansas</a:t>
+              <a:t>Lonoke, Fri–Mon</a:t>
             </a:r>
           </a:p>
         </p:txBody>
@@ -14278,34 +14671,34 @@
       <p:sp>
         <p:nvSpPr>
           <p:cNvPr id="7" name="">
-            <a:extLst xmlns:a="http://schemas.openxmlformats.org/drawingml/2006/main">
+            <a:extLst>
               <a:ext uri="{FF2B5EF4-FFF2-40B4-BE49-F238E27FC236}">
-                <a16:creationId xmlns:a16="http://schemas.microsoft.com/office/drawing/2014/main" id="{D177DCFC-C46C-479B-87AD-CF5C7CAB4F2F}"/>
+                <ns2:creationId id="{D177DCFC-C46C-479B-87AD-CF5C7CAB4F2F}"/>
               </a:ext>
             </a:extLst>
           </p:cNvPr>
           <p:cNvSpPr>
-            <a:spLocks xmlns:a="http://schemas.openxmlformats.org/drawingml/2006/main" noGrp="1"/>
+            <a:spLocks noGrp="1"/>
           </p:cNvSpPr>
           <p:nvPr/>
         </p:nvSpPr>
         <p:spPr>
-          <a:xfrm xmlns:a="http://schemas.openxmlformats.org/drawingml/2006/main">
+          <a:xfrm>
             <a:off x="6210300" y="2781300"/>
             <a:ext cx="2476500" cy="742950"/>
           </a:xfrm>
-          <a:prstGeom xmlns:a="http://schemas.openxmlformats.org/drawingml/2006/main" prst="rect">
+          <a:prstGeom prst="rect">
             <a:avLst/>
           </a:prstGeom>
-          <a:noFill xmlns:a="http://schemas.openxmlformats.org/drawingml/2006/main"/>
-          <a:ln xmlns:a="http://schemas.openxmlformats.org/drawingml/2006/main" w="0">
+          <a:noFill/>
+          <a:ln w="0">
             <a:noFill/>
             <a:prstDash val="solid"/>
           </a:ln>
         </p:spPr>
         <p:txBody>
-          <a:bodyPr xmlns:a="http://schemas.openxmlformats.org/drawingml/2006/main" lIns="0" tIns="0" rIns="0" bIns="0"/>
-          <a:lstStyle xmlns:a="http://schemas.openxmlformats.org/drawingml/2006/main">
+          <a:bodyPr lIns="0" tIns="0" rIns="0" bIns="0"/>
+          <a:lstStyle>
             <a:defPPr algn="l">
               <a:defRPr sz="4200" b="1" i="0">
                 <a:solidFill>
@@ -14386,7 +14779,7 @@
               </a:defRPr>
             </a:lvl9pPr>
           </a:lstStyle>
-          <a:p xmlns:a="http://schemas.openxmlformats.org/drawingml/2006/main">
+          <a:p>
             <a:pPr algn="l">
               <a:buNone/>
               <a:defRPr sz="4200" b="1" i="0">
@@ -14401,7 +14794,7 @@
                   <a:srgbClr val="BEA06A"/>
                 </a:solidFill>
               </a:rPr>
-              <a:t>NEXT</a:t>
+              <a:t>OCR</a:t>
             </a:r>
           </a:p>
         </p:txBody>
@@ -14409,34 +14802,34 @@
       <p:sp>
         <p:nvSpPr>
           <p:cNvPr id="8" name="">
-            <a:extLst xmlns:a="http://schemas.openxmlformats.org/drawingml/2006/main">
+            <a:extLst>
               <a:ext uri="{FF2B5EF4-FFF2-40B4-BE49-F238E27FC236}">
-                <a16:creationId xmlns:a16="http://schemas.microsoft.com/office/drawing/2014/main" id="{C3484B32-C19C-486F-BA3A-43B81D9CF873}"/>
+                <ns2:creationId id="{C3484B32-C19C-486F-BA3A-43B81D9CF873}"/>
               </a:ext>
             </a:extLst>
           </p:cNvPr>
           <p:cNvSpPr>
-            <a:spLocks xmlns:a="http://schemas.openxmlformats.org/drawingml/2006/main" noGrp="1"/>
+            <a:spLocks noGrp="1"/>
           </p:cNvSpPr>
           <p:nvPr/>
         </p:nvSpPr>
         <p:spPr>
-          <a:xfrm xmlns:a="http://schemas.openxmlformats.org/drawingml/2006/main">
+          <a:xfrm>
             <a:off x="6210300" y="3600450"/>
             <a:ext cx="2571750" cy="447675"/>
           </a:xfrm>
-          <a:prstGeom xmlns:a="http://schemas.openxmlformats.org/drawingml/2006/main" prst="rect">
+          <a:prstGeom prst="rect">
             <a:avLst/>
           </a:prstGeom>
-          <a:noFill xmlns:a="http://schemas.openxmlformats.org/drawingml/2006/main"/>
-          <a:ln xmlns:a="http://schemas.openxmlformats.org/drawingml/2006/main" w="0">
+          <a:noFill/>
+          <a:ln w="0">
             <a:noFill/>
             <a:prstDash val="solid"/>
           </a:ln>
         </p:spPr>
         <p:txBody>
-          <a:bodyPr xmlns:a="http://schemas.openxmlformats.org/drawingml/2006/main" lIns="0" tIns="0" rIns="0" bIns="0"/>
-          <a:lstStyle xmlns:a="http://schemas.openxmlformats.org/drawingml/2006/main">
+          <a:bodyPr lIns="0" tIns="0" rIns="0" bIns="0"/>
+          <a:lstStyle>
             <a:defPPr algn="l">
               <a:defRPr sz="1875" b="0" i="0">
                 <a:solidFill>
@@ -14517,7 +14910,7 @@
               </a:defRPr>
             </a:lvl9pPr>
           </a:lstStyle>
-          <a:p xmlns:a="http://schemas.openxmlformats.org/drawingml/2006/main">
+          <a:p>
             <a:pPr algn="l">
               <a:buNone/>
               <a:defRPr sz="1875" b="0" i="0">
@@ -14532,7 +14925,7 @@
                   <a:srgbClr val="FFFFFF"/>
                 </a:solidFill>
               </a:rPr>
-              <a:t>Remington + TKG</a:t>
+              <a:t>HMI web servers</a:t>
             </a:r>
           </a:p>
         </p:txBody>
@@ -14540,34 +14933,34 @@
       <p:sp>
         <p:nvSpPr>
           <p:cNvPr id="9" name="">
-            <a:extLst xmlns:a="http://schemas.openxmlformats.org/drawingml/2006/main">
+            <a:extLst>
               <a:ext uri="{FF2B5EF4-FFF2-40B4-BE49-F238E27FC236}">
-                <a16:creationId xmlns:a16="http://schemas.microsoft.com/office/drawing/2014/main" id="{E4838EB9-11B7-4449-9E65-E46A7DE866D0}"/>
+                <ns2:creationId id="{E4838EB9-11B7-4449-9E65-E46A7DE866D0}"/>
               </a:ext>
             </a:extLst>
           </p:cNvPr>
           <p:cNvSpPr>
-            <a:spLocks xmlns:a="http://schemas.openxmlformats.org/drawingml/2006/main" noGrp="1"/>
+            <a:spLocks noGrp="1"/>
           </p:cNvSpPr>
           <p:nvPr/>
         </p:nvSpPr>
         <p:spPr>
-          <a:xfrm xmlns:a="http://schemas.openxmlformats.org/drawingml/2006/main">
+          <a:xfrm>
             <a:off x="723900" y="5124450"/>
             <a:ext cx="7858125" cy="857250"/>
           </a:xfrm>
-          <a:prstGeom xmlns:a="http://schemas.openxmlformats.org/drawingml/2006/main" prst="rect">
+          <a:prstGeom prst="rect">
             <a:avLst/>
           </a:prstGeom>
-          <a:noFill xmlns:a="http://schemas.openxmlformats.org/drawingml/2006/main"/>
-          <a:ln xmlns:a="http://schemas.openxmlformats.org/drawingml/2006/main" w="0">
+          <a:noFill/>
+          <a:ln w="0">
             <a:noFill/>
             <a:prstDash val="solid"/>
           </a:ln>
         </p:spPr>
         <p:txBody>
-          <a:bodyPr xmlns:a="http://schemas.openxmlformats.org/drawingml/2006/main" lIns="0" tIns="0" rIns="0" bIns="0"/>
-          <a:lstStyle xmlns:a="http://schemas.openxmlformats.org/drawingml/2006/main">
+          <a:bodyPr lIns="0" tIns="0" rIns="0" bIns="0"/>
+          <a:lstStyle>
             <a:defPPr algn="l">
               <a:defRPr sz="2550" b="1" i="0">
                 <a:solidFill>
@@ -14648,7 +15041,7 @@
               </a:defRPr>
             </a:lvl9pPr>
           </a:lstStyle>
-          <a:p xmlns:a="http://schemas.openxmlformats.org/drawingml/2006/main">
+          <a:p>
             <a:pPr algn="l">
               <a:buNone/>
               <a:defRPr sz="2550" b="1" i="0">
@@ -14663,7 +15056,7 @@
                   <a:srgbClr val="FFFFFF"/>
                 </a:solidFill>
               </a:rPr>
-              <a:t>Keep writing the rules for decades to come.</a:t>
+              <a:t>My first AI. A very rough beginning.</a:t>
             </a:r>
           </a:p>
         </p:txBody>
@@ -14671,34 +15064,34 @@
       <p:sp>
         <p:nvSpPr>
           <p:cNvPr id="11" name="">
-            <a:extLst xmlns:a="http://schemas.openxmlformats.org/drawingml/2006/main">
+            <a:extLst>
               <a:ext uri="{FF2B5EF4-FFF2-40B4-BE49-F238E27FC236}">
-                <a16:creationId xmlns:a16="http://schemas.microsoft.com/office/drawing/2014/main" id="{4F10A49B-1807-4AE6-B554-7F74A182FBB9}"/>
+                <ns2:creationId id="{4F10A49B-1807-4AE6-B554-7F74A182FBB9}"/>
               </a:ext>
             </a:extLst>
           </p:cNvPr>
           <p:cNvSpPr>
-            <a:spLocks xmlns:a="http://schemas.openxmlformats.org/drawingml/2006/main" noGrp="1"/>
+            <a:spLocks noGrp="1"/>
           </p:cNvSpPr>
           <p:nvPr/>
         </p:nvSpPr>
         <p:spPr>
-          <a:xfrm xmlns:a="http://schemas.openxmlformats.org/drawingml/2006/main">
+          <a:xfrm>
             <a:off x="723900" y="4429125"/>
             <a:ext cx="7810500" cy="447675"/>
           </a:xfrm>
-          <a:prstGeom xmlns:a="http://schemas.openxmlformats.org/drawingml/2006/main" prst="rect">
+          <a:prstGeom prst="rect">
             <a:avLst/>
           </a:prstGeom>
-          <a:noFill xmlns:a="http://schemas.openxmlformats.org/drawingml/2006/main"/>
-          <a:ln xmlns:a="http://schemas.openxmlformats.org/drawingml/2006/main" w="0">
+          <a:noFill/>
+          <a:ln w="0">
             <a:noFill/>
             <a:prstDash val="solid"/>
           </a:ln>
         </p:spPr>
         <p:txBody>
-          <a:bodyPr xmlns:a="http://schemas.openxmlformats.org/drawingml/2006/main" lIns="0" tIns="0" rIns="0" bIns="0"/>
-          <a:lstStyle xmlns:a="http://schemas.openxmlformats.org/drawingml/2006/main">
+          <a:bodyPr lIns="0" tIns="0" rIns="0" bIns="0"/>
+          <a:lstStyle>
             <a:defPPr algn="l">
               <a:defRPr sz="1950" b="0" i="0">
                 <a:solidFill>
@@ -14770,7 +15163,7 @@
               </a:defRPr>
             </a:lvl9pPr>
           </a:lstStyle>
-          <a:p xmlns:a="http://schemas.openxmlformats.org/drawingml/2006/main">
+          <a:p>
             <a:pPr algn="l">
               <a:defRPr sz="1950" b="0" i="0">
                 <a:solidFill>
@@ -14784,7 +15177,7 @@
                   <a:srgbClr val="D5D8DA"/>
                 </a:solidFill>
               </a:rPr>
-              <a:t>Remington is one of five TKG ammunition brands.</a:t>
+              <a:t>A mechanical engineering intern learning as I went.</a:t>
             </a:r>
           </a:p>
         </p:txBody>
@@ -14792,7 +15185,7 @@
     </p:spTree>
     <p:extLst>
       <p:ext uri="{BB962C8B-B14F-4D97-AF65-F5344CB8AC3E}">
-        <p14:creationId xmlns:p14="http://schemas.microsoft.com/office/powerpoint/2010/main" val="1554081099"/>
+        <ns3:creationId val="1554081099"/>
       </p:ext>
     </p:extLst>
   </p:cSld>
@@ -14800,7 +15193,7 @@
 </file>
 
 <file path=ppt/slides/slide3.xml><?xml version="1.0" encoding="utf-8"?>
-<p:sld xmlns:p="http://schemas.openxmlformats.org/presentationml/2006/main">
+<p:sld xmlns:a="http://schemas.openxmlformats.org/drawingml/2006/main" xmlns:ns2="http://schemas.microsoft.com/office/drawing/2014/main" xmlns:ns3="http://schemas.microsoft.com/office/powerpoint/2010/main" xmlns:p="http://schemas.openxmlformats.org/presentationml/2006/main">
   <p:cSld>
     <p:spTree>
       <p:nvGrpSpPr>
@@ -14809,39 +15202,39 @@
         <p:nvPr/>
       </p:nvGrpSpPr>
       <p:grpSpPr>
-        <a:xfrm xmlns:a="http://schemas.openxmlformats.org/drawingml/2006/main"/>
+        <a:xfrm/>
       </p:grpSpPr>
       <p:sp>
         <p:nvSpPr>
           <p:cNvPr id="6" name="">
-            <a:extLst xmlns:a="http://schemas.openxmlformats.org/drawingml/2006/main">
+            <a:extLst>
               <a:ext uri="{FF2B5EF4-FFF2-40B4-BE49-F238E27FC236}">
-                <a16:creationId xmlns:a16="http://schemas.microsoft.com/office/drawing/2014/main" id="{BD22FF75-5B25-47DA-9C89-F014C4B1A032}"/>
+                <ns2:creationId id="{BD22FF75-5B25-47DA-9C89-F014C4B1A032}"/>
               </a:ext>
             </a:extLst>
           </p:cNvPr>
           <p:cNvSpPr>
-            <a:spLocks xmlns:a="http://schemas.openxmlformats.org/drawingml/2006/main" noGrp="1"/>
+            <a:spLocks noGrp="1"/>
           </p:cNvSpPr>
           <p:nvPr/>
         </p:nvSpPr>
         <p:spPr>
-          <a:xfrm xmlns:a="http://schemas.openxmlformats.org/drawingml/2006/main">
+          <a:xfrm>
             <a:off x="704850" y="1495425"/>
             <a:ext cx="7743825" cy="619125"/>
           </a:xfrm>
-          <a:prstGeom xmlns:a="http://schemas.openxmlformats.org/drawingml/2006/main" prst="rect">
+          <a:prstGeom prst="rect">
             <a:avLst/>
           </a:prstGeom>
-          <a:noFill xmlns:a="http://schemas.openxmlformats.org/drawingml/2006/main"/>
-          <a:ln xmlns:a="http://schemas.openxmlformats.org/drawingml/2006/main" w="0">
+          <a:noFill/>
+          <a:ln w="0">
             <a:noFill/>
             <a:prstDash val="solid"/>
           </a:ln>
         </p:spPr>
         <p:txBody>
-          <a:bodyPr xmlns:a="http://schemas.openxmlformats.org/drawingml/2006/main" lIns="0" tIns="0" rIns="0" bIns="0"/>
-          <a:lstStyle xmlns:a="http://schemas.openxmlformats.org/drawingml/2006/main">
+          <a:bodyPr lIns="0" tIns="0" rIns="0" bIns="0"/>
+          <a:lstStyle>
             <a:defPPr algn="l">
               <a:defRPr sz="3000" b="0" i="0">
                 <a:solidFill>
@@ -14913,7 +15306,7 @@
               </a:defRPr>
             </a:lvl9pPr>
           </a:lstStyle>
-          <a:p xmlns:a="http://schemas.openxmlformats.org/drawingml/2006/main">
+          <a:p>
             <a:pPr algn="l">
               <a:defRPr sz="3000" b="0" i="0">
                 <a:solidFill>
@@ -14927,7 +15320,7 @@
                   <a:srgbClr val="FFFFFF"/>
                 </a:solidFill>
               </a:rPr>
-              <a:t>The stakes are real</a:t>
+              <a:t>A year of trying</a:t>
             </a:r>
           </a:p>
         </p:txBody>
@@ -14935,34 +15328,34 @@
       <p:sp>
         <p:nvSpPr>
           <p:cNvPr id="2" name="">
-            <a:extLst xmlns:a="http://schemas.openxmlformats.org/drawingml/2006/main">
+            <a:extLst>
               <a:ext uri="{FF2B5EF4-FFF2-40B4-BE49-F238E27FC236}">
-                <a16:creationId xmlns:a16="http://schemas.microsoft.com/office/drawing/2014/main" id="{9617ED25-3782-4F93-B42D-EB969BFB6419}"/>
+                <ns2:creationId id="{9617ED25-3782-4F93-B42D-EB969BFB6419}"/>
               </a:ext>
             </a:extLst>
           </p:cNvPr>
           <p:cNvSpPr>
-            <a:spLocks xmlns:a="http://schemas.openxmlformats.org/drawingml/2006/main" noGrp="1"/>
+            <a:spLocks noGrp="1"/>
           </p:cNvSpPr>
           <p:nvPr/>
         </p:nvSpPr>
         <p:spPr>
-          <a:xfrm xmlns:a="http://schemas.openxmlformats.org/drawingml/2006/main">
+          <a:xfrm>
             <a:off x="723900" y="2743200"/>
             <a:ext cx="7810500" cy="685800"/>
           </a:xfrm>
-          <a:prstGeom xmlns:a="http://schemas.openxmlformats.org/drawingml/2006/main" prst="rect">
+          <a:prstGeom prst="rect">
             <a:avLst/>
           </a:prstGeom>
-          <a:noFill xmlns:a="http://schemas.openxmlformats.org/drawingml/2006/main"/>
-          <a:ln xmlns:a="http://schemas.openxmlformats.org/drawingml/2006/main" w="0">
+          <a:noFill/>
+          <a:ln w="0">
             <a:noFill/>
             <a:prstDash val="solid"/>
           </a:ln>
         </p:spPr>
         <p:txBody>
-          <a:bodyPr xmlns:a="http://schemas.openxmlformats.org/drawingml/2006/main" lIns="0" tIns="0" rIns="0" bIns="0"/>
-          <a:lstStyle xmlns:a="http://schemas.openxmlformats.org/drawingml/2006/main">
+          <a:bodyPr lIns="0" tIns="0" rIns="0" bIns="0"/>
+          <a:lstStyle>
             <a:defPPr algn="l">
               <a:defRPr sz="3225" b="1" i="0">
                 <a:solidFill>
@@ -15034,7 +15427,7 @@
               </a:defRPr>
             </a:lvl9pPr>
           </a:lstStyle>
-          <a:p xmlns:a="http://schemas.openxmlformats.org/drawingml/2006/main">
+          <a:p>
             <a:pPr algn="l">
               <a:defRPr sz="3225" b="1" i="0">
                 <a:solidFill>
@@ -15048,7 +15441,7 @@
                   <a:srgbClr val="BEA06A"/>
                 </a:solidFill>
               </a:rPr>
-              <a:t>Ammunition manufacturing</a:t>
+              <a:t>Off-the-shelf inspection</a:t>
             </a:r>
           </a:p>
         </p:txBody>
@@ -15056,34 +15449,34 @@
       <p:sp>
         <p:nvSpPr>
           <p:cNvPr id="3" name="">
-            <a:extLst xmlns:a="http://schemas.openxmlformats.org/drawingml/2006/main">
+            <a:extLst>
               <a:ext uri="{FF2B5EF4-FFF2-40B4-BE49-F238E27FC236}">
-                <a16:creationId xmlns:a16="http://schemas.microsoft.com/office/drawing/2014/main" id="{8BA32C32-AFFD-404C-81BF-4A0718BF792A}"/>
+                <ns2:creationId id="{8BA32C32-AFFD-404C-81BF-4A0718BF792A}"/>
               </a:ext>
             </a:extLst>
           </p:cNvPr>
           <p:cNvSpPr>
-            <a:spLocks xmlns:a="http://schemas.openxmlformats.org/drawingml/2006/main" noGrp="1"/>
+            <a:spLocks noGrp="1"/>
           </p:cNvSpPr>
           <p:nvPr/>
         </p:nvSpPr>
         <p:spPr>
-          <a:xfrm xmlns:a="http://schemas.openxmlformats.org/drawingml/2006/main">
+          <a:xfrm>
             <a:off x="723900" y="3714750"/>
             <a:ext cx="7810500" cy="1047750"/>
           </a:xfrm>
-          <a:prstGeom xmlns:a="http://schemas.openxmlformats.org/drawingml/2006/main" prst="rect">
+          <a:prstGeom prst="rect">
             <a:avLst/>
           </a:prstGeom>
-          <a:noFill xmlns:a="http://schemas.openxmlformats.org/drawingml/2006/main"/>
-          <a:ln xmlns:a="http://schemas.openxmlformats.org/drawingml/2006/main" w="0">
+          <a:noFill/>
+          <a:ln w="0">
             <a:noFill/>
             <a:prstDash val="solid"/>
           </a:ln>
         </p:spPr>
         <p:txBody>
-          <a:bodyPr xmlns:a="http://schemas.openxmlformats.org/drawingml/2006/main" lIns="0" tIns="0" rIns="0" bIns="0"/>
-          <a:lstStyle xmlns:a="http://schemas.openxmlformats.org/drawingml/2006/main">
+          <a:bodyPr lIns="0" tIns="0" rIns="0" bIns="0"/>
+          <a:lstStyle>
             <a:defPPr algn="l">
               <a:defRPr sz="2250" b="0" i="0">
                 <a:solidFill>
@@ -15155,7 +15548,7 @@
               </a:defRPr>
             </a:lvl9pPr>
           </a:lstStyle>
-          <a:p xmlns:a="http://schemas.openxmlformats.org/drawingml/2006/main">
+          <a:p>
             <a:pPr algn="l">
               <a:defRPr sz="2250" b="0" i="0">
                 <a:solidFill>
@@ -15169,10 +15562,10 @@
                   <a:srgbClr val="FFFFFF"/>
                 </a:solidFill>
               </a:rPr>
-              <a:t>Propellants and primers. Moving machinery.</a:t>
-            </a:r>
-          </a:p>
-          <a:p xmlns:a="http://schemas.openxmlformats.org/drawingml/2006/main">
+              <a:t>Nearly a year of trying.</a:t>
+            </a:r>
+          </a:p>
+          <a:p>
             <a:pPr algn="l">
               <a:defRPr sz="2250" b="0" i="0">
                 <a:solidFill>
@@ -15186,7 +15579,7 @@
                   <a:srgbClr val="FFFFFF"/>
                 </a:solidFill>
               </a:rPr>
-              <a:t>Real production.</a:t>
+              <a:t>Still no working answer.</a:t>
             </a:r>
           </a:p>
         </p:txBody>
@@ -15194,34 +15587,34 @@
       <p:sp>
         <p:nvSpPr>
           <p:cNvPr id="4" name="">
-            <a:extLst xmlns:a="http://schemas.openxmlformats.org/drawingml/2006/main">
+            <a:extLst>
               <a:ext uri="{FF2B5EF4-FFF2-40B4-BE49-F238E27FC236}">
-                <a16:creationId xmlns:a16="http://schemas.microsoft.com/office/drawing/2014/main" id="{867EFB6A-CFD9-4C2B-A4E4-A5FB7FD41BB8}"/>
+                <ns2:creationId id="{867EFB6A-CFD9-4C2B-A4E4-A5FB7FD41BB8}"/>
               </a:ext>
             </a:extLst>
           </p:cNvPr>
           <p:cNvSpPr>
-            <a:spLocks xmlns:a="http://schemas.openxmlformats.org/drawingml/2006/main" noGrp="1"/>
+            <a:spLocks noGrp="1"/>
           </p:cNvSpPr>
           <p:nvPr/>
         </p:nvSpPr>
         <p:spPr>
-          <a:xfrm xmlns:a="http://schemas.openxmlformats.org/drawingml/2006/main">
+          <a:xfrm>
             <a:off x="723900" y="5314950"/>
             <a:ext cx="7810500" cy="552450"/>
           </a:xfrm>
-          <a:prstGeom xmlns:a="http://schemas.openxmlformats.org/drawingml/2006/main" prst="rect">
+          <a:prstGeom prst="rect">
             <a:avLst/>
           </a:prstGeom>
-          <a:noFill xmlns:a="http://schemas.openxmlformats.org/drawingml/2006/main"/>
-          <a:ln xmlns:a="http://schemas.openxmlformats.org/drawingml/2006/main" w="0">
+          <a:noFill/>
+          <a:ln w="0">
             <a:noFill/>
             <a:prstDash val="solid"/>
           </a:ln>
         </p:spPr>
         <p:txBody>
-          <a:bodyPr xmlns:a="http://schemas.openxmlformats.org/drawingml/2006/main" lIns="0" tIns="0" rIns="0" bIns="0"/>
-          <a:lstStyle xmlns:a="http://schemas.openxmlformats.org/drawingml/2006/main">
+          <a:bodyPr lIns="0" tIns="0" rIns="0" bIns="0"/>
+          <a:lstStyle>
             <a:defPPr algn="l">
               <a:defRPr sz="2325" b="1" i="0">
                 <a:solidFill>
@@ -15293,7 +15686,7 @@
               </a:defRPr>
             </a:lvl9pPr>
           </a:lstStyle>
-          <a:p xmlns:a="http://schemas.openxmlformats.org/drawingml/2006/main">
+          <a:p>
             <a:pPr algn="l">
               <a:defRPr sz="2325" b="1" i="0">
                 <a:solidFill>
@@ -15307,7 +15700,7 @@
                   <a:srgbClr val="FFFFFF"/>
                 </a:solidFill>
               </a:rPr>
-              <a:t>Build with the people who rely on it.</a:t>
+              <a:t>I thought I was the problem.</a:t>
             </a:r>
           </a:p>
         </p:txBody>
@@ -15315,34 +15708,34 @@
       <p:sp>
         <p:nvSpPr>
           <p:cNvPr id="5" name="">
-            <a:extLst xmlns:a="http://schemas.openxmlformats.org/drawingml/2006/main">
+            <a:extLst>
               <a:ext uri="{FF2B5EF4-FFF2-40B4-BE49-F238E27FC236}">
-                <a16:creationId xmlns:a16="http://schemas.microsoft.com/office/drawing/2014/main" id="{A468379D-915A-4138-A97D-416741AE5643}"/>
+                <ns2:creationId id="{A468379D-915A-4138-A97D-416741AE5643}"/>
               </a:ext>
             </a:extLst>
           </p:cNvPr>
           <p:cNvSpPr>
-            <a:spLocks xmlns:a="http://schemas.openxmlformats.org/drawingml/2006/main" noGrp="1"/>
+            <a:spLocks noGrp="1"/>
           </p:cNvSpPr>
           <p:nvPr/>
         </p:nvSpPr>
         <p:spPr>
-          <a:xfrm xmlns:a="http://schemas.openxmlformats.org/drawingml/2006/main">
+          <a:xfrm>
             <a:off x="161925" y="6372225"/>
             <a:ext cx="552450" cy="419100"/>
           </a:xfrm>
-          <a:prstGeom xmlns:a="http://schemas.openxmlformats.org/drawingml/2006/main" prst="rect">
+          <a:prstGeom prst="rect">
             <a:avLst/>
           </a:prstGeom>
-          <a:noFill xmlns:a="http://schemas.openxmlformats.org/drawingml/2006/main"/>
-          <a:ln xmlns:a="http://schemas.openxmlformats.org/drawingml/2006/main" w="0">
+          <a:noFill/>
+          <a:ln w="0">
             <a:noFill/>
             <a:prstDash val="solid"/>
           </a:ln>
         </p:spPr>
         <p:txBody>
-          <a:bodyPr xmlns:a="http://schemas.openxmlformats.org/drawingml/2006/main" lIns="0" tIns="0" rIns="0" bIns="0"/>
-          <a:lstStyle xmlns:a="http://schemas.openxmlformats.org/drawingml/2006/main">
+          <a:bodyPr lIns="0" tIns="0" rIns="0" bIns="0"/>
+          <a:lstStyle>
             <a:defPPr algn="l">
               <a:defRPr sz="1125" b="1" i="0">
                 <a:solidFill>
@@ -15414,7 +15807,7 @@
               </a:defRPr>
             </a:lvl9pPr>
           </a:lstStyle>
-          <a:p xmlns:a="http://schemas.openxmlformats.org/drawingml/2006/main">
+          <a:p>
             <a:pPr algn="l">
               <a:defRPr sz="1125" b="1" i="0">
                 <a:solidFill>
@@ -15436,7 +15829,7 @@
     </p:spTree>
     <p:extLst>
       <p:ext uri="{BB962C8B-B14F-4D97-AF65-F5344CB8AC3E}">
-        <p14:creationId xmlns:p14="http://schemas.microsoft.com/office/powerpoint/2010/main" val="576258420"/>
+        <ns3:creationId val="576258420"/>
       </p:ext>
     </p:extLst>
   </p:cSld>
@@ -15444,7 +15837,7 @@
 </file>
 
 <file path=ppt/slides/slide4.xml><?xml version="1.0" encoding="utf-8"?>
-<p:sld xmlns:p="http://schemas.openxmlformats.org/presentationml/2006/main">
+<p:sld xmlns:a="http://schemas.openxmlformats.org/drawingml/2006/main" xmlns:ns2="http://schemas.microsoft.com/office/drawing/2014/main" xmlns:ns3="http://schemas.microsoft.com/office/powerpoint/2010/main" xmlns:p="http://schemas.openxmlformats.org/presentationml/2006/main">
   <p:cSld>
     <p:spTree>
       <p:nvGrpSpPr>
@@ -15453,39 +15846,39 @@
         <p:nvPr/>
       </p:nvGrpSpPr>
       <p:grpSpPr>
-        <a:xfrm xmlns:a="http://schemas.openxmlformats.org/drawingml/2006/main"/>
+        <a:xfrm/>
       </p:grpSpPr>
       <p:sp>
         <p:nvSpPr>
           <p:cNvPr id="10" name="">
-            <a:extLst xmlns:a="http://schemas.openxmlformats.org/drawingml/2006/main">
+            <a:extLst>
               <a:ext uri="{FF2B5EF4-FFF2-40B4-BE49-F238E27FC236}">
-                <a16:creationId xmlns:a16="http://schemas.microsoft.com/office/drawing/2014/main" id="{D0F38884-198E-4A16-8A86-C1862F382EE2}"/>
+                <ns2:creationId id="{D0F38884-198E-4A16-8A86-C1862F382EE2}"/>
               </a:ext>
             </a:extLst>
           </p:cNvPr>
           <p:cNvSpPr>
-            <a:spLocks xmlns:a="http://schemas.openxmlformats.org/drawingml/2006/main" noGrp="1"/>
+            <a:spLocks noGrp="1"/>
           </p:cNvSpPr>
           <p:nvPr/>
         </p:nvSpPr>
         <p:spPr>
-          <a:xfrm xmlns:a="http://schemas.openxmlformats.org/drawingml/2006/main">
+          <a:xfrm>
             <a:off x="704850" y="1495425"/>
             <a:ext cx="7743825" cy="619125"/>
           </a:xfrm>
-          <a:prstGeom xmlns:a="http://schemas.openxmlformats.org/drawingml/2006/main" prst="rect">
+          <a:prstGeom prst="rect">
             <a:avLst/>
           </a:prstGeom>
-          <a:noFill xmlns:a="http://schemas.openxmlformats.org/drawingml/2006/main"/>
-          <a:ln xmlns:a="http://schemas.openxmlformats.org/drawingml/2006/main" w="0">
+          <a:noFill/>
+          <a:ln w="0">
             <a:noFill/>
             <a:prstDash val="solid"/>
           </a:ln>
         </p:spPr>
         <p:txBody>
-          <a:bodyPr xmlns:a="http://schemas.openxmlformats.org/drawingml/2006/main" lIns="0" tIns="0" rIns="0" bIns="0"/>
-          <a:lstStyle xmlns:a="http://schemas.openxmlformats.org/drawingml/2006/main">
+          <a:bodyPr lIns="0" tIns="0" rIns="0" bIns="0"/>
+          <a:lstStyle>
             <a:defPPr algn="l">
               <a:defRPr sz="3000" b="0" i="0">
                 <a:solidFill>
@@ -15566,7 +15959,7 @@
               </a:defRPr>
             </a:lvl9pPr>
           </a:lstStyle>
-          <a:p xmlns:a="http://schemas.openxmlformats.org/drawingml/2006/main">
+          <a:p>
             <a:pPr algn="l">
               <a:buNone/>
               <a:defRPr sz="3000" b="0" i="0">
@@ -15581,7 +15974,7 @@
                   <a:srgbClr val="FFFFFF"/>
                 </a:solidFill>
               </a:rPr>
-              <a:t>Engineering that reaches the floor</a:t>
+              <a:t>A chance to build it ourselves</a:t>
             </a:r>
           </a:p>
         </p:txBody>
@@ -15589,34 +15982,34 @@
       <p:sp>
         <p:nvSpPr>
           <p:cNvPr id="2" name="">
-            <a:extLst xmlns:a="http://schemas.openxmlformats.org/drawingml/2006/main">
+            <a:extLst>
               <a:ext uri="{FF2B5EF4-FFF2-40B4-BE49-F238E27FC236}">
-                <a16:creationId xmlns:a16="http://schemas.microsoft.com/office/drawing/2014/main" id="{FBBC7091-D511-4C55-BC16-67368151C20D}"/>
+                <ns2:creationId id="{FBBC7091-D511-4C55-BC16-67368151C20D}"/>
               </a:ext>
             </a:extLst>
           </p:cNvPr>
           <p:cNvSpPr>
-            <a:spLocks xmlns:a="http://schemas.openxmlformats.org/drawingml/2006/main" noGrp="1"/>
+            <a:spLocks noGrp="1"/>
           </p:cNvSpPr>
           <p:nvPr/>
         </p:nvSpPr>
         <p:spPr>
-          <a:xfrm xmlns:a="http://schemas.openxmlformats.org/drawingml/2006/main">
+          <a:xfrm>
             <a:off x="161925" y="6372225"/>
             <a:ext cx="552450" cy="419100"/>
           </a:xfrm>
-          <a:prstGeom xmlns:a="http://schemas.openxmlformats.org/drawingml/2006/main" prst="rect">
+          <a:prstGeom prst="rect">
             <a:avLst/>
           </a:prstGeom>
-          <a:noFill xmlns:a="http://schemas.openxmlformats.org/drawingml/2006/main"/>
-          <a:ln xmlns:a="http://schemas.openxmlformats.org/drawingml/2006/main" w="0">
+          <a:noFill/>
+          <a:ln w="0">
             <a:noFill/>
             <a:prstDash val="solid"/>
           </a:ln>
         </p:spPr>
         <p:txBody>
-          <a:bodyPr xmlns:a="http://schemas.openxmlformats.org/drawingml/2006/main" lIns="0" tIns="0" rIns="0" bIns="0"/>
-          <a:lstStyle xmlns:a="http://schemas.openxmlformats.org/drawingml/2006/main">
+          <a:bodyPr lIns="0" tIns="0" rIns="0" bIns="0"/>
+          <a:lstStyle>
             <a:defPPr algn="l">
               <a:defRPr sz="1125" b="1" i="0">
                 <a:solidFill>
@@ -15697,7 +16090,7 @@
               </a:defRPr>
             </a:lvl9pPr>
           </a:lstStyle>
-          <a:p xmlns:a="http://schemas.openxmlformats.org/drawingml/2006/main">
+          <a:p>
             <a:pPr algn="l">
               <a:buNone/>
               <a:defRPr sz="1125" b="1" i="0">
@@ -15720,34 +16113,34 @@
       <p:sp>
         <p:nvSpPr>
           <p:cNvPr id="3" name="">
-            <a:extLst xmlns:a="http://schemas.openxmlformats.org/drawingml/2006/main">
+            <a:extLst>
               <a:ext uri="{FF2B5EF4-FFF2-40B4-BE49-F238E27FC236}">
-                <a16:creationId xmlns:a16="http://schemas.microsoft.com/office/drawing/2014/main" id="{397AAB4E-702C-4357-88ED-A71219DCD0B1}"/>
+                <ns2:creationId id="{397AAB4E-702C-4357-88ED-A71219DCD0B1}"/>
               </a:ext>
             </a:extLst>
           </p:cNvPr>
           <p:cNvSpPr>
-            <a:spLocks xmlns:a="http://schemas.openxmlformats.org/drawingml/2006/main" noGrp="1"/>
+            <a:spLocks noGrp="1"/>
           </p:cNvSpPr>
           <p:nvPr/>
         </p:nvSpPr>
         <p:spPr>
-          <a:xfrm xmlns:a="http://schemas.openxmlformats.org/drawingml/2006/main">
+          <a:xfrm>
             <a:off x="723900" y="2800350"/>
             <a:ext cx="2381250" cy="619125"/>
           </a:xfrm>
-          <a:prstGeom xmlns:a="http://schemas.openxmlformats.org/drawingml/2006/main" prst="rect">
+          <a:prstGeom prst="rect">
             <a:avLst/>
           </a:prstGeom>
-          <a:noFill xmlns:a="http://schemas.openxmlformats.org/drawingml/2006/main"/>
-          <a:ln xmlns:a="http://schemas.openxmlformats.org/drawingml/2006/main" w="0">
+          <a:noFill/>
+          <a:ln w="0">
             <a:noFill/>
             <a:prstDash val="solid"/>
           </a:ln>
         </p:spPr>
         <p:txBody>
-          <a:bodyPr xmlns:a="http://schemas.openxmlformats.org/drawingml/2006/main" lIns="0" tIns="0" rIns="0" bIns="0"/>
-          <a:lstStyle xmlns:a="http://schemas.openxmlformats.org/drawingml/2006/main">
+          <a:bodyPr lIns="0" tIns="0" rIns="0" bIns="0"/>
+          <a:lstStyle>
             <a:defPPr algn="l">
               <a:defRPr sz="2625" b="1" i="0">
                 <a:solidFill>
@@ -15828,7 +16221,7 @@
               </a:defRPr>
             </a:lvl9pPr>
           </a:lstStyle>
-          <a:p xmlns:a="http://schemas.openxmlformats.org/drawingml/2006/main">
+          <a:p>
             <a:pPr algn="l">
               <a:buNone/>
               <a:defRPr sz="2625" b="1" i="0">
@@ -15843,7 +16236,7 @@
                   <a:srgbClr val="BEA06A"/>
                 </a:solidFill>
               </a:rPr>
-              <a:t>SENSE</a:t>
+              <a:t>PROPOSE</a:t>
             </a:r>
           </a:p>
         </p:txBody>
@@ -15851,34 +16244,34 @@
       <p:sp>
         <p:nvSpPr>
           <p:cNvPr id="4" name="">
-            <a:extLst xmlns:a="http://schemas.openxmlformats.org/drawingml/2006/main">
+            <a:extLst>
               <a:ext uri="{FF2B5EF4-FFF2-40B4-BE49-F238E27FC236}">
-                <a16:creationId xmlns:a16="http://schemas.microsoft.com/office/drawing/2014/main" id="{A34BA23E-0CD2-4E38-8F37-7AAB56C38762}"/>
+                <ns2:creationId id="{A34BA23E-0CD2-4E38-8F37-7AAB56C38762}"/>
               </a:ext>
             </a:extLst>
           </p:cNvPr>
           <p:cNvSpPr>
-            <a:spLocks xmlns:a="http://schemas.openxmlformats.org/drawingml/2006/main" noGrp="1"/>
+            <a:spLocks noGrp="1"/>
           </p:cNvSpPr>
           <p:nvPr/>
         </p:nvSpPr>
         <p:spPr>
-          <a:xfrm xmlns:a="http://schemas.openxmlformats.org/drawingml/2006/main">
+          <a:xfrm>
             <a:off x="723900" y="3543300"/>
             <a:ext cx="2524125" cy="1066800"/>
           </a:xfrm>
-          <a:prstGeom xmlns:a="http://schemas.openxmlformats.org/drawingml/2006/main" prst="rect">
+          <a:prstGeom prst="rect">
             <a:avLst/>
           </a:prstGeom>
-          <a:noFill xmlns:a="http://schemas.openxmlformats.org/drawingml/2006/main"/>
-          <a:ln xmlns:a="http://schemas.openxmlformats.org/drawingml/2006/main" w="0">
+          <a:noFill/>
+          <a:ln w="0">
             <a:noFill/>
             <a:prstDash val="solid"/>
           </a:ln>
         </p:spPr>
         <p:txBody>
-          <a:bodyPr xmlns:a="http://schemas.openxmlformats.org/drawingml/2006/main" lIns="0" tIns="0" rIns="0" bIns="0"/>
-          <a:lstStyle xmlns:a="http://schemas.openxmlformats.org/drawingml/2006/main">
+          <a:bodyPr lIns="0" tIns="0" rIns="0" bIns="0"/>
+          <a:lstStyle>
             <a:defPPr algn="l">
               <a:defRPr sz="1875" b="0" i="0">
                 <a:solidFill>
@@ -15959,7 +16352,7 @@
               </a:defRPr>
             </a:lvl9pPr>
           </a:lstStyle>
-          <a:p xmlns:a="http://schemas.openxmlformats.org/drawingml/2006/main">
+          <a:p>
             <a:pPr algn="l">
               <a:buNone/>
               <a:defRPr sz="1875" b="0" i="0">
@@ -15974,10 +16367,10 @@
                   <a:srgbClr val="FFFFFF"/>
                 </a:solidFill>
               </a:rPr>
-              <a:t>Machines capture</a:t>
-            </a:r>
-          </a:p>
-          <a:p xmlns:a="http://schemas.openxmlformats.org/drawingml/2006/main">
+              <a:t>What if we</a:t>
+            </a:r>
+          </a:p>
+          <a:p>
             <a:pPr algn="l">
               <a:buNone/>
               <a:defRPr sz="1875" b="0" i="0">
@@ -15992,7 +16385,7 @@
                   <a:srgbClr val="FFFFFF"/>
                 </a:solidFill>
               </a:rPr>
-              <a:t>what is happening</a:t>
+              <a:t>built it ourselves?</a:t>
             </a:r>
           </a:p>
         </p:txBody>
@@ -16000,34 +16393,34 @@
       <p:sp>
         <p:nvSpPr>
           <p:cNvPr id="5" name="">
-            <a:extLst xmlns:a="http://schemas.openxmlformats.org/drawingml/2006/main">
+            <a:extLst>
               <a:ext uri="{FF2B5EF4-FFF2-40B4-BE49-F238E27FC236}">
-                <a16:creationId xmlns:a16="http://schemas.microsoft.com/office/drawing/2014/main" id="{74EF2072-0F5B-4869-B3C8-B8EF0150DF55}"/>
+                <ns2:creationId id="{74EF2072-0F5B-4869-B3C8-B8EF0150DF55}"/>
               </a:ext>
             </a:extLst>
           </p:cNvPr>
           <p:cNvSpPr>
-            <a:spLocks xmlns:a="http://schemas.openxmlformats.org/drawingml/2006/main" noGrp="1"/>
+            <a:spLocks noGrp="1"/>
           </p:cNvSpPr>
           <p:nvPr/>
         </p:nvSpPr>
         <p:spPr>
-          <a:xfrm xmlns:a="http://schemas.openxmlformats.org/drawingml/2006/main">
+          <a:xfrm>
             <a:off x="3419475" y="2800350"/>
             <a:ext cx="2381250" cy="619125"/>
           </a:xfrm>
-          <a:prstGeom xmlns:a="http://schemas.openxmlformats.org/drawingml/2006/main" prst="rect">
+          <a:prstGeom prst="rect">
             <a:avLst/>
           </a:prstGeom>
-          <a:noFill xmlns:a="http://schemas.openxmlformats.org/drawingml/2006/main"/>
-          <a:ln xmlns:a="http://schemas.openxmlformats.org/drawingml/2006/main" w="0">
+          <a:noFill/>
+          <a:ln w="0">
             <a:noFill/>
             <a:prstDash val="solid"/>
           </a:ln>
         </p:spPr>
         <p:txBody>
-          <a:bodyPr xmlns:a="http://schemas.openxmlformats.org/drawingml/2006/main" lIns="0" tIns="0" rIns="0" bIns="0"/>
-          <a:lstStyle xmlns:a="http://schemas.openxmlformats.org/drawingml/2006/main">
+          <a:bodyPr lIns="0" tIns="0" rIns="0" bIns="0"/>
+          <a:lstStyle>
             <a:defPPr algn="l">
               <a:defRPr sz="2625" b="1" i="0">
                 <a:solidFill>
@@ -16108,7 +16501,7 @@
               </a:defRPr>
             </a:lvl9pPr>
           </a:lstStyle>
-          <a:p xmlns:a="http://schemas.openxmlformats.org/drawingml/2006/main">
+          <a:p>
             <a:pPr algn="l">
               <a:buNone/>
               <a:defRPr sz="2625" b="1" i="0">
@@ -16123,7 +16516,7 @@
                   <a:srgbClr val="BEA06A"/>
                 </a:solidFill>
               </a:rPr>
-              <a:t>DECIDE</a:t>
+              <a:t>APPROVE</a:t>
             </a:r>
           </a:p>
         </p:txBody>
@@ -16131,34 +16524,34 @@
       <p:sp>
         <p:nvSpPr>
           <p:cNvPr id="6" name="">
-            <a:extLst xmlns:a="http://schemas.openxmlformats.org/drawingml/2006/main">
+            <a:extLst>
               <a:ext uri="{FF2B5EF4-FFF2-40B4-BE49-F238E27FC236}">
-                <a16:creationId xmlns:a16="http://schemas.microsoft.com/office/drawing/2014/main" id="{578E9F30-B97B-4D21-9887-533D7D1E5D39}"/>
+                <ns2:creationId id="{578E9F30-B97B-4D21-9887-533D7D1E5D39}"/>
               </a:ext>
             </a:extLst>
           </p:cNvPr>
           <p:cNvSpPr>
-            <a:spLocks xmlns:a="http://schemas.openxmlformats.org/drawingml/2006/main" noGrp="1"/>
+            <a:spLocks noGrp="1"/>
           </p:cNvSpPr>
           <p:nvPr/>
         </p:nvSpPr>
         <p:spPr>
-          <a:xfrm xmlns:a="http://schemas.openxmlformats.org/drawingml/2006/main">
+          <a:xfrm>
             <a:off x="3419475" y="3543300"/>
             <a:ext cx="2524125" cy="1066800"/>
           </a:xfrm>
-          <a:prstGeom xmlns:a="http://schemas.openxmlformats.org/drawingml/2006/main" prst="rect">
+          <a:prstGeom prst="rect">
             <a:avLst/>
           </a:prstGeom>
-          <a:noFill xmlns:a="http://schemas.openxmlformats.org/drawingml/2006/main"/>
-          <a:ln xmlns:a="http://schemas.openxmlformats.org/drawingml/2006/main" w="0">
+          <a:noFill/>
+          <a:ln w="0">
             <a:noFill/>
             <a:prstDash val="solid"/>
           </a:ln>
         </p:spPr>
         <p:txBody>
-          <a:bodyPr xmlns:a="http://schemas.openxmlformats.org/drawingml/2006/main" lIns="0" tIns="0" rIns="0" bIns="0"/>
-          <a:lstStyle xmlns:a="http://schemas.openxmlformats.org/drawingml/2006/main">
+          <a:bodyPr lIns="0" tIns="0" rIns="0" bIns="0"/>
+          <a:lstStyle>
             <a:defPPr algn="l">
               <a:defRPr sz="1875" b="0" i="0">
                 <a:solidFill>
@@ -16239,7 +16632,7 @@
               </a:defRPr>
             </a:lvl9pPr>
           </a:lstStyle>
-          <a:p xmlns:a="http://schemas.openxmlformats.org/drawingml/2006/main">
+          <a:p>
             <a:pPr algn="l">
               <a:buNone/>
               <a:defRPr sz="1875" b="0" i="0">
@@ -16254,10 +16647,10 @@
                   <a:srgbClr val="FFFFFF"/>
                 </a:solidFill>
               </a:rPr>
-              <a:t>Software turns signals</a:t>
-            </a:r>
-          </a:p>
-          <a:p xmlns:a="http://schemas.openxmlformats.org/drawingml/2006/main">
+              <a:t>New CSG management</a:t>
+            </a:r>
+          </a:p>
+          <a:p>
             <a:pPr algn="l">
               <a:buNone/>
               <a:defRPr sz="1875" b="0" i="0">
@@ -16272,7 +16665,7 @@
                   <a:srgbClr val="FFFFFF"/>
                 </a:solidFill>
               </a:rPr>
-              <a:t>into a decision</a:t>
+              <a:t>approved the proposal</a:t>
             </a:r>
           </a:p>
         </p:txBody>
@@ -16280,34 +16673,34 @@
       <p:sp>
         <p:nvSpPr>
           <p:cNvPr id="7" name="">
-            <a:extLst xmlns:a="http://schemas.openxmlformats.org/drawingml/2006/main">
+            <a:extLst>
               <a:ext uri="{FF2B5EF4-FFF2-40B4-BE49-F238E27FC236}">
-                <a16:creationId xmlns:a16="http://schemas.microsoft.com/office/drawing/2014/main" id="{3644D645-77AD-4BEA-B186-DA1B65F1C548}"/>
+                <ns2:creationId id="{3644D645-77AD-4BEA-B186-DA1B65F1C548}"/>
               </a:ext>
             </a:extLst>
           </p:cNvPr>
           <p:cNvSpPr>
-            <a:spLocks xmlns:a="http://schemas.openxmlformats.org/drawingml/2006/main" noGrp="1"/>
+            <a:spLocks noGrp="1"/>
           </p:cNvSpPr>
           <p:nvPr/>
         </p:nvSpPr>
         <p:spPr>
-          <a:xfrm xmlns:a="http://schemas.openxmlformats.org/drawingml/2006/main">
+          <a:xfrm>
             <a:off x="6229350" y="2800350"/>
             <a:ext cx="2381250" cy="619125"/>
           </a:xfrm>
-          <a:prstGeom xmlns:a="http://schemas.openxmlformats.org/drawingml/2006/main" prst="rect">
+          <a:prstGeom prst="rect">
             <a:avLst/>
           </a:prstGeom>
-          <a:noFill xmlns:a="http://schemas.openxmlformats.org/drawingml/2006/main"/>
-          <a:ln xmlns:a="http://schemas.openxmlformats.org/drawingml/2006/main" w="0">
+          <a:noFill/>
+          <a:ln w="0">
             <a:noFill/>
             <a:prstDash val="solid"/>
           </a:ln>
         </p:spPr>
         <p:txBody>
-          <a:bodyPr xmlns:a="http://schemas.openxmlformats.org/drawingml/2006/main" lIns="0" tIns="0" rIns="0" bIns="0"/>
-          <a:lstStyle xmlns:a="http://schemas.openxmlformats.org/drawingml/2006/main">
+          <a:bodyPr lIns="0" tIns="0" rIns="0" bIns="0"/>
+          <a:lstStyle>
             <a:defPPr algn="l">
               <a:defRPr sz="2625" b="1" i="0">
                 <a:solidFill>
@@ -16388,7 +16781,7 @@
               </a:defRPr>
             </a:lvl9pPr>
           </a:lstStyle>
-          <a:p xmlns:a="http://schemas.openxmlformats.org/drawingml/2006/main">
+          <a:p>
             <a:pPr algn="l">
               <a:buNone/>
               <a:defRPr sz="2625" b="1" i="0">
@@ -16403,7 +16796,7 @@
                   <a:srgbClr val="BEA06A"/>
                 </a:solidFill>
               </a:rPr>
-              <a:t>ACT</a:t>
+              <a:t>CALL</a:t>
             </a:r>
           </a:p>
         </p:txBody>
@@ -16411,34 +16804,34 @@
       <p:sp>
         <p:nvSpPr>
           <p:cNvPr id="8" name="">
-            <a:extLst xmlns:a="http://schemas.openxmlformats.org/drawingml/2006/main">
+            <a:extLst>
               <a:ext uri="{FF2B5EF4-FFF2-40B4-BE49-F238E27FC236}">
-                <a16:creationId xmlns:a16="http://schemas.microsoft.com/office/drawing/2014/main" id="{8CD4209B-EEAA-49CF-B1CF-B1BCE1C02033}"/>
+                <ns2:creationId id="{8CD4209B-EEAA-49CF-B1CF-B1BCE1C02033}"/>
               </a:ext>
             </a:extLst>
           </p:cNvPr>
           <p:cNvSpPr>
-            <a:spLocks xmlns:a="http://schemas.openxmlformats.org/drawingml/2006/main" noGrp="1"/>
+            <a:spLocks noGrp="1"/>
           </p:cNvSpPr>
           <p:nvPr/>
         </p:nvSpPr>
         <p:spPr>
-          <a:xfrm xmlns:a="http://schemas.openxmlformats.org/drawingml/2006/main">
+          <a:xfrm>
             <a:off x="6229350" y="3543300"/>
             <a:ext cx="2524125" cy="1066800"/>
           </a:xfrm>
-          <a:prstGeom xmlns:a="http://schemas.openxmlformats.org/drawingml/2006/main" prst="rect">
+          <a:prstGeom prst="rect">
             <a:avLst/>
           </a:prstGeom>
-          <a:noFill xmlns:a="http://schemas.openxmlformats.org/drawingml/2006/main"/>
-          <a:ln xmlns:a="http://schemas.openxmlformats.org/drawingml/2006/main" w="0">
+          <a:noFill/>
+          <a:ln w="0">
             <a:noFill/>
             <a:prstDash val="solid"/>
           </a:ln>
         </p:spPr>
         <p:txBody>
-          <a:bodyPr xmlns:a="http://schemas.openxmlformats.org/drawingml/2006/main" lIns="0" tIns="0" rIns="0" bIns="0"/>
-          <a:lstStyle xmlns:a="http://schemas.openxmlformats.org/drawingml/2006/main">
+          <a:bodyPr lIns="0" tIns="0" rIns="0" bIns="0"/>
+          <a:lstStyle>
             <a:defPPr algn="l">
               <a:defRPr sz="1875" b="0" i="0">
                 <a:solidFill>
@@ -16519,7 +16912,7 @@
               </a:defRPr>
             </a:lvl9pPr>
           </a:lstStyle>
-          <a:p xmlns:a="http://schemas.openxmlformats.org/drawingml/2006/main">
+          <a:p>
             <a:pPr algn="l">
               <a:buNone/>
               <a:defRPr sz="1875" b="0" i="0">
@@ -16534,10 +16927,10 @@
                   <a:srgbClr val="FFFFFF"/>
                 </a:solidFill>
               </a:rPr>
-              <a:t>People and equipment</a:t>
-            </a:r>
-          </a:p>
-          <a:p xmlns:a="http://schemas.openxmlformats.org/drawingml/2006/main">
+              <a:t>Go get</a:t>
+            </a:r>
+          </a:p>
+          <a:p>
             <a:pPr algn="l">
               <a:buNone/>
               <a:defRPr sz="1875" b="0" i="0">
@@ -16552,7 +16945,7 @@
                   <a:srgbClr val="FFFFFF"/>
                 </a:solidFill>
               </a:rPr>
-              <a:t>respond</a:t>
+              <a:t>an intern</a:t>
             </a:r>
           </a:p>
         </p:txBody>
@@ -16560,34 +16953,34 @@
       <p:sp>
         <p:nvSpPr>
           <p:cNvPr id="9" name="">
-            <a:extLst xmlns:a="http://schemas.openxmlformats.org/drawingml/2006/main">
+            <a:extLst>
               <a:ext uri="{FF2B5EF4-FFF2-40B4-BE49-F238E27FC236}">
-                <a16:creationId xmlns:a16="http://schemas.microsoft.com/office/drawing/2014/main" id="{EFEC76D1-80FD-4BC8-AFC9-1E585F89C1B7}"/>
+                <ns2:creationId id="{EFEC76D1-80FD-4BC8-AFC9-1E585F89C1B7}"/>
               </a:ext>
             </a:extLst>
           </p:cNvPr>
           <p:cNvSpPr>
-            <a:spLocks xmlns:a="http://schemas.openxmlformats.org/drawingml/2006/main" noGrp="1"/>
+            <a:spLocks noGrp="1"/>
           </p:cNvSpPr>
           <p:nvPr/>
         </p:nvSpPr>
         <p:spPr>
-          <a:xfrm xmlns:a="http://schemas.openxmlformats.org/drawingml/2006/main">
+          <a:xfrm>
             <a:off x="723900" y="5362575"/>
             <a:ext cx="7429500" cy="619125"/>
           </a:xfrm>
-          <a:prstGeom xmlns:a="http://schemas.openxmlformats.org/drawingml/2006/main" prst="rect">
+          <a:prstGeom prst="rect">
             <a:avLst/>
           </a:prstGeom>
-          <a:noFill xmlns:a="http://schemas.openxmlformats.org/drawingml/2006/main"/>
-          <a:ln xmlns:a="http://schemas.openxmlformats.org/drawingml/2006/main" w="0">
+          <a:noFill/>
+          <a:ln w="0">
             <a:noFill/>
             <a:prstDash val="solid"/>
           </a:ln>
         </p:spPr>
         <p:txBody>
-          <a:bodyPr xmlns:a="http://schemas.openxmlformats.org/drawingml/2006/main" lIns="0" tIns="0" rIns="0" bIns="0"/>
-          <a:lstStyle xmlns:a="http://schemas.openxmlformats.org/drawingml/2006/main">
+          <a:bodyPr lIns="0" tIns="0" rIns="0" bIns="0"/>
+          <a:lstStyle>
             <a:defPPr algn="l">
               <a:defRPr sz="2550" b="1" i="0">
                 <a:solidFill>
@@ -16668,7 +17061,7 @@
               </a:defRPr>
             </a:lvl9pPr>
           </a:lstStyle>
-          <a:p xmlns:a="http://schemas.openxmlformats.org/drawingml/2006/main">
+          <a:p>
             <a:pPr algn="l">
               <a:buNone/>
               <a:defRPr sz="2550" b="1" i="0">
@@ -16683,7 +17076,7 @@
                   <a:srgbClr val="FFFFFF"/>
                 </a:solidFill>
               </a:rPr>
-              <a:t>Make every decision useful on the floor.</a:t>
+              <a:t>I called Wesley.</a:t>
             </a:r>
           </a:p>
         </p:txBody>
@@ -16691,7 +17084,7 @@
     </p:spTree>
     <p:extLst>
       <p:ext uri="{BB962C8B-B14F-4D97-AF65-F5344CB8AC3E}">
-        <p14:creationId xmlns:p14="http://schemas.microsoft.com/office/powerpoint/2010/main" val="1022646670"/>
+        <ns3:creationId val="1022646670"/>
       </p:ext>
     </p:extLst>
   </p:cSld>
@@ -16826,7 +17219,7 @@
                   <a:srgbClr val="FFFFFF"/>
                 </a:solidFill>
               </a:rPr>
-              <a:t>The work spans the organization</a:t>
+              <a:t>Then I called Wesley</a:t>
             </a:r>
           </a:p>
         </p:txBody>
@@ -16947,7 +17340,7 @@
                   <a:srgbClr val="BEA06A"/>
                 </a:solidFill>
               </a:rPr>
-              <a:t>LIVE IN PRODUCTION</a:t>
+              <a:t>THE INVITATION</a:t>
             </a:r>
           </a:p>
         </p:txBody>
@@ -17068,7 +17461,7 @@
                   <a:srgbClr val="FFFFFF"/>
                 </a:solidFill>
               </a:rPr>
-              <a:t>Centerfire inspection</a:t>
+              <a:t>Come to central Arkansas.</a:t>
             </a:r>
           </a:p>
           <a:p>
@@ -17085,7 +17478,7 @@
                   <a:srgbClr val="FFFFFF"/>
                 </a:solidFill>
               </a:rPr>
-              <a:t>Shotshell inspection</a:t>
+              <a:t>Take on the project with me.</a:t>
             </a:r>
           </a:p>
         </p:txBody>
@@ -17206,7 +17599,7 @@
                   <a:srgbClr val="BEA06A"/>
                 </a:solidFill>
               </a:rPr>
-              <a:t>OTHER CAPABILITIES</a:t>
+              <a:t>THE WORK</a:t>
             </a:r>
           </a:p>
         </p:txBody>
@@ -17327,7 +17720,7 @@
                   <a:srgbClr val="FFFFFF"/>
                 </a:solidFill>
               </a:rPr>
-              <a:t>Public sentiment</a:t>
+              <a:t>Learn the problem.</a:t>
             </a:r>
           </a:p>
           <a:p>
@@ -17344,7 +17737,7 @@
                   <a:srgbClr val="FFFFFF"/>
                 </a:solidFill>
               </a:rPr>
-              <a:t>Remi</a:t>
+              <a:t>Build the first system.</a:t>
             </a:r>
           </a:p>
         </p:txBody>
@@ -17465,7 +17858,7 @@
                   <a:srgbClr val="FFFFFF"/>
                 </a:solidFill>
               </a:rPr>
-              <a:t>Each system helps someone make a better decision.</a:t>
+              <a:t>Wesley, take it from here.</a:t>
             </a:r>
           </a:p>
         </p:txBody>
@@ -17729,7 +18122,7 @@
                   <a:srgbClr val="FFFFFF"/>
                 </a:solidFill>
               </a:rPr>
-              <a:t>Centerfire inspection</a:t>
+              <a:t>Seeing it do its job</a:t>
             </a:r>
           </a:p>
         </p:txBody>
@@ -17867,7 +18260,7 @@
                   <a:srgbClr val="FFFFFF"/>
                 </a:solidFill>
               </a:rPr>
-              <a:t>Inference. A usable result.</a:t>
+              <a:t>Inference. A real reject.</a:t>
             </a:r>
           </a:p>
         </p:txBody>
@@ -18373,7 +18766,7 @@
                   <a:srgbClr val="FFFFFF"/>
                 </a:solidFill>
               </a:rPr>
-              <a:t>Shotshell inspection</a:t>
+              <a:t>One project teaches the next</a:t>
             </a:r>
           </a:p>
         </p:txBody>
@@ -18753,7 +19146,7 @@
                   <a:srgbClr val="D5D8DA"/>
                 </a:solidFill>
               </a:rPr>
-              <a:t>Live on the floor. Tailored to a different product.</a:t>
+              <a:t>Shotshell inspection. A different product and line.</a:t>
             </a:r>
           </a:p>
         </p:txBody>

</xml_diff>

<commit_message>
Restore original presentation flow with personal opening and CSG context
</commit_message>
<xml_diff>
--- a/docs/presentation/Engineering_at_The_Kinetic_Group.pptx
+++ b/docs/presentation/Engineering_at_The_Kinetic_Group.pptx
@@ -9,6 +9,7 @@
   </p:notesMasterIdLst>
   <p:sldIdLst>
     <p:sldId id="256" r:id="R9a70a15f79814586"/>
+    <p:sldId id="273" r:id="rIdCsgOriginalFlow"/>
     <p:sldId id="257" r:id="R0fe56bb8b7f540ab"/>
     <p:sldId id="258" r:id="Ra9a2213aca20468f"/>
     <p:sldId id="259" r:id="Rc4254491657446f0"/>
@@ -719,7 +720,7 @@
           <a:lstStyle/>
           <a:p>
             <a:r>
-              <a:t>Story-led talk. Demo 0:16–0:36; close 0:40; homepage QR 0:40–0:41; final-slide activity 0:41–0:49; questions to 1:00.</a:t>
+              <a:t>Keep the familiar company/project visual flow. The personal introduction runs over the cover and CSG slide; do not advance for each story beat. Demo 0:16–0:36; homepage slide 16; lab slide 17; activity 0:41–0:49; questions to 1:00.</a:t>
             </a:r>
           </a:p>
           <a:p>
@@ -729,7 +730,7 @@
           </a:p>
           <a:p>
             <a:r>
-              <a:t>Cue: Introduce the people, then begin where you actually started.</a:t>
+              <a:t>Cue: Use the cover as a visual anchor for your personal introduction. Do not advance for every story beat. About 3 minutes, with room to speak naturally.</a:t>
             </a:r>
           </a:p>
           <a:p>
@@ -739,7 +740,7 @@
           </a:p>
           <a:p>
             <a:r>
-              <a:t>Brad: “Good morning. I'm Brad Daugherty, an electrical engineer at Remington. Most of my work is in Lonoke, and I support projects across The Kinetic Group. This is Wesley Siharath, who helped start our Remington Vision work.”</a:t>
+              <a:t>Brad: “Good morning. I'm Brad Daugherty, an electrical engineer at Remington. Most of my work is in Lonoke, and I support projects across The Kinetic Group. I'm here with Wesley Siharath.”</a:t>
             </a:r>
           </a:p>
           <a:p>
@@ -749,7 +750,7 @@
           </a:p>
           <a:p>
             <a:r>
-              <a:t>“We could spend this hour showing you a list of projects. I want to start with how we got here, because I did not begin as somebody who knew how to build AI systems.”</a:t>
+              <a:t>“Today is about bringing AI into something real and helping build the next generation of manufacturing. I want to start with how we got into this work, because I did not begin knowing how to build AI systems.”</a:t>
             </a:r>
           </a:p>
           <a:p>
@@ -759,7 +760,77 @@
           </a:p>
           <a:p>
             <a:r>
-              <a:t>Bridge: “I started as a mechanical engineering intern.”</a:t>
+              <a:t>“I started as a mechanical engineering intern. I was going to school full time in Fayetteville and working full time in Lonoke, Friday through Monday. I was learning as I went.”</a:t>
+            </a:r>
+          </a:p>
+          <a:p>
+            <a:r>
+              <a:t/>
+            </a:r>
+          </a:p>
+          <a:p>
+            <a:r>
+              <a:t>“My first application used OCR to pull data off HMI web servers. That was my first AI application, and probably the worst SCADA system the world has ever seen.”</a:t>
+            </a:r>
+          </a:p>
+          <a:p>
+            <a:r>
+              <a:t/>
+            </a:r>
+          </a:p>
+          <a:p>
+            <a:r>
+              <a:t>Delivery: Pause for the joke. If helpful: “OCR reads text from an image. An HMI is the screen people use to see and operate a machine.”</a:t>
+            </a:r>
+          </a:p>
+          <a:p>
+            <a:r>
+              <a:t/>
+            </a:r>
+          </a:p>
+          <a:p>
+            <a:r>
+              <a:t>Brad: “At the same time, I was struggling with inspection projects. I was working with off-the-shelf systems, including Keyence and Cognex. I was told it was crazy to make our own AI, and that I needed to make those solutions work.”</a:t>
+            </a:r>
+          </a:p>
+          <a:p>
+            <a:r>
+              <a:t/>
+            </a:r>
+          </a:p>
+          <a:p>
+            <a:r>
+              <a:t>“I spent nearly a year on it and could not get where I needed to go. I did not fully understand the systems. I felt defeated. I did not realize that I was walking in the shoes of experienced engineers who had struggled with these kinds of problems before me.”</a:t>
+            </a:r>
+          </a:p>
+          <a:p>
+            <a:r>
+              <a:t/>
+            </a:r>
+          </a:p>
+          <a:p>
+            <a:r>
+              <a:t>“Eventually, I could not keep approaching it the same way. I proposed that we build it ourselves.”</a:t>
+            </a:r>
+          </a:p>
+          <a:p>
+            <a:r>
+              <a:t/>
+            </a:r>
+          </a:p>
+          <a:p>
+            <a:r>
+              <a:t>Delivery: Keep this centered on your learning and your experience with that application. This is a personal introduction over the cover, not a series of new story slides.</a:t>
+            </a:r>
+          </a:p>
+          <a:p>
+            <a:r>
+              <a:t/>
+            </a:r>
+          </a:p>
+          <a:p>
+            <a:r>
+              <a:t>Bridge: Advance to the CSG slide for the company context and the opportunity to try.</a:t>
             </a:r>
           </a:p>
         </p:txBody>
@@ -829,7 +900,7 @@
           <a:lstStyle/>
           <a:p>
             <a:r>
-              <a:t>Cue: Remi / Little Chef. Project knowledge with sources.</a:t>
+              <a:t>Cue: Retrieve project material, generate an answer, check the source.</a:t>
             </a:r>
           </a:p>
           <a:p>
@@ -849,17 +920,7 @@
           </a:p>
           <a:p>
             <a:r>
-              <a:t>Brad: “As the work grows, finding what we already know becomes another engineering problem. We want the answer to stay connected to the evidence behind it.”</a:t>
-            </a:r>
-          </a:p>
-          <a:p>
-            <a:r>
-              <a:t/>
-            </a:r>
-          </a:p>
-          <a:p>
-            <a:r>
-              <a:t>Delivery: Keep this brief. The optional REMI demonstration remains separate and needs a real rehearsal before use.</a:t>
+              <a:t>Brad: “Here the integration problem is keeping the answer connected to evidence and controlling what the tools can do.”</a:t>
             </a:r>
           </a:p>
         </p:txBody>
@@ -929,7 +990,7 @@
           <a:lstStyle/>
           <a:p>
             <a:r>
-              <a:t>Cue: Variety, freedom, ownership. Start the demo at 0:16.</a:t>
+              <a:t>Cue: Variety, freedom, ownership, and a real result. Demo at 0:16.</a:t>
             </a:r>
           </a:p>
           <a:p>
@@ -969,6 +1030,16 @@
           </a:p>
           <a:p>
             <a:r>
+              <a:t>“One moment that really stuck with me was seeing a real reject come through and watching our system toss it out. Seeing something I helped build actually do its job was an amazing feeling.”</a:t>
+            </a:r>
+          </a:p>
+          <a:p>
+            <a:r>
+              <a:t/>
+            </a:r>
+          </a:p>
+          <a:p>
+            <a:r>
               <a:t>“Following ideas through and seeing people get invested feels like helping pave the way for Remington. I enjoy figuring it out.”</a:t>
             </a:r>
           </a:p>
@@ -979,7 +1050,7 @@
           </a:p>
           <a:p>
             <a:r>
-              <a:t>Brad: “That is what being given a chance opened up for us. Let's show you a small example of the work.”</a:t>
+              <a:t>Brad: “Let's show that connection between an image, a decision, and a visible result.”</a:t>
             </a:r>
           </a:p>
         </p:txBody>
@@ -1049,7 +1120,7 @@
           <a:lstStyle/>
           <a:p>
             <a:r>
-              <a:t>Cue: The demo illustrates the story. 0:16–0:36.</a:t>
+              <a:t>Cue: Detection, color prediction, track, decision, one variation. 0:16–0:36.</a:t>
             </a:r>
           </a:p>
           <a:p>
@@ -1059,7 +1130,7 @@
           </a:p>
           <a:p>
             <a:r>
-              <a:t>Before the event: Rehearse the exact application build, camera, props, and one variation. Describe only the mode being shown. The documented standard sorter uses trained color predictions; a generic bottle locator alone cannot predict colors. A visual-tracking build can show boxes, labels, and track identity without color sorting. Include physical action only after the complete event setup is validated. The event setup is separate from the production inspection systems.</a:t>
+              <a:t>Before the event: Rehearse the exact application build, camera, two bottles, and one variation. The repository's standard mode uses YOLOX bottle detection and a trained color model. A visual-tracking build can instead show boxes, labels, and track identity; use the rehearsed outcomes of the actual build. The generic bundled bottle locator does not predict colors. Describe the mode actually shown. Keep the core demonstration on screen; include physical movement only if the complete event setup has been validated.</a:t>
             </a:r>
           </a:p>
           <a:p>
@@ -1069,7 +1140,7 @@
           </a:p>
           <a:p>
             <a:r>
-              <a:t>Opening, about 2 minutes. Brad: “These bottles give us a simple way to show the kind of work we have been talking about. Watch what the camera sees, what the software produces, and what changes when we change a condition. First, make a prediction.”</a:t>
+              <a:t>Opening, 2 minutes. Brad: “This is a separate event demo using Gatorade bottles, a small example of AI becoming something useful in manufacturing. We detect the bottle, associate evidence with its track, and apply a color rule to produce an on-screen sort decision. First, predict the result. Then we will change one condition and look at what happened.”</a:t>
             </a:r>
           </a:p>
           <a:p>
@@ -1079,7 +1150,7 @@
           </a:p>
           <a:p>
             <a:r>
-              <a:t>Baseline, about 4 minutes: Show two clear observations or outcomes supported by the actual build. Wesley points to the box, label or model evidence, tracked identity, and any actual decision. If showing a tested sorting mode, Brad states the pass rule and contrasts two bottles. If showing tracking, use the rehearsed identity/position sequence. Call a displayed decision on-screen; describe a physical action only when it actually occurs.</a:t>
+              <a:t>Baseline, 4 minutes. Brad states the pass color and asks for predictions for two contrasting bottles. Wesley points out the bottle box, model color prediction, track, and displayed decision. In the standard repository mode, unknown color diverts. Show what this build actually did.</a:t>
             </a:r>
           </a:p>
           <a:p>
@@ -1089,7 +1160,7 @@
           </a:p>
           <a:p>
             <a:r>
-              <a:t>One planned variation, about 4 minutes: Change one rehearsed orientation, position, or other condition. Ask for a prediction and compare the evidence. If surprised: “That gives us something useful to test.”</a:t>
+              <a:t>Variation, 4 minutes. Change one pretested orientation or position. Ask for a prediction. Compare the evidence with the baseline. If the result is surprising: “That gives us something useful to test.”</a:t>
             </a:r>
           </a:p>
           <a:p>
@@ -1099,7 +1170,7 @@
           </a:p>
           <a:p>
             <a:r>
-              <a:t>Guided discussion, about 8 minutes. Brad: “What would you test before asking someone to rely on this all day?” Wesley connects answers to lighting, missed detections, timing, and the operator's evidence. A model score is not automatically a calibrated probability. A timing estimate does not independently establish physical position.</a:t>
+              <a:t>Engineering discussion, 8 minutes. Brad: “What would you test before relying on this all day?” Wesley connects answers to lighting, missed detections, timing, and the information an operator needs. If confidence comes up, explain that the model score is not automatically a calibrated probability. If physical timing comes up, explain that the demo estimates arrival from distance and measured speed; it does not independently measure physical actuator position.</a:t>
             </a:r>
           </a:p>
           <a:p>
@@ -1109,7 +1180,7 @@
           </a:p>
           <a:p>
             <a:r>
-              <a:t>Exit, about 2 minutes. Brad: “You have seen a small version of the problem: make something work, change the conditions, and find out what still needs attention. Wesley, this is where your point about reliability comes in.” Return to slide 12 by 0:36.</a:t>
+              <a:t>Transition, 2 minutes. Brad: “The image, model, tracking, and response each have to hold up. Wesley's experience on the floor is where those requirements become concrete.” Return to slide 13 by 0:36.</a:t>
             </a:r>
           </a:p>
           <a:p>
@@ -1119,7 +1190,7 @@
           </a:p>
           <a:p>
             <a:r>
-              <a:t>Recovery: Show the camera view and last successful result. Ask what the audience would inspect first. Move on within two minutes. Barcodes, extra features, sentiment, and REMI are not required in this default block.</a:t>
+              <a:t>Recovery: Show the camera view and last successful result. Ask what the audience would inspect first. Move on within two minutes. Optional barcodes and physical motion are outside the core sequence.</a:t>
             </a:r>
           </a:p>
         </p:txBody>
@@ -1189,7 +1260,7 @@
           <a:lstStyle/>
           <a:p>
             <a:r>
-              <a:t>Cue: Reliability is what lets the work leave our hands.</a:t>
+              <a:t>Cue: Timing, signals, sunlight, and confidence.</a:t>
             </a:r>
           </a:p>
           <a:p>
@@ -1249,7 +1320,7 @@
           </a:p>
           <a:p>
             <a:r>
-              <a:t>Brad: “That is the difference between something we can demonstrate ourselves and something other people can rely on.”</a:t>
+              <a:t>Brad: “That is the step from a prototype we operate ourselves to a system other people can rely on.”</a:t>
             </a:r>
           </a:p>
         </p:txBody>
@@ -1319,7 +1390,7 @@
           <a:lstStyle/>
           <a:p>
             <a:r>
-              <a:t>Cue: Mechanical, controls, software, testing. Invite people who are still learning.</a:t>
+              <a:t>Cue: Mechanical, controls, software, and testing. Close before the two final QR slides.</a:t>
             </a:r>
           </a:p>
           <a:p>
@@ -1329,17 +1400,7 @@
           </a:p>
           <a:p>
             <a:r>
-              <a:t>Brad: “I started as a mechanical engineering intern who did not know how to do this. Wesley came in through software and machine prototyping. The work needs mechanical engineering, controls, software, and testing.”</a:t>
-            </a:r>
-          </a:p>
-          <a:p>
-            <a:r>
-              <a:t/>
-            </a:r>
-          </a:p>
-          <a:p>
-            <a:r>
-              <a:t>“Tell us what you have built, what you are trying to learn, and what problem you want to take on. Your starting point may look different from ours.”</a:t>
+              <a:t>Brad: “Building the next generation of manufacturing means connecting AI to real work. These problems cross mechanical engineering, controls, software, and testing. We want people who will follow a problem from the first question through deployment and improvement. Tell us what you have built and what you want to take on next.”</a:t>
             </a:r>
           </a:p>
         </p:txBody>
@@ -1409,7 +1470,7 @@
           <a:lstStyle/>
           <a:p>
             <a:r>
-              <a:t>Cue: Final slide. Interactive lab QR, URL, and PIN stay visible through questions. 0:41–0:49 activity.</a:t>
+              <a:t>Cue: Scan, PIN, try, share. 0:41–0:49.</a:t>
             </a:r>
           </a:p>
           <a:p>
@@ -1419,7 +1480,7 @@
           </a:p>
           <a:p>
             <a:r>
-              <a:t>Brad: “Scan this code for the interactive demo, or open 4founders.dev/demo/ai-in-action/. Enter PIN 877262. Try the Audience Lab and notice what matches or surprises your expectations.”</a:t>
+              <a:t>Brad: “Scan the QR code or open the URL on screen. Enter PIN 877262. Try the Audience Lab and notice what matches or surprises your expectations.”</a:t>
             </a:r>
           </a:p>
           <a:p>
@@ -1429,7 +1490,7 @@
           </a:p>
           <a:p>
             <a:r>
-              <a:t>Give 4–5 minutes. Wesley helps with access. Brad keeps the final slide visible, then takes two or three observations: “What would you change before people used this every day?”</a:t>
+              <a:t>Give 4–5 minutes. Wesley helps with access. Brad keeps the QR and PIN visible, then takes two or three observations. Ask: “What would you change before people used this every day?”</a:t>
             </a:r>
           </a:p>
           <a:p>
@@ -1439,7 +1500,7 @@
           </a:p>
           <a:p>
             <a:r>
-              <a:t>Brad: “We have time for questions. What are you curious about, or what are you trying to build?” Hold this final slide through 1:00 so the QR and PIN remain available.</a:t>
+              <a:t>Backup URL: 4founders.dev/demo/ai-in-action/ (https://4founders.dev/demo/ai-in-action/). Recheck access and scan before the event. If access fails, show one prepared example and ask the room to predict it.</a:t>
             </a:r>
           </a:p>
           <a:p>
@@ -1449,17 +1510,12 @@
           </a:p>
           <a:p>
             <a:r>
-              <a:t>Access fallback: Show one prepared example and ask for a prediction. Recheck the live URL, PIN, and projector scan before the event. The QR destination is verified in the file; service access still needs the event check.</a:t>
-            </a:r>
-          </a:p>
-          <a:p>
-            <a:r>
               <a:t/>
             </a:r>
           </a:p>
           <a:p>
             <a:r>
-              <a:t>Brad supplied the internship/OCR story, full-time school in Fayetteville, Friday–Monday work in Lonoke, inspection frustration, Keyence/Cognex experience, new CSG management approval, and call to Wesley in this chat on October 22, 2026. The script presents these as his personal experience, without adding dates, results, or performance comparisons. Wesley's supplied introduction, ownership remarks, real-reject moment, reliability remarks, and invitation are retained; additional story prompts remain his to fill.</a:t>
+              <a:t>Questions, 0:49–1:00: Keep this final slide visible so the lab QR, URL, and PIN remain available. “What are you curious about, or what are you trying to build?”</a:t>
             </a:r>
           </a:p>
           <a:p>
@@ -1469,7 +1525,7 @@
           </a:p>
           <a:p>
             <a:r>
-              <a:t>Technical capabilities follow the existing project documentation: RemingtonVision for capture/labeling/YOLOX training and inference; Public Sentiment for VADER/domain scoring and source review; Little Chef README and docs/KNOWLEDGE.md for retrieval, citations, and scoped tools. The bottle demo README (https://github.com/YeChamo/part-tracking-demo-ualr/blob/main/README.md) distinguishes documented modes. No production settings, inspection criteria, accuracy metrics, or private architecture have been added.</a:t>
+              <a:t>The supplied deck and Brad's project descriptions establish the company context and that the two inspection systems are live and still being refined. Remington's company history (https://www.remington.com/about-us.html) and employee history (https://www.remington.com/big-green-blog/labor-day-special.html) are the existing sources for the 1816 origin and 1969 Lonoke start.</a:t>
             </a:r>
           </a:p>
           <a:p>
@@ -1479,7 +1535,32 @@
           </a:p>
           <a:p>
             <a:r>
-              <a:t>The historical OCR/SCADA anecdote is part of Brad's origin story; a standalone SCADA project slide remains removed. Sentiment and REMI live inserts remain optional and separate. The homepage QR and lab QR have distinct destinations. This revision does not establish hardware or venue readiness.</a:t>
+              <a:t>Technical descriptions were checked against the supplied local project documentation: RemingtonVision README (capture, labeling, YOLOX training/inference, and deployment options); Public Sentiment README (collection, VADER/domain scoring, storage, and dashboard); Little Chef README and docs/KNOWLEDGE.md (local model, retrieval, citations, and scoped tools). These describe software capabilities, not a claim that every feature is deployed on every production line. No inspection criteria, process settings, performance metrics, or production architecture have been added.</a:t>
+            </a:r>
+          </a:p>
+          <a:p>
+            <a:r>
+              <a:t/>
+            </a:r>
+          </a:p>
+          <a:p>
+            <a:r>
+              <a:t>The bottle demo description follows the repository README (https://github.com/YeChamo/part-tracking-demo-ualr/blob/main/README.md). This revision does not establish live hardware, camera, or venue readiness. Wesley supplied his four personal sections; his wording is retained.</a:t>
+            </a:r>
+          </a:p>
+          <a:p>
+            <a:r>
+              <a:t/>
+            </a:r>
+          </a:p>
+          <a:p>
+            <a:r>
+              <a:t/>
+            </a:r>
+          </a:p>
+          <a:p>
+            <a:r>
+              <a:t>Brad's personal introduction comes from his account supplied in this chat: mechanical engineering internship, full-time school in Fayetteville and work in Lonoke Friday–Monday, OCR from HMI web servers, inspection struggles with Keyence/Cognex, CSG approval, and the call to Wesley. The historical OCR/SCADA anecdote does not reintroduce a standalone SCADA project slide. CSG context is sourced in slide 2 notes. The AI/next-generation ambition is the presenters' framing.</a:t>
             </a:r>
           </a:p>
         </p:txBody>
@@ -1549,7 +1630,7 @@
           <a:lstStyle/>
           <a:p>
             <a:r>
-              <a:t>Cue: Homepage QR. This is not the interactive lab link. About 1 minute.</a:t>
+              <a:t>Cue: Penultimate slide. Homepage QR, about 0:40–0:41.</a:t>
             </a:r>
           </a:p>
           <a:p>
@@ -1569,7 +1650,7 @@
           </a:p>
           <a:p>
             <a:r>
-              <a:t>Give the room a moment to scan. The QR encodes https://4founders.dev/. Do not describe unverified homepage features. The next slide is the separate event activity.</a:t>
+              <a:t>Pause for a scan. The QR encodes https://4founders.dev/. Do not promise unverified homepage features.</a:t>
             </a:r>
           </a:p>
           <a:p>
@@ -1649,7 +1730,7 @@
           <a:lstStyle/>
           <a:p>
             <a:r>
-              <a:t>Cue: Close the story before the two QR slides. Finish by about 0:40.</a:t>
+              <a:t>Cue: awhite@tkghunt.com, questions, internship, and ideas. Close the story by about 0:40, before the homepage and lab QR slides.</a:t>
             </a:r>
           </a:p>
           <a:p>
@@ -1659,7 +1740,7 @@
           </a:p>
           <a:p>
             <a:r>
-              <a:t>Brad: “Reach us at awhite@tkghunt.com. We'll be here afterward. Wesley, anything you'd like to add?”</a:t>
+              <a:t>Brad: “Reach us at awhite@tkghunt.com. We’ll be here afterward if anyone wants to connect. Wesley, anything you’d like to add?”</a:t>
             </a:r>
           </a:p>
           <a:p>
@@ -1679,7 +1760,7 @@
           </a:p>
           <a:p>
             <a:r>
-              <a:t>Brad: “We started with a rough OCR application, a problem we could not solve yet, and a chance to try. I called Wesley, and we got to build from there. The generations before us built the foundation. We want to build what the next generation can stand on.”</a:t>
+              <a:t>Brad: “The generations before us built the foundation. We want to build what the next generation can stand on. Our history was made on the factory floor. The future will be, too. Let's bring AI into real work and build the next generation of manufacturing together. Come build and fight with us. Turn AI into action.”</a:t>
             </a:r>
           </a:p>
           <a:p>
@@ -1689,17 +1770,172 @@
           </a:p>
           <a:p>
             <a:r>
-              <a:t>“Our history was made on the factory floor. The future will be, too. Come build and fight with us. Turn AI into action.”</a:t>
-            </a:r>
-          </a:p>
-          <a:p>
-            <a:r>
               <a:t/>
             </a:r>
           </a:p>
           <a:p>
             <a:r>
               <a:t>Bridge: “Before we finish, here are two ways to keep exploring.”</a:t>
+            </a:r>
+          </a:p>
+        </p:txBody>
+      </p:sp>
+      <p:sp>
+        <p:nvSpPr>
+          <p:cNvPr id="4" name="Slide Number Placeholder 3"/>
+          <p:cNvSpPr>
+            <a:spLocks noGrp="1"/>
+          </p:cNvSpPr>
+          <p:nvPr>
+            <p:ph type="sldNum" idx="5"/>
+          </p:nvPr>
+        </p:nvSpPr>
+        <p:spPr/>
+        <p:txBody>
+          <a:bodyPr/>
+          <a:lstStyle/>
+          <a:p/>
+        </p:txBody>
+      </p:sp>
+    </p:spTree>
+  </p:cSld>
+  <p:clrMapOvr>
+    <a:masterClrMapping/>
+  </p:clrMapOvr>
+</p:notes>
+</file>
+
+<file path=ppt/notesSlides/notesSlide18.xml><?xml version="1.0" encoding="utf-8"?>
+<p:notes xmlns:a="http://schemas.openxmlformats.org/drawingml/2006/main" xmlns:p="http://schemas.openxmlformats.org/presentationml/2006/main">
+  <p:cSld>
+    <p:spTree>
+      <p:nvGrpSpPr>
+        <p:cNvPr id="1" name=""/>
+        <p:cNvGrpSpPr/>
+        <p:nvPr/>
+      </p:nvGrpSpPr>
+      <p:grpSpPr>
+        <a:xfrm/>
+      </p:grpSpPr>
+      <p:sp>
+        <p:nvSpPr>
+          <p:cNvPr id="2" name="Slide Image Placeholder 1"/>
+          <p:cNvSpPr>
+            <a:spLocks noGrp="1"/>
+          </p:cNvSpPr>
+          <p:nvPr>
+            <p:ph type="sldImg" idx="0"/>
+          </p:nvPr>
+        </p:nvSpPr>
+        <p:spPr/>
+      </p:sp>
+      <p:sp>
+        <p:nvSpPr>
+          <p:cNvPr id="3" name="Notes Placeholder 2"/>
+          <p:cNvSpPr>
+            <a:spLocks noGrp="1"/>
+          </p:cNvSpPr>
+          <p:nvPr>
+            <p:ph type="body" idx="1"/>
+          </p:nvPr>
+        </p:nvSpPr>
+        <p:spPr/>
+        <p:txBody>
+          <a:bodyPr/>
+          <a:lstStyle/>
+          <a:p>
+            <a:r>
+              <a:t>Cue: CSG context, approval, and the call to Wesley. Complete the personal introduction by about 0:06.</a:t>
+            </a:r>
+          </a:p>
+          <a:p>
+            <a:r>
+              <a:t/>
+            </a:r>
+          </a:p>
+          <a:p>
+            <a:r>
+              <a:t>Brad: “CSG is Czechoslovak Group, an industrial and technology group. The Kinetic Group is part of its Ammo+ division, and Remington is one of the TKG brands. Today's examples come mainly from Lonoke.”</a:t>
+            </a:r>
+          </a:p>
+          <a:p>
+            <a:r>
+              <a:t/>
+            </a:r>
+          </a:p>
+          <a:p>
+            <a:r>
+              <a:t>“Under the new CSG management, the proposal to build our own system was actually approved. They told me to go get an intern.”</a:t>
+            </a:r>
+          </a:p>
+          <a:p>
+            <a:r>
+              <a:t/>
+            </a:r>
+          </a:p>
+          <a:p>
+            <a:r>
+              <a:t>Delivery: Pause at the turn in the story.</a:t>
+            </a:r>
+          </a:p>
+          <a:p>
+            <a:r>
+              <a:t/>
+            </a:r>
+          </a:p>
+          <a:p>
+            <a:r>
+              <a:t>Brad: “So I called Wesley. He decided to come down to central Arkansas and take on the project with me. Wesley, I've told them how I got to that phone call. Tell them your part of the story.”</a:t>
+            </a:r>
+          </a:p>
+          <a:p>
+            <a:r>
+              <a:t/>
+            </a:r>
+          </a:p>
+          <a:p>
+            <a:r>
+              <a:t>Wesley: “Hi, I’m Wesley Siharath. I’m an engineer here at Remington. I got started as an intern focused on software, with some prototyping on machines.”</a:t>
+            </a:r>
+          </a:p>
+          <a:p>
+            <a:r>
+              <a:t/>
+            </a:r>
+          </a:p>
+          <a:p>
+            <a:r>
+              <a:t>“I came on full time this February, and now I work on AI tools and machines. One of the things that drew me here was being able to build a solution and see it put to use on the floor.”</a:t>
+            </a:r>
+          </a:p>
+          <a:p>
+            <a:r>
+              <a:t/>
+            </a:r>
+          </a:p>
+          <a:p>
+            <a:r>
+              <a:t>Wesley's optional story slot, 30–60 seconds: [Add your own memory of the call, coming to central Arkansas, or the first problem you tackled together. The supplied introduction works without an added anecdote.]</a:t>
+            </a:r>
+          </a:p>
+          <a:p>
+            <a:r>
+              <a:t/>
+            </a:r>
+          </a:p>
+          <a:p>
+            <a:r>
+              <a:t>Brad: “We want to turn that opportunity into useful capability on the floor. That is how we want to help build the next generation of manufacturing. Here is the company and the work that story sits inside.”</a:t>
+            </a:r>
+          </a:p>
+          <a:p>
+            <a:r>
+              <a:t/>
+            </a:r>
+          </a:p>
+          <a:p>
+            <a:r>
+              <a:t>Sources for company context: The Kinetic Group About Us (https://www.thekineticgroup.com/aboutus.html); CSG companies (https://csg.com/en/companies), checked October 22, 2026. The AI ambition is the presenters' framing. The approval and internship details are Brad's account.</a:t>
             </a:r>
           </a:p>
         </p:txBody>
@@ -1769,7 +2005,7 @@
           <a:lstStyle/>
           <a:p>
             <a:r>
-              <a:t>Cue: Mechanical intern. Full-time school in Fayetteville. Full-time work in Lonoke, Friday–Monday. OCR.</a:t>
+              <a:t>Cue: 1816, Lonoke 1969, and our turn to contribute.</a:t>
             </a:r>
           </a:p>
           <a:p>
@@ -1779,7 +2015,7 @@
           </a:p>
           <a:p>
             <a:r>
-              <a:t>Brad: “I was a mechanical engineering intern, going to school full time in Fayetteville and working full time in Lonoke, Friday through Monday. I did not know what I was doing yet. I was learning as I went.”</a:t>
+              <a:t>Brad: “Remington's history goes back to 1816. Lonoke has been part of it since 1969. We inherited generations of work in machinery and manufacturing. Our contribution is to connect that experience with cameras, controls, and software. Remington is one of five TKG ammunition brands, so the problems we support extend beyond one site.”</a:t>
             </a:r>
           </a:p>
           <a:p>
@@ -1789,27 +2025,12 @@
           </a:p>
           <a:p>
             <a:r>
-              <a:t>“The first application was OCR: pulling data off HMI web servers. That was my first AI application, and probably the worst SCADA system the world has ever seen.”</a:t>
-            </a:r>
-          </a:p>
-          <a:p>
-            <a:r>
               <a:t/>
             </a:r>
           </a:p>
           <a:p>
             <a:r>
-              <a:t>Delivery: Pause after the joke. Let the room react; do not explain it twice. For anyone unfamiliar with the terms: “OCR reads text from an image. An HMI is the screen people use to see and operate a machine.”</a:t>
-            </a:r>
-          </a:p>
-          <a:p>
-            <a:r>
-              <a:t/>
-            </a:r>
-          </a:p>
-          <a:p>
-            <a:r>
-              <a:t>Brad: “It was rough, but I was building something around a problem I could see. At the same time, I was struggling with inspection projects.”</a:t>
+              <a:t>Bridge from the personal introduction: The slides now return to the original company/project flow. Use the history as context rather than retelling the internship.</a:t>
             </a:r>
           </a:p>
         </p:txBody>
@@ -1879,7 +2100,7 @@
           <a:lstStyle/>
           <a:p>
             <a:r>
-              <a:t>Cue: Off-the-shelf inspection. Keyence and Cognex. Frustration and perspective.</a:t>
+              <a:t>Cue: Real machinery, real operators, real consequences.</a:t>
             </a:r>
           </a:p>
           <a:p>
@@ -1889,47 +2110,7 @@
           </a:p>
           <a:p>
             <a:r>
-              <a:t>Brad: “I was working with off-the-shelf inspection systems, including Keyence and Cognex. I was told it was crazy to make our own AI, and that I needed to make the existing solutions work.”</a:t>
-            </a:r>
-          </a:p>
-          <a:p>
-            <a:r>
-              <a:t/>
-            </a:r>
-          </a:p>
-          <a:p>
-            <a:r>
-              <a:t>“I spent nearly a year on it and could not get where I needed to go. I did not fully understand the systems. I felt defeated.”</a:t>
-            </a:r>
-          </a:p>
-          <a:p>
-            <a:r>
-              <a:t/>
-            </a:r>
-          </a:p>
-          <a:p>
-            <a:r>
-              <a:t>“What I did not appreciate at the time was that I was walking in the shoes of experienced engineers who had struggled with these kinds of problems before me. I thought I was the problem.”</a:t>
-            </a:r>
-          </a:p>
-          <a:p>
-            <a:r>
-              <a:t/>
-            </a:r>
-          </a:p>
-          <a:p>
-            <a:r>
-              <a:t>Delivery: This is your experience with that application and your learning at the time. Keep the emphasis on what you struggled to understand and accomplish. Let the pause after “defeated” carry the moment.</a:t>
-            </a:r>
-          </a:p>
-          <a:p>
-            <a:r>
-              <a:t/>
-            </a:r>
-          </a:p>
-          <a:p>
-            <a:r>
-              <a:t>Bridge: “Eventually, I could not keep approaching it the same way.”</a:t>
+              <a:t>Brad: “We work around energetic materials and moving machinery. That makes timing, clear information, and recovery part of the engineering problem. We build with operators, maintenance, quality, and safety. The software has to fit their workflow and the established safeguards.”</a:t>
             </a:r>
           </a:p>
         </p:txBody>
@@ -1999,7 +2180,7 @@
           <a:lstStyle/>
           <a:p>
             <a:r>
-              <a:t>Cue: Propose another approach. New CSG management approves. Go get an intern.</a:t>
+              <a:t>Cue: Capture, inference, decision, response.</a:t>
             </a:r>
           </a:p>
           <a:p>
@@ -2009,37 +2190,7 @@
           </a:p>
           <a:p>
             <a:r>
-              <a:t>Brad: “I proposed that we build it ourselves. Under the new CSG management, that proposal was actually approved.”</a:t>
-            </a:r>
-          </a:p>
-          <a:p>
-            <a:r>
-              <a:t/>
-            </a:r>
-          </a:p>
-          <a:p>
-            <a:r>
-              <a:t>“They told me to go get an intern.”</a:t>
-            </a:r>
-          </a:p>
-          <a:p>
-            <a:r>
-              <a:t/>
-            </a:r>
-          </a:p>
-          <a:p>
-            <a:r>
-              <a:t>Delivery: Pause. This is the turn in the story.</a:t>
-            </a:r>
-          </a:p>
-          <a:p>
-            <a:r>
-              <a:t/>
-            </a:r>
-          </a:p>
-          <a:p>
-            <a:r>
-              <a:t>Brad: “So I called Wesley. He decided to come down to central Arkansas and take on the project with me.”</a:t>
+              <a:t>Brad: “Sense, decide, act. For a vision system, that means acquiring an image, running inference, interpreting the output, and delivering a result in time for the workflow. A model result is one step in that chain. Camera conditions, signals, software latency, and the response all have to fit together. We test the whole chain and show people the evidence behind the result.”</a:t>
             </a:r>
           </a:p>
         </p:txBody>
@@ -2109,7 +2260,7 @@
           <a:lstStyle/>
           <a:p>
             <a:r>
-              <a:t>Cue: Give Wesley ownership of the next chapter.</a:t>
+              <a:t>Cue: Two live inspection systems, two broader capabilities. Finish this context block by about 0:10.</a:t>
             </a:r>
           </a:p>
           <a:p>
@@ -2119,47 +2270,7 @@
           </a:p>
           <a:p>
             <a:r>
-              <a:t>Brad: “Wesley, I've told them how I got to that phone call. Take it from here. Tell them how you got started and where the project went from there.”</a:t>
-            </a:r>
-          </a:p>
-          <a:p>
-            <a:r>
-              <a:t/>
-            </a:r>
-          </a:p>
-          <a:p>
-            <a:r>
-              <a:t>Wesley: “Hi, I’m Wesley Siharath. I’m an engineer here at Remington. I got started as an intern focused on software, with some prototyping on machines.”</a:t>
-            </a:r>
-          </a:p>
-          <a:p>
-            <a:r>
-              <a:t/>
-            </a:r>
-          </a:p>
-          <a:p>
-            <a:r>
-              <a:t>“I came on full time this February, and now I work on AI tools and machines. One of the things that drew me here was being able to build a solution and see it put to use on the floor.”</a:t>
-            </a:r>
-          </a:p>
-          <a:p>
-            <a:r>
-              <a:t/>
-            </a:r>
-          </a:p>
-          <a:p>
-            <a:r>
-              <a:t>Wesley's story slot, 30–60 seconds: [Add your own memory of Brad's call, coming to central Arkansas, or the first problem you tackled together. What did you think you were taking on? Choose one real moment; the short introduction above is enough if you do not add a story.]</a:t>
-            </a:r>
-          </a:p>
-          <a:p>
-            <a:r>
-              <a:t/>
-            </a:r>
-          </a:p>
-          <a:p>
-            <a:r>
-              <a:t>Bridge for Wesley: “The moment that made it real for me was seeing the system do its job.”</a:t>
+              <a:t>Brad: “Centerfire and shotshell inspection are live and still being refined. Public sentiment and Remi apply software to different questions: what customers are saying, and how engineers find project knowledge. The common problem is making the evidence useful to someone making a decision.”</a:t>
             </a:r>
           </a:p>
         </p:txBody>
@@ -2229,7 +2340,7 @@
           <a:lstStyle/>
           <a:p>
             <a:r>
-              <a:t>Cue: Centerfire inspection. The real reject is the payoff.</a:t>
+              <a:t>Cue: Vision pipeline, visible evidence, operator trust.</a:t>
             </a:r>
           </a:p>
           <a:p>
@@ -2239,7 +2350,7 @@
           </a:p>
           <a:p>
             <a:r>
-              <a:t>Wesley: “One moment that really stuck with me was seeing a real reject come through and watching our system toss it out. Seeing something I helped build actually do its job was an amazing feeling.”</a:t>
+              <a:t>Brad: “Remington Vision brings image capture, labeling, model training, and inference into one toolset. It uses YOLOX detection models and supports workstation and edge deployment. The model is only part of the system. The result has to reach a usable workflow, and people need to understand what the camera saw.”</a:t>
             </a:r>
           </a:p>
           <a:p>
@@ -2249,7 +2360,7 @@
           </a:p>
           <a:p>
             <a:r>
-              <a:t>Wesley's story slot, up to 30 seconds: [What could the room picture about that moment? Add what you personally saw or felt. Do not invent performance numbers or describe an unapproved inspection criterion.]</a:t>
+              <a:t>Wesley: “On the floor we show operators what the system sees, listen when something is confusing, and make changes they can judge for themselves.”</a:t>
             </a:r>
           </a:p>
           <a:p>
@@ -2259,27 +2370,7 @@
           </a:p>
           <a:p>
             <a:r>
-              <a:t>Brad: “That is the connection we had been trying to make: an image, a model result, and something useful happening on the floor. The tools now cover image capture, labeling, model training, and inference with YOLOX detection models.”</a:t>
-            </a:r>
-          </a:p>
-          <a:p>
-            <a:r>
-              <a:t/>
-            </a:r>
-          </a:p>
-          <a:p>
-            <a:r>
-              <a:t>Wesley: “On the floor we show operators what the system sees, listen when something is confusing, and make changes they can judge for themselves.”</a:t>
-            </a:r>
-          </a:p>
-          <a:p>
-            <a:r>
-              <a:t/>
-            </a:r>
-          </a:p>
-          <a:p>
-            <a:r>
-              <a:t>Brad: “The result working is a milestone. Earning the confidence of the people using it is more work.”</a:t>
+              <a:t>Brad: “That feedback is part of commissioning and continued improvement. It is how the technical result earns trust.”</a:t>
             </a:r>
           </a:p>
         </p:txBody>
@@ -2349,7 +2440,7 @@
           <a:lstStyle/>
           <a:p>
             <a:r>
-              <a:t>Cue: Shotshell inspection. Reuse the tooling; learn the application again.</a:t>
+              <a:t>Cue: A different product changes the image and the data.</a:t>
             </a:r>
           </a:p>
           <a:p>
@@ -2369,17 +2460,7 @@
           </a:p>
           <a:p>
             <a:r>
-              <a:t>Optional Wesley story slot: [One short example of something that had to change for the different product. Use an example you are comfortable sharing.]</a:t>
-            </a:r>
-          </a:p>
-          <a:p>
-            <a:r>
-              <a:t/>
-            </a:r>
-          </a:p>
-          <a:p>
-            <a:r>
-              <a:t>Brad: “Centerfire and shotshell inspection are live and still being refined. What we learned on one project gave us a starting point for the next, and the next application still had to earn its result.”</a:t>
+              <a:t>Brad: “This is also live and being refined. Reusing software still leaves real integration work.”</a:t>
             </a:r>
           </a:p>
         </p:txBody>
@@ -2449,7 +2530,7 @@
           <a:lstStyle/>
           <a:p>
             <a:r>
-              <a:t>Cue: Public sentiment. A brief example of where the same approach led.</a:t>
+              <a:t>Cue: Collect, score, retain the source.</a:t>
             </a:r>
           </a:p>
           <a:p>
@@ -2459,27 +2540,7 @@
           </a:p>
           <a:p>
             <a:r>
-              <a:t>Brad: “The questions grew beyond images of parts. Sometimes the information is what people are saying publicly about products. The sentiment project collects discussion, uses VADER with domain vocabulary to score it, and keeps the original comments available.”</a:t>
-            </a:r>
-          </a:p>
-          <a:p>
-            <a:r>
-              <a:t/>
-            </a:r>
-          </a:p>
-          <a:p>
-            <a:r>
-              <a:t>“The same lesson applies: give somebody a useful place to investigate, and let them inspect the evidence.”</a:t>
-            </a:r>
-          </a:p>
-          <a:p>
-            <a:r>
-              <a:t/>
-            </a:r>
-          </a:p>
-          <a:p>
-            <a:r>
-              <a:t>Delivery: Keep this to about 30–45 seconds. The optional sentiment demonstration is prepared separately; it is not part of this default sequence.</a:t>
+              <a:t>Brad: “The sentiment project collects public discussion, scores sentiment and product themes, and stores the results for review. The scoring uses VADER with a domain vocabulary. A trend gives the team somewhere to investigate. Keeping the original comments available lets people check what the score actually represents.”</a:t>
             </a:r>
           </a:p>
         </p:txBody>
@@ -5508,7 +5569,7 @@
 </file>
 
 <file path=ppt/slides/slide1.xml><?xml version="1.0" encoding="utf-8"?>
-<p:sld xmlns:p="http://schemas.openxmlformats.org/presentationml/2006/main">
+<p:sld xmlns:a="http://schemas.openxmlformats.org/drawingml/2006/main" xmlns:ns2="http://schemas.microsoft.com/office/drawing/2014/main" xmlns:ns3="http://schemas.microsoft.com/office/powerpoint/2010/main" xmlns:p="http://schemas.openxmlformats.org/presentationml/2006/main">
   <p:cSld>
     <p:spTree>
       <p:nvGrpSpPr>
@@ -5517,39 +5578,39 @@
         <p:nvPr/>
       </p:nvGrpSpPr>
       <p:grpSpPr>
-        <a:xfrm xmlns:a="http://schemas.openxmlformats.org/drawingml/2006/main"/>
+        <a:xfrm/>
       </p:grpSpPr>
       <p:sp>
         <p:nvSpPr>
           <p:cNvPr id="5" name="">
-            <a:extLst xmlns:a="http://schemas.openxmlformats.org/drawingml/2006/main">
+            <a:extLst>
               <a:ext uri="{FF2B5EF4-FFF2-40B4-BE49-F238E27FC236}">
-                <a16:creationId xmlns:a16="http://schemas.microsoft.com/office/drawing/2014/main" id="{FDE87B26-18C7-45F5-93FF-53ED48BFE142}"/>
+                <ns2:creationId id="{FDE87B26-18C7-45F5-93FF-53ED48BFE142}"/>
               </a:ext>
             </a:extLst>
           </p:cNvPr>
           <p:cNvSpPr>
-            <a:spLocks xmlns:a="http://schemas.openxmlformats.org/drawingml/2006/main" noGrp="1"/>
+            <a:spLocks noGrp="1"/>
           </p:cNvSpPr>
           <p:nvPr/>
         </p:nvSpPr>
         <p:spPr>
-          <a:xfrm xmlns:a="http://schemas.openxmlformats.org/drawingml/2006/main">
+          <a:xfrm>
             <a:off x="904875" y="2247900"/>
             <a:ext cx="7334250" cy="1362075"/>
           </a:xfrm>
-          <a:prstGeom xmlns:a="http://schemas.openxmlformats.org/drawingml/2006/main" prst="rect">
+          <a:prstGeom prst="rect">
             <a:avLst/>
           </a:prstGeom>
-          <a:noFill xmlns:a="http://schemas.openxmlformats.org/drawingml/2006/main"/>
-          <a:ln xmlns:a="http://schemas.openxmlformats.org/drawingml/2006/main" w="0">
+          <a:noFill/>
+          <a:ln w="0">
             <a:noFill/>
             <a:prstDash val="solid"/>
           </a:ln>
         </p:spPr>
         <p:txBody>
-          <a:bodyPr xmlns:a="http://schemas.openxmlformats.org/drawingml/2006/main" lIns="0" tIns="0" rIns="0" bIns="0"/>
-          <a:lstStyle xmlns:a="http://schemas.openxmlformats.org/drawingml/2006/main">
+          <a:bodyPr lIns="0" tIns="0" rIns="0" bIns="0"/>
+          <a:lstStyle>
             <a:defPPr algn="ctr">
               <a:defRPr sz="4125" b="0" i="0">
                 <a:solidFill>
@@ -5630,7 +5691,7 @@
               </a:defRPr>
             </a:lvl9pPr>
           </a:lstStyle>
-          <a:p xmlns:a="http://schemas.openxmlformats.org/drawingml/2006/main">
+          <a:p>
             <a:pPr algn="ctr">
               <a:buNone/>
               <a:defRPr sz="4125" b="0" i="0">
@@ -5648,7 +5709,7 @@
               <a:t>Engineering at</a:t>
             </a:r>
           </a:p>
-          <a:p xmlns:a="http://schemas.openxmlformats.org/drawingml/2006/main">
+          <a:p>
             <a:pPr algn="ctr">
               <a:buNone/>
               <a:defRPr sz="4125" b="0" i="0">
@@ -5671,34 +5732,34 @@
       <p:sp>
         <p:nvSpPr>
           <p:cNvPr id="2" name="">
-            <a:extLst xmlns:a="http://schemas.openxmlformats.org/drawingml/2006/main">
+            <a:extLst>
               <a:ext uri="{FF2B5EF4-FFF2-40B4-BE49-F238E27FC236}">
-                <a16:creationId xmlns:a16="http://schemas.microsoft.com/office/drawing/2014/main" id="{4ABA60F8-29B6-4B9A-85ED-6AC64EC1527C}"/>
+                <ns2:creationId id="{4ABA60F8-29B6-4B9A-85ED-6AC64EC1527C}"/>
               </a:ext>
             </a:extLst>
           </p:cNvPr>
           <p:cNvSpPr>
-            <a:spLocks xmlns:a="http://schemas.openxmlformats.org/drawingml/2006/main" noGrp="1"/>
+            <a:spLocks noGrp="1"/>
           </p:cNvSpPr>
           <p:nvPr/>
         </p:nvSpPr>
         <p:spPr>
-          <a:xfrm xmlns:a="http://schemas.openxmlformats.org/drawingml/2006/main">
+          <a:xfrm>
             <a:off x="952500" y="4286250"/>
             <a:ext cx="7239000" cy="495300"/>
           </a:xfrm>
-          <a:prstGeom xmlns:a="http://schemas.openxmlformats.org/drawingml/2006/main" prst="rect">
+          <a:prstGeom prst="rect">
             <a:avLst/>
           </a:prstGeom>
-          <a:noFill xmlns:a="http://schemas.openxmlformats.org/drawingml/2006/main"/>
-          <a:ln xmlns:a="http://schemas.openxmlformats.org/drawingml/2006/main" w="0">
+          <a:noFill/>
+          <a:ln w="0">
             <a:noFill/>
             <a:prstDash val="solid"/>
           </a:ln>
         </p:spPr>
         <p:txBody>
-          <a:bodyPr xmlns:a="http://schemas.openxmlformats.org/drawingml/2006/main" lIns="0" tIns="0" rIns="0" bIns="0"/>
-          <a:lstStyle xmlns:a="http://schemas.openxmlformats.org/drawingml/2006/main">
+          <a:bodyPr lIns="0" tIns="0" rIns="0" bIns="0"/>
+          <a:lstStyle>
             <a:defPPr algn="ctr">
               <a:defRPr sz="2250" b="0" i="0">
                 <a:solidFill>
@@ -5779,7 +5840,7 @@
               </a:defRPr>
             </a:lvl9pPr>
           </a:lstStyle>
-          <a:p xmlns:a="http://schemas.openxmlformats.org/drawingml/2006/main">
+          <a:p>
             <a:pPr algn="ctr">
               <a:buNone/>
               <a:defRPr sz="2250" b="0" i="0">
@@ -5802,34 +5863,34 @@
       <p:sp>
         <p:nvSpPr>
           <p:cNvPr id="3" name="">
-            <a:extLst xmlns:a="http://schemas.openxmlformats.org/drawingml/2006/main">
+            <a:extLst>
               <a:ext uri="{FF2B5EF4-FFF2-40B4-BE49-F238E27FC236}">
-                <a16:creationId xmlns:a16="http://schemas.microsoft.com/office/drawing/2014/main" id="{7B96AC22-F9C7-4365-8E03-CDD4D7110DBE}"/>
+                <ns2:creationId id="{7B96AC22-F9C7-4365-8E03-CDD4D7110DBE}"/>
               </a:ext>
             </a:extLst>
           </p:cNvPr>
           <p:cNvSpPr>
-            <a:spLocks xmlns:a="http://schemas.openxmlformats.org/drawingml/2006/main" noGrp="1"/>
+            <a:spLocks noGrp="1"/>
           </p:cNvSpPr>
           <p:nvPr/>
         </p:nvSpPr>
         <p:spPr>
-          <a:xfrm xmlns:a="http://schemas.openxmlformats.org/drawingml/2006/main">
+          <a:xfrm>
             <a:off x="1238250" y="5019675"/>
             <a:ext cx="6667500" cy="400050"/>
           </a:xfrm>
-          <a:prstGeom xmlns:a="http://schemas.openxmlformats.org/drawingml/2006/main" prst="rect">
+          <a:prstGeom prst="rect">
             <a:avLst/>
           </a:prstGeom>
-          <a:noFill xmlns:a="http://schemas.openxmlformats.org/drawingml/2006/main"/>
-          <a:ln xmlns:a="http://schemas.openxmlformats.org/drawingml/2006/main" w="0">
+          <a:noFill/>
+          <a:ln w="0">
             <a:noFill/>
             <a:prstDash val="solid"/>
           </a:ln>
         </p:spPr>
         <p:txBody>
-          <a:bodyPr xmlns:a="http://schemas.openxmlformats.org/drawingml/2006/main" lIns="0" tIns="0" rIns="0" bIns="0"/>
-          <a:lstStyle xmlns:a="http://schemas.openxmlformats.org/drawingml/2006/main">
+          <a:bodyPr lIns="0" tIns="0" rIns="0" bIns="0"/>
+          <a:lstStyle>
             <a:defPPr algn="ctr">
               <a:defRPr sz="1650" b="0" i="0">
                 <a:solidFill>
@@ -5910,7 +5971,7 @@
               </a:defRPr>
             </a:lvl9pPr>
           </a:lstStyle>
-          <a:p xmlns:a="http://schemas.openxmlformats.org/drawingml/2006/main">
+          <a:p>
             <a:pPr algn="ctr">
               <a:buNone/>
               <a:defRPr sz="1650" b="0" i="0">
@@ -5933,34 +5994,34 @@
       <p:sp>
         <p:nvSpPr>
           <p:cNvPr id="4" name="">
-            <a:extLst xmlns:a="http://schemas.openxmlformats.org/drawingml/2006/main">
+            <a:extLst>
               <a:ext uri="{FF2B5EF4-FFF2-40B4-BE49-F238E27FC236}">
-                <a16:creationId xmlns:a16="http://schemas.microsoft.com/office/drawing/2014/main" id="{1675AF90-ACB1-4495-A523-4F205D0DBC90}"/>
+                <ns2:creationId id="{1675AF90-ACB1-4495-A523-4F205D0DBC90}"/>
               </a:ext>
             </a:extLst>
           </p:cNvPr>
           <p:cNvSpPr>
-            <a:spLocks xmlns:a="http://schemas.openxmlformats.org/drawingml/2006/main" noGrp="1"/>
+            <a:spLocks noGrp="1"/>
           </p:cNvSpPr>
           <p:nvPr/>
         </p:nvSpPr>
         <p:spPr>
-          <a:xfrm xmlns:a="http://schemas.openxmlformats.org/drawingml/2006/main">
+          <a:xfrm>
             <a:off x="161925" y="6372225"/>
             <a:ext cx="552450" cy="419100"/>
           </a:xfrm>
-          <a:prstGeom xmlns:a="http://schemas.openxmlformats.org/drawingml/2006/main" prst="rect">
+          <a:prstGeom prst="rect">
             <a:avLst/>
           </a:prstGeom>
-          <a:noFill xmlns:a="http://schemas.openxmlformats.org/drawingml/2006/main"/>
-          <a:ln xmlns:a="http://schemas.openxmlformats.org/drawingml/2006/main" w="0">
+          <a:noFill/>
+          <a:ln w="0">
             <a:noFill/>
             <a:prstDash val="solid"/>
           </a:ln>
         </p:spPr>
         <p:txBody>
-          <a:bodyPr xmlns:a="http://schemas.openxmlformats.org/drawingml/2006/main" lIns="0" tIns="0" rIns="0" bIns="0"/>
-          <a:lstStyle xmlns:a="http://schemas.openxmlformats.org/drawingml/2006/main">
+          <a:bodyPr lIns="0" tIns="0" rIns="0" bIns="0"/>
+          <a:lstStyle>
             <a:defPPr algn="l">
               <a:defRPr sz="1125" b="1" i="0">
                 <a:solidFill>
@@ -6041,7 +6102,7 @@
               </a:defRPr>
             </a:lvl9pPr>
           </a:lstStyle>
-          <a:p xmlns:a="http://schemas.openxmlformats.org/drawingml/2006/main">
+          <a:p>
             <a:pPr algn="l">
               <a:buNone/>
               <a:defRPr sz="1125" b="1" i="0">
@@ -6064,7 +6125,7 @@
     </p:spTree>
     <p:extLst>
       <p:ext uri="{BB962C8B-B14F-4D97-AF65-F5344CB8AC3E}">
-        <p14:creationId xmlns:p14="http://schemas.microsoft.com/office/powerpoint/2010/main" val="667113381"/>
+        <ns3:creationId val="667113381"/>
       </p:ext>
     </p:extLst>
   </p:cSld>
@@ -6700,7 +6761,7 @@
                   <a:srgbClr val="000000"/>
                 </a:solidFill>
               </a:rPr>
-              <a:t>9</a:t>
+              <a:t>10</a:t>
             </a:r>
           </a:p>
         </p:txBody>
@@ -6984,7 +7045,7 @@
                   <a:srgbClr val="000000"/>
                 </a:solidFill>
               </a:rPr>
-              <a:t>10</a:t>
+              <a:t>11</a:t>
             </a:r>
           </a:p>
         </p:txBody>
@@ -8185,7 +8246,7 @@
                   <a:srgbClr val="FFFFFF"/>
                 </a:solidFill>
               </a:rPr>
-              <a:t>What we learned, live</a:t>
+              <a:t>Live demonstration</a:t>
             </a:r>
           </a:p>
         </p:txBody>
@@ -8316,7 +8377,7 @@
                   <a:srgbClr val="000000"/>
                 </a:solidFill>
               </a:rPr>
-              <a:t>11</a:t>
+              <a:t>12</a:t>
             </a:r>
           </a:p>
         </p:txBody>
@@ -8447,7 +8508,7 @@
                   <a:srgbClr val="FFFFFF"/>
                 </a:solidFill>
               </a:rPr>
-              <a:t>CAMERA  →  AI  →  RESULT</a:t>
+              <a:t>CAMERA  →  AI  →  ACTION</a:t>
             </a:r>
           </a:p>
         </p:txBody>
@@ -8578,7 +8639,7 @@
                   <a:srgbClr val="BEA06A"/>
                 </a:solidFill>
               </a:rPr>
-              <a:t>Gatorade bottles  ·  detection and tracking</a:t>
+              <a:t>Gatorade bottles  ·  on-screen sorting</a:t>
             </a:r>
           </a:p>
         </p:txBody>
@@ -8862,7 +8923,7 @@
                   <a:srgbClr val="000000"/>
                 </a:solidFill>
               </a:rPr>
-              <a:t>12</a:t>
+              <a:t>13</a:t>
             </a:r>
           </a:p>
         </p:txBody>
@@ -10063,7 +10124,7 @@
                   <a:srgbClr val="FFFFFF"/>
                 </a:solidFill>
               </a:rPr>
-              <a:t>Your starting point could look different</a:t>
+              <a:t>Come fight for what is next</a:t>
             </a:r>
           </a:p>
         </p:txBody>
@@ -10194,7 +10255,7 @@
                   <a:srgbClr val="000000"/>
                 </a:solidFill>
               </a:rPr>
-              <a:t>13</a:t>
+              <a:t>14</a:t>
             </a:r>
           </a:p>
         </p:txBody>
@@ -11657,7 +11718,7 @@
                   <a:srgbClr val="FFFFFF"/>
                 </a:solidFill>
               </a:rPr>
-              <a:t>Your turn to explore</a:t>
+              <a:t>4Founders challenge</a:t>
             </a:r>
           </a:p>
         </p:txBody>
@@ -11788,7 +11849,7 @@
                   <a:srgbClr val="000000"/>
                 </a:solidFill>
               </a:rPr>
-              <a:t>16</a:t>
+              <a:t>17</a:t>
             </a:r>
           </a:p>
         </p:txBody>
@@ -12049,7 +12110,7 @@
                 <a:solidFill>
                   <a:srgbClr val="BEA06A"/>
                 </a:solidFill>
-                <a:hlinkClick r:id="rIdStoryWeb"/>
+                <a:hlinkClick r:id="rIdOriginalFlowWeb"/>
               </a:rPr>
               <a:t>4founders.dev/demo/ai-in-action/</a:t>
             </a:r>
@@ -12064,7 +12125,7 @@
                 <ns2:creationId id="{17A57D48-9186-4AB0-A73C-9A9F9454AD3D}"/>
               </a:ext>
             </a:extLst>
-            <a:hlinkClick r:id="rIdStoryWeb"/>
+            <a:hlinkClick r:id="rIdOriginalFlowWeb"/>
           </p:cNvPr>
           <p:cNvPicPr>
             <a:picLocks noChangeAspect="1"/>
@@ -12616,7 +12677,7 @@
                   <a:srgbClr val="000000"/>
                 </a:solidFill>
               </a:rPr>
-              <a:t>15</a:t>
+              <a:t>16</a:t>
             </a:r>
           </a:p>
         </p:txBody>
@@ -12877,7 +12938,7 @@
                 <a:solidFill>
                   <a:srgbClr val="BEA06A"/>
                 </a:solidFill>
-                <a:hlinkClick r:id="rIdStoryWeb"/>
+                <a:hlinkClick r:id="rIdOriginalFlowWeb"/>
               </a:rPr>
               <a:t>4founders.dev</a:t>
             </a:r>
@@ -12892,7 +12953,7 @@
                 <ns2:creationId id="{17A57D48-9186-4AB0-A73C-9A9F9454AD3D}"/>
               </a:ext>
             </a:extLst>
-            <a:hlinkClick r:id="rIdStoryWeb"/>
+            <a:hlinkClick r:id="rIdOriginalFlowWeb"/>
           </p:cNvPr>
           <p:cNvPicPr>
             <a:picLocks noChangeAspect="1"/>
@@ -13444,7 +13505,7 @@
                   <a:srgbClr val="000000"/>
                 </a:solidFill>
               </a:rPr>
-              <a:t>14</a:t>
+              <a:t>15</a:t>
             </a:r>
           </a:p>
         </p:txBody>
@@ -13864,6 +13925,1261 @@
     <p:extLst>
       <p:ext uri="{BB962C8B-B14F-4D97-AF65-F5344CB8AC3E}">
         <ns3:creationId val="526665785"/>
+      </p:ext>
+    </p:extLst>
+  </p:cSld>
+</p:sld>
+</file>
+
+<file path=ppt/slides/slide18.xml><?xml version="1.0" encoding="utf-8"?>
+<p:sld xmlns:a="http://schemas.openxmlformats.org/drawingml/2006/main" xmlns:ns2="http://schemas.microsoft.com/office/drawing/2014/main" xmlns:ns3="http://schemas.microsoft.com/office/powerpoint/2010/main" xmlns:p="http://schemas.openxmlformats.org/presentationml/2006/main">
+  <p:cSld>
+    <p:spTree>
+      <p:nvGrpSpPr>
+        <p:cNvPr id="1" name=""/>
+        <p:cNvGrpSpPr/>
+        <p:nvPr/>
+      </p:nvGrpSpPr>
+      <p:grpSpPr>
+        <a:xfrm/>
+      </p:grpSpPr>
+      <p:sp>
+        <p:nvSpPr>
+          <p:cNvPr id="10" name="">
+            <a:extLst>
+              <a:ext uri="{FF2B5EF4-FFF2-40B4-BE49-F238E27FC236}">
+                <ns2:creationId id="{D0F38884-198E-4A16-8A86-C1862F382EE2}"/>
+              </a:ext>
+            </a:extLst>
+          </p:cNvPr>
+          <p:cNvSpPr>
+            <a:spLocks noGrp="1"/>
+          </p:cNvSpPr>
+          <p:nvPr/>
+        </p:nvSpPr>
+        <p:spPr>
+          <a:xfrm>
+            <a:off x="704850" y="1495425"/>
+            <a:ext cx="7743825" cy="619125"/>
+          </a:xfrm>
+          <a:prstGeom prst="rect">
+            <a:avLst/>
+          </a:prstGeom>
+          <a:noFill/>
+          <a:ln w="0">
+            <a:noFill/>
+            <a:prstDash val="solid"/>
+          </a:ln>
+        </p:spPr>
+        <p:txBody>
+          <a:bodyPr lIns="0" tIns="0" rIns="0" bIns="0"/>
+          <a:lstStyle>
+            <a:defPPr algn="l">
+              <a:defRPr sz="3000" b="0" i="0">
+                <a:solidFill>
+                  <a:srgbClr val="FFFFFF"/>
+                </a:solidFill>
+              </a:defRPr>
+            </a:defPPr>
+            <a:lvl1pPr algn="l">
+              <a:buNone/>
+              <a:defRPr sz="3000" b="0" i="0">
+                <a:solidFill>
+                  <a:srgbClr val="FFFFFF"/>
+                </a:solidFill>
+              </a:defRPr>
+            </a:lvl1pPr>
+            <a:lvl2pPr algn="l">
+              <a:buNone/>
+              <a:defRPr sz="3000" b="0" i="0">
+                <a:solidFill>
+                  <a:srgbClr val="FFFFFF"/>
+                </a:solidFill>
+              </a:defRPr>
+            </a:lvl2pPr>
+            <a:lvl3pPr algn="l">
+              <a:buNone/>
+              <a:defRPr sz="3000" b="0" i="0">
+                <a:solidFill>
+                  <a:srgbClr val="FFFFFF"/>
+                </a:solidFill>
+              </a:defRPr>
+            </a:lvl3pPr>
+            <a:lvl4pPr algn="l">
+              <a:buNone/>
+              <a:defRPr sz="3000" b="0" i="0">
+                <a:solidFill>
+                  <a:srgbClr val="FFFFFF"/>
+                </a:solidFill>
+              </a:defRPr>
+            </a:lvl4pPr>
+            <a:lvl5pPr algn="l">
+              <a:buNone/>
+              <a:defRPr sz="3000" b="0" i="0">
+                <a:solidFill>
+                  <a:srgbClr val="FFFFFF"/>
+                </a:solidFill>
+              </a:defRPr>
+            </a:lvl5pPr>
+            <a:lvl6pPr algn="l">
+              <a:buNone/>
+              <a:defRPr sz="3000" b="0" i="0">
+                <a:solidFill>
+                  <a:srgbClr val="FFFFFF"/>
+                </a:solidFill>
+              </a:defRPr>
+            </a:lvl6pPr>
+            <a:lvl7pPr algn="l">
+              <a:buNone/>
+              <a:defRPr sz="3000" b="0" i="0">
+                <a:solidFill>
+                  <a:srgbClr val="FFFFFF"/>
+                </a:solidFill>
+              </a:defRPr>
+            </a:lvl7pPr>
+            <a:lvl8pPr algn="l">
+              <a:buNone/>
+              <a:defRPr sz="3000" b="0" i="0">
+                <a:solidFill>
+                  <a:srgbClr val="FFFFFF"/>
+                </a:solidFill>
+              </a:defRPr>
+            </a:lvl8pPr>
+            <a:lvl9pPr algn="l">
+              <a:buNone/>
+              <a:defRPr sz="3000" b="0" i="0">
+                <a:solidFill>
+                  <a:srgbClr val="FFFFFF"/>
+                </a:solidFill>
+              </a:defRPr>
+            </a:lvl9pPr>
+          </a:lstStyle>
+          <a:p>
+            <a:pPr algn="l">
+              <a:buNone/>
+              <a:defRPr sz="3000" b="0" i="0">
+                <a:solidFill>
+                  <a:srgbClr val="FFFFFF"/>
+                </a:solidFill>
+              </a:defRPr>
+            </a:pPr>
+            <a:r>
+              <a:rPr sz="3000" b="0" i="0">
+                <a:solidFill>
+                  <a:srgbClr val="FFFFFF"/>
+                </a:solidFill>
+              </a:rPr>
+              <a:t>CSG: Czechoslovak Group</a:t>
+            </a:r>
+          </a:p>
+        </p:txBody>
+      </p:sp>
+      <p:sp>
+        <p:nvSpPr>
+          <p:cNvPr id="2" name="">
+            <a:extLst>
+              <a:ext uri="{FF2B5EF4-FFF2-40B4-BE49-F238E27FC236}">
+                <ns2:creationId id="{FBBC7091-D511-4C55-BC16-67368151C20D}"/>
+              </a:ext>
+            </a:extLst>
+          </p:cNvPr>
+          <p:cNvSpPr>
+            <a:spLocks noGrp="1"/>
+          </p:cNvSpPr>
+          <p:nvPr/>
+        </p:nvSpPr>
+        <p:spPr>
+          <a:xfrm>
+            <a:off x="161925" y="6372225"/>
+            <a:ext cx="552450" cy="419100"/>
+          </a:xfrm>
+          <a:prstGeom prst="rect">
+            <a:avLst/>
+          </a:prstGeom>
+          <a:noFill/>
+          <a:ln w="0">
+            <a:noFill/>
+            <a:prstDash val="solid"/>
+          </a:ln>
+        </p:spPr>
+        <p:txBody>
+          <a:bodyPr lIns="0" tIns="0" rIns="0" bIns="0"/>
+          <a:lstStyle>
+            <a:defPPr algn="l">
+              <a:defRPr sz="1125" b="1" i="0">
+                <a:solidFill>
+                  <a:srgbClr val="000000"/>
+                </a:solidFill>
+              </a:defRPr>
+            </a:defPPr>
+            <a:lvl1pPr algn="l">
+              <a:buNone/>
+              <a:defRPr sz="1125" b="1" i="0">
+                <a:solidFill>
+                  <a:srgbClr val="000000"/>
+                </a:solidFill>
+              </a:defRPr>
+            </a:lvl1pPr>
+            <a:lvl2pPr algn="l">
+              <a:buNone/>
+              <a:defRPr sz="1125" b="1" i="0">
+                <a:solidFill>
+                  <a:srgbClr val="000000"/>
+                </a:solidFill>
+              </a:defRPr>
+            </a:lvl2pPr>
+            <a:lvl3pPr algn="l">
+              <a:buNone/>
+              <a:defRPr sz="1125" b="1" i="0">
+                <a:solidFill>
+                  <a:srgbClr val="000000"/>
+                </a:solidFill>
+              </a:defRPr>
+            </a:lvl3pPr>
+            <a:lvl4pPr algn="l">
+              <a:buNone/>
+              <a:defRPr sz="1125" b="1" i="0">
+                <a:solidFill>
+                  <a:srgbClr val="000000"/>
+                </a:solidFill>
+              </a:defRPr>
+            </a:lvl4pPr>
+            <a:lvl5pPr algn="l">
+              <a:buNone/>
+              <a:defRPr sz="1125" b="1" i="0">
+                <a:solidFill>
+                  <a:srgbClr val="000000"/>
+                </a:solidFill>
+              </a:defRPr>
+            </a:lvl5pPr>
+            <a:lvl6pPr algn="l">
+              <a:buNone/>
+              <a:defRPr sz="1125" b="1" i="0">
+                <a:solidFill>
+                  <a:srgbClr val="000000"/>
+                </a:solidFill>
+              </a:defRPr>
+            </a:lvl6pPr>
+            <a:lvl7pPr algn="l">
+              <a:buNone/>
+              <a:defRPr sz="1125" b="1" i="0">
+                <a:solidFill>
+                  <a:srgbClr val="000000"/>
+                </a:solidFill>
+              </a:defRPr>
+            </a:lvl7pPr>
+            <a:lvl8pPr algn="l">
+              <a:buNone/>
+              <a:defRPr sz="1125" b="1" i="0">
+                <a:solidFill>
+                  <a:srgbClr val="000000"/>
+                </a:solidFill>
+              </a:defRPr>
+            </a:lvl8pPr>
+            <a:lvl9pPr algn="l">
+              <a:buNone/>
+              <a:defRPr sz="1125" b="1" i="0">
+                <a:solidFill>
+                  <a:srgbClr val="000000"/>
+                </a:solidFill>
+              </a:defRPr>
+            </a:lvl9pPr>
+          </a:lstStyle>
+          <a:p>
+            <a:pPr algn="l">
+              <a:buNone/>
+              <a:defRPr sz="1125" b="1" i="0">
+                <a:solidFill>
+                  <a:srgbClr val="000000"/>
+                </a:solidFill>
+              </a:defRPr>
+            </a:pPr>
+            <a:r>
+              <a:rPr sz="1125" b="1" i="0">
+                <a:solidFill>
+                  <a:srgbClr val="000000"/>
+                </a:solidFill>
+              </a:rPr>
+              <a:t>2</a:t>
+            </a:r>
+          </a:p>
+        </p:txBody>
+      </p:sp>
+      <p:sp>
+        <p:nvSpPr>
+          <p:cNvPr id="3" name="">
+            <a:extLst>
+              <a:ext uri="{FF2B5EF4-FFF2-40B4-BE49-F238E27FC236}">
+                <ns2:creationId id="{397AAB4E-702C-4357-88ED-A71219DCD0B1}"/>
+              </a:ext>
+            </a:extLst>
+          </p:cNvPr>
+          <p:cNvSpPr>
+            <a:spLocks noGrp="1"/>
+          </p:cNvSpPr>
+          <p:nvPr/>
+        </p:nvSpPr>
+        <p:spPr>
+          <a:xfrm>
+            <a:off x="723900" y="2800350"/>
+            <a:ext cx="2381250" cy="619125"/>
+          </a:xfrm>
+          <a:prstGeom prst="rect">
+            <a:avLst/>
+          </a:prstGeom>
+          <a:noFill/>
+          <a:ln w="0">
+            <a:noFill/>
+            <a:prstDash val="solid"/>
+          </a:ln>
+        </p:spPr>
+        <p:txBody>
+          <a:bodyPr lIns="0" tIns="0" rIns="0" bIns="0"/>
+          <a:lstStyle>
+            <a:defPPr algn="l">
+              <a:defRPr sz="2625" b="1" i="0">
+                <a:solidFill>
+                  <a:srgbClr val="BEA06A"/>
+                </a:solidFill>
+              </a:defRPr>
+            </a:defPPr>
+            <a:lvl1pPr algn="l">
+              <a:buNone/>
+              <a:defRPr sz="2625" b="1" i="0">
+                <a:solidFill>
+                  <a:srgbClr val="BEA06A"/>
+                </a:solidFill>
+              </a:defRPr>
+            </a:lvl1pPr>
+            <a:lvl2pPr algn="l">
+              <a:buNone/>
+              <a:defRPr sz="2625" b="1" i="0">
+                <a:solidFill>
+                  <a:srgbClr val="BEA06A"/>
+                </a:solidFill>
+              </a:defRPr>
+            </a:lvl2pPr>
+            <a:lvl3pPr algn="l">
+              <a:buNone/>
+              <a:defRPr sz="2625" b="1" i="0">
+                <a:solidFill>
+                  <a:srgbClr val="BEA06A"/>
+                </a:solidFill>
+              </a:defRPr>
+            </a:lvl3pPr>
+            <a:lvl4pPr algn="l">
+              <a:buNone/>
+              <a:defRPr sz="2625" b="1" i="0">
+                <a:solidFill>
+                  <a:srgbClr val="BEA06A"/>
+                </a:solidFill>
+              </a:defRPr>
+            </a:lvl4pPr>
+            <a:lvl5pPr algn="l">
+              <a:buNone/>
+              <a:defRPr sz="2625" b="1" i="0">
+                <a:solidFill>
+                  <a:srgbClr val="BEA06A"/>
+                </a:solidFill>
+              </a:defRPr>
+            </a:lvl5pPr>
+            <a:lvl6pPr algn="l">
+              <a:buNone/>
+              <a:defRPr sz="2625" b="1" i="0">
+                <a:solidFill>
+                  <a:srgbClr val="BEA06A"/>
+                </a:solidFill>
+              </a:defRPr>
+            </a:lvl6pPr>
+            <a:lvl7pPr algn="l">
+              <a:buNone/>
+              <a:defRPr sz="2625" b="1" i="0">
+                <a:solidFill>
+                  <a:srgbClr val="BEA06A"/>
+                </a:solidFill>
+              </a:defRPr>
+            </a:lvl7pPr>
+            <a:lvl8pPr algn="l">
+              <a:buNone/>
+              <a:defRPr sz="2625" b="1" i="0">
+                <a:solidFill>
+                  <a:srgbClr val="BEA06A"/>
+                </a:solidFill>
+              </a:defRPr>
+            </a:lvl8pPr>
+            <a:lvl9pPr algn="l">
+              <a:buNone/>
+              <a:defRPr sz="2625" b="1" i="0">
+                <a:solidFill>
+                  <a:srgbClr val="BEA06A"/>
+                </a:solidFill>
+              </a:defRPr>
+            </a:lvl9pPr>
+          </a:lstStyle>
+          <a:p>
+            <a:pPr algn="l">
+              <a:buNone/>
+              <a:defRPr sz="2625" b="1" i="0">
+                <a:solidFill>
+                  <a:srgbClr val="BEA06A"/>
+                </a:solidFill>
+              </a:defRPr>
+            </a:pPr>
+            <a:r>
+              <a:rPr sz="2625" b="1" i="0">
+                <a:solidFill>
+                  <a:srgbClr val="BEA06A"/>
+                </a:solidFill>
+              </a:rPr>
+              <a:t>CSG</a:t>
+            </a:r>
+          </a:p>
+        </p:txBody>
+      </p:sp>
+      <p:sp>
+        <p:nvSpPr>
+          <p:cNvPr id="4" name="">
+            <a:extLst>
+              <a:ext uri="{FF2B5EF4-FFF2-40B4-BE49-F238E27FC236}">
+                <ns2:creationId id="{A34BA23E-0CD2-4E38-8F37-7AAB56C38762}"/>
+              </a:ext>
+            </a:extLst>
+          </p:cNvPr>
+          <p:cNvSpPr>
+            <a:spLocks noGrp="1"/>
+          </p:cNvSpPr>
+          <p:nvPr/>
+        </p:nvSpPr>
+        <p:spPr>
+          <a:xfrm>
+            <a:off x="723900" y="3543300"/>
+            <a:ext cx="2524125" cy="1066800"/>
+          </a:xfrm>
+          <a:prstGeom prst="rect">
+            <a:avLst/>
+          </a:prstGeom>
+          <a:noFill/>
+          <a:ln w="0">
+            <a:noFill/>
+            <a:prstDash val="solid"/>
+          </a:ln>
+        </p:spPr>
+        <p:txBody>
+          <a:bodyPr lIns="0" tIns="0" rIns="0" bIns="0"/>
+          <a:lstStyle>
+            <a:defPPr algn="l">
+              <a:defRPr sz="1875" b="0" i="0">
+                <a:solidFill>
+                  <a:srgbClr val="FFFFFF"/>
+                </a:solidFill>
+              </a:defRPr>
+            </a:defPPr>
+            <a:lvl1pPr algn="l">
+              <a:buNone/>
+              <a:defRPr sz="1875" b="0" i="0">
+                <a:solidFill>
+                  <a:srgbClr val="FFFFFF"/>
+                </a:solidFill>
+              </a:defRPr>
+            </a:lvl1pPr>
+            <a:lvl2pPr algn="l">
+              <a:buNone/>
+              <a:defRPr sz="1875" b="0" i="0">
+                <a:solidFill>
+                  <a:srgbClr val="FFFFFF"/>
+                </a:solidFill>
+              </a:defRPr>
+            </a:lvl2pPr>
+            <a:lvl3pPr algn="l">
+              <a:buNone/>
+              <a:defRPr sz="1875" b="0" i="0">
+                <a:solidFill>
+                  <a:srgbClr val="FFFFFF"/>
+                </a:solidFill>
+              </a:defRPr>
+            </a:lvl3pPr>
+            <a:lvl4pPr algn="l">
+              <a:buNone/>
+              <a:defRPr sz="1875" b="0" i="0">
+                <a:solidFill>
+                  <a:srgbClr val="FFFFFF"/>
+                </a:solidFill>
+              </a:defRPr>
+            </a:lvl4pPr>
+            <a:lvl5pPr algn="l">
+              <a:buNone/>
+              <a:defRPr sz="1875" b="0" i="0">
+                <a:solidFill>
+                  <a:srgbClr val="FFFFFF"/>
+                </a:solidFill>
+              </a:defRPr>
+            </a:lvl5pPr>
+            <a:lvl6pPr algn="l">
+              <a:buNone/>
+              <a:defRPr sz="1875" b="0" i="0">
+                <a:solidFill>
+                  <a:srgbClr val="FFFFFF"/>
+                </a:solidFill>
+              </a:defRPr>
+            </a:lvl6pPr>
+            <a:lvl7pPr algn="l">
+              <a:buNone/>
+              <a:defRPr sz="1875" b="0" i="0">
+                <a:solidFill>
+                  <a:srgbClr val="FFFFFF"/>
+                </a:solidFill>
+              </a:defRPr>
+            </a:lvl7pPr>
+            <a:lvl8pPr algn="l">
+              <a:buNone/>
+              <a:defRPr sz="1875" b="0" i="0">
+                <a:solidFill>
+                  <a:srgbClr val="FFFFFF"/>
+                </a:solidFill>
+              </a:defRPr>
+            </a:lvl8pPr>
+            <a:lvl9pPr algn="l">
+              <a:buNone/>
+              <a:defRPr sz="1875" b="0" i="0">
+                <a:solidFill>
+                  <a:srgbClr val="FFFFFF"/>
+                </a:solidFill>
+              </a:defRPr>
+            </a:lvl9pPr>
+          </a:lstStyle>
+          <a:p>
+            <a:pPr algn="l">
+              <a:buNone/>
+              <a:defRPr sz="1875" b="0" i="0">
+                <a:solidFill>
+                  <a:srgbClr val="FFFFFF"/>
+                </a:solidFill>
+              </a:defRPr>
+            </a:pPr>
+            <a:r>
+              <a:rPr sz="1875" b="0" i="0">
+                <a:solidFill>
+                  <a:srgbClr val="FFFFFF"/>
+                </a:solidFill>
+              </a:rPr>
+              <a:t>Industrial and</a:t>
+            </a:r>
+          </a:p>
+          <a:p>
+            <a:pPr algn="l">
+              <a:buNone/>
+              <a:defRPr sz="1875" b="0" i="0">
+                <a:solidFill>
+                  <a:srgbClr val="FFFFFF"/>
+                </a:solidFill>
+              </a:defRPr>
+            </a:pPr>
+            <a:r>
+              <a:rPr sz="1875" b="0" i="0">
+                <a:solidFill>
+                  <a:srgbClr val="FFFFFF"/>
+                </a:solidFill>
+              </a:rPr>
+              <a:t>technology group</a:t>
+            </a:r>
+          </a:p>
+        </p:txBody>
+      </p:sp>
+      <p:sp>
+        <p:nvSpPr>
+          <p:cNvPr id="5" name="">
+            <a:extLst>
+              <a:ext uri="{FF2B5EF4-FFF2-40B4-BE49-F238E27FC236}">
+                <ns2:creationId id="{74EF2072-0F5B-4869-B3C8-B8EF0150DF55}"/>
+              </a:ext>
+            </a:extLst>
+          </p:cNvPr>
+          <p:cNvSpPr>
+            <a:spLocks noGrp="1"/>
+          </p:cNvSpPr>
+          <p:nvPr/>
+        </p:nvSpPr>
+        <p:spPr>
+          <a:xfrm>
+            <a:off x="3419475" y="2800350"/>
+            <a:ext cx="2381250" cy="619125"/>
+          </a:xfrm>
+          <a:prstGeom prst="rect">
+            <a:avLst/>
+          </a:prstGeom>
+          <a:noFill/>
+          <a:ln w="0">
+            <a:noFill/>
+            <a:prstDash val="solid"/>
+          </a:ln>
+        </p:spPr>
+        <p:txBody>
+          <a:bodyPr lIns="0" tIns="0" rIns="0" bIns="0"/>
+          <a:lstStyle>
+            <a:defPPr algn="l">
+              <a:defRPr sz="2625" b="1" i="0">
+                <a:solidFill>
+                  <a:srgbClr val="BEA06A"/>
+                </a:solidFill>
+              </a:defRPr>
+            </a:defPPr>
+            <a:lvl1pPr algn="l">
+              <a:buNone/>
+              <a:defRPr sz="2625" b="1" i="0">
+                <a:solidFill>
+                  <a:srgbClr val="BEA06A"/>
+                </a:solidFill>
+              </a:defRPr>
+            </a:lvl1pPr>
+            <a:lvl2pPr algn="l">
+              <a:buNone/>
+              <a:defRPr sz="2625" b="1" i="0">
+                <a:solidFill>
+                  <a:srgbClr val="BEA06A"/>
+                </a:solidFill>
+              </a:defRPr>
+            </a:lvl2pPr>
+            <a:lvl3pPr algn="l">
+              <a:buNone/>
+              <a:defRPr sz="2625" b="1" i="0">
+                <a:solidFill>
+                  <a:srgbClr val="BEA06A"/>
+                </a:solidFill>
+              </a:defRPr>
+            </a:lvl3pPr>
+            <a:lvl4pPr algn="l">
+              <a:buNone/>
+              <a:defRPr sz="2625" b="1" i="0">
+                <a:solidFill>
+                  <a:srgbClr val="BEA06A"/>
+                </a:solidFill>
+              </a:defRPr>
+            </a:lvl4pPr>
+            <a:lvl5pPr algn="l">
+              <a:buNone/>
+              <a:defRPr sz="2625" b="1" i="0">
+                <a:solidFill>
+                  <a:srgbClr val="BEA06A"/>
+                </a:solidFill>
+              </a:defRPr>
+            </a:lvl5pPr>
+            <a:lvl6pPr algn="l">
+              <a:buNone/>
+              <a:defRPr sz="2625" b="1" i="0">
+                <a:solidFill>
+                  <a:srgbClr val="BEA06A"/>
+                </a:solidFill>
+              </a:defRPr>
+            </a:lvl6pPr>
+            <a:lvl7pPr algn="l">
+              <a:buNone/>
+              <a:defRPr sz="2625" b="1" i="0">
+                <a:solidFill>
+                  <a:srgbClr val="BEA06A"/>
+                </a:solidFill>
+              </a:defRPr>
+            </a:lvl7pPr>
+            <a:lvl8pPr algn="l">
+              <a:buNone/>
+              <a:defRPr sz="2625" b="1" i="0">
+                <a:solidFill>
+                  <a:srgbClr val="BEA06A"/>
+                </a:solidFill>
+              </a:defRPr>
+            </a:lvl8pPr>
+            <a:lvl9pPr algn="l">
+              <a:buNone/>
+              <a:defRPr sz="2625" b="1" i="0">
+                <a:solidFill>
+                  <a:srgbClr val="BEA06A"/>
+                </a:solidFill>
+              </a:defRPr>
+            </a:lvl9pPr>
+          </a:lstStyle>
+          <a:p>
+            <a:pPr algn="l">
+              <a:buNone/>
+              <a:defRPr sz="2625" b="1" i="0">
+                <a:solidFill>
+                  <a:srgbClr val="BEA06A"/>
+                </a:solidFill>
+              </a:defRPr>
+            </a:pPr>
+            <a:r>
+              <a:rPr sz="2625" b="1" i="0">
+                <a:solidFill>
+                  <a:srgbClr val="BEA06A"/>
+                </a:solidFill>
+              </a:rPr>
+              <a:t>TKG</a:t>
+            </a:r>
+          </a:p>
+        </p:txBody>
+      </p:sp>
+      <p:sp>
+        <p:nvSpPr>
+          <p:cNvPr id="6" name="">
+            <a:extLst>
+              <a:ext uri="{FF2B5EF4-FFF2-40B4-BE49-F238E27FC236}">
+                <ns2:creationId id="{578E9F30-B97B-4D21-9887-533D7D1E5D39}"/>
+              </a:ext>
+            </a:extLst>
+          </p:cNvPr>
+          <p:cNvSpPr>
+            <a:spLocks noGrp="1"/>
+          </p:cNvSpPr>
+          <p:nvPr/>
+        </p:nvSpPr>
+        <p:spPr>
+          <a:xfrm>
+            <a:off x="3419475" y="3543300"/>
+            <a:ext cx="2524125" cy="1066800"/>
+          </a:xfrm>
+          <a:prstGeom prst="rect">
+            <a:avLst/>
+          </a:prstGeom>
+          <a:noFill/>
+          <a:ln w="0">
+            <a:noFill/>
+            <a:prstDash val="solid"/>
+          </a:ln>
+        </p:spPr>
+        <p:txBody>
+          <a:bodyPr lIns="0" tIns="0" rIns="0" bIns="0"/>
+          <a:lstStyle>
+            <a:defPPr algn="l">
+              <a:defRPr sz="1875" b="0" i="0">
+                <a:solidFill>
+                  <a:srgbClr val="FFFFFF"/>
+                </a:solidFill>
+              </a:defRPr>
+            </a:defPPr>
+            <a:lvl1pPr algn="l">
+              <a:buNone/>
+              <a:defRPr sz="1875" b="0" i="0">
+                <a:solidFill>
+                  <a:srgbClr val="FFFFFF"/>
+                </a:solidFill>
+              </a:defRPr>
+            </a:lvl1pPr>
+            <a:lvl2pPr algn="l">
+              <a:buNone/>
+              <a:defRPr sz="1875" b="0" i="0">
+                <a:solidFill>
+                  <a:srgbClr val="FFFFFF"/>
+                </a:solidFill>
+              </a:defRPr>
+            </a:lvl2pPr>
+            <a:lvl3pPr algn="l">
+              <a:buNone/>
+              <a:defRPr sz="1875" b="0" i="0">
+                <a:solidFill>
+                  <a:srgbClr val="FFFFFF"/>
+                </a:solidFill>
+              </a:defRPr>
+            </a:lvl3pPr>
+            <a:lvl4pPr algn="l">
+              <a:buNone/>
+              <a:defRPr sz="1875" b="0" i="0">
+                <a:solidFill>
+                  <a:srgbClr val="FFFFFF"/>
+                </a:solidFill>
+              </a:defRPr>
+            </a:lvl4pPr>
+            <a:lvl5pPr algn="l">
+              <a:buNone/>
+              <a:defRPr sz="1875" b="0" i="0">
+                <a:solidFill>
+                  <a:srgbClr val="FFFFFF"/>
+                </a:solidFill>
+              </a:defRPr>
+            </a:lvl5pPr>
+            <a:lvl6pPr algn="l">
+              <a:buNone/>
+              <a:defRPr sz="1875" b="0" i="0">
+                <a:solidFill>
+                  <a:srgbClr val="FFFFFF"/>
+                </a:solidFill>
+              </a:defRPr>
+            </a:lvl6pPr>
+            <a:lvl7pPr algn="l">
+              <a:buNone/>
+              <a:defRPr sz="1875" b="0" i="0">
+                <a:solidFill>
+                  <a:srgbClr val="FFFFFF"/>
+                </a:solidFill>
+              </a:defRPr>
+            </a:lvl7pPr>
+            <a:lvl8pPr algn="l">
+              <a:buNone/>
+              <a:defRPr sz="1875" b="0" i="0">
+                <a:solidFill>
+                  <a:srgbClr val="FFFFFF"/>
+                </a:solidFill>
+              </a:defRPr>
+            </a:lvl8pPr>
+            <a:lvl9pPr algn="l">
+              <a:buNone/>
+              <a:defRPr sz="1875" b="0" i="0">
+                <a:solidFill>
+                  <a:srgbClr val="FFFFFF"/>
+                </a:solidFill>
+              </a:defRPr>
+            </a:lvl9pPr>
+          </a:lstStyle>
+          <a:p>
+            <a:pPr algn="l">
+              <a:buNone/>
+              <a:defRPr sz="1875" b="0" i="0">
+                <a:solidFill>
+                  <a:srgbClr val="FFFFFF"/>
+                </a:solidFill>
+              </a:defRPr>
+            </a:pPr>
+            <a:r>
+              <a:rPr sz="1875" b="0" i="0">
+                <a:solidFill>
+                  <a:srgbClr val="FFFFFF"/>
+                </a:solidFill>
+              </a:rPr>
+              <a:t>Part of</a:t>
+            </a:r>
+          </a:p>
+          <a:p>
+            <a:pPr algn="l">
+              <a:buNone/>
+              <a:defRPr sz="1875" b="0" i="0">
+                <a:solidFill>
+                  <a:srgbClr val="FFFFFF"/>
+                </a:solidFill>
+              </a:defRPr>
+            </a:pPr>
+            <a:r>
+              <a:rPr sz="1875" b="0" i="0">
+                <a:solidFill>
+                  <a:srgbClr val="FFFFFF"/>
+                </a:solidFill>
+              </a:rPr>
+              <a:t>CSG Ammo+</a:t>
+            </a:r>
+          </a:p>
+        </p:txBody>
+      </p:sp>
+      <p:sp>
+        <p:nvSpPr>
+          <p:cNvPr id="7" name="">
+            <a:extLst>
+              <a:ext uri="{FF2B5EF4-FFF2-40B4-BE49-F238E27FC236}">
+                <ns2:creationId id="{3644D645-77AD-4BEA-B186-DA1B65F1C548}"/>
+              </a:ext>
+            </a:extLst>
+          </p:cNvPr>
+          <p:cNvSpPr>
+            <a:spLocks noGrp="1"/>
+          </p:cNvSpPr>
+          <p:nvPr/>
+        </p:nvSpPr>
+        <p:spPr>
+          <a:xfrm>
+            <a:off x="6229350" y="2800350"/>
+            <a:ext cx="2381250" cy="619125"/>
+          </a:xfrm>
+          <a:prstGeom prst="rect">
+            <a:avLst/>
+          </a:prstGeom>
+          <a:noFill/>
+          <a:ln w="0">
+            <a:noFill/>
+            <a:prstDash val="solid"/>
+          </a:ln>
+        </p:spPr>
+        <p:txBody>
+          <a:bodyPr lIns="0" tIns="0" rIns="0" bIns="0"/>
+          <a:lstStyle>
+            <a:defPPr algn="l">
+              <a:defRPr sz="2625" b="1" i="0">
+                <a:solidFill>
+                  <a:srgbClr val="BEA06A"/>
+                </a:solidFill>
+              </a:defRPr>
+            </a:defPPr>
+            <a:lvl1pPr algn="l">
+              <a:buNone/>
+              <a:defRPr sz="2625" b="1" i="0">
+                <a:solidFill>
+                  <a:srgbClr val="BEA06A"/>
+                </a:solidFill>
+              </a:defRPr>
+            </a:lvl1pPr>
+            <a:lvl2pPr algn="l">
+              <a:buNone/>
+              <a:defRPr sz="2625" b="1" i="0">
+                <a:solidFill>
+                  <a:srgbClr val="BEA06A"/>
+                </a:solidFill>
+              </a:defRPr>
+            </a:lvl2pPr>
+            <a:lvl3pPr algn="l">
+              <a:buNone/>
+              <a:defRPr sz="2625" b="1" i="0">
+                <a:solidFill>
+                  <a:srgbClr val="BEA06A"/>
+                </a:solidFill>
+              </a:defRPr>
+            </a:lvl3pPr>
+            <a:lvl4pPr algn="l">
+              <a:buNone/>
+              <a:defRPr sz="2625" b="1" i="0">
+                <a:solidFill>
+                  <a:srgbClr val="BEA06A"/>
+                </a:solidFill>
+              </a:defRPr>
+            </a:lvl4pPr>
+            <a:lvl5pPr algn="l">
+              <a:buNone/>
+              <a:defRPr sz="2625" b="1" i="0">
+                <a:solidFill>
+                  <a:srgbClr val="BEA06A"/>
+                </a:solidFill>
+              </a:defRPr>
+            </a:lvl5pPr>
+            <a:lvl6pPr algn="l">
+              <a:buNone/>
+              <a:defRPr sz="2625" b="1" i="0">
+                <a:solidFill>
+                  <a:srgbClr val="BEA06A"/>
+                </a:solidFill>
+              </a:defRPr>
+            </a:lvl6pPr>
+            <a:lvl7pPr algn="l">
+              <a:buNone/>
+              <a:defRPr sz="2625" b="1" i="0">
+                <a:solidFill>
+                  <a:srgbClr val="BEA06A"/>
+                </a:solidFill>
+              </a:defRPr>
+            </a:lvl7pPr>
+            <a:lvl8pPr algn="l">
+              <a:buNone/>
+              <a:defRPr sz="2625" b="1" i="0">
+                <a:solidFill>
+                  <a:srgbClr val="BEA06A"/>
+                </a:solidFill>
+              </a:defRPr>
+            </a:lvl8pPr>
+            <a:lvl9pPr algn="l">
+              <a:buNone/>
+              <a:defRPr sz="2625" b="1" i="0">
+                <a:solidFill>
+                  <a:srgbClr val="BEA06A"/>
+                </a:solidFill>
+              </a:defRPr>
+            </a:lvl9pPr>
+          </a:lstStyle>
+          <a:p>
+            <a:pPr algn="l">
+              <a:buNone/>
+              <a:defRPr sz="2625" b="1" i="0">
+                <a:solidFill>
+                  <a:srgbClr val="BEA06A"/>
+                </a:solidFill>
+              </a:defRPr>
+            </a:pPr>
+            <a:r>
+              <a:rPr sz="2625" b="1" i="0">
+                <a:solidFill>
+                  <a:srgbClr val="BEA06A"/>
+                </a:solidFill>
+              </a:rPr>
+              <a:t>REMINGTON</a:t>
+            </a:r>
+          </a:p>
+        </p:txBody>
+      </p:sp>
+      <p:sp>
+        <p:nvSpPr>
+          <p:cNvPr id="8" name="">
+            <a:extLst>
+              <a:ext uri="{FF2B5EF4-FFF2-40B4-BE49-F238E27FC236}">
+                <ns2:creationId id="{8CD4209B-EEAA-49CF-B1CF-B1BCE1C02033}"/>
+              </a:ext>
+            </a:extLst>
+          </p:cNvPr>
+          <p:cNvSpPr>
+            <a:spLocks noGrp="1"/>
+          </p:cNvSpPr>
+          <p:nvPr/>
+        </p:nvSpPr>
+        <p:spPr>
+          <a:xfrm>
+            <a:off x="6229350" y="3543300"/>
+            <a:ext cx="2524125" cy="1066800"/>
+          </a:xfrm>
+          <a:prstGeom prst="rect">
+            <a:avLst/>
+          </a:prstGeom>
+          <a:noFill/>
+          <a:ln w="0">
+            <a:noFill/>
+            <a:prstDash val="solid"/>
+          </a:ln>
+        </p:spPr>
+        <p:txBody>
+          <a:bodyPr lIns="0" tIns="0" rIns="0" bIns="0"/>
+          <a:lstStyle>
+            <a:defPPr algn="l">
+              <a:defRPr sz="1875" b="0" i="0">
+                <a:solidFill>
+                  <a:srgbClr val="FFFFFF"/>
+                </a:solidFill>
+              </a:defRPr>
+            </a:defPPr>
+            <a:lvl1pPr algn="l">
+              <a:buNone/>
+              <a:defRPr sz="1875" b="0" i="0">
+                <a:solidFill>
+                  <a:srgbClr val="FFFFFF"/>
+                </a:solidFill>
+              </a:defRPr>
+            </a:lvl1pPr>
+            <a:lvl2pPr algn="l">
+              <a:buNone/>
+              <a:defRPr sz="1875" b="0" i="0">
+                <a:solidFill>
+                  <a:srgbClr val="FFFFFF"/>
+                </a:solidFill>
+              </a:defRPr>
+            </a:lvl2pPr>
+            <a:lvl3pPr algn="l">
+              <a:buNone/>
+              <a:defRPr sz="1875" b="0" i="0">
+                <a:solidFill>
+                  <a:srgbClr val="FFFFFF"/>
+                </a:solidFill>
+              </a:defRPr>
+            </a:lvl3pPr>
+            <a:lvl4pPr algn="l">
+              <a:buNone/>
+              <a:defRPr sz="1875" b="0" i="0">
+                <a:solidFill>
+                  <a:srgbClr val="FFFFFF"/>
+                </a:solidFill>
+              </a:defRPr>
+            </a:lvl4pPr>
+            <a:lvl5pPr algn="l">
+              <a:buNone/>
+              <a:defRPr sz="1875" b="0" i="0">
+                <a:solidFill>
+                  <a:srgbClr val="FFFFFF"/>
+                </a:solidFill>
+              </a:defRPr>
+            </a:lvl5pPr>
+            <a:lvl6pPr algn="l">
+              <a:buNone/>
+              <a:defRPr sz="1875" b="0" i="0">
+                <a:solidFill>
+                  <a:srgbClr val="FFFFFF"/>
+                </a:solidFill>
+              </a:defRPr>
+            </a:lvl6pPr>
+            <a:lvl7pPr algn="l">
+              <a:buNone/>
+              <a:defRPr sz="1875" b="0" i="0">
+                <a:solidFill>
+                  <a:srgbClr val="FFFFFF"/>
+                </a:solidFill>
+              </a:defRPr>
+            </a:lvl7pPr>
+            <a:lvl8pPr algn="l">
+              <a:buNone/>
+              <a:defRPr sz="1875" b="0" i="0">
+                <a:solidFill>
+                  <a:srgbClr val="FFFFFF"/>
+                </a:solidFill>
+              </a:defRPr>
+            </a:lvl8pPr>
+            <a:lvl9pPr algn="l">
+              <a:buNone/>
+              <a:defRPr sz="1875" b="0" i="0">
+                <a:solidFill>
+                  <a:srgbClr val="FFFFFF"/>
+                </a:solidFill>
+              </a:defRPr>
+            </a:lvl9pPr>
+          </a:lstStyle>
+          <a:p>
+            <a:pPr algn="l">
+              <a:buNone/>
+              <a:defRPr sz="1875" b="0" i="0">
+                <a:solidFill>
+                  <a:srgbClr val="FFFFFF"/>
+                </a:solidFill>
+              </a:defRPr>
+            </a:pPr>
+            <a:r>
+              <a:rPr sz="1875" b="0" i="0">
+                <a:solidFill>
+                  <a:srgbClr val="FFFFFF"/>
+                </a:solidFill>
+              </a:rPr>
+              <a:t>Manufacturing in</a:t>
+            </a:r>
+          </a:p>
+          <a:p>
+            <a:pPr algn="l">
+              <a:buNone/>
+              <a:defRPr sz="1875" b="0" i="0">
+                <a:solidFill>
+                  <a:srgbClr val="FFFFFF"/>
+                </a:solidFill>
+              </a:defRPr>
+            </a:pPr>
+            <a:r>
+              <a:rPr sz="1875" b="0" i="0">
+                <a:solidFill>
+                  <a:srgbClr val="FFFFFF"/>
+                </a:solidFill>
+              </a:rPr>
+              <a:t>Lonoke, Arkansas</a:t>
+            </a:r>
+          </a:p>
+        </p:txBody>
+      </p:sp>
+      <p:sp>
+        <p:nvSpPr>
+          <p:cNvPr id="9" name="">
+            <a:extLst>
+              <a:ext uri="{FF2B5EF4-FFF2-40B4-BE49-F238E27FC236}">
+                <ns2:creationId id="{EFEC76D1-80FD-4BC8-AFC9-1E585F89C1B7}"/>
+              </a:ext>
+            </a:extLst>
+          </p:cNvPr>
+          <p:cNvSpPr>
+            <a:spLocks noGrp="1"/>
+          </p:cNvSpPr>
+          <p:nvPr/>
+        </p:nvSpPr>
+        <p:spPr>
+          <a:xfrm>
+            <a:off x="723900" y="5362575"/>
+            <a:ext cx="7429500" cy="619125"/>
+          </a:xfrm>
+          <a:prstGeom prst="rect">
+            <a:avLst/>
+          </a:prstGeom>
+          <a:noFill/>
+          <a:ln w="0">
+            <a:noFill/>
+            <a:prstDash val="solid"/>
+          </a:ln>
+        </p:spPr>
+        <p:txBody>
+          <a:bodyPr lIns="0" tIns="0" rIns="0" bIns="0"/>
+          <a:lstStyle>
+            <a:defPPr algn="l">
+              <a:defRPr sz="2550" b="1" i="0">
+                <a:solidFill>
+                  <a:srgbClr val="FFFFFF"/>
+                </a:solidFill>
+              </a:defRPr>
+            </a:defPPr>
+            <a:lvl1pPr algn="l">
+              <a:buNone/>
+              <a:defRPr sz="2550" b="1" i="0">
+                <a:solidFill>
+                  <a:srgbClr val="FFFFFF"/>
+                </a:solidFill>
+              </a:defRPr>
+            </a:lvl1pPr>
+            <a:lvl2pPr algn="l">
+              <a:buNone/>
+              <a:defRPr sz="2550" b="1" i="0">
+                <a:solidFill>
+                  <a:srgbClr val="FFFFFF"/>
+                </a:solidFill>
+              </a:defRPr>
+            </a:lvl2pPr>
+            <a:lvl3pPr algn="l">
+              <a:buNone/>
+              <a:defRPr sz="2550" b="1" i="0">
+                <a:solidFill>
+                  <a:srgbClr val="FFFFFF"/>
+                </a:solidFill>
+              </a:defRPr>
+            </a:lvl3pPr>
+            <a:lvl4pPr algn="l">
+              <a:buNone/>
+              <a:defRPr sz="2550" b="1" i="0">
+                <a:solidFill>
+                  <a:srgbClr val="FFFFFF"/>
+                </a:solidFill>
+              </a:defRPr>
+            </a:lvl4pPr>
+            <a:lvl5pPr algn="l">
+              <a:buNone/>
+              <a:defRPr sz="2550" b="1" i="0">
+                <a:solidFill>
+                  <a:srgbClr val="FFFFFF"/>
+                </a:solidFill>
+              </a:defRPr>
+            </a:lvl5pPr>
+            <a:lvl6pPr algn="l">
+              <a:buNone/>
+              <a:defRPr sz="2550" b="1" i="0">
+                <a:solidFill>
+                  <a:srgbClr val="FFFFFF"/>
+                </a:solidFill>
+              </a:defRPr>
+            </a:lvl6pPr>
+            <a:lvl7pPr algn="l">
+              <a:buNone/>
+              <a:defRPr sz="2550" b="1" i="0">
+                <a:solidFill>
+                  <a:srgbClr val="FFFFFF"/>
+                </a:solidFill>
+              </a:defRPr>
+            </a:lvl7pPr>
+            <a:lvl8pPr algn="l">
+              <a:buNone/>
+              <a:defRPr sz="2550" b="1" i="0">
+                <a:solidFill>
+                  <a:srgbClr val="FFFFFF"/>
+                </a:solidFill>
+              </a:defRPr>
+            </a:lvl8pPr>
+            <a:lvl9pPr algn="l">
+              <a:buNone/>
+              <a:defRPr sz="2550" b="1" i="0">
+                <a:solidFill>
+                  <a:srgbClr val="FFFFFF"/>
+                </a:solidFill>
+              </a:defRPr>
+            </a:lvl9pPr>
+          </a:lstStyle>
+          <a:p>
+            <a:pPr algn="l">
+              <a:buNone/>
+              <a:defRPr sz="2550" b="1" i="0">
+                <a:solidFill>
+                  <a:srgbClr val="FFFFFF"/>
+                </a:solidFill>
+              </a:defRPr>
+            </a:pPr>
+            <a:r>
+              <a:rPr sz="2550" b="1" i="0">
+                <a:solidFill>
+                  <a:srgbClr val="FFFFFF"/>
+                </a:solidFill>
+              </a:rPr>
+              <a:t>AI for the next generation of manufacturing.</a:t>
+            </a:r>
+          </a:p>
+        </p:txBody>
+      </p:sp>
+    </p:spTree>
+    <p:extLst>
+      <p:ext uri="{BB962C8B-B14F-4D97-AF65-F5344CB8AC3E}">
+        <ns3:creationId val="1022646670"/>
       </p:ext>
     </p:extLst>
   </p:cSld>
@@ -14008,7 +15324,7 @@
                   <a:srgbClr val="FFFFFF"/>
                 </a:solidFill>
               </a:rPr>
-              <a:t>My first AI application</a:t>
+              <a:t>Writing the next rules</a:t>
             </a:r>
           </a:p>
         </p:txBody>
@@ -14139,7 +15455,7 @@
                   <a:srgbClr val="000000"/>
                 </a:solidFill>
               </a:rPr>
-              <a:t>2</a:t>
+              <a:t>3</a:t>
             </a:r>
           </a:p>
         </p:txBody>
@@ -14270,7 +15586,7 @@
                   <a:srgbClr val="BEA06A"/>
                 </a:solidFill>
               </a:rPr>
-              <a:t>SCHOOL</a:t>
+              <a:t>1816</a:t>
             </a:r>
           </a:p>
         </p:txBody>
@@ -14401,7 +15717,7 @@
                   <a:srgbClr val="FFFFFF"/>
                 </a:solidFill>
               </a:rPr>
-              <a:t>Fayetteville</a:t>
+              <a:t>Remington</a:t>
             </a:r>
           </a:p>
         </p:txBody>
@@ -14532,7 +15848,7 @@
                   <a:srgbClr val="BEA06A"/>
                 </a:solidFill>
               </a:rPr>
-              <a:t>WORK</a:t>
+              <a:t>1969</a:t>
             </a:r>
           </a:p>
         </p:txBody>
@@ -14663,7 +15979,7 @@
                   <a:srgbClr val="FFFFFF"/>
                 </a:solidFill>
               </a:rPr>
-              <a:t>Lonoke, Fri–Mon</a:t>
+              <a:t>Lonoke, Arkansas</a:t>
             </a:r>
           </a:p>
         </p:txBody>
@@ -14794,7 +16110,7 @@
                   <a:srgbClr val="BEA06A"/>
                 </a:solidFill>
               </a:rPr>
-              <a:t>OCR</a:t>
+              <a:t>NEXT</a:t>
             </a:r>
           </a:p>
         </p:txBody>
@@ -14925,7 +16241,7 @@
                   <a:srgbClr val="FFFFFF"/>
                 </a:solidFill>
               </a:rPr>
-              <a:t>HMI web servers</a:t>
+              <a:t>Remington + TKG</a:t>
             </a:r>
           </a:p>
         </p:txBody>
@@ -15056,7 +16372,7 @@
                   <a:srgbClr val="FFFFFF"/>
                 </a:solidFill>
               </a:rPr>
-              <a:t>My first AI. A very rough beginning.</a:t>
+              <a:t>Keep writing the rules for decades to come.</a:t>
             </a:r>
           </a:p>
         </p:txBody>
@@ -15177,7 +16493,7 @@
                   <a:srgbClr val="D5D8DA"/>
                 </a:solidFill>
               </a:rPr>
-              <a:t>A mechanical engineering intern learning as I went.</a:t>
+              <a:t>Remington is one of five TKG ammunition brands.</a:t>
             </a:r>
           </a:p>
         </p:txBody>
@@ -15320,7 +16636,7 @@
                   <a:srgbClr val="FFFFFF"/>
                 </a:solidFill>
               </a:rPr>
-              <a:t>A year of trying</a:t>
+              <a:t>The stakes are real</a:t>
             </a:r>
           </a:p>
         </p:txBody>
@@ -15441,7 +16757,7 @@
                   <a:srgbClr val="BEA06A"/>
                 </a:solidFill>
               </a:rPr>
-              <a:t>Off-the-shelf inspection</a:t>
+              <a:t>Ammunition manufacturing</a:t>
             </a:r>
           </a:p>
         </p:txBody>
@@ -15562,7 +16878,7 @@
                   <a:srgbClr val="FFFFFF"/>
                 </a:solidFill>
               </a:rPr>
-              <a:t>Nearly a year of trying.</a:t>
+              <a:t>Propellants and primers. Moving machinery.</a:t>
             </a:r>
           </a:p>
           <a:p>
@@ -15579,7 +16895,7 @@
                   <a:srgbClr val="FFFFFF"/>
                 </a:solidFill>
               </a:rPr>
-              <a:t>Still no working answer.</a:t>
+              <a:t>Real production.</a:t>
             </a:r>
           </a:p>
         </p:txBody>
@@ -15700,7 +17016,7 @@
                   <a:srgbClr val="FFFFFF"/>
                 </a:solidFill>
               </a:rPr>
-              <a:t>I thought I was the problem.</a:t>
+              <a:t>Build with the people who rely on it.</a:t>
             </a:r>
           </a:p>
         </p:txBody>
@@ -15821,7 +17137,7 @@
                   <a:srgbClr val="000000"/>
                 </a:solidFill>
               </a:rPr>
-              <a:t>3</a:t>
+              <a:t>4</a:t>
             </a:r>
           </a:p>
         </p:txBody>
@@ -15974,7 +17290,7 @@
                   <a:srgbClr val="FFFFFF"/>
                 </a:solidFill>
               </a:rPr>
-              <a:t>A chance to build it ourselves</a:t>
+              <a:t>Engineering that reaches the floor</a:t>
             </a:r>
           </a:p>
         </p:txBody>
@@ -16105,7 +17421,7 @@
                   <a:srgbClr val="000000"/>
                 </a:solidFill>
               </a:rPr>
-              <a:t>4</a:t>
+              <a:t>5</a:t>
             </a:r>
           </a:p>
         </p:txBody>
@@ -16236,7 +17552,7 @@
                   <a:srgbClr val="BEA06A"/>
                 </a:solidFill>
               </a:rPr>
-              <a:t>PROPOSE</a:t>
+              <a:t>SENSE</a:t>
             </a:r>
           </a:p>
         </p:txBody>
@@ -16367,7 +17683,7 @@
                   <a:srgbClr val="FFFFFF"/>
                 </a:solidFill>
               </a:rPr>
-              <a:t>What if we</a:t>
+              <a:t>Machines capture</a:t>
             </a:r>
           </a:p>
           <a:p>
@@ -16385,7 +17701,7 @@
                   <a:srgbClr val="FFFFFF"/>
                 </a:solidFill>
               </a:rPr>
-              <a:t>built it ourselves?</a:t>
+              <a:t>what is happening</a:t>
             </a:r>
           </a:p>
         </p:txBody>
@@ -16516,7 +17832,7 @@
                   <a:srgbClr val="BEA06A"/>
                 </a:solidFill>
               </a:rPr>
-              <a:t>APPROVE</a:t>
+              <a:t>DECIDE</a:t>
             </a:r>
           </a:p>
         </p:txBody>
@@ -16647,7 +17963,7 @@
                   <a:srgbClr val="FFFFFF"/>
                 </a:solidFill>
               </a:rPr>
-              <a:t>New CSG management</a:t>
+              <a:t>Software turns signals</a:t>
             </a:r>
           </a:p>
           <a:p>
@@ -16665,7 +17981,7 @@
                   <a:srgbClr val="FFFFFF"/>
                 </a:solidFill>
               </a:rPr>
-              <a:t>approved the proposal</a:t>
+              <a:t>into a decision</a:t>
             </a:r>
           </a:p>
         </p:txBody>
@@ -16796,7 +18112,7 @@
                   <a:srgbClr val="BEA06A"/>
                 </a:solidFill>
               </a:rPr>
-              <a:t>CALL</a:t>
+              <a:t>ACT</a:t>
             </a:r>
           </a:p>
         </p:txBody>
@@ -16927,7 +18243,7 @@
                   <a:srgbClr val="FFFFFF"/>
                 </a:solidFill>
               </a:rPr>
-              <a:t>Go get</a:t>
+              <a:t>People and equipment</a:t>
             </a:r>
           </a:p>
           <a:p>
@@ -16945,7 +18261,7 @@
                   <a:srgbClr val="FFFFFF"/>
                 </a:solidFill>
               </a:rPr>
-              <a:t>an intern</a:t>
+              <a:t>respond</a:t>
             </a:r>
           </a:p>
         </p:txBody>
@@ -17076,7 +18392,7 @@
                   <a:srgbClr val="FFFFFF"/>
                 </a:solidFill>
               </a:rPr>
-              <a:t>I called Wesley.</a:t>
+              <a:t>Make every decision useful on the floor.</a:t>
             </a:r>
           </a:p>
         </p:txBody>
@@ -17219,7 +18535,7 @@
                   <a:srgbClr val="FFFFFF"/>
                 </a:solidFill>
               </a:rPr>
-              <a:t>Then I called Wesley</a:t>
+              <a:t>The work spans the organization</a:t>
             </a:r>
           </a:p>
         </p:txBody>
@@ -17340,7 +18656,7 @@
                   <a:srgbClr val="BEA06A"/>
                 </a:solidFill>
               </a:rPr>
-              <a:t>THE INVITATION</a:t>
+              <a:t>LIVE IN PRODUCTION</a:t>
             </a:r>
           </a:p>
         </p:txBody>
@@ -17461,7 +18777,7 @@
                   <a:srgbClr val="FFFFFF"/>
                 </a:solidFill>
               </a:rPr>
-              <a:t>Come to central Arkansas.</a:t>
+              <a:t>Centerfire inspection</a:t>
             </a:r>
           </a:p>
           <a:p>
@@ -17478,7 +18794,7 @@
                   <a:srgbClr val="FFFFFF"/>
                 </a:solidFill>
               </a:rPr>
-              <a:t>Take on the project with me.</a:t>
+              <a:t>Shotshell inspection</a:t>
             </a:r>
           </a:p>
         </p:txBody>
@@ -17599,7 +18915,7 @@
                   <a:srgbClr val="BEA06A"/>
                 </a:solidFill>
               </a:rPr>
-              <a:t>THE WORK</a:t>
+              <a:t>OTHER CAPABILITIES</a:t>
             </a:r>
           </a:p>
         </p:txBody>
@@ -17720,7 +19036,7 @@
                   <a:srgbClr val="FFFFFF"/>
                 </a:solidFill>
               </a:rPr>
-              <a:t>Learn the problem.</a:t>
+              <a:t>Public sentiment</a:t>
             </a:r>
           </a:p>
           <a:p>
@@ -17737,7 +19053,7 @@
                   <a:srgbClr val="FFFFFF"/>
                 </a:solidFill>
               </a:rPr>
-              <a:t>Build the first system.</a:t>
+              <a:t>Remi</a:t>
             </a:r>
           </a:p>
         </p:txBody>
@@ -17858,7 +19174,7 @@
                   <a:srgbClr val="FFFFFF"/>
                 </a:solidFill>
               </a:rPr>
-              <a:t>Wesley, take it from here.</a:t>
+              <a:t>Each system helps someone make a better decision.</a:t>
             </a:r>
           </a:p>
         </p:txBody>
@@ -17979,7 +19295,7 @@
                   <a:srgbClr val="000000"/>
                 </a:solidFill>
               </a:rPr>
-              <a:t>5</a:t>
+              <a:t>6</a:t>
             </a:r>
           </a:p>
         </p:txBody>
@@ -18122,7 +19438,7 @@
                   <a:srgbClr val="FFFFFF"/>
                 </a:solidFill>
               </a:rPr>
-              <a:t>Seeing it do its job</a:t>
+              <a:t>Centerfire inspection</a:t>
             </a:r>
           </a:p>
         </p:txBody>
@@ -18260,7 +19576,7 @@
                   <a:srgbClr val="FFFFFF"/>
                 </a:solidFill>
               </a:rPr>
-              <a:t>Inference. A real reject.</a:t>
+              <a:t>Inference. A usable result.</a:t>
             </a:r>
           </a:p>
         </p:txBody>
@@ -18623,7 +19939,7 @@
                   <a:srgbClr val="000000"/>
                 </a:solidFill>
               </a:rPr>
-              <a:t>6</a:t>
+              <a:t>7</a:t>
             </a:r>
           </a:p>
         </p:txBody>
@@ -18766,7 +20082,7 @@
                   <a:srgbClr val="FFFFFF"/>
                 </a:solidFill>
               </a:rPr>
-              <a:t>One project teaches the next</a:t>
+              <a:t>Shotshell inspection</a:t>
             </a:r>
           </a:p>
         </p:txBody>
@@ -19146,7 +20462,7 @@
                   <a:srgbClr val="D5D8DA"/>
                 </a:solidFill>
               </a:rPr>
-              <a:t>Shotshell inspection. A different product and line.</a:t>
+              <a:t>Live on the floor. Tailored to a different product.</a:t>
             </a:r>
           </a:p>
         </p:txBody>
@@ -19267,7 +20583,7 @@
                   <a:srgbClr val="000000"/>
                 </a:solidFill>
               </a:rPr>
-              <a:t>7</a:t>
+              <a:t>8</a:t>
             </a:r>
           </a:p>
         </p:txBody>
@@ -19911,7 +21227,7 @@
                   <a:srgbClr val="000000"/>
                 </a:solidFill>
               </a:rPr>
-              <a:t>8</a:t>
+              <a:t>9</a:t>
             </a:r>
           </a:p>
         </p:txBody>

</xml_diff>

<commit_message>
Polish CSG slide with supplied branding and verified company facts
</commit_message>
<xml_diff>
--- a/docs/presentation/Engineering_at_The_Kinetic_Group.pptx
+++ b/docs/presentation/Engineering_at_The_Kinetic_Group.pptx
@@ -1855,7 +1855,7 @@
           </a:p>
           <a:p>
             <a:r>
-              <a:t>Brad: “CSG is Czechoslovak Group, an industrial and technology group. The Kinetic Group is part of its Ammo+ division, and Remington is one of the TKG brands. Today's examples come mainly from Lonoke.”</a:t>
+              <a:t>Brad: “CSG stands for Czechoslovak Group. It is a global industrial and technology group headquartered in Prague, in the Czech Republic. Its roots go back to Excalibur Army in 1995, and its businesses span defense, aerospace, and automotive industries. The Kinetic Group is part of CSG Ammo+, and Remington is one of the TKG brands. Today's examples come mainly from Lonoke.”</a:t>
             </a:r>
           </a:p>
           <a:p>
@@ -1935,7 +1935,7 @@
           </a:p>
           <a:p>
             <a:r>
-              <a:t>Sources for company context: The Kinetic Group About Us (https://www.thekineticgroup.com/aboutus.html); CSG companies (https://csg.com/en/companies), checked October 22, 2026. The AI ambition is the presenters' framing. The approval and internship details are Brad's account.</a:t>
+              <a:t>Sources for company context: CSG About Us (https://csg.com/en/about-us) (Prague headquarters, 1995 origins, industries); The Kinetic Group About Us (https://www.thekineticgroup.com/aboutus.html) (Ammo+ membership), checked October 22, 2026. Brand image supplied by Brad in this chat. The AI ambition is the presenters' framing. The approval and internship details are Brad's account.</a:t>
             </a:r>
           </a:p>
         </p:txBody>
@@ -13932,7 +13932,7 @@
 </file>
 
 <file path=ppt/slides/slide18.xml><?xml version="1.0" encoding="utf-8"?>
-<p:sld xmlns:a="http://schemas.openxmlformats.org/drawingml/2006/main" xmlns:ns2="http://schemas.microsoft.com/office/drawing/2014/main" xmlns:ns3="http://schemas.microsoft.com/office/powerpoint/2010/main" xmlns:p="http://schemas.openxmlformats.org/presentationml/2006/main">
+<p:sld xmlns:a="http://schemas.openxmlformats.org/drawingml/2006/main" xmlns:ns2="http://schemas.microsoft.com/office/drawing/2014/main" xmlns:ns4="http://schemas.microsoft.com/office/powerpoint/2010/main" xmlns:p="http://schemas.openxmlformats.org/presentationml/2006/main" xmlns:r="http://schemas.openxmlformats.org/officeDocument/2006/relationships">
   <p:cSld>
     <p:spTree>
       <p:nvGrpSpPr>
@@ -13959,8 +13959,8 @@
         </p:nvSpPr>
         <p:spPr>
           <a:xfrm>
-            <a:off x="704850" y="1495425"/>
-            <a:ext cx="7743825" cy="619125"/>
+            <a:off x="704850" y="1504950"/>
+            <a:ext cx="7734300" cy="609600"/>
           </a:xfrm>
           <a:prstGeom prst="rect">
             <a:avLst/>
@@ -14069,7 +14069,7 @@
                   <a:srgbClr val="FFFFFF"/>
                 </a:solidFill>
               </a:rPr>
-              <a:t>CSG: Czechoslovak Group</a:t>
+              <a:t>Czechoslovak Group (CSG)</a:t>
             </a:r>
           </a:p>
         </p:txBody>
@@ -14221,8 +14221,8 @@
         </p:nvSpPr>
         <p:spPr>
           <a:xfrm>
-            <a:off x="723900" y="2800350"/>
-            <a:ext cx="2381250" cy="619125"/>
+            <a:off x="723900" y="2667000"/>
+            <a:ext cx="4762500" cy="838200"/>
           </a:xfrm>
           <a:prstGeom prst="rect">
             <a:avLst/>
@@ -14237,9 +14237,9 @@
           <a:bodyPr lIns="0" tIns="0" rIns="0" bIns="0"/>
           <a:lstStyle>
             <a:defPPr algn="l">
-              <a:defRPr sz="2625" b="1" i="0">
-                <a:solidFill>
-                  <a:srgbClr val="BEA06A"/>
+              <a:defRPr sz="2400" b="1" i="0">
+                <a:solidFill>
+                  <a:srgbClr val="BBA16B"/>
                 </a:solidFill>
               </a:defRPr>
             </a:defPPr>
@@ -14319,19 +14319,37 @@
           <a:p>
             <a:pPr algn="l">
               <a:buNone/>
-              <a:defRPr sz="2625" b="1" i="0">
-                <a:solidFill>
-                  <a:srgbClr val="BEA06A"/>
+              <a:defRPr sz="2400" b="1" i="0">
+                <a:solidFill>
+                  <a:srgbClr val="BBA16B"/>
                 </a:solidFill>
               </a:defRPr>
             </a:pPr>
             <a:r>
-              <a:rPr sz="2625" b="1" i="0">
-                <a:solidFill>
-                  <a:srgbClr val="BEA06A"/>
+              <a:rPr sz="2400" b="1" i="0">
+                <a:solidFill>
+                  <a:srgbClr val="BBA16B"/>
                 </a:solidFill>
               </a:rPr>
-              <a:t>CSG</a:t>
+              <a:t>Global industrial and</a:t>
+            </a:r>
+          </a:p>
+          <a:p>
+            <a:pPr algn="l">
+              <a:buNone/>
+              <a:defRPr sz="2400" b="1" i="0">
+                <a:solidFill>
+                  <a:srgbClr val="BBA16B"/>
+                </a:solidFill>
+              </a:defRPr>
+            </a:pPr>
+            <a:r>
+              <a:rPr sz="2400" b="1" i="0">
+                <a:solidFill>
+                  <a:srgbClr val="BBA16B"/>
+                </a:solidFill>
+              </a:rPr>
+              <a:t>technology group</a:t>
             </a:r>
           </a:p>
         </p:txBody>
@@ -14352,8 +14370,8 @@
         </p:nvSpPr>
         <p:spPr>
           <a:xfrm>
-            <a:off x="723900" y="3543300"/>
-            <a:ext cx="2524125" cy="1066800"/>
+            <a:off x="723900" y="3790950"/>
+            <a:ext cx="7715250" cy="381000"/>
           </a:xfrm>
           <a:prstGeom prst="rect">
             <a:avLst/>
@@ -14368,7 +14386,7 @@
           <a:bodyPr lIns="0" tIns="0" rIns="0" bIns="0"/>
           <a:lstStyle>
             <a:defPPr algn="l">
-              <a:defRPr sz="1875" b="0" i="0">
+              <a:defRPr sz="1950" b="0" i="0">
                 <a:solidFill>
                   <a:srgbClr val="FFFFFF"/>
                 </a:solidFill>
@@ -14450,37 +14468,19 @@
           <a:p>
             <a:pPr algn="l">
               <a:buNone/>
-              <a:defRPr sz="1875" b="0" i="0">
+              <a:defRPr sz="1950" b="0" i="0">
                 <a:solidFill>
                   <a:srgbClr val="FFFFFF"/>
                 </a:solidFill>
               </a:defRPr>
             </a:pPr>
             <a:r>
-              <a:rPr sz="1875" b="0" i="0">
+              <a:rPr sz="1950" b="0" i="0">
                 <a:solidFill>
                   <a:srgbClr val="FFFFFF"/>
                 </a:solidFill>
               </a:rPr>
-              <a:t>Industrial and</a:t>
-            </a:r>
-          </a:p>
-          <a:p>
-            <a:pPr algn="l">
-              <a:buNone/>
-              <a:defRPr sz="1875" b="0" i="0">
-                <a:solidFill>
-                  <a:srgbClr val="FFFFFF"/>
-                </a:solidFill>
-              </a:defRPr>
-            </a:pPr>
-            <a:r>
-              <a:rPr sz="1875" b="0" i="0">
-                <a:solidFill>
-                  <a:srgbClr val="FFFFFF"/>
-                </a:solidFill>
-              </a:rPr>
-              <a:t>technology group</a:t>
+              <a:t>Headquartered in Prague, Czech Republic</a:t>
             </a:r>
           </a:p>
         </p:txBody>
@@ -14501,8 +14501,8 @@
         </p:nvSpPr>
         <p:spPr>
           <a:xfrm>
-            <a:off x="3419475" y="2800350"/>
-            <a:ext cx="2381250" cy="619125"/>
+            <a:off x="723900" y="4305300"/>
+            <a:ext cx="7715250" cy="381000"/>
           </a:xfrm>
           <a:prstGeom prst="rect">
             <a:avLst/>
@@ -14517,9 +14517,9 @@
           <a:bodyPr lIns="0" tIns="0" rIns="0" bIns="0"/>
           <a:lstStyle>
             <a:defPPr algn="l">
-              <a:defRPr sz="2625" b="1" i="0">
-                <a:solidFill>
-                  <a:srgbClr val="BEA06A"/>
+              <a:defRPr sz="1950" b="0" i="0">
+                <a:solidFill>
+                  <a:srgbClr val="FFFFFF"/>
                 </a:solidFill>
               </a:defRPr>
             </a:defPPr>
@@ -14599,19 +14599,19 @@
           <a:p>
             <a:pPr algn="l">
               <a:buNone/>
-              <a:defRPr sz="2625" b="1" i="0">
-                <a:solidFill>
-                  <a:srgbClr val="BEA06A"/>
+              <a:defRPr sz="1950" b="0" i="0">
+                <a:solidFill>
+                  <a:srgbClr val="FFFFFF"/>
                 </a:solidFill>
               </a:defRPr>
             </a:pPr>
             <a:r>
-              <a:rPr sz="2625" b="1" i="0">
-                <a:solidFill>
-                  <a:srgbClr val="BEA06A"/>
+              <a:rPr sz="1950" b="0" i="0">
+                <a:solidFill>
+                  <a:srgbClr val="FFFFFF"/>
                 </a:solidFill>
               </a:rPr>
-              <a:t>TKG</a:t>
+              <a:t>Origins in 1995 with Excalibur Army</a:t>
             </a:r>
           </a:p>
         </p:txBody>
@@ -14632,8 +14632,8 @@
         </p:nvSpPr>
         <p:spPr>
           <a:xfrm>
-            <a:off x="3419475" y="3543300"/>
-            <a:ext cx="2524125" cy="1066800"/>
+            <a:off x="723900" y="4819650"/>
+            <a:ext cx="7715250" cy="381000"/>
           </a:xfrm>
           <a:prstGeom prst="rect">
             <a:avLst/>
@@ -14648,7 +14648,7 @@
           <a:bodyPr lIns="0" tIns="0" rIns="0" bIns="0"/>
           <a:lstStyle>
             <a:defPPr algn="l">
-              <a:defRPr sz="1875" b="0" i="0">
+              <a:defRPr sz="1950" b="0" i="0">
                 <a:solidFill>
                   <a:srgbClr val="FFFFFF"/>
                 </a:solidFill>
@@ -14730,317 +14730,19 @@
           <a:p>
             <a:pPr algn="l">
               <a:buNone/>
-              <a:defRPr sz="1875" b="0" i="0">
+              <a:defRPr sz="1950" b="0" i="0">
                 <a:solidFill>
                   <a:srgbClr val="FFFFFF"/>
                 </a:solidFill>
               </a:defRPr>
             </a:pPr>
             <a:r>
-              <a:rPr sz="1875" b="0" i="0">
+              <a:rPr sz="1950" b="0" i="0">
                 <a:solidFill>
                   <a:srgbClr val="FFFFFF"/>
                 </a:solidFill>
               </a:rPr>
-              <a:t>Part of</a:t>
-            </a:r>
-          </a:p>
-          <a:p>
-            <a:pPr algn="l">
-              <a:buNone/>
-              <a:defRPr sz="1875" b="0" i="0">
-                <a:solidFill>
-                  <a:srgbClr val="FFFFFF"/>
-                </a:solidFill>
-              </a:defRPr>
-            </a:pPr>
-            <a:r>
-              <a:rPr sz="1875" b="0" i="0">
-                <a:solidFill>
-                  <a:srgbClr val="FFFFFF"/>
-                </a:solidFill>
-              </a:rPr>
-              <a:t>CSG Ammo+</a:t>
-            </a:r>
-          </a:p>
-        </p:txBody>
-      </p:sp>
-      <p:sp>
-        <p:nvSpPr>
-          <p:cNvPr id="7" name="">
-            <a:extLst>
-              <a:ext uri="{FF2B5EF4-FFF2-40B4-BE49-F238E27FC236}">
-                <ns2:creationId id="{3644D645-77AD-4BEA-B186-DA1B65F1C548}"/>
-              </a:ext>
-            </a:extLst>
-          </p:cNvPr>
-          <p:cNvSpPr>
-            <a:spLocks noGrp="1"/>
-          </p:cNvSpPr>
-          <p:nvPr/>
-        </p:nvSpPr>
-        <p:spPr>
-          <a:xfrm>
-            <a:off x="6229350" y="2800350"/>
-            <a:ext cx="2381250" cy="619125"/>
-          </a:xfrm>
-          <a:prstGeom prst="rect">
-            <a:avLst/>
-          </a:prstGeom>
-          <a:noFill/>
-          <a:ln w="0">
-            <a:noFill/>
-            <a:prstDash val="solid"/>
-          </a:ln>
-        </p:spPr>
-        <p:txBody>
-          <a:bodyPr lIns="0" tIns="0" rIns="0" bIns="0"/>
-          <a:lstStyle>
-            <a:defPPr algn="l">
-              <a:defRPr sz="2625" b="1" i="0">
-                <a:solidFill>
-                  <a:srgbClr val="BEA06A"/>
-                </a:solidFill>
-              </a:defRPr>
-            </a:defPPr>
-            <a:lvl1pPr algn="l">
-              <a:buNone/>
-              <a:defRPr sz="2625" b="1" i="0">
-                <a:solidFill>
-                  <a:srgbClr val="BEA06A"/>
-                </a:solidFill>
-              </a:defRPr>
-            </a:lvl1pPr>
-            <a:lvl2pPr algn="l">
-              <a:buNone/>
-              <a:defRPr sz="2625" b="1" i="0">
-                <a:solidFill>
-                  <a:srgbClr val="BEA06A"/>
-                </a:solidFill>
-              </a:defRPr>
-            </a:lvl2pPr>
-            <a:lvl3pPr algn="l">
-              <a:buNone/>
-              <a:defRPr sz="2625" b="1" i="0">
-                <a:solidFill>
-                  <a:srgbClr val="BEA06A"/>
-                </a:solidFill>
-              </a:defRPr>
-            </a:lvl3pPr>
-            <a:lvl4pPr algn="l">
-              <a:buNone/>
-              <a:defRPr sz="2625" b="1" i="0">
-                <a:solidFill>
-                  <a:srgbClr val="BEA06A"/>
-                </a:solidFill>
-              </a:defRPr>
-            </a:lvl4pPr>
-            <a:lvl5pPr algn="l">
-              <a:buNone/>
-              <a:defRPr sz="2625" b="1" i="0">
-                <a:solidFill>
-                  <a:srgbClr val="BEA06A"/>
-                </a:solidFill>
-              </a:defRPr>
-            </a:lvl5pPr>
-            <a:lvl6pPr algn="l">
-              <a:buNone/>
-              <a:defRPr sz="2625" b="1" i="0">
-                <a:solidFill>
-                  <a:srgbClr val="BEA06A"/>
-                </a:solidFill>
-              </a:defRPr>
-            </a:lvl6pPr>
-            <a:lvl7pPr algn="l">
-              <a:buNone/>
-              <a:defRPr sz="2625" b="1" i="0">
-                <a:solidFill>
-                  <a:srgbClr val="BEA06A"/>
-                </a:solidFill>
-              </a:defRPr>
-            </a:lvl7pPr>
-            <a:lvl8pPr algn="l">
-              <a:buNone/>
-              <a:defRPr sz="2625" b="1" i="0">
-                <a:solidFill>
-                  <a:srgbClr val="BEA06A"/>
-                </a:solidFill>
-              </a:defRPr>
-            </a:lvl8pPr>
-            <a:lvl9pPr algn="l">
-              <a:buNone/>
-              <a:defRPr sz="2625" b="1" i="0">
-                <a:solidFill>
-                  <a:srgbClr val="BEA06A"/>
-                </a:solidFill>
-              </a:defRPr>
-            </a:lvl9pPr>
-          </a:lstStyle>
-          <a:p>
-            <a:pPr algn="l">
-              <a:buNone/>
-              <a:defRPr sz="2625" b="1" i="0">
-                <a:solidFill>
-                  <a:srgbClr val="BEA06A"/>
-                </a:solidFill>
-              </a:defRPr>
-            </a:pPr>
-            <a:r>
-              <a:rPr sz="2625" b="1" i="0">
-                <a:solidFill>
-                  <a:srgbClr val="BEA06A"/>
-                </a:solidFill>
-              </a:rPr>
-              <a:t>REMINGTON</a:t>
-            </a:r>
-          </a:p>
-        </p:txBody>
-      </p:sp>
-      <p:sp>
-        <p:nvSpPr>
-          <p:cNvPr id="8" name="">
-            <a:extLst>
-              <a:ext uri="{FF2B5EF4-FFF2-40B4-BE49-F238E27FC236}">
-                <ns2:creationId id="{8CD4209B-EEAA-49CF-B1CF-B1BCE1C02033}"/>
-              </a:ext>
-            </a:extLst>
-          </p:cNvPr>
-          <p:cNvSpPr>
-            <a:spLocks noGrp="1"/>
-          </p:cNvSpPr>
-          <p:nvPr/>
-        </p:nvSpPr>
-        <p:spPr>
-          <a:xfrm>
-            <a:off x="6229350" y="3543300"/>
-            <a:ext cx="2524125" cy="1066800"/>
-          </a:xfrm>
-          <a:prstGeom prst="rect">
-            <a:avLst/>
-          </a:prstGeom>
-          <a:noFill/>
-          <a:ln w="0">
-            <a:noFill/>
-            <a:prstDash val="solid"/>
-          </a:ln>
-        </p:spPr>
-        <p:txBody>
-          <a:bodyPr lIns="0" tIns="0" rIns="0" bIns="0"/>
-          <a:lstStyle>
-            <a:defPPr algn="l">
-              <a:defRPr sz="1875" b="0" i="0">
-                <a:solidFill>
-                  <a:srgbClr val="FFFFFF"/>
-                </a:solidFill>
-              </a:defRPr>
-            </a:defPPr>
-            <a:lvl1pPr algn="l">
-              <a:buNone/>
-              <a:defRPr sz="1875" b="0" i="0">
-                <a:solidFill>
-                  <a:srgbClr val="FFFFFF"/>
-                </a:solidFill>
-              </a:defRPr>
-            </a:lvl1pPr>
-            <a:lvl2pPr algn="l">
-              <a:buNone/>
-              <a:defRPr sz="1875" b="0" i="0">
-                <a:solidFill>
-                  <a:srgbClr val="FFFFFF"/>
-                </a:solidFill>
-              </a:defRPr>
-            </a:lvl2pPr>
-            <a:lvl3pPr algn="l">
-              <a:buNone/>
-              <a:defRPr sz="1875" b="0" i="0">
-                <a:solidFill>
-                  <a:srgbClr val="FFFFFF"/>
-                </a:solidFill>
-              </a:defRPr>
-            </a:lvl3pPr>
-            <a:lvl4pPr algn="l">
-              <a:buNone/>
-              <a:defRPr sz="1875" b="0" i="0">
-                <a:solidFill>
-                  <a:srgbClr val="FFFFFF"/>
-                </a:solidFill>
-              </a:defRPr>
-            </a:lvl4pPr>
-            <a:lvl5pPr algn="l">
-              <a:buNone/>
-              <a:defRPr sz="1875" b="0" i="0">
-                <a:solidFill>
-                  <a:srgbClr val="FFFFFF"/>
-                </a:solidFill>
-              </a:defRPr>
-            </a:lvl5pPr>
-            <a:lvl6pPr algn="l">
-              <a:buNone/>
-              <a:defRPr sz="1875" b="0" i="0">
-                <a:solidFill>
-                  <a:srgbClr val="FFFFFF"/>
-                </a:solidFill>
-              </a:defRPr>
-            </a:lvl6pPr>
-            <a:lvl7pPr algn="l">
-              <a:buNone/>
-              <a:defRPr sz="1875" b="0" i="0">
-                <a:solidFill>
-                  <a:srgbClr val="FFFFFF"/>
-                </a:solidFill>
-              </a:defRPr>
-            </a:lvl7pPr>
-            <a:lvl8pPr algn="l">
-              <a:buNone/>
-              <a:defRPr sz="1875" b="0" i="0">
-                <a:solidFill>
-                  <a:srgbClr val="FFFFFF"/>
-                </a:solidFill>
-              </a:defRPr>
-            </a:lvl8pPr>
-            <a:lvl9pPr algn="l">
-              <a:buNone/>
-              <a:defRPr sz="1875" b="0" i="0">
-                <a:solidFill>
-                  <a:srgbClr val="FFFFFF"/>
-                </a:solidFill>
-              </a:defRPr>
-            </a:lvl9pPr>
-          </a:lstStyle>
-          <a:p>
-            <a:pPr algn="l">
-              <a:buNone/>
-              <a:defRPr sz="1875" b="0" i="0">
-                <a:solidFill>
-                  <a:srgbClr val="FFFFFF"/>
-                </a:solidFill>
-              </a:defRPr>
-            </a:pPr>
-            <a:r>
-              <a:rPr sz="1875" b="0" i="0">
-                <a:solidFill>
-                  <a:srgbClr val="FFFFFF"/>
-                </a:solidFill>
-              </a:rPr>
-              <a:t>Manufacturing in</a:t>
-            </a:r>
-          </a:p>
-          <a:p>
-            <a:pPr algn="l">
-              <a:buNone/>
-              <a:defRPr sz="1875" b="0" i="0">
-                <a:solidFill>
-                  <a:srgbClr val="FFFFFF"/>
-                </a:solidFill>
-              </a:defRPr>
-            </a:pPr>
-            <a:r>
-              <a:rPr sz="1875" b="0" i="0">
-                <a:solidFill>
-                  <a:srgbClr val="FFFFFF"/>
-                </a:solidFill>
-              </a:rPr>
-              <a:t>Lonoke, Arkansas</a:t>
+              <a:t>Defense, aerospace and automotive businesses</a:t>
             </a:r>
           </a:p>
         </p:txBody>
@@ -15061,8 +14763,8 @@
         </p:nvSpPr>
         <p:spPr>
           <a:xfrm>
-            <a:off x="723900" y="5362575"/>
-            <a:ext cx="7429500" cy="619125"/>
+            <a:off x="723900" y="5629275"/>
+            <a:ext cx="7715250" cy="428625"/>
           </a:xfrm>
           <a:prstGeom prst="rect">
             <a:avLst/>
@@ -15077,7 +14779,7 @@
           <a:bodyPr lIns="0" tIns="0" rIns="0" bIns="0"/>
           <a:lstStyle>
             <a:defPPr algn="l">
-              <a:defRPr sz="2550" b="1" i="0">
+              <a:defRPr sz="2250" b="1" i="0">
                 <a:solidFill>
                   <a:srgbClr val="FFFFFF"/>
                 </a:solidFill>
@@ -15159,27 +14861,55 @@
           <a:p>
             <a:pPr algn="l">
               <a:buNone/>
-              <a:defRPr sz="2550" b="1" i="0">
+              <a:defRPr sz="2250" b="1" i="0">
                 <a:solidFill>
                   <a:srgbClr val="FFFFFF"/>
                 </a:solidFill>
               </a:defRPr>
             </a:pPr>
             <a:r>
-              <a:rPr sz="2550" b="1" i="0">
+              <a:rPr sz="2250" b="1" i="0">
                 <a:solidFill>
                   <a:srgbClr val="FFFFFF"/>
                 </a:solidFill>
               </a:rPr>
-              <a:t>AI for the next generation of manufacturing.</a:t>
+              <a:t>The Kinetic Group is part of CSG Ammo+.</a:t>
             </a:r>
           </a:p>
         </p:txBody>
       </p:sp>
+      <p:pic>
+        <p:nvPicPr>
+          <p:cNvPr id="90" name="">
+            <a:extLst>
+              <a:ext uri="{FF2B5EF4-FFF2-40B4-BE49-F238E27FC236}">
+                <ns2:creationId id="{93296FAB-E45C-431A-A0B6-521D97F80EE2}"/>
+              </a:ext>
+            </a:extLst>
+          </p:cNvPr>
+          <p:cNvPicPr>
+            <a:picLocks noChangeAspect="1"/>
+          </p:cNvPicPr>
+          <p:nvPr/>
+        </p:nvPicPr>
+        <p:blipFill>
+          <a:blip r:embed="rIdCSGBrand"/>
+          <a:stretch/>
+        </p:blipFill>
+        <p:spPr>
+          <a:xfrm>
+            <a:off x="5781717" y="2647950"/>
+            <a:ext cx="2657392" cy="836390"/>
+          </a:xfrm>
+          <a:prstGeom prst="rect">
+            <a:avLst/>
+          </a:prstGeom>
+        </p:spPr>
+      </p:pic>
     </p:spTree>
     <p:extLst>
       <p:ext uri="{BB962C8B-B14F-4D97-AF65-F5344CB8AC3E}">
-        <ns3:creationId val="1022646670"/>
+        <ns4:creationId val="1022646670"/>
       </p:ext>
     </p:extLst>
   </p:cSld>

</xml_diff>

<commit_message>
Align speech and speaker notes with current slides while preserving personal story
</commit_message>
<xml_diff>
--- a/docs/presentation/Engineering_at_The_Kinetic_Group.pptx
+++ b/docs/presentation/Engineering_at_The_Kinetic_Group.pptx
@@ -720,7 +720,7 @@
           <a:lstStyle/>
           <a:p>
             <a:r>
-              <a:t>Keep the familiar company/project visual flow. The personal introduction runs over the cover and CSG slide; do not advance for each story beat. Demo 0:16–0:36; homepage slide 16; lab slide 17; activity 0:41–0:49; questions to 1:00.</a:t>
+              <a:t>SLIDE CONTROL: Brad advances; Wesley operates demo. Full introduction over slides 1–2, target 6 minutes, room to 8. Use short overview route if needed. Demo target 0:16–0:36. Homepage slide 16; final lab slide 17 at 0:41; questions 0:49–1:00.</a:t>
             </a:r>
           </a:p>
           <a:p>
@@ -730,7 +730,7 @@
           </a:p>
           <a:p>
             <a:r>
-              <a:t>Cue: Use the cover as a visual anchor for your personal introduction. Do not advance for every story beat. About 3 minutes, with room to speak naturally.</a:t>
+              <a:t>On screen: Title, names, event.</a:t>
             </a:r>
           </a:p>
           <a:p>
@@ -740,6 +740,16 @@
           </a:p>
           <a:p>
             <a:r>
+              <a:t>HOLD SLIDE 1: Tell the complete beginning, including the inspection struggle. Allow roughly 3–5 minutes. Look at the audience; no slide change is needed for the school, OCR, or inspection beats.</a:t>
+            </a:r>
+          </a:p>
+          <a:p>
+            <a:r>
+              <a:t/>
+            </a:r>
+          </a:p>
+          <a:p>
+            <a:r>
               <a:t>Brad: “Good morning. I'm Brad Daugherty, an electrical engineer at Remington. Most of my work is in Lonoke, and I support projects across The Kinetic Group. I'm here with Wesley Siharath.”</a:t>
             </a:r>
           </a:p>
@@ -830,7 +840,7 @@
           </a:p>
           <a:p>
             <a:r>
-              <a:t>Bridge: Advance to the CSG slide for the company context and the opportunity to try.</a:t>
+              <a:t>ADVANCE TO SLIDE 2 after: “I proposed that we build it ourselves.” Let that sentence land, then introduce the company context before telling them what happened to the proposal.</a:t>
             </a:r>
           </a:p>
         </p:txBody>
@@ -900,6 +910,16 @@
           <a:lstStyle/>
           <a:p>
             <a:r>
+              <a:t>On screen: Project documents, retrieval, citations, local model, scoped tools. Brief overview.</a:t>
+            </a:r>
+          </a:p>
+          <a:p>
+            <a:r>
+              <a:t/>
+            </a:r>
+          </a:p>
+          <a:p>
+            <a:r>
               <a:t>Cue: Retrieve project material, generate an answer, check the source.</a:t>
             </a:r>
           </a:p>
@@ -910,7 +930,7 @@
           </a:p>
           <a:p>
             <a:r>
-              <a:t>Wesley: “Remi uses a local language model with retrieval over approved project documents. It indexes the material, finds relevant passages, and answers with citations. Scoped tools let it work within a defined workspace. The engineer still checks the source and the result.”</a:t>
+              <a:t>Wesley: “Another kind of information we work with is project documentation. Remi uses a local language model with retrieval over approved project documents. It indexes the material, finds relevant passages, and answers with citations. Scoped tools let it work within a defined workspace. The engineer still checks the source and the result.”</a:t>
             </a:r>
           </a:p>
           <a:p>
@@ -921,6 +941,36 @@
           <a:p>
             <a:r>
               <a:t>Brad: “Here the integration problem is keeping the answer connected to evidence and controlling what the tools can do.”</a:t>
+            </a:r>
+          </a:p>
+          <a:p>
+            <a:r>
+              <a:t/>
+            </a:r>
+          </a:p>
+          <a:p>
+            <a:r>
+              <a:t>If behind: About 30 seconds. Keep retrieval, citations, and the engineer checking the source.</a:t>
+            </a:r>
+          </a:p>
+          <a:p>
+            <a:r>
+              <a:t/>
+            </a:r>
+          </a:p>
+          <a:p>
+            <a:r>
+              <a:t>Brad, transition: “Those are the projects. The part that keeps us interested is getting to carry an idea into use.”</a:t>
+            </a:r>
+          </a:p>
+          <a:p>
+            <a:r>
+              <a:t/>
+            </a:r>
+          </a:p>
+          <a:p>
+            <a:r>
+              <a:t>ADVANCE TO SLIDE 11 after: “carry an idea into use.”</a:t>
             </a:r>
           </a:p>
         </p:txBody>
@@ -990,6 +1040,16 @@
           <a:lstStyle/>
           <a:p>
             <a:r>
+              <a:t>On screen: Variety, freedom, ownership, growth. This is where Wesley tells his real-reject moment.</a:t>
+            </a:r>
+          </a:p>
+          <a:p>
+            <a:r>
+              <a:t/>
+            </a:r>
+          </a:p>
+          <a:p>
+            <a:r>
               <a:t>Cue: Variety, freedom, ownership, and a real result. Demo at 0:16.</a:t>
             </a:r>
           </a:p>
@@ -1000,7 +1060,7 @@
           </a:p>
           <a:p>
             <a:r>
-              <a:t>Brad: “Wesley, what do you enjoy most about working here?”</a:t>
+              <a:t>Brad: “We have shown you the kinds of work. Wesley, what do you enjoy most about actually doing it here?”</a:t>
             </a:r>
           </a:p>
           <a:p>
@@ -1051,6 +1111,16 @@
           <a:p>
             <a:r>
               <a:t>Brad: “Let's show that connection between an image, a decision, and a visible result.”</a:t>
+            </a:r>
+          </a:p>
+          <a:p>
+            <a:r>
+              <a:t/>
+            </a:r>
+          </a:p>
+          <a:p>
+            <a:r>
+              <a:t>ADVANCE TO SLIDE 12 after: “a visible result.” Target 0:16. Keep Wesley's real-reject moment here so it lands once.</a:t>
             </a:r>
           </a:p>
         </p:txBody>
@@ -1120,6 +1190,16 @@
           <a:lstStyle/>
           <a:p>
             <a:r>
+              <a:t>On screen: CAMERA → AI → ACTION and Gatorade bottles. Hold this while framing the demo, then switch applications.</a:t>
+            </a:r>
+          </a:p>
+          <a:p>
+            <a:r>
+              <a:t/>
+            </a:r>
+          </a:p>
+          <a:p>
+            <a:r>
               <a:t>Cue: Detection, color prediction, track, decision, one variation. 0:16–0:36.</a:t>
             </a:r>
           </a:p>
@@ -1150,6 +1230,16 @@
           </a:p>
           <a:p>
             <a:r>
+              <a:t>Application cue: Show slide 12 for the opening, then say, “Wesley, let's look at it.” Switch to the rehearsed demo application before the baseline.</a:t>
+            </a:r>
+          </a:p>
+          <a:p>
+            <a:r>
+              <a:t/>
+            </a:r>
+          </a:p>
+          <a:p>
+            <a:r>
               <a:t>Baseline, 4 minutes. Brad states the pass color and asks for predictions for two contrasting bottles. Wesley points out the bottle box, model color prediction, track, and displayed decision. In the standard repository mode, unknown color diverts. Show what this build actually did.</a:t>
             </a:r>
           </a:p>
@@ -1191,6 +1281,26 @@
           <a:p>
             <a:r>
               <a:t>Recovery: Show the camera view and last successful result. Ask what the audience would inspect first. Move on within two minutes. Optional barcodes and physical motion are outside the core sequence.</a:t>
+            </a:r>
+          </a:p>
+          <a:p>
+            <a:r>
+              <a:t/>
+            </a:r>
+          </a:p>
+          <a:p>
+            <a:r>
+              <a:t>Short route if starting late: Two minutes framing, four minutes for the two baseline outcomes, four minutes for one variation, then guided questions and exit by 0:36. Trim discussion to the time remaining.</a:t>
+            </a:r>
+          </a:p>
+          <a:p>
+            <a:r>
+              <a:t/>
+            </a:r>
+          </a:p>
+          <a:p>
+            <a:r>
+              <a:t>RETURN TO THE DECK AT SLIDE 13 after the demo transition. Do not move through the sentiment or Remi slides again.</a:t>
             </a:r>
           </a:p>
         </p:txBody>
@@ -1260,6 +1370,16 @@
           <a:lstStyle/>
           <a:p>
             <a:r>
+              <a:t>On screen: Variation, timing, reliability. Return here from the application after the demo.</a:t>
+            </a:r>
+          </a:p>
+          <a:p>
+            <a:r>
+              <a:t/>
+            </a:r>
+          </a:p>
+          <a:p>
+            <a:r>
               <a:t>Cue: Timing, signals, sunlight, and confidence.</a:t>
             </a:r>
           </a:p>
@@ -1321,6 +1441,26 @@
           <a:p>
             <a:r>
               <a:t>Brad: “That is the step from a prototype we operate ourselves to a system other people can rely on.”</a:t>
+            </a:r>
+          </a:p>
+          <a:p>
+            <a:r>
+              <a:t/>
+            </a:r>
+          </a:p>
+          <a:p>
+            <a:r>
+              <a:t>Brad, transition: “Working through those problems takes people with different skills. That is where the next person can come in.”</a:t>
+            </a:r>
+          </a:p>
+          <a:p>
+            <a:r>
+              <a:t/>
+            </a:r>
+          </a:p>
+          <a:p>
+            <a:r>
+              <a:t>ADVANCE TO SLIDE 14 after: “the next person can come in.”</a:t>
             </a:r>
           </a:p>
         </p:txBody>
@@ -1390,6 +1530,16 @@
           <a:lstStyle/>
           <a:p>
             <a:r>
+              <a:t>On screen: Mechanical, controls, software, testing. Tie the invitation to how Brad and Wesley started.</a:t>
+            </a:r>
+          </a:p>
+          <a:p>
+            <a:r>
+              <a:t/>
+            </a:r>
+          </a:p>
+          <a:p>
+            <a:r>
               <a:t>Cue: Mechanical, controls, software, and testing. Close before the two final QR slides.</a:t>
             </a:r>
           </a:p>
@@ -1400,7 +1550,27 @@
           </a:p>
           <a:p>
             <a:r>
-              <a:t>Brad: “Building the next generation of manufacturing means connecting AI to real work. These problems cross mechanical engineering, controls, software, and testing. We want people who will follow a problem from the first question through deployment and improvement. Tell us what you have built and what you want to take on next.”</a:t>
+              <a:t>Brad: “I started as a mechanical engineering intern trying to solve a problem I did not understand. Wesley started through software and machine prototyping. Building the next generation of manufacturing needs people from all of those directions. These problems cross mechanical engineering, controls, software, and testing. We want people who will follow a problem from the first question through deployment and improvement. Tell us what you have built and what you want to take on next.”</a:t>
+            </a:r>
+          </a:p>
+          <a:p>
+            <a:r>
+              <a:t/>
+            </a:r>
+          </a:p>
+          <a:p>
+            <a:r>
+              <a:t>Brad, transition: “If that sounds like the kind of work you want to do, come talk to us.”</a:t>
+            </a:r>
+          </a:p>
+          <a:p>
+            <a:r>
+              <a:t/>
+            </a:r>
+          </a:p>
+          <a:p>
+            <a:r>
+              <a:t>ADVANCE TO SLIDE 15 after: “come talk to us.”</a:t>
             </a:r>
           </a:p>
         </p:txBody>
@@ -1470,6 +1640,16 @@
           <a:lstStyle/>
           <a:p>
             <a:r>
+              <a:t>On screen: Interactive lab QR, URL, and PIN 877262. Hold through the activity and open questions.</a:t>
+            </a:r>
+          </a:p>
+          <a:p>
+            <a:r>
+              <a:t/>
+            </a:r>
+          </a:p>
+          <a:p>
+            <a:r>
               <a:t>Cue: Scan, PIN, try, share. 0:41–0:49.</a:t>
             </a:r>
           </a:p>
@@ -1516,6 +1696,16 @@
           <a:p>
             <a:r>
               <a:t>Questions, 0:49–1:00: Keep this final slide visible so the lab QR, URL, and PIN remain available. “What are you curious about, or what are you trying to build?”</a:t>
+            </a:r>
+          </a:p>
+          <a:p>
+            <a:r>
+              <a:t/>
+            </a:r>
+          </a:p>
+          <a:p>
+            <a:r>
+              <a:t>HOLD SLIDE 17: Keep the QR, URL, and PIN visible during the activity and questions. No further slide change.</a:t>
             </a:r>
           </a:p>
           <a:p>
@@ -1630,6 +1820,16 @@
           <a:lstStyle/>
           <a:p>
             <a:r>
+              <a:t>On screen: Homepage QR and 4founders.dev. Pause for people to scan.</a:t>
+            </a:r>
+          </a:p>
+          <a:p>
+            <a:r>
+              <a:t/>
+            </a:r>
+          </a:p>
+          <a:p>
+            <a:r>
               <a:t>Cue: Penultimate slide. Homepage QR, about 0:40–0:41.</a:t>
             </a:r>
           </a:p>
@@ -1661,6 +1861,16 @@
           <a:p>
             <a:r>
               <a:t>Bridge: “The last slide takes you straight to the interactive demo.”</a:t>
+            </a:r>
+          </a:p>
+          <a:p>
+            <a:r>
+              <a:t/>
+            </a:r>
+          </a:p>
+          <a:p>
+            <a:r>
+              <a:t>ADVANCE TO SLIDE 17 after: “straight to the interactive demo.” Allow time for the homepage scan first.</a:t>
             </a:r>
           </a:p>
         </p:txBody>
@@ -1730,6 +1940,16 @@
           <a:lstStyle/>
           <a:p>
             <a:r>
+              <a:t>On screen: Factory-floor closing message and awhite@tkghunt.com. Close the story before the QR slides.</a:t>
+            </a:r>
+          </a:p>
+          <a:p>
+            <a:r>
+              <a:t/>
+            </a:r>
+          </a:p>
+          <a:p>
+            <a:r>
               <a:t>Cue: awhite@tkghunt.com, questions, internship, and ideas. Close the story by about 0:40, before the homepage and lab QR slides.</a:t>
             </a:r>
           </a:p>
@@ -1760,7 +1980,7 @@
           </a:p>
           <a:p>
             <a:r>
-              <a:t>Brad: “The generations before us built the foundation. We want to build what the next generation can stand on. Our history was made on the factory floor. The future will be, too. Let's bring AI into real work and build the next generation of manufacturing together. Come build and fight with us. Turn AI into action.”</a:t>
+              <a:t>Brad: “For me, this started with a rough OCR application and a problem I could not solve. Then we got the chance to try, and I called Wesley. That is what I hope you take from our story: you can start while you are still learning, find people to build with, and keep working until the result is useful to someone else. Our history was made on the factory floor. The future will be, too. Come help us bring AI into real work and build the next generation of manufacturing.”</a:t>
             </a:r>
           </a:p>
           <a:p>
@@ -1776,6 +1996,16 @@
           <a:p>
             <a:r>
               <a:t>Bridge: “Before we finish, here are two ways to keep exploring.”</a:t>
+            </a:r>
+          </a:p>
+          <a:p>
+            <a:r>
+              <a:t/>
+            </a:r>
+          </a:p>
+          <a:p>
+            <a:r>
+              <a:t>ADVANCE TO SLIDE 16 after: “two ways to keep exploring.” Aim to close the personal story around 0:40.</a:t>
             </a:r>
           </a:p>
         </p:txBody>
@@ -1845,7 +2075,7 @@
           <a:lstStyle/>
           <a:p>
             <a:r>
-              <a:t>Cue: CSG context, approval, and the call to Wesley. Complete the personal introduction by about 0:06.</a:t>
+              <a:t>On screen: CSG brand, Prague headquarters, 1995 origins, main industries, and TKG membership in Ammo+.</a:t>
             </a:r>
           </a:p>
           <a:p>
@@ -1855,7 +2085,7 @@
           </a:p>
           <a:p>
             <a:r>
-              <a:t>Brad: “CSG stands for Czechoslovak Group. It is a global industrial and technology group headquartered in Prague, in the Czech Republic. Its roots go back to Excalibur Army in 1995, and its businesses span defense, aerospace, and automotive industries. The Kinetic Group is part of CSG Ammo+, and Remington is one of the TKG brands. Today's examples come mainly from Lonoke.”</a:t>
+              <a:t>HOLD SLIDE 2: Briefly explain who CSG is, then continue the approval story and hand off to Wesley. Keep this slide visible through his introduction and optional memory. Target the end of the opening around 0:06; up to 0:08 is workable.</a:t>
             </a:r>
           </a:p>
           <a:p>
@@ -1865,6 +2095,16 @@
           </a:p>
           <a:p>
             <a:r>
+              <a:t>Brad: “Before I tell you what happened to that proposal, this is where CSG fits. CSG stands for Czechoslovak Group. It is a global industrial and technology group headquartered in Prague, in the Czech Republic. Its roots go back to Excalibur Army in 1995, and its businesses span defense, aerospace, and automotive industries. The Kinetic Group is part of CSG Ammo+, and Remington is one of the TKG brands. Today's examples come mainly from Lonoke.”</a:t>
+            </a:r>
+          </a:p>
+          <a:p>
+            <a:r>
+              <a:t/>
+            </a:r>
+          </a:p>
+          <a:p>
+            <a:r>
               <a:t>“Under the new CSG management, the proposal to build our own system was actually approved. They told me to go get an intern.”</a:t>
             </a:r>
           </a:p>
@@ -1925,7 +2165,17 @@
           </a:p>
           <a:p>
             <a:r>
-              <a:t>Brad: “We want to turn that opportunity into useful capability on the floor. That is how we want to help build the next generation of manufacturing. Here is the company and the work that story sits inside.”</a:t>
+              <a:t>Brad: “That is how the two of us got into this work. We were given a chance to turn an idea into something people could use on the floor. Our part in that story is recent. The manufacturing history we are building on goes back much further.”</a:t>
+            </a:r>
+          </a:p>
+          <a:p>
+            <a:r>
+              <a:t/>
+            </a:r>
+          </a:p>
+          <a:p>
+            <a:r>
+              <a:t>ADVANCE TO SLIDE 3 after: “goes back much further.”</a:t>
             </a:r>
           </a:p>
           <a:p>
@@ -2005,6 +2255,16 @@
           <a:lstStyle/>
           <a:p>
             <a:r>
+              <a:t>On screen: 1816, Lonoke 1969, NEXT. Use the timeline as the setting for your story.</a:t>
+            </a:r>
+          </a:p>
+          <a:p>
+            <a:r>
+              <a:t/>
+            </a:r>
+          </a:p>
+          <a:p>
+            <a:r>
               <a:t>Cue: 1816, Lonoke 1969, and our turn to contribute.</a:t>
             </a:r>
           </a:p>
@@ -2030,7 +2290,27 @@
           </a:p>
           <a:p>
             <a:r>
-              <a:t>Bridge from the personal introduction: The slides now return to the original company/project flow. Use the history as context rather than retelling the internship.</a:t>
+              <a:t>Short route if the introduction ran long: “Our part of the story is recent. Remington goes back to 1816, and Lonoke to 1969. Our contribution is to build on that experience with cameras, controls, and software.”</a:t>
+            </a:r>
+          </a:p>
+          <a:p>
+            <a:r>
+              <a:t/>
+            </a:r>
+          </a:p>
+          <a:p>
+            <a:r>
+              <a:t>Brad, transition: “That history carries responsibility, because this is real manufacturing.”</a:t>
+            </a:r>
+          </a:p>
+          <a:p>
+            <a:r>
+              <a:t/>
+            </a:r>
+          </a:p>
+          <a:p>
+            <a:r>
+              <a:t>ADVANCE TO SLIDE 4 after: “real manufacturing.”</a:t>
             </a:r>
           </a:p>
         </p:txBody>
@@ -2100,6 +2380,16 @@
           <a:lstStyle/>
           <a:p>
             <a:r>
+              <a:t>On screen: Ammunition manufacturing, propellants and primers, moving machinery, real production.</a:t>
+            </a:r>
+          </a:p>
+          <a:p>
+            <a:r>
+              <a:t/>
+            </a:r>
+          </a:p>
+          <a:p>
+            <a:r>
               <a:t>Cue: Real machinery, real operators, real consequences.</a:t>
             </a:r>
           </a:p>
@@ -2110,7 +2400,37 @@
           </a:p>
           <a:p>
             <a:r>
-              <a:t>Brad: “We work around energetic materials and moving machinery. That makes timing, clear information, and recovery part of the engineering problem. We build with operators, maintenance, quality, and safety. The software has to fit their workflow and the established safeguards.”</a:t>
+              <a:t>Brad: “That was part of what made those inspection projects so challenging. We work around energetic materials and moving machinery. That makes timing, clear information, and recovery part of the engineering problem. We build with operators, maintenance, quality, and safety. The software has to fit their workflow and the established safeguards.”</a:t>
+            </a:r>
+          </a:p>
+          <a:p>
+            <a:r>
+              <a:t/>
+            </a:r>
+          </a:p>
+          <a:p>
+            <a:r>
+              <a:t>Short route: “We work around energetic materials, moving machinery, and real production. The system has to fit the people, workflow, and safeguards.”</a:t>
+            </a:r>
+          </a:p>
+          <a:p>
+            <a:r>
+              <a:t/>
+            </a:r>
+          </a:p>
+          <a:p>
+            <a:r>
+              <a:t>Brad, transition: “So what does it take for software to reach that floor?”</a:t>
+            </a:r>
+          </a:p>
+          <a:p>
+            <a:r>
+              <a:t/>
+            </a:r>
+          </a:p>
+          <a:p>
+            <a:r>
+              <a:t>ADVANCE TO SLIDE 5 after: “reach that floor?”</a:t>
             </a:r>
           </a:p>
         </p:txBody>
@@ -2180,6 +2500,16 @@
           <a:lstStyle/>
           <a:p>
             <a:r>
+              <a:t>On screen: SENSE / DECIDE / ACT. Connect each word to the whole system you had to build.</a:t>
+            </a:r>
+          </a:p>
+          <a:p>
+            <a:r>
+              <a:t/>
+            </a:r>
+          </a:p>
+          <a:p>
+            <a:r>
               <a:t>Cue: Capture, inference, decision, response.</a:t>
             </a:r>
           </a:p>
@@ -2190,7 +2520,37 @@
           </a:p>
           <a:p>
             <a:r>
-              <a:t>Brad: “Sense, decide, act. For a vision system, that means acquiring an image, running inference, interpreting the output, and delivering a result in time for the workflow. A model result is one step in that chain. Camera conditions, signals, software latency, and the response all have to fit together. We test the whole chain and show people the evidence behind the result.”</a:t>
+              <a:t>Brad: “When we proposed building it ourselves, this was the whole problem we were taking on. Sense, decide, act. For a vision system, that means acquiring an image, running inference, interpreting the output, and delivering a result in time for the workflow. A model result is one step in that chain. Camera conditions, signals, software latency, and the response all have to fit together. We test the whole chain and show people the evidence behind the result.”</a:t>
+            </a:r>
+          </a:p>
+          <a:p>
+            <a:r>
+              <a:t/>
+            </a:r>
+          </a:p>
+          <a:p>
+            <a:r>
+              <a:t>Short route: “Sense, decide, act. Capturing an image, making a decision, and getting a usable response all have to work together.”</a:t>
+            </a:r>
+          </a:p>
+          <a:p>
+            <a:r>
+              <a:t/>
+            </a:r>
+          </a:p>
+          <a:p>
+            <a:r>
+              <a:t>Brad, transition: “You can see that same pattern across our work.”</a:t>
+            </a:r>
+          </a:p>
+          <a:p>
+            <a:r>
+              <a:t/>
+            </a:r>
+          </a:p>
+          <a:p>
+            <a:r>
+              <a:t>ADVANCE TO SLIDE 6 after: “across our work.”</a:t>
             </a:r>
           </a:p>
         </p:txBody>
@@ -2260,6 +2620,16 @@
           <a:lstStyle/>
           <a:p>
             <a:r>
+              <a:t>On screen: Two production inspection systems and two other capabilities. Give the room a brief map.</a:t>
+            </a:r>
+          </a:p>
+          <a:p>
+            <a:r>
+              <a:t/>
+            </a:r>
+          </a:p>
+          <a:p>
+            <a:r>
               <a:t>Cue: Two live inspection systems, two broader capabilities. Finish this context block by about 0:10.</a:t>
             </a:r>
           </a:p>
@@ -2270,7 +2640,37 @@
           </a:p>
           <a:p>
             <a:r>
-              <a:t>Brad: “Centerfire and shotshell inspection are live and still being refined. Public sentiment and Remi apply software to different questions: what customers are saying, and how engineers find project knowledge. The common problem is making the evidence useful to someone making a decision.”</a:t>
+              <a:t>Brad: “That approach now connects the different kinds of work we do. Centerfire and shotshell inspection are live and still being refined. Public sentiment and Remi apply software to different questions: what customers are saying, and how engineers find project knowledge. The common problem is making the evidence useful to someone making a decision.”</a:t>
+            </a:r>
+          </a:p>
+          <a:p>
+            <a:r>
+              <a:t/>
+            </a:r>
+          </a:p>
+          <a:p>
+            <a:r>
+              <a:t>Short route: “Centerfire and shotshell inspection are live and being refined. Sentiment and Remi address other kinds of information. I will start with inspection.”</a:t>
+            </a:r>
+          </a:p>
+          <a:p>
+            <a:r>
+              <a:t/>
+            </a:r>
+          </a:p>
+          <a:p>
+            <a:r>
+              <a:t>Brad, transition for the full route: “Start with centerfire inspection and what building that capability involves.”</a:t>
+            </a:r>
+          </a:p>
+          <a:p>
+            <a:r>
+              <a:t/>
+            </a:r>
+          </a:p>
+          <a:p>
+            <a:r>
+              <a:t>ADVANCE TO SLIDE 7 after: the centerfire introduction. Finish this overview around 0:10.</a:t>
             </a:r>
           </a:p>
         </p:txBody>
@@ -2340,6 +2740,16 @@
           <a:lstStyle/>
           <a:p>
             <a:r>
+              <a:t>On screen: Image capture, inference, a usable result, and earning trust. Explain what building our own involves.</a:t>
+            </a:r>
+          </a:p>
+          <a:p>
+            <a:r>
+              <a:t/>
+            </a:r>
+          </a:p>
+          <a:p>
+            <a:r>
               <a:t>Cue: Vision pipeline, visible evidence, operator trust.</a:t>
             </a:r>
           </a:p>
@@ -2350,7 +2760,7 @@
           </a:p>
           <a:p>
             <a:r>
-              <a:t>Brad: “Remington Vision brings image capture, labeling, model training, and inference into one toolset. It uses YOLOX detection models and supports workstation and edge deployment. The model is only part of the system. The result has to reach a usable workflow, and people need to understand what the camera saw.”</a:t>
+              <a:t>Brad: “Here is what building our own system involves. Remington Vision brings image capture, labeling, model training, and inference into one toolset. It uses YOLOX detection models and supports workstation and edge deployment. The model is only part of the system. The result has to reach a usable workflow, and people need to understand what the camera saw.”</a:t>
             </a:r>
           </a:p>
           <a:p>
@@ -2371,6 +2781,26 @@
           <a:p>
             <a:r>
               <a:t>Brad: “That feedback is part of commissioning and continued improvement. It is how the technical result earns trust.”</a:t>
+            </a:r>
+          </a:p>
+          <a:p>
+            <a:r>
+              <a:t/>
+            </a:r>
+          </a:p>
+          <a:p>
+            <a:r>
+              <a:t>Brad, transition: “Carrying that tooling into another product still leaves a different engineering problem. Wesley, take shotshell.”</a:t>
+            </a:r>
+          </a:p>
+          <a:p>
+            <a:r>
+              <a:t/>
+            </a:r>
+          </a:p>
+          <a:p>
+            <a:r>
+              <a:t>ADVANCE TO SLIDE 8 after: “take shotshell.”</a:t>
             </a:r>
           </a:p>
         </p:txBody>
@@ -2440,6 +2870,16 @@
           <a:lstStyle/>
           <a:p>
             <a:r>
+              <a:t>On screen: A different product, different data and view. Wesley explains why reuse still requires engineering.</a:t>
+            </a:r>
+          </a:p>
+          <a:p>
+            <a:r>
+              <a:t/>
+            </a:r>
+          </a:p>
+          <a:p>
+            <a:r>
               <a:t>Cue: A different product changes the image and the data.</a:t>
             </a:r>
           </a:p>
@@ -2461,6 +2901,26 @@
           <a:p>
             <a:r>
               <a:t>Brad: “This is also live and being refined. Reusing software still leaves real integration work.”</a:t>
+            </a:r>
+          </a:p>
+          <a:p>
+            <a:r>
+              <a:t/>
+            </a:r>
+          </a:p>
+          <a:p>
+            <a:r>
+              <a:t>Brad, transition: “Those are image problems on the floor. Other teams need help making sense of text.”</a:t>
+            </a:r>
+          </a:p>
+          <a:p>
+            <a:r>
+              <a:t/>
+            </a:r>
+          </a:p>
+          <a:p>
+            <a:r>
+              <a:t>ADVANCE TO SLIDE 9 after: “making sense of text.”</a:t>
             </a:r>
           </a:p>
         </p:txBody>
@@ -2530,6 +2990,16 @@
           <a:lstStyle/>
           <a:p>
             <a:r>
+              <a:t>On screen: Public discussion, themes, source links. Brief overview; no optional live insert is enabled.</a:t>
+            </a:r>
+          </a:p>
+          <a:p>
+            <a:r>
+              <a:t/>
+            </a:r>
+          </a:p>
+          <a:p>
+            <a:r>
               <a:t>Cue: Collect, score, retain the source.</a:t>
             </a:r>
           </a:p>
@@ -2540,7 +3010,37 @@
           </a:p>
           <a:p>
             <a:r>
-              <a:t>Brad: “The sentiment project collects public discussion, scores sentiment and product themes, and stores the results for review. The scoring uses VADER with a domain vocabulary. A trend gives the team somewhere to investigate. Keeping the original comments available lets people check what the score actually represents.”</a:t>
+              <a:t>Brad: “The same need to turn information into a useful decision also shows up away from the production line. The sentiment project collects public discussion, scores sentiment and product themes, and stores the results for review. The scoring uses VADER with a domain vocabulary. A trend gives the team somewhere to investigate. Keeping the original comments available lets people check what the score actually represents.”</a:t>
+            </a:r>
+          </a:p>
+          <a:p>
+            <a:r>
+              <a:t/>
+            </a:r>
+          </a:p>
+          <a:p>
+            <a:r>
+              <a:t>If behind: Keep the spoken overview to about 30 seconds. Retain the original-comment point.</a:t>
+            </a:r>
+          </a:p>
+          <a:p>
+            <a:r>
+              <a:t/>
+            </a:r>
+          </a:p>
+          <a:p>
+            <a:r>
+              <a:t>Brad, transition: “Public comments are one source. Our own project documents are another. Wesley?”</a:t>
+            </a:r>
+          </a:p>
+          <a:p>
+            <a:r>
+              <a:t/>
+            </a:r>
+          </a:p>
+          <a:p>
+            <a:r>
+              <a:t>ADVANCE TO SLIDE 10 after: “Wesley?”</a:t>
             </a:r>
           </a:p>
         </p:txBody>

</xml_diff>

<commit_message>
Include Wesley's interview, GPIO, dented-shell and next-application stories
</commit_message>
<xml_diff>
--- a/docs/presentation/Engineering_at_The_Kinetic_Group.pptx
+++ b/docs/presentation/Engineering_at_The_Kinetic_Group.pptx
@@ -1100,6 +1100,26 @@
           </a:p>
           <a:p>
             <a:r>
+              <a:t>“Brad started calling that dented shell his child. I remember him being happy about it for a week straight.”</a:t>
+            </a:r>
+          </a:p>
+          <a:p>
+            <a:r>
+              <a:t/>
+            </a:r>
+          </a:p>
+          <a:p>
+            <a:r>
+              <a:t>Delivery: Pause for the laugh, then finish the ownership thought.</a:t>
+            </a:r>
+          </a:p>
+          <a:p>
+            <a:r>
+              <a:t/>
+            </a:r>
+          </a:p>
+          <a:p>
+            <a:r>
               <a:t>“Following ideas through and seeing people get invested feels like helping pave the way for Remington. I enjoy figuring it out.”</a:t>
             </a:r>
           </a:p>
@@ -1735,7 +1755,7 @@
           </a:p>
           <a:p>
             <a:r>
-              <a:t>The bottle demo description follows the repository README (https://github.com/YeChamo/part-tracking-demo-ualr/blob/main/README.md). This revision does not establish live hardware, camera, or venue readiness. Wesley supplied his four personal sections; his wording is retained.</a:t>
+              <a:t>The bottle demo description follows the repository README (https://github.com/YeChamo/part-tracking-demo-ualr/blob/main/README.md). This revision does not establish live hardware, camera, or venue readiness. Wesley supplied his introduction, interview-notification and GPIO story, dented-shell moment, next-application lesson, reliability examples, and closing invitation. His new story wording is retained. The original worksheet used an earlier slide order; these memories now belong to slides 2, 11, and 8 respectively. The GPIO and relay account is a personal recollection, not equipment instructions or a claim about the event demo's hardware.</a:t>
             </a:r>
           </a:p>
           <a:p>
@@ -2085,7 +2105,7 @@
           </a:p>
           <a:p>
             <a:r>
-              <a:t>HOLD SLIDE 2: Briefly explain who CSG is, then continue the approval story and hand off to Wesley. Keep this slide visible through his introduction and optional memory. Target the end of the opening around 0:06; up to 0:08 is workable.</a:t>
+              <a:t>HOLD SLIDE 2: Briefly explain who CSG is, then continue the approval story and hand off to Wesley. Keep this slide visible through his introduction, interview memory, and GPIO story. Target the end of the opening around 0:06; up to 0:08 is workable.</a:t>
             </a:r>
           </a:p>
           <a:p>
@@ -2125,7 +2145,7 @@
           </a:p>
           <a:p>
             <a:r>
-              <a:t>Brad: “So I called Wesley. He decided to come down to central Arkansas and take on the project with me. Wesley, I've told them how I got to that phone call. Tell them your part of the story.”</a:t>
+              <a:t>Brad: “So I called Wesley. He decided to come down to central Arkansas and take on the project with me. Wesley, I've told them how I got to that phone call. Take it from here.”</a:t>
             </a:r>
           </a:p>
           <a:p>
@@ -2145,7 +2165,7 @@
           </a:p>
           <a:p>
             <a:r>
-              <a:t>“I came on full time this February, and now I work on AI tools and machines. One of the things that drew me here was being able to build a solution and see it put to use on the floor.”</a:t>
+              <a:t>“I remember it was about eight at night, and I was stacking boxes when that interview notification came through.”</a:t>
             </a:r>
           </a:p>
           <a:p>
@@ -2155,7 +2175,37 @@
           </a:p>
           <a:p>
             <a:r>
-              <a:t>Wesley's optional story slot, 30–60 seconds: [Add your own memory of the call, coming to central Arkansas, or the first problem you tackled together. The supplied introduction works without an added anecdote.]</a:t>
+              <a:t>“I looked at my phone and thought, ‘Thank God, I might actually get to use this degree.’ Hearing about the projects they were working on, I saw an opportunity. It sounded interesting and exciting, so I decided to charge headfirst into something I knew very little about.”</a:t>
+            </a:r>
+          </a:p>
+          <a:p>
+            <a:r>
+              <a:t/>
+            </a:r>
+          </a:p>
+          <a:p>
+            <a:r>
+              <a:t>“The first problem we tackled was GPIO. We didn’t realize the Jetson needed a patch, and then we had to figure out how to control a 24-volt relay from its low-voltage output. That was my introduction to making software actually work with a machine.”</a:t>
+            </a:r>
+          </a:p>
+          <a:p>
+            <a:r>
+              <a:t/>
+            </a:r>
+          </a:p>
+          <a:p>
+            <a:r>
+              <a:t>Delivery: Pause after “use this degree.” Let the room hear the turn from stacking boxes to building machines. Keep the GPIO memory at the level of the story; no wiring explanation is needed. If the acronym needs one short gloss, GPIO means the computer's input/output pins. Hold slide 2 throughout.</a:t>
+            </a:r>
+          </a:p>
+          <a:p>
+            <a:r>
+              <a:t/>
+            </a:r>
+          </a:p>
+          <a:p>
+            <a:r>
+              <a:t>Wesley: “I came on full time this February, and now I work on AI tools and machines. One of the things that drew me here was being able to build a solution and see it put to use on the floor.”</a:t>
             </a:r>
           </a:p>
           <a:p>
@@ -2890,7 +2940,37 @@
           </a:p>
           <a:p>
             <a:r>
-              <a:t>Wesley: “A different product creates a different visual problem. We have to check the camera view, the examples used to train and test the model, and how the result fits the line. We carry the tooling forward, then validate the application in its own conditions.”</a:t>
+              <a:t>Wesley: “One thing Remington Vision taught me is how much work happens before you even train the model. You have to figure out what the camera can actually see, collect useful examples, and label them consistently.”</a:t>
+            </a:r>
+          </a:p>
+          <a:p>
+            <a:r>
+              <a:t/>
+            </a:r>
+          </a:p>
+          <a:p>
+            <a:r>
+              <a:t>“When we move to a different product, those questions come up again. We can carry over the software and what we’ve learned, but we still have to get the images and testing right for that application.”</a:t>
+            </a:r>
+          </a:p>
+          <a:p>
+            <a:r>
+              <a:t/>
+            </a:r>
+          </a:p>
+          <a:p>
+            <a:r>
+              <a:t>“That’s something I enjoy about this work. Every problem we figure out gives us a better starting point for the next one—and there’s always something new to learn.”</a:t>
+            </a:r>
+          </a:p>
+          <a:p>
+            <a:r>
+              <a:t/>
+            </a:r>
+          </a:p>
+          <a:p>
+            <a:r>
+              <a:t>Wesley handback: Finish on “there’s always something new to learn.” Pause and look to Brad. Keep slide 8 visible until Brad's transition.</a:t>
             </a:r>
           </a:p>
           <a:p>

</xml_diff>

<commit_message>
Remove short-route alternatives from speaker script and matching notes
</commit_message>
<xml_diff>
--- a/docs/presentation/Engineering_at_The_Kinetic_Group.pptx
+++ b/docs/presentation/Engineering_at_The_Kinetic_Group.pptx
@@ -720,7 +720,7 @@
           <a:lstStyle/>
           <a:p>
             <a:r>
-              <a:t>SLIDE CONTROL: Brad advances; Wesley operates demo. Full introduction over slides 1–2, target 6 minutes, room to 8. Use short overview route if needed. Demo target 0:16–0:36. Homepage slide 16; final lab slide 17 at 0:41; questions 0:49–1:00.</a:t>
+              <a:t>SLIDE CONTROL: Brad advances; Wesley operates demo. Full introduction over slides 1–2, target 6 minutes, room to 8. Demo target 0:16–0:36. Homepage slide 16; final lab slide 17 at 0:41; questions 0:49–1:00.</a:t>
             </a:r>
           </a:p>
           <a:p>
@@ -950,16 +950,6 @@
           </a:p>
           <a:p>
             <a:r>
-              <a:t>If behind: About 30 seconds. Keep retrieval, citations, and the engineer checking the source.</a:t>
-            </a:r>
-          </a:p>
-          <a:p>
-            <a:r>
-              <a:t/>
-            </a:r>
-          </a:p>
-          <a:p>
-            <a:r>
               <a:t>Brad, transition: “Those are the projects. The part that keeps us interested is getting to carry an idea into use.”</a:t>
             </a:r>
           </a:p>
@@ -1310,16 +1300,6 @@
           </a:p>
           <a:p>
             <a:r>
-              <a:t>Short route if starting late: Two minutes framing, four minutes for the two baseline outcomes, four minutes for one variation, then guided questions and exit by 0:36. Trim discussion to the time remaining.</a:t>
-            </a:r>
-          </a:p>
-          <a:p>
-            <a:r>
-              <a:t/>
-            </a:r>
-          </a:p>
-          <a:p>
-            <a:r>
               <a:t>RETURN TO THE DECK AT SLIDE 13 after the demo transition. Do not move through the sentiment or Remi slides again.</a:t>
             </a:r>
           </a:p>
@@ -2340,16 +2320,6 @@
           </a:p>
           <a:p>
             <a:r>
-              <a:t>Short route if the introduction ran long: “Our part of the story is recent. Remington goes back to 1816, and Lonoke to 1969. Our contribution is to build on that experience with cameras, controls, and software.”</a:t>
-            </a:r>
-          </a:p>
-          <a:p>
-            <a:r>
-              <a:t/>
-            </a:r>
-          </a:p>
-          <a:p>
-            <a:r>
               <a:t>Brad, transition: “That history carries responsibility, because this is real manufacturing.”</a:t>
             </a:r>
           </a:p>
@@ -2460,16 +2430,6 @@
           </a:p>
           <a:p>
             <a:r>
-              <a:t>Short route: “We work around energetic materials, moving machinery, and real production. The system has to fit the people, workflow, and safeguards.”</a:t>
-            </a:r>
-          </a:p>
-          <a:p>
-            <a:r>
-              <a:t/>
-            </a:r>
-          </a:p>
-          <a:p>
-            <a:r>
               <a:t>Brad, transition: “So what does it take for software to reach that floor?”</a:t>
             </a:r>
           </a:p>
@@ -2580,16 +2540,6 @@
           </a:p>
           <a:p>
             <a:r>
-              <a:t>Short route: “Sense, decide, act. Capturing an image, making a decision, and getting a usable response all have to work together.”</a:t>
-            </a:r>
-          </a:p>
-          <a:p>
-            <a:r>
-              <a:t/>
-            </a:r>
-          </a:p>
-          <a:p>
-            <a:r>
               <a:t>Brad, transition: “You can see that same pattern across our work.”</a:t>
             </a:r>
           </a:p>
@@ -2700,17 +2650,7 @@
           </a:p>
           <a:p>
             <a:r>
-              <a:t>Short route: “Centerfire and shotshell inspection are live and being refined. Sentiment and Remi address other kinds of information. I will start with inspection.”</a:t>
-            </a:r>
-          </a:p>
-          <a:p>
-            <a:r>
-              <a:t/>
-            </a:r>
-          </a:p>
-          <a:p>
-            <a:r>
-              <a:t>Brad, transition for the full route: “Start with centerfire inspection and what building that capability involves.”</a:t>
+              <a:t>Brad, transition: “Start with centerfire inspection and what building that capability involves.”</a:t>
             </a:r>
           </a:p>
           <a:p>
@@ -3091,16 +3031,6 @@
           <a:p>
             <a:r>
               <a:t>Brad: “The same need to turn information into a useful decision also shows up away from the production line. The sentiment project collects public discussion, scores sentiment and product themes, and stores the results for review. The scoring uses VADER with a domain vocabulary. A trend gives the team somewhere to investigate. Keeping the original comments available lets people check what the score actually represents.”</a:t>
-            </a:r>
-          </a:p>
-          <a:p>
-            <a:r>
-              <a:t/>
-            </a:r>
-          </a:p>
-          <a:p>
-            <a:r>
-              <a:t>If behind: Keep the spoken overview to about 30 seconds. Retain the original-comment point.</a:t>
             </a:r>
           </a:p>
           <a:p>

</xml_diff>

<commit_message>
Simplify Brad's shotshell handback to requested floor-problems sentence
</commit_message>
<xml_diff>
--- a/docs/presentation/Engineering_at_The_Kinetic_Group.pptx
+++ b/docs/presentation/Engineering_at_The_Kinetic_Group.pptx
@@ -2920,7 +2920,7 @@
           </a:p>
           <a:p>
             <a:r>
-              <a:t>Brad: “This is also live and being refined. Reusing software still leaves real integration work.”</a:t>
+              <a:t>Brad: “These are the problems we face on the floor”</a:t>
             </a:r>
           </a:p>
           <a:p>
@@ -2930,17 +2930,7 @@
           </a:p>
           <a:p>
             <a:r>
-              <a:t>Brad, transition: “Those are image problems on the floor. Other teams need help making sense of text.”</a:t>
-            </a:r>
-          </a:p>
-          <a:p>
-            <a:r>
-              <a:t/>
-            </a:r>
-          </a:p>
-          <a:p>
-            <a:r>
-              <a:t>ADVANCE TO SLIDE 9 after: “making sense of text.”</a:t>
+              <a:t>ADVANCE TO SLIDE 9 after: “These are the problems we face on the floor”</a:t>
             </a:r>
           </a:p>
         </p:txBody>

</xml_diff>

<commit_message>
Use Brad and Wesley email addresses for presentation follow-up
</commit_message>
<xml_diff>
--- a/docs/presentation/Engineering_at_The_Kinetic_Group.pptx
+++ b/docs/presentation/Engineering_at_The_Kinetic_Group.pptx
@@ -1940,7 +1940,7 @@
           <a:lstStyle/>
           <a:p>
             <a:r>
-              <a:t>On screen: Factory-floor closing message and awhite@tkghunt.com. Close the story before the QR slides.</a:t>
+              <a:t>On screen: Factory-floor closing message and bdaugherty@tkghunt.com and wsiharath@tkghunt.com. Close the story before the QR slides.</a:t>
             </a:r>
           </a:p>
           <a:p>
@@ -1950,7 +1950,7 @@
           </a:p>
           <a:p>
             <a:r>
-              <a:t>Cue: awhite@tkghunt.com, questions, internship, and ideas. Close the story by about 0:40, before the homepage and lab QR slides.</a:t>
+              <a:t>Cue: bdaugherty@tkghunt.com and wsiharath@tkghunt.com, questions, internship, and ideas. Close the story by about 0:40, before the homepage and lab QR slides.</a:t>
             </a:r>
           </a:p>
           <a:p>
@@ -1960,7 +1960,7 @@
           </a:p>
           <a:p>
             <a:r>
-              <a:t>Brad: “Reach us at awhite@tkghunt.com. We’ll be here afterward if anyone wants to connect. Wesley, anything you’d like to add?”</a:t>
+              <a:t>Brad: “Reach me at bdaugherty@tkghunt.com, and Wesley at wsiharath@tkghunt.com. We’ll be here afterward if anyone wants to connect. Wesley, anything you’d like to add?”</a:t>
             </a:r>
           </a:p>
           <a:p>
@@ -14306,8 +14306,8 @@
         </p:nvSpPr>
         <p:spPr>
           <a:xfrm>
-            <a:off x="914400" y="5057775"/>
-            <a:ext cx="7315200" cy="552450"/>
+            <a:off x="914400" y="5000625"/>
+            <a:ext cx="7315200" cy="952500"/>
           </a:xfrm>
           <a:prstGeom prst="rect">
             <a:avLst/>
@@ -14322,7 +14322,7 @@
           <a:bodyPr lIns="0" tIns="0" rIns="0" bIns="0"/>
           <a:lstStyle>
             <a:defPPr algn="ctr">
-              <a:defRPr sz="2600" b="1" i="0">
+              <a:defRPr sz="2400" b="1" i="0">
                 <a:solidFill>
                   <a:srgbClr val="FFFFFF"/>
                 </a:solidFill>
@@ -14404,19 +14404,37 @@
           <a:p>
             <a:pPr algn="ctr">
               <a:buNone/>
-              <a:defRPr sz="2600" b="1" i="0">
+              <a:defRPr sz="2400" b="1" i="0">
                 <a:solidFill>
                   <a:srgbClr val="FFFFFF"/>
                 </a:solidFill>
               </a:defRPr>
             </a:pPr>
             <a:r>
-              <a:rPr sz="2600" b="1" i="0">
+              <a:rPr sz="2400" b="1" i="0">
                 <a:solidFill>
                   <a:srgbClr val="FFFFFF"/>
                 </a:solidFill>
               </a:rPr>
-              <a:t>awhite@tkghunt.com</a:t>
+              <a:t>bdaugherty@tkghunt.com</a:t>
+            </a:r>
+          </a:p>
+          <a:p>
+            <a:pPr algn="ctr">
+              <a:buNone/>
+              <a:defRPr sz="2400" b="1" i="0">
+                <a:solidFill>
+                  <a:srgbClr val="FFFFFF"/>
+                </a:solidFill>
+              </a:defRPr>
+            </a:pPr>
+            <a:r>
+              <a:rPr sz="2400" b="1" i="0">
+                <a:solidFill>
+                  <a:srgbClr val="FFFFFF"/>
+                </a:solidFill>
+              </a:rPr>
+              <a:t>wsiharath@tkghunt.com</a:t>
             </a:r>
           </a:p>
         </p:txBody>

</xml_diff>